<commit_message>
Announce lesson 1's notebooks on slides, like every other lesson
Lesson 1 gave notebook 02 a "Notebook 02, live" slide and left the other
two in speaker notes: notebook 01 was opened from the notes of "The
workflow" and notebook 03 from the notes of "Four ways a model misleads
you". Nothing on the projector marked either one, which is how a
notebook gets skipped in the room.

Lessons 2 to 10 all carry three such slides - the deck is the oldest and
predates the convention. It now has them too, each placed where the
notes already said the live work began, so the flow is unchanged and
only the announcement is new.

The lesson plan is rewritten in the format the other nine use: a minutes
column, a row per notebook with its own budget, and slide ranges checked
against the built PDF page by page. 66 slides, and the segments still
sum to 180.

Co-Authored-By: Claude Opus 5 <noreply@anthropic.com>
</commit_message>
<xml_diff>
--- a/Lessons/01_introduction_and_workflow/Slides/introduction_and_workflow_slides.pptx
+++ b/Lessons/01_introduction_and_workflow/Slides/introduction_and_workflow_slides.pptx
@@ -5,7 +5,7 @@
     <p:sldMasterId id="2147483648" r:id="rId1"/>
   </p:sldMasterIdLst>
   <p:notesMasterIdLst>
-    <p:notesMasterId r:id="rId66"/>
+    <p:notesMasterId r:id="rId68"/>
   </p:notesMasterIdLst>
   <p:sldIdLst>
     <p:sldId id="256" r:id="rId2"/>
@@ -72,6 +72,8 @@
     <p:sldId id="317" r:id="rId63"/>
     <p:sldId id="318" r:id="rId64"/>
     <p:sldId id="319" r:id="rId65"/>
+    <p:sldId id="320" r:id="rId66"/>
+    <p:sldId id="321" r:id="rId67"/>
   </p:sldIdLst>
   <p:sldSz cx="9144000" cy="5143500" type="screen16x9"/>
   <p:notesSz cx="6858000" cy="9144000"/>
@@ -4445,7 +4447,7 @@
             </a:pPr>
             <a:r>
               <a:rPr/>
-              <a:t>This is the map for notebook 01, which we now work through live. Tell them to open it and follow along rather than watch.</a:t>
+              <a:t>This is the map for notebook 01, which the next slide starts. Tell them to open it and follow along rather than watch.</a:t>
             </a:r>
           </a:p>
           <a:p>
@@ -4541,49 +4543,35 @@
             </a:pPr>
             <a:r>
               <a:rPr/>
-              <a:t>The step everyone skips, and the one the exercise marks hardest.</a:t>
-            </a:r>
-          </a:p>
-          <a:p>
-            <a:pPr lvl="0" indent="0" marL="0">
-              <a:buNone/>
-            </a:pPr>
-          </a:p>
-          <a:p>
-            <a:pPr lvl="0" indent="0" marL="0">
-              <a:buNone/>
-            </a:pPr>
-            <a:r>
-              <a:rPr/>
-              <a:t>Our example: predicting whether a breast tumour is malignant from measurements of cell nuclei. A model here would be a screening aid, never a diagnosis - say that clearly, it matters.</a:t>
-            </a:r>
-          </a:p>
-          <a:p>
-            <a:pPr lvl="0" indent="0" marL="0">
-              <a:buNone/>
-            </a:pPr>
-          </a:p>
-          <a:p>
-            <a:pPr lvl="0" indent="0" marL="0">
-              <a:buNone/>
-            </a:pPr>
-            <a:r>
-              <a:rPr/>
-              <a:t>The two errors are not comparable. A false alarm costs anxiety and a follow-up test; a missed malignancy can cost a life. Ask the room which they would rather make, and let them answer before showing any metric.</a:t>
-            </a:r>
-          </a:p>
-          <a:p>
-            <a:pPr lvl="0" indent="0" marL="0">
-              <a:buNone/>
-            </a:pPr>
-          </a:p>
-          <a:p>
-            <a:pPr lvl="0" indent="0" marL="0">
-              <a:buNone/>
-            </a:pPr>
-            <a:r>
-              <a:rPr/>
-              <a:t>That answer determines the metric, and it must be fixed BEFORE seeing results. A metric chosen afterwards is a metric chosen to flatter - with enough candidates, one always looks good.</a:t>
+              <a:t>45 minutes, and it runs alongside the next twelve slides rather than instead of them: each step of the workflow is a slide and then the cell that performs it.</a:t>
+            </a:r>
+          </a:p>
+          <a:p>
+            <a:pPr lvl="0" indent="0" marL="0">
+              <a:buNone/>
+            </a:pPr>
+          </a:p>
+          <a:p>
+            <a:pPr lvl="0" indent="0" marL="0">
+              <a:buNone/>
+            </a:pPr>
+            <a:r>
+              <a:rPr/>
+              <a:t>Three moments to stop on together. The split, because it happens before anything is learned and that is the whole rule of the day. The baseline at 0.629, because it is what makes 0.986 mean something. And the threshold sweep at the end, where the same model - unchanged, same weights - goes from missing no malignancy with eleven false alarms to missing seven with none.</a:t>
+            </a:r>
+          </a:p>
+          <a:p>
+            <a:pPr lvl="0" indent="0" marL="0">
+              <a:buNone/>
+            </a:pPr>
+          </a:p>
+          <a:p>
+            <a:pPr lvl="0" indent="0" marL="0">
+              <a:buNone/>
+            </a:pPr>
+            <a:r>
+              <a:rPr/>
+              <a:t>Tell them to run it themselves rather than watch: everything after this in the course assumes they have a working environment, and this is the session where a broken one shows up.</a:t>
             </a:r>
           </a:p>
         </p:txBody>
@@ -4775,49 +4763,49 @@
             </a:pPr>
             <a:r>
               <a:rPr/>
-              <a:t>One problem, four outcomes, and the two failures are not the same size. Two of these cells are fine and two are not, and accuracy adds all four up as though they weighed the same.</a:t>
-            </a:r>
-          </a:p>
-          <a:p>
-            <a:pPr lvl="0" indent="0" marL="0">
-              <a:buNone/>
-            </a:pPr>
-          </a:p>
-          <a:p>
-            <a:pPr lvl="0" indent="0" marL="0">
-              <a:buNone/>
-            </a:pPr>
-            <a:r>
-              <a:rPr/>
-              <a:t>Ask the room which of the two failures they would rather make, and let them answer before any metric appears. A missed case sends home a patient who should not go; a false alarm costs anxiety and a follow-up test. Nobody needs statistics to rank those.</a:t>
-            </a:r>
-          </a:p>
-          <a:p>
-            <a:pPr lvl="0" indent="0" marL="0">
-              <a:buNone/>
-            </a:pPr>
-          </a:p>
-          <a:p>
-            <a:pPr lvl="0" indent="0" marL="0">
-              <a:buNone/>
-            </a:pPr>
-            <a:r>
-              <a:rPr/>
-              <a:t>Then the part that makes it a lesson rather than an anecdote: answering requires knowing who bears the cost, which is not a question about data. Change the application and the answer changes with it - on a spam filter the expensive cell is the legitimate mail that got blocked, not the spam that got through. The ranking comes from the application, and it has to arrive before any modelling decision is made.</a:t>
-            </a:r>
-          </a:p>
-          <a:p>
-            <a:pPr lvl="0" indent="0" marL="0">
-              <a:buNone/>
-            </a:pPr>
-          </a:p>
-          <a:p>
-            <a:pPr lvl="0" indent="0" marL="0">
-              <a:buNone/>
-            </a:pPr>
-            <a:r>
-              <a:rPr/>
-              <a:t>Lesson 4 turns this into a threshold that can be computed. Today it is enough that they see the question is not a modelling question, and that answering it with accuracy answers it by accident.</a:t>
+              <a:t>The step everyone skips, and the one the exercise marks hardest.</a:t>
+            </a:r>
+          </a:p>
+          <a:p>
+            <a:pPr lvl="0" indent="0" marL="0">
+              <a:buNone/>
+            </a:pPr>
+          </a:p>
+          <a:p>
+            <a:pPr lvl="0" indent="0" marL="0">
+              <a:buNone/>
+            </a:pPr>
+            <a:r>
+              <a:rPr/>
+              <a:t>Our example: predicting whether a breast tumour is malignant from measurements of cell nuclei. A model here would be a screening aid, never a diagnosis - say that clearly, it matters.</a:t>
+            </a:r>
+          </a:p>
+          <a:p>
+            <a:pPr lvl="0" indent="0" marL="0">
+              <a:buNone/>
+            </a:pPr>
+          </a:p>
+          <a:p>
+            <a:pPr lvl="0" indent="0" marL="0">
+              <a:buNone/>
+            </a:pPr>
+            <a:r>
+              <a:rPr/>
+              <a:t>The two errors are not comparable. A false alarm costs anxiety and a follow-up test; a missed malignancy can cost a life. Ask the room which they would rather make, and let them answer before showing any metric.</a:t>
+            </a:r>
+          </a:p>
+          <a:p>
+            <a:pPr lvl="0" indent="0" marL="0">
+              <a:buNone/>
+            </a:pPr>
+          </a:p>
+          <a:p>
+            <a:pPr lvl="0" indent="0" marL="0">
+              <a:buNone/>
+            </a:pPr>
+            <a:r>
+              <a:rPr/>
+              <a:t>That answer determines the metric, and it must be fixed BEFORE seeing results. A metric chosen afterwards is a metric chosen to flatter - with enough candidates, one always looks good.</a:t>
             </a:r>
           </a:p>
         </p:txBody>
@@ -4899,35 +4887,49 @@
             </a:pPr>
             <a:r>
               <a:rPr/>
-              <a:t>569 samples, 30 features, 357 benign against 212 malignant.</a:t>
-            </a:r>
-          </a:p>
-          <a:p>
-            <a:pPr lvl="0" indent="0" marL="0">
-              <a:buNone/>
-            </a:pPr>
-          </a:p>
-          <a:p>
-            <a:pPr lvl="0" indent="0" marL="0">
-              <a:buNone/>
-            </a:pPr>
-            <a:r>
-              <a:rPr/>
-              <a:t>Get them to compute the consequence out loud: always answering “benign” is right 62.7% of the time. That number is the bar any real model has to clear, and it is why step 4 exists.</a:t>
-            </a:r>
-          </a:p>
-          <a:p>
-            <a:pPr lvl="0" indent="0" marL="0">
-              <a:buNone/>
-            </a:pPr>
-          </a:p>
-          <a:p>
-            <a:pPr lvl="0" indent="0" marL="0">
-              <a:buNone/>
-            </a:pPr>
-            <a:r>
-              <a:rPr/>
-              <a:t>Mild imbalance here. Later today we will see what happens at 99 to 1, where the same reasoning destroys accuracy as a metric entirely.</a:t>
+              <a:t>One problem, four outcomes, and the two failures are not the same size. Two of these cells are fine and two are not, and accuracy adds all four up as though they weighed the same.</a:t>
+            </a:r>
+          </a:p>
+          <a:p>
+            <a:pPr lvl="0" indent="0" marL="0">
+              <a:buNone/>
+            </a:pPr>
+          </a:p>
+          <a:p>
+            <a:pPr lvl="0" indent="0" marL="0">
+              <a:buNone/>
+            </a:pPr>
+            <a:r>
+              <a:rPr/>
+              <a:t>Ask the room which of the two failures they would rather make, and let them answer before any metric appears. A missed case sends home a patient who should not go; a false alarm costs anxiety and a follow-up test. Nobody needs statistics to rank those.</a:t>
+            </a:r>
+          </a:p>
+          <a:p>
+            <a:pPr lvl="0" indent="0" marL="0">
+              <a:buNone/>
+            </a:pPr>
+          </a:p>
+          <a:p>
+            <a:pPr lvl="0" indent="0" marL="0">
+              <a:buNone/>
+            </a:pPr>
+            <a:r>
+              <a:rPr/>
+              <a:t>Then the part that makes it a lesson rather than an anecdote: answering requires knowing who bears the cost, which is not a question about data. Change the application and the answer changes with it - on a spam filter the expensive cell is the legitimate mail that got blocked, not the spam that got through. The ranking comes from the application, and it has to arrive before any modelling decision is made.</a:t>
+            </a:r>
+          </a:p>
+          <a:p>
+            <a:pPr lvl="0" indent="0" marL="0">
+              <a:buNone/>
+            </a:pPr>
+          </a:p>
+          <a:p>
+            <a:pPr lvl="0" indent="0" marL="0">
+              <a:buNone/>
+            </a:pPr>
+            <a:r>
+              <a:rPr/>
+              <a:t>Lesson 4 turns this into a threshold that can be computed. Today it is enough that they see the question is not a modelling question, and that answering it with accuracy answers it by accident.</a:t>
             </a:r>
           </a:p>
         </p:txBody>
@@ -5009,63 +5011,35 @@
             </a:pPr>
             <a:r>
               <a:rPr/>
-              <a:t>Return to the risk_gap figure verbally - this slide is that argument made operational.</a:t>
-            </a:r>
-          </a:p>
-          <a:p>
-            <a:pPr lvl="0" indent="0" marL="0">
-              <a:buNone/>
-            </a:pPr>
-          </a:p>
-          <a:p>
-            <a:pPr lvl="0" indent="0" marL="0">
-              <a:buNone/>
-            </a:pPr>
-            <a:r>
-              <a:rPr/>
-              <a:t>The moment anything from the test rows influences a decision, even something as innocent as computing a mean for scaling, the test set stops being unseen and the number it gives you is optimistic.</a:t>
-            </a:r>
-          </a:p>
-          <a:p>
-            <a:pPr lvl="0" indent="0" marL="0">
-              <a:buNone/>
-            </a:pPr>
-          </a:p>
-          <a:p>
-            <a:pPr lvl="0" indent="0" marL="0">
-              <a:buNone/>
-            </a:pPr>
-            <a:r>
-              <a:rPr/>
-              <a:t>Mention stratify=y: it keeps the class proportions identical in both parts, so the test set is a fair miniature of the whole. Without it, on a small or imbalanced dataset, you can get a test set whose composition differs from the training set by chance.</a:t>
-            </a:r>
-          </a:p>
-          <a:p>
-            <a:pPr lvl="0" indent="0" marL="0">
-              <a:buNone/>
-            </a:pPr>
-          </a:p>
-          <a:p>
-            <a:pPr lvl="0" indent="0" marL="0">
-              <a:buNone/>
-            </a:pPr>
-            <a:r>
-              <a:rPr/>
-              <a:t>They will violate this deliberately in the third notebook and see what it costs.</a:t>
-            </a:r>
-          </a:p>
-          <a:p>
-            <a:pPr lvl="0" indent="0" marL="0">
-              <a:buNone/>
-            </a:pPr>
-          </a:p>
-          <a:p>
-            <a:pPr lvl="0" indent="0" marL="0">
-              <a:buNone/>
-            </a:pPr>
-            <a:r>
-              <a:rPr/>
-              <a:t>The caption under the test set is the whole discipline: touched once, at the very end. Say that every additional look spends some of its independence - if you test twenty variants and report the best, you have selected on the test set and the number is no longer honest.</a:t>
+              <a:t>569 samples, 30 features, 357 benign against 212 malignant.</a:t>
+            </a:r>
+          </a:p>
+          <a:p>
+            <a:pPr lvl="0" indent="0" marL="0">
+              <a:buNone/>
+            </a:pPr>
+          </a:p>
+          <a:p>
+            <a:pPr lvl="0" indent="0" marL="0">
+              <a:buNone/>
+            </a:pPr>
+            <a:r>
+              <a:rPr/>
+              <a:t>Get them to compute the consequence out loud: always answering “benign” is right 62.7% of the time. That number is the bar any real model has to clear, and it is why step 4 exists.</a:t>
+            </a:r>
+          </a:p>
+          <a:p>
+            <a:pPr lvl="0" indent="0" marL="0">
+              <a:buNone/>
+            </a:pPr>
+          </a:p>
+          <a:p>
+            <a:pPr lvl="0" indent="0" marL="0">
+              <a:buNone/>
+            </a:pPr>
+            <a:r>
+              <a:rPr/>
+              <a:t>Mild imbalance here. Later today we will see what happens at 99 to 1, where the same reasoning destroys accuracy as a metric entirely.</a:t>
             </a:r>
           </a:p>
         </p:txBody>
@@ -5147,35 +5121,63 @@
             </a:pPr>
             <a:r>
               <a:rPr/>
-              <a:t>Without this, “96% accuracy” has no scale at all. With it, they can see whether the model is worth anything.</a:t>
-            </a:r>
-          </a:p>
-          <a:p>
-            <a:pPr lvl="0" indent="0" marL="0">
-              <a:buNone/>
-            </a:pPr>
-          </a:p>
-          <a:p>
-            <a:pPr lvl="0" indent="0" marL="0">
-              <a:buNone/>
-            </a:pPr>
-            <a:r>
-              <a:rPr/>
-              <a:t>DummyClassifier does this in two lines, and the exercise requires it.</a:t>
-            </a:r>
-          </a:p>
-          <a:p>
-            <a:pPr lvl="0" indent="0" marL="0">
-              <a:buNone/>
-            </a:pPr>
-          </a:p>
-          <a:p>
-            <a:pPr lvl="0" indent="0" marL="0">
-              <a:buNone/>
-            </a:pPr>
-            <a:r>
-              <a:rPr/>
-              <a:t>Foreshadow: on the imbalanced example later, the baseline will be unbeatable on accuracy and completely useless in practice. That is the lesson, not a curiosity - it is how you discover that accuracy is the wrong metric for your problem.</a:t>
+              <a:t>Return to the risk_gap figure verbally - this slide is that argument made operational.</a:t>
+            </a:r>
+          </a:p>
+          <a:p>
+            <a:pPr lvl="0" indent="0" marL="0">
+              <a:buNone/>
+            </a:pPr>
+          </a:p>
+          <a:p>
+            <a:pPr lvl="0" indent="0" marL="0">
+              <a:buNone/>
+            </a:pPr>
+            <a:r>
+              <a:rPr/>
+              <a:t>The moment anything from the test rows influences a decision, even something as innocent as computing a mean for scaling, the test set stops being unseen and the number it gives you is optimistic.</a:t>
+            </a:r>
+          </a:p>
+          <a:p>
+            <a:pPr lvl="0" indent="0" marL="0">
+              <a:buNone/>
+            </a:pPr>
+          </a:p>
+          <a:p>
+            <a:pPr lvl="0" indent="0" marL="0">
+              <a:buNone/>
+            </a:pPr>
+            <a:r>
+              <a:rPr/>
+              <a:t>Mention stratify=y: it keeps the class proportions identical in both parts, so the test set is a fair miniature of the whole. Without it, on a small or imbalanced dataset, you can get a test set whose composition differs from the training set by chance.</a:t>
+            </a:r>
+          </a:p>
+          <a:p>
+            <a:pPr lvl="0" indent="0" marL="0">
+              <a:buNone/>
+            </a:pPr>
+          </a:p>
+          <a:p>
+            <a:pPr lvl="0" indent="0" marL="0">
+              <a:buNone/>
+            </a:pPr>
+            <a:r>
+              <a:rPr/>
+              <a:t>They will violate this deliberately in the third notebook and see what it costs.</a:t>
+            </a:r>
+          </a:p>
+          <a:p>
+            <a:pPr lvl="0" indent="0" marL="0">
+              <a:buNone/>
+            </a:pPr>
+          </a:p>
+          <a:p>
+            <a:pPr lvl="0" indent="0" marL="0">
+              <a:buNone/>
+            </a:pPr>
+            <a:r>
+              <a:rPr/>
+              <a:t>The caption under the test set is the whole discipline: touched once, at the very end. Say that every additional look spends some of its independence - if you test twenty variants and report the best, you have selected on the test set and the number is no longer honest.</a:t>
             </a:r>
           </a:p>
         </p:txBody>
@@ -5257,49 +5259,35 @@
             </a:pPr>
             <a:r>
               <a:rPr/>
-              <a:t>Explain WHY, not just what.</a:t>
-            </a:r>
-          </a:p>
-          <a:p>
-            <a:pPr lvl="0" indent="0" marL="0">
-              <a:buNone/>
-            </a:pPr>
-          </a:p>
-          <a:p>
-            <a:pPr lvl="0" indent="0" marL="0">
-              <a:buNone/>
-            </a:pPr>
-            <a:r>
-              <a:rPr/>
-              <a:t>StandardScaler LEARNS something - a mean and a standard deviation per feature. That makes it part of the model, not preparation of the data. Inside a pipeline it learns them from the training fold every time the pipeline is fitted, including inside each cross-validation fold in lesson 5.</a:t>
-            </a:r>
-          </a:p>
-          <a:p>
-            <a:pPr lvl="0" indent="0" marL="0">
-              <a:buNone/>
-            </a:pPr>
-          </a:p>
-          <a:p>
-            <a:pPr lvl="0" indent="0" marL="0">
-              <a:buNone/>
-            </a:pPr>
-            <a:r>
-              <a:rPr/>
-              <a:t>Write the two steps separately and one day you will scale using statistics computed over the whole dataset. Nothing warns you: no error, no exception, just a better number than you deserve.</a:t>
-            </a:r>
-          </a:p>
-          <a:p>
-            <a:pPr lvl="0" indent="0" marL="0">
-              <a:buNone/>
-            </a:pPr>
-          </a:p>
-          <a:p>
-            <a:pPr lvl="0" indent="0" marL="0">
-              <a:buNone/>
-            </a:pPr>
-            <a:r>
-              <a:rPr/>
-              <a:t>This is structure beating discipline, and it is the single most useful habit in the scikit-learn API.</a:t>
+              <a:t>Without this, “96% accuracy” has no scale at all. With it, they can see whether the model is worth anything.</a:t>
+            </a:r>
+          </a:p>
+          <a:p>
+            <a:pPr lvl="0" indent="0" marL="0">
+              <a:buNone/>
+            </a:pPr>
+          </a:p>
+          <a:p>
+            <a:pPr lvl="0" indent="0" marL="0">
+              <a:buNone/>
+            </a:pPr>
+            <a:r>
+              <a:rPr/>
+              <a:t>DummyClassifier does this in two lines, and the exercise requires it.</a:t>
+            </a:r>
+          </a:p>
+          <a:p>
+            <a:pPr lvl="0" indent="0" marL="0">
+              <a:buNone/>
+            </a:pPr>
+          </a:p>
+          <a:p>
+            <a:pPr lvl="0" indent="0" marL="0">
+              <a:buNone/>
+            </a:pPr>
+            <a:r>
+              <a:rPr/>
+              <a:t>Foreshadow: on the imbalanced example later, the baseline will be unbeatable on accuracy and completely useless in practice. That is the lesson, not a curiosity - it is how you discover that accuracy is the wrong metric for your problem.</a:t>
             </a:r>
           </a:p>
         </p:txBody>
@@ -5381,49 +5369,49 @@
             </a:pPr>
             <a:r>
               <a:rPr/>
-              <a:t>The same two steps, done in the two orders, with what each one shows the test set.</a:t>
-            </a:r>
-          </a:p>
-          <a:p>
-            <a:pPr lvl="0" indent="0" marL="0">
-              <a:buNone/>
-            </a:pPr>
-          </a:p>
-          <a:p>
-            <a:pPr lvl="0" indent="0" marL="0">
-              <a:buNone/>
-            </a:pPr>
-            <a:r>
-              <a:rPr/>
-              <a:t>Point at the top row and at where ‘split’ sits on it: after the scaling. That is the whole mistake, and it is one line out of order.</a:t>
-            </a:r>
-          </a:p>
-          <a:p>
-            <a:pPr lvl="0" indent="0" marL="0">
-              <a:buNone/>
-            </a:pPr>
-          </a:p>
-          <a:p>
-            <a:pPr lvl="0" indent="0" marL="0">
-              <a:buNone/>
-            </a:pPr>
-            <a:r>
-              <a:rPr/>
-              <a:t>On the manual side the scaler is fitted on everything, so the mean and the standard deviation it subtracts already contain the test rows. The model is then evaluated on data it has, in a small way, already seen. The score comes out slightly too high, and nothing anywhere raises an error.</a:t>
-            </a:r>
-          </a:p>
-          <a:p>
-            <a:pPr lvl="0" indent="0" marL="0">
-              <a:buNone/>
-            </a:pPr>
-          </a:p>
-          <a:p>
-            <a:pPr lvl="0" indent="0" marL="0">
-              <a:buNone/>
-            </a:pPr>
-            <a:r>
-              <a:rPr/>
-              <a:t>Emphasise that last part. This is not a mistake that announces itself: it produces a working notebook and a plausible number. Lesson 2 measures what it costs on a real dataset, and lesson 5 gives it its name.</a:t>
+              <a:t>Explain WHY, not just what.</a:t>
+            </a:r>
+          </a:p>
+          <a:p>
+            <a:pPr lvl="0" indent="0" marL="0">
+              <a:buNone/>
+            </a:pPr>
+          </a:p>
+          <a:p>
+            <a:pPr lvl="0" indent="0" marL="0">
+              <a:buNone/>
+            </a:pPr>
+            <a:r>
+              <a:rPr/>
+              <a:t>StandardScaler LEARNS something - a mean and a standard deviation per feature. That makes it part of the model, not preparation of the data. Inside a pipeline it learns them from the training fold every time the pipeline is fitted, including inside each cross-validation fold in lesson 5.</a:t>
+            </a:r>
+          </a:p>
+          <a:p>
+            <a:pPr lvl="0" indent="0" marL="0">
+              <a:buNone/>
+            </a:pPr>
+          </a:p>
+          <a:p>
+            <a:pPr lvl="0" indent="0" marL="0">
+              <a:buNone/>
+            </a:pPr>
+            <a:r>
+              <a:rPr/>
+              <a:t>Write the two steps separately and one day you will scale using statistics computed over the whole dataset. Nothing warns you: no error, no exception, just a better number than you deserve.</a:t>
+            </a:r>
+          </a:p>
+          <a:p>
+            <a:pPr lvl="0" indent="0" marL="0">
+              <a:buNone/>
+            </a:pPr>
+          </a:p>
+          <a:p>
+            <a:pPr lvl="0" indent="0" marL="0">
+              <a:buNone/>
+            </a:pPr>
+            <a:r>
+              <a:rPr/>
+              <a:t>This is structure beating discipline, and it is the single most useful habit in the scikit-learn API.</a:t>
             </a:r>
           </a:p>
         </p:txBody>
@@ -5505,21 +5493,49 @@
             </a:pPr>
             <a:r>
               <a:rPr/>
-              <a:t>Let “done?” hang for a few seconds. Someone will say no.</a:t>
-            </a:r>
-          </a:p>
-          <a:p>
-            <a:pPr lvl="0" indent="0" marL="0">
-              <a:buNone/>
-            </a:pPr>
-          </a:p>
-          <a:p>
-            <a:pPr lvl="0" indent="0" marL="0">
-              <a:buNone/>
-            </a:pPr>
-            <a:r>
-              <a:rPr/>
-              <a:t>If nobody does, ask what 0.986 does not tell them. Then move to the confusion matrix - this is the pivot of the entire lesson.</a:t>
+              <a:t>The same two steps, done in the two orders, with what each one shows the test set.</a:t>
+            </a:r>
+          </a:p>
+          <a:p>
+            <a:pPr lvl="0" indent="0" marL="0">
+              <a:buNone/>
+            </a:pPr>
+          </a:p>
+          <a:p>
+            <a:pPr lvl="0" indent="0" marL="0">
+              <a:buNone/>
+            </a:pPr>
+            <a:r>
+              <a:rPr/>
+              <a:t>Point at the top row and at where ‘split’ sits on it: after the scaling. That is the whole mistake, and it is one line out of order.</a:t>
+            </a:r>
+          </a:p>
+          <a:p>
+            <a:pPr lvl="0" indent="0" marL="0">
+              <a:buNone/>
+            </a:pPr>
+          </a:p>
+          <a:p>
+            <a:pPr lvl="0" indent="0" marL="0">
+              <a:buNone/>
+            </a:pPr>
+            <a:r>
+              <a:rPr/>
+              <a:t>On the manual side the scaler is fitted on everything, so the mean and the standard deviation it subtracts already contain the test rows. The model is then evaluated on data it has, in a small way, already seen. The score comes out slightly too high, and nothing anywhere raises an error.</a:t>
+            </a:r>
+          </a:p>
+          <a:p>
+            <a:pPr lvl="0" indent="0" marL="0">
+              <a:buNone/>
+            </a:pPr>
+          </a:p>
+          <a:p>
+            <a:pPr lvl="0" indent="0" marL="0">
+              <a:buNone/>
+            </a:pPr>
+            <a:r>
+              <a:rPr/>
+              <a:t>Emphasise that last part. This is not a mistake that announces itself: it produces a working notebook and a plausible number. Lesson 2 measures what it costs on a real dataset, and lesson 5 gives it its name.</a:t>
             </a:r>
           </a:p>
         </p:txBody>
@@ -5601,49 +5617,21 @@
             </a:pPr>
             <a:r>
               <a:rPr/>
-              <a:t>One malignant tumour classified as benign.</a:t>
-            </a:r>
-          </a:p>
-          <a:p>
-            <a:pPr lvl="0" indent="0" marL="0">
-              <a:buNone/>
-            </a:pPr>
-          </a:p>
-          <a:p>
-            <a:pPr lvl="0" indent="0" marL="0">
-              <a:buNone/>
-            </a:pPr>
-            <a:r>
-              <a:rPr/>
-              <a:t>As a fraction it is 1 in 143 and vanishes into the accuracy figure. As a consequence it is a person sent home who should not have been.</a:t>
-            </a:r>
-          </a:p>
-          <a:p>
-            <a:pPr lvl="0" indent="0" marL="0">
-              <a:buNone/>
-            </a:pPr>
-          </a:p>
-          <a:p>
-            <a:pPr lvl="0" indent="0" marL="0">
-              <a:buNone/>
-            </a:pPr>
-            <a:r>
-              <a:rPr/>
-              <a:t>Say that sentence deliberately and let it sit. It is the gap between a metric and what the metric stands for, and it is the most important idea in today’s lesson.</a:t>
-            </a:r>
-          </a:p>
-          <a:p>
-            <a:pPr lvl="0" indent="0" marL="0">
-              <a:buNone/>
-            </a:pPr>
-          </a:p>
-          <a:p>
-            <a:pPr lvl="0" indent="0" marL="0">
-              <a:buNone/>
-            </a:pPr>
-            <a:r>
-              <a:rPr/>
-              <a:t>Then the practical form: accuracy collapses every kind of mistake into one number, and our two mistakes are not comparable. The confusion matrix is the minimum tool for seeing them separately.</a:t>
+              <a:t>Let “done?” hang for a few seconds. Someone will say no.</a:t>
+            </a:r>
+          </a:p>
+          <a:p>
+            <a:pPr lvl="0" indent="0" marL="0">
+              <a:buNone/>
+            </a:pPr>
+          </a:p>
+          <a:p>
+            <a:pPr lvl="0" indent="0" marL="0">
+              <a:buNone/>
+            </a:pPr>
+            <a:r>
+              <a:rPr/>
+              <a:t>If nobody does, ask what 0.986 does not tell them. Then move to the confusion matrix - this is the pivot of the entire lesson.</a:t>
             </a:r>
           </a:p>
         </p:txBody>
@@ -5725,49 +5713,49 @@
             </a:pPr>
             <a:r>
               <a:rPr/>
-              <a:t>Define both against the confusion matrix still in their heads from the last slide, and keep them the right way round: recall divides by the row of things that really were malignant, precision by the column of things we flagged. The next slide makes the trade physical.</a:t>
-            </a:r>
-          </a:p>
-          <a:p>
-            <a:pPr lvl="0" indent="0" marL="0">
-              <a:buNone/>
-            </a:pPr>
-          </a:p>
-          <a:p>
-            <a:pPr lvl="0" indent="0" marL="0">
-              <a:buNone/>
-            </a:pPr>
-            <a:r>
-              <a:rPr/>
-              <a:t>Push recall towards 1.0 by flagging anything suspicious, and precision collapses - the clinic drowns in unnecessary biopsies. Demand high precision and you start missing cases.</a:t>
-            </a:r>
-          </a:p>
-          <a:p>
-            <a:pPr lvl="0" indent="0" marL="0">
-              <a:buNone/>
-            </a:pPr>
-          </a:p>
-          <a:p>
-            <a:pPr lvl="0" indent="0" marL="0">
-              <a:buNone/>
-            </a:pPr>
-            <a:r>
-              <a:rPr/>
-              <a:t>No single number resolves this, because the resolution is not mathematical. It is a question about consequences and it belongs to the people who bear them - here, patients and clinicians, not the person who trained the model.</a:t>
-            </a:r>
-          </a:p>
-          <a:p>
-            <a:pPr lvl="0" indent="0" marL="0">
-              <a:buNone/>
-            </a:pPr>
-          </a:p>
-          <a:p>
-            <a:pPr lvl="0" indent="0" marL="0">
-              <a:buNone/>
-            </a:pPr>
-            <a:r>
-              <a:rPr/>
-              <a:t>Lesson 4 builds the tools properly: receiver operating characteristic (ROC) curves, precision-recall curves, choosing an operating point. Today they need to see that the trade-off exists and that it is not the model’s decision to make.</a:t>
+              <a:t>One malignant tumour classified as benign.</a:t>
+            </a:r>
+          </a:p>
+          <a:p>
+            <a:pPr lvl="0" indent="0" marL="0">
+              <a:buNone/>
+            </a:pPr>
+          </a:p>
+          <a:p>
+            <a:pPr lvl="0" indent="0" marL="0">
+              <a:buNone/>
+            </a:pPr>
+            <a:r>
+              <a:rPr/>
+              <a:t>As a fraction it is 1 in 143 and vanishes into the accuracy figure. As a consequence it is a person sent home who should not have been.</a:t>
+            </a:r>
+          </a:p>
+          <a:p>
+            <a:pPr lvl="0" indent="0" marL="0">
+              <a:buNone/>
+            </a:pPr>
+          </a:p>
+          <a:p>
+            <a:pPr lvl="0" indent="0" marL="0">
+              <a:buNone/>
+            </a:pPr>
+            <a:r>
+              <a:rPr/>
+              <a:t>Say that sentence deliberately and let it sit. It is the gap between a metric and what the metric stands for, and it is the most important idea in today’s lesson.</a:t>
+            </a:r>
+          </a:p>
+          <a:p>
+            <a:pPr lvl="0" indent="0" marL="0">
+              <a:buNone/>
+            </a:pPr>
+          </a:p>
+          <a:p>
+            <a:pPr lvl="0" indent="0" marL="0">
+              <a:buNone/>
+            </a:pPr>
+            <a:r>
+              <a:rPr/>
+              <a:t>Then the practical form: accuracy collapses every kind of mistake into one number, and our two mistakes are not comparable. The confusion matrix is the minimum tool for seeing them separately.</a:t>
             </a:r>
           </a:p>
         </p:txBody>
@@ -5849,63 +5837,49 @@
             </a:pPr>
             <a:r>
               <a:rPr/>
-              <a:t>Say what the axis is before anything else, because nothing else makes sense without it: every dot is one of the 143 tumours in the test set, and its position is the probability our model gave to “malignant”. Not a distance, not a score - a probability, 0 to 1.</a:t>
-            </a:r>
-          </a:p>
-          <a:p>
-            <a:pPr lvl="0" indent="0" marL="0">
-              <a:buNone/>
-            </a:pPr>
-          </a:p>
-          <a:p>
-            <a:pPr lvl="0" indent="0" marL="0">
-              <a:buNone/>
-            </a:pPr>
-            <a:r>
-              <a:rPr/>
-              <a:t>The black line is 0.5, and it is worth saying out loud that nothing chose it. It is the default. Everything to the right of it we flag; everything to the left we send home.</a:t>
-            </a:r>
-          </a:p>
-          <a:p>
-            <a:pPr lvl="0" indent="0" marL="0">
-              <a:buNone/>
-            </a:pPr>
-          </a:p>
-          <a:p>
-            <a:pPr lvl="0" indent="0" marL="0">
-              <a:buNone/>
-            </a:pPr>
-            <a:r>
-              <a:rPr/>
-              <a:t>Now the point of the slide. Most of the picture is the model being certain: 105 of the 143 sit within 0.02 of one end, which is where 0.986 comes from. Tell them to ignore those and look at the middle. The band from 0.11 to 0.62 holds the 12 it was unsure about - 1 malignant, 11 benign - and at 0.5 only two of the twelve are on the wrong side: the malignancy at 0.11 that we missed, and the benign at 0.62 that we flagged.</a:t>
-            </a:r>
-          </a:p>
-          <a:p>
-            <a:pPr lvl="0" indent="0" marL="0">
-              <a:buNone/>
-            </a:pPr>
-          </a:p>
-          <a:p>
-            <a:pPr lvl="0" indent="0" marL="0">
-              <a:buNone/>
-            </a:pPr>
-            <a:r>
-              <a:rPr/>
-              <a:t>Then slide the line, and make them watch the band rather than the numbers. Down to 0.10 and it passes below the whole band: the missed malignancy is caught, and all 11 uncertain benign tumours turn into false alarms. Point at them - the eleven are countable on the slide, which is the whole reason this figure is here rather than a table. Up to 0.90 instead and no false alarm survives, at the price of 7 women sent home who should not have been.</a:t>
-            </a:r>
-          </a:p>
-          <a:p>
-            <a:pPr lvl="0" indent="0" marL="0">
-              <a:buNone/>
-            </a:pPr>
-          </a:p>
-          <a:p>
-            <a:pPr lvl="0" indent="0" marL="0">
-              <a:buNone/>
-            </a:pPr>
-            <a:r>
-              <a:rPr/>
-              <a:t>Nothing about the model changed between those two sentences. So the question of whether it is good has no answer until somebody says which error is worse - which is the earlier slide arriving again, now with a number attached. Lesson 4 spends an hour here.</a:t>
+              <a:t>Define both against the confusion matrix still in their heads from the last slide, and keep them the right way round: recall divides by the row of things that really were malignant, precision by the column of things we flagged. The next slide makes the trade physical.</a:t>
+            </a:r>
+          </a:p>
+          <a:p>
+            <a:pPr lvl="0" indent="0" marL="0">
+              <a:buNone/>
+            </a:pPr>
+          </a:p>
+          <a:p>
+            <a:pPr lvl="0" indent="0" marL="0">
+              <a:buNone/>
+            </a:pPr>
+            <a:r>
+              <a:rPr/>
+              <a:t>Push recall towards 1.0 by flagging anything suspicious, and precision collapses - the clinic drowns in unnecessary biopsies. Demand high precision and you start missing cases.</a:t>
+            </a:r>
+          </a:p>
+          <a:p>
+            <a:pPr lvl="0" indent="0" marL="0">
+              <a:buNone/>
+            </a:pPr>
+          </a:p>
+          <a:p>
+            <a:pPr lvl="0" indent="0" marL="0">
+              <a:buNone/>
+            </a:pPr>
+            <a:r>
+              <a:rPr/>
+              <a:t>No single number resolves this, because the resolution is not mathematical. It is a question about consequences and it belongs to the people who bear them - here, patients and clinicians, not the person who trained the model.</a:t>
+            </a:r>
+          </a:p>
+          <a:p>
+            <a:pPr lvl="0" indent="0" marL="0">
+              <a:buNone/>
+            </a:pPr>
+          </a:p>
+          <a:p>
+            <a:pPr lvl="0" indent="0" marL="0">
+              <a:buNone/>
+            </a:pPr>
+            <a:r>
+              <a:rPr/>
+              <a:t>Lesson 4 builds the tools properly: receiver operating characteristic (ROC) curves, precision-recall curves, choosing an operating point. Today they need to see that the trade-off exists and that it is not the model’s decision to make.</a:t>
             </a:r>
           </a:p>
         </p:txBody>
@@ -6125,21 +6099,63 @@
             </a:pPr>
             <a:r>
               <a:rPr/>
-              <a:t>Name where each omission gets addressed: tuning and stability in lesson 5, model families in 6 and 7.</a:t>
-            </a:r>
-          </a:p>
-          <a:p>
-            <a:pPr lvl="0" indent="0" marL="0">
-              <a:buNone/>
-            </a:pPr>
-          </a:p>
-          <a:p>
-            <a:pPr lvl="0" indent="0" marL="0">
-              <a:buNone/>
-            </a:pPr>
-            <a:r>
-              <a:rPr/>
-              <a:t>Then land the last line, which is the point of the slide: that discipline is the reason the 0.986 is worth anything at all. Every one of the four failures we are about to see comes from breaking it in some form.</a:t>
+              <a:t>Say what the axis is before anything else, because nothing else makes sense without it: every dot is one of the 143 tumours in the test set, and its position is the probability our model gave to “malignant”. Not a distance, not a score - a probability, 0 to 1.</a:t>
+            </a:r>
+          </a:p>
+          <a:p>
+            <a:pPr lvl="0" indent="0" marL="0">
+              <a:buNone/>
+            </a:pPr>
+          </a:p>
+          <a:p>
+            <a:pPr lvl="0" indent="0" marL="0">
+              <a:buNone/>
+            </a:pPr>
+            <a:r>
+              <a:rPr/>
+              <a:t>The black line is 0.5, and it is worth saying out loud that nothing chose it. It is the default. Everything to the right of it we flag; everything to the left we send home.</a:t>
+            </a:r>
+          </a:p>
+          <a:p>
+            <a:pPr lvl="0" indent="0" marL="0">
+              <a:buNone/>
+            </a:pPr>
+          </a:p>
+          <a:p>
+            <a:pPr lvl="0" indent="0" marL="0">
+              <a:buNone/>
+            </a:pPr>
+            <a:r>
+              <a:rPr/>
+              <a:t>Now the point of the slide. Most of the picture is the model being certain: 105 of the 143 sit within 0.02 of one end, which is where 0.986 comes from. Tell them to ignore those and look at the middle. The band from 0.11 to 0.62 holds the 12 it was unsure about - 1 malignant, 11 benign - and at 0.5 only two of the twelve are on the wrong side: the malignancy at 0.11 that we missed, and the benign at 0.62 that we flagged.</a:t>
+            </a:r>
+          </a:p>
+          <a:p>
+            <a:pPr lvl="0" indent="0" marL="0">
+              <a:buNone/>
+            </a:pPr>
+          </a:p>
+          <a:p>
+            <a:pPr lvl="0" indent="0" marL="0">
+              <a:buNone/>
+            </a:pPr>
+            <a:r>
+              <a:rPr/>
+              <a:t>Then slide the line, and make them watch the band rather than the numbers. Down to 0.10 and it passes below the whole band: the missed malignancy is caught, and all 11 uncertain benign tumours turn into false alarms. Point at them - the eleven are countable on the slide, which is the whole reason this figure is here rather than a table. Up to 0.90 instead and no false alarm survives, at the price of 7 women sent home who should not have been.</a:t>
+            </a:r>
+          </a:p>
+          <a:p>
+            <a:pPr lvl="0" indent="0" marL="0">
+              <a:buNone/>
+            </a:pPr>
+          </a:p>
+          <a:p>
+            <a:pPr lvl="0" indent="0" marL="0">
+              <a:buNone/>
+            </a:pPr>
+            <a:r>
+              <a:rPr/>
+              <a:t>Nothing about the model changed between those two sentences. So the question of whether it is good has no answer until somebody says which error is worse - which is the earlier slide arriving again, now with a number attached. Lesson 4 spends an hour here.</a:t>
             </a:r>
           </a:p>
         </p:txBody>
@@ -6221,21 +6237,21 @@
             </a:pPr>
             <a:r>
               <a:rPr/>
-              <a:t>Open notebook 03. Frame it before starting: none of these is a coding error. All four run exactly as written and return a number that a reviewer, a supervisor or a customer would accept.</a:t>
-            </a:r>
-          </a:p>
-          <a:p>
-            <a:pPr lvl="0" indent="0" marL="0">
-              <a:buNone/>
-            </a:pPr>
-          </a:p>
-          <a:p>
-            <a:pPr lvl="0" indent="0" marL="0">
-              <a:buNone/>
-            </a:pPr>
-            <a:r>
-              <a:rPr/>
-              <a:t>This is the section they should still remember in five years. Handout section 7 summarises it, and every one of the four has been found in published work and in shipped products.</a:t>
+              <a:t>Name where each omission gets addressed: tuning and stability in lesson 5, model families in 6 and 7.</a:t>
+            </a:r>
+          </a:p>
+          <a:p>
+            <a:pPr lvl="0" indent="0" marL="0">
+              <a:buNone/>
+            </a:pPr>
+          </a:p>
+          <a:p>
+            <a:pPr lvl="0" indent="0" marL="0">
+              <a:buNone/>
+            </a:pPr>
+            <a:r>
+              <a:rPr/>
+              <a:t>Then land the last line, which is the point of the slide: that discipline is the reason the 0.986 is worth anything at all. Every one of the four failures we are about to see comes from breaking it in some form.</a:t>
             </a:r>
           </a:p>
         </p:txBody>
@@ -6317,21 +6333,21 @@
             </a:pPr>
             <a:r>
               <a:rPr/>
-              <a:t>Set this up carefully before revealing anything. Make sure they understand the data is pure noise BY CONSTRUCTION - the labels come from a random number generator and no feature carries any information about them.</a:t>
-            </a:r>
-          </a:p>
-          <a:p>
-            <a:pPr lvl="0" indent="0" marL="0">
-              <a:buNone/>
-            </a:pPr>
-          </a:p>
-          <a:p>
-            <a:pPr lvl="0" indent="0" marL="0">
-              <a:buNone/>
-            </a:pPr>
-            <a:r>
-              <a:rPr/>
-              <a:t>Ask what accuracy they expect. The honest answer is 50%, chance.</a:t>
+              <a:t>The frame, and the next slide opens the notebook: none of these is a coding error. All four run exactly as written and return a number that a reviewer, a supervisor or a customer would accept.</a:t>
+            </a:r>
+          </a:p>
+          <a:p>
+            <a:pPr lvl="0" indent="0" marL="0">
+              <a:buNone/>
+            </a:pPr>
+          </a:p>
+          <a:p>
+            <a:pPr lvl="0" indent="0" marL="0">
+              <a:buNone/>
+            </a:pPr>
+            <a:r>
+              <a:rPr/>
+              <a:t>This is the section they should still remember in five years. Handout section 7 summarises it, and every one of the four has been found in published work and in shipped products.</a:t>
             </a:r>
           </a:p>
         </p:txBody>
@@ -6413,49 +6429,35 @@
             </a:pPr>
             <a:r>
               <a:rPr/>
-              <a:t>77% on pure noise, against 50% for the honest pipeline.</a:t>
-            </a:r>
-          </a:p>
-          <a:p>
-            <a:pPr lvl="0" indent="0" marL="0">
-              <a:buNone/>
-            </a:pPr>
-          </a:p>
-          <a:p>
-            <a:pPr lvl="0" indent="0" marL="0">
-              <a:buNone/>
-            </a:pPr>
-            <a:r>
-              <a:rPr/>
-              <a:t>Explain the mechanism: with 5000 random features, some correlate with the labels by chance. Selecting the best 20 using the whole dataset picks exactly those - including the ones that correlate with the labels of rows that later become the test set. The selection encoded information about the test labels, and the model inherited it.</a:t>
-            </a:r>
-          </a:p>
-          <a:p>
-            <a:pPr lvl="0" indent="0" marL="0">
-              <a:buNone/>
-            </a:pPr>
-          </a:p>
-          <a:p>
-            <a:pPr lvl="0" indent="0" marL="0">
-              <a:buNone/>
-            </a:pPr>
-            <a:r>
-              <a:rPr/>
-              <a:t>Nobody wrote a bug. Selection feels harmless because it fits no model - but it LEARNS from data, so it belongs inside the training fold.</a:t>
-            </a:r>
-          </a:p>
-          <a:p>
-            <a:pPr lvl="0" indent="0" marL="0">
-              <a:buNone/>
-            </a:pPr>
-          </a:p>
-          <a:p>
-            <a:pPr lvl="0" indent="0" marL="0">
-              <a:buNone/>
-            </a:pPr>
-            <a:r>
-              <a:rPr/>
-              <a:t>Then ask what happens with 20000 features instead of 5000. The illusion gets STRONGER, because there are more opportunities for a spurious correlation. That is the “try this” at the end of the notebook.</a:t>
+              <a:t>25 minutes, again alongside the slides that follow rather than instead of them.</a:t>
+            </a:r>
+          </a:p>
+          <a:p>
+            <a:pPr lvl="0" indent="0" marL="0">
+              <a:buNone/>
+            </a:pPr>
+          </a:p>
+          <a:p>
+            <a:pPr lvl="0" indent="0" marL="0">
+              <a:buNone/>
+            </a:pPr>
+            <a:r>
+              <a:rPr/>
+              <a:t>Say what to watch for before they start, because the notebook is deliberately undramatic: every cell runs, nothing raises, and every number it prints would pass a review. The work is reading them.</a:t>
+            </a:r>
+          </a:p>
+          <a:p>
+            <a:pPr lvl="0" indent="0" marL="0">
+              <a:buNone/>
+            </a:pPr>
+          </a:p>
+          <a:p>
+            <a:pPr lvl="0" indent="0" marL="0">
+              <a:buNone/>
+            </a:pPr>
+            <a:r>
+              <a:rPr/>
+              <a:t>The two cells to make sure nobody skips: the leaked selection reaching 77% on labels generated by a coin flip, and the four deployment scenarios for the shortcut column, where the two that raise an exception turn out to be the lucky ones.</a:t>
             </a:r>
           </a:p>
         </p:txBody>
@@ -6537,35 +6539,21 @@
             </a:pPr>
             <a:r>
               <a:rPr/>
-              <a:t>The practical takeaway from the whole leakage section, and the thing to put on the board if anything goes on the board today.</a:t>
-            </a:r>
-          </a:p>
-          <a:p>
-            <a:pPr lvl="0" indent="0" marL="0">
-              <a:buNone/>
-            </a:pPr>
-          </a:p>
-          <a:p>
-            <a:pPr lvl="0" indent="0" marL="0">
-              <a:buNone/>
-            </a:pPr>
-            <a:r>
-              <a:rPr/>
-              <a:t>Pipelines enforce it structurally, which is why we used one from the first notebook.</a:t>
-            </a:r>
-          </a:p>
-          <a:p>
-            <a:pPr lvl="0" indent="0" marL="0">
-              <a:buNone/>
-            </a:pPr>
-          </a:p>
-          <a:p>
-            <a:pPr lvl="0" indent="0" marL="0">
-              <a:buNone/>
-            </a:pPr>
-            <a:r>
-              <a:rPr/>
-              <a:t>Tell them the exercise checks this: scaling the full dataset before splitting caps the methodology marks regardless of the result obtained.</a:t>
+              <a:t>Set this up carefully before revealing anything. Make sure they understand the data is pure noise BY CONSTRUCTION - the labels come from a random number generator and no feature carries any information about them.</a:t>
+            </a:r>
+          </a:p>
+          <a:p>
+            <a:pPr lvl="0" indent="0" marL="0">
+              <a:buNone/>
+            </a:pPr>
+          </a:p>
+          <a:p>
+            <a:pPr lvl="0" indent="0" marL="0">
+              <a:buNone/>
+            </a:pPr>
+            <a:r>
+              <a:rPr/>
+              <a:t>Ask what accuracy they expect. The honest answer is 50%, chance.</a:t>
             </a:r>
           </a:p>
         </p:txBody>
@@ -6647,35 +6635,49 @@
             </a:pPr>
             <a:r>
               <a:rPr/>
-              <a:t>The trained model in the notebook reaches 0.987 accuracy - barely above the trivial one - while missing 20 of the 21 positives in the test set.</a:t>
-            </a:r>
-          </a:p>
-          <a:p>
-            <a:pPr lvl="0" indent="0" marL="0">
-              <a:buNone/>
-            </a:pPr>
-          </a:p>
-          <a:p>
-            <a:pPr lvl="0" indent="0" marL="0">
-              <a:buNone/>
-            </a:pPr>
-            <a:r>
-              <a:rPr/>
-              <a:t>On a problem where the positives are the entire reason the system exists.</a:t>
-            </a:r>
-          </a:p>
-          <a:p>
-            <a:pPr lvl="0" indent="0" marL="0">
-              <a:buNone/>
-            </a:pPr>
-          </a:p>
-          <a:p>
-            <a:pPr lvl="0" indent="0" marL="0">
-              <a:buNone/>
-            </a:pPr>
-            <a:r>
-              <a:rPr/>
-              <a:t>Accuracy is dominated by the class nobody is looking for. Ask them what metric they would report to someone deploying this, and steer towards recall on the positive class - then note that recall alone is also gameable, by flagging everything, which is why lesson 4 needs a whole session.</a:t>
+              <a:t>77% on pure noise, against 50% for the honest pipeline.</a:t>
+            </a:r>
+          </a:p>
+          <a:p>
+            <a:pPr lvl="0" indent="0" marL="0">
+              <a:buNone/>
+            </a:pPr>
+          </a:p>
+          <a:p>
+            <a:pPr lvl="0" indent="0" marL="0">
+              <a:buNone/>
+            </a:pPr>
+            <a:r>
+              <a:rPr/>
+              <a:t>Explain the mechanism: with 5000 random features, some correlate with the labels by chance. Selecting the best 20 using the whole dataset picks exactly those - including the ones that correlate with the labels of rows that later become the test set. The selection encoded information about the test labels, and the model inherited it.</a:t>
+            </a:r>
+          </a:p>
+          <a:p>
+            <a:pPr lvl="0" indent="0" marL="0">
+              <a:buNone/>
+            </a:pPr>
+          </a:p>
+          <a:p>
+            <a:pPr lvl="0" indent="0" marL="0">
+              <a:buNone/>
+            </a:pPr>
+            <a:r>
+              <a:rPr/>
+              <a:t>Nobody wrote a bug. Selection feels harmless because it fits no model - but it LEARNS from data, so it belongs inside the training fold.</a:t>
+            </a:r>
+          </a:p>
+          <a:p>
+            <a:pPr lvl="0" indent="0" marL="0">
+              <a:buNone/>
+            </a:pPr>
+          </a:p>
+          <a:p>
+            <a:pPr lvl="0" indent="0" marL="0">
+              <a:buNone/>
+            </a:pPr>
+            <a:r>
+              <a:rPr/>
+              <a:t>Then ask what happens with 20000 features instead of 5000. The illusion gets STRONGER, because there are more opportunities for a spurious correlation. That is the “try this” at the end of the notebook.</a:t>
             </a:r>
           </a:p>
         </p:txBody>
@@ -6757,35 +6759,35 @@
             </a:pPr>
             <a:r>
               <a:rPr/>
-              <a:t>Two confusion matrices side by side. Give them a moment to spot that the accuracies agree to three decimal places.</a:t>
-            </a:r>
-          </a:p>
-          <a:p>
-            <a:pPr lvl="0" indent="0" marL="0">
-              <a:buNone/>
-            </a:pPr>
-          </a:p>
-          <a:p>
-            <a:pPr lvl="0" indent="0" marL="0">
-              <a:buNone/>
-            </a:pPr>
-            <a:r>
-              <a:rPr/>
-              <a:t>Left is the model that answers negative every time and has learned nothing whatever. Right is a trained model. 0.986 against 0.987 - and the one on the right finds a single positive out of twenty-one, which is barely better than nothing but is not nothing.</a:t>
-            </a:r>
-          </a:p>
-          <a:p>
-            <a:pPr lvl="0" indent="0" marL="0">
-              <a:buNone/>
-            </a:pPr>
-          </a:p>
-          <a:p>
-            <a:pPr lvl="0" indent="0" marL="0">
-              <a:buNone/>
-            </a:pPr>
-            <a:r>
-              <a:rPr/>
-              <a:t>Ask what a report containing only the accuracy would say about these two, and let the silence do the work. Then point at the bottom-left cell of each: 21 missed, then 20 missed. That is the number the application cares about, and it is the one accuracy averages away.</a:t>
+              <a:t>The practical takeaway from the whole leakage section, and the thing to put on the board if anything goes on the board today.</a:t>
+            </a:r>
+          </a:p>
+          <a:p>
+            <a:pPr lvl="0" indent="0" marL="0">
+              <a:buNone/>
+            </a:pPr>
+          </a:p>
+          <a:p>
+            <a:pPr lvl="0" indent="0" marL="0">
+              <a:buNone/>
+            </a:pPr>
+            <a:r>
+              <a:rPr/>
+              <a:t>Pipelines enforce it structurally, which is why we used one from the first notebook.</a:t>
+            </a:r>
+          </a:p>
+          <a:p>
+            <a:pPr lvl="0" indent="0" marL="0">
+              <a:buNone/>
+            </a:pPr>
+          </a:p>
+          <a:p>
+            <a:pPr lvl="0" indent="0" marL="0">
+              <a:buNone/>
+            </a:pPr>
+            <a:r>
+              <a:rPr/>
+              <a:t>Tell them the exercise checks this: scaling the full dataset before splitting caps the methodology marks regardless of the result obtained.</a:t>
             </a:r>
           </a:p>
         </p:txBody>
@@ -6867,49 +6869,35 @@
             </a:pPr>
             <a:r>
               <a:rPr/>
-              <a:t>Explain why it is worthless: biopsies are scheduled once malignancy is already suspected, so the field is populated AFTER the diagnosis it is supposed to predict. At prediction time for a new patient it is empty.</a:t>
-            </a:r>
-          </a:p>
-          <a:p>
-            <a:pPr lvl="0" indent="0" marL="0">
-              <a:buNone/>
-            </a:pPr>
-          </a:p>
-          <a:p>
-            <a:pPr lvl="0" indent="0" marL="0">
-              <a:buNone/>
-            </a:pPr>
-            <a:r>
-              <a:rPr/>
-              <a:t>Then the point that makes this different from the others: no metric detects it, including cross-validated ones, because the information genuinely IS in the training data. The model is not cheating; the data is.</a:t>
-            </a:r>
-          </a:p>
-          <a:p>
-            <a:pPr lvl="0" indent="0" marL="0">
-              <a:buNone/>
-            </a:pPr>
-          </a:p>
-          <a:p>
-            <a:pPr lvl="0" indent="0" marL="0">
-              <a:buNone/>
-            </a:pPr>
-            <a:r>
-              <a:rPr/>
-              <a:t>Only knowing how the data was recorded catches it. Ask them to imagine a hospital extract with 200 columns and no documentation - which is the normal case - and to think about how they would find this.</a:t>
-            </a:r>
-          </a:p>
-          <a:p>
-            <a:pPr lvl="0" indent="0" marL="0">
-              <a:buNone/>
-            </a:pPr>
-          </a:p>
-          <a:p>
-            <a:pPr lvl="0" indent="0" marL="0">
-              <a:buNone/>
-            </a:pPr>
-            <a:r>
-              <a:rPr/>
-              <a:t>The question to carry: at the moment a prediction is needed, does this value exist yet?</a:t>
+              <a:t>The trained model in the notebook reaches 0.987 accuracy - barely above the trivial one - while missing 20 of the 21 positives in the test set.</a:t>
+            </a:r>
+          </a:p>
+          <a:p>
+            <a:pPr lvl="0" indent="0" marL="0">
+              <a:buNone/>
+            </a:pPr>
+          </a:p>
+          <a:p>
+            <a:pPr lvl="0" indent="0" marL="0">
+              <a:buNone/>
+            </a:pPr>
+            <a:r>
+              <a:rPr/>
+              <a:t>On a problem where the positives are the entire reason the system exists.</a:t>
+            </a:r>
+          </a:p>
+          <a:p>
+            <a:pPr lvl="0" indent="0" marL="0">
+              <a:buNone/>
+            </a:pPr>
+          </a:p>
+          <a:p>
+            <a:pPr lvl="0" indent="0" marL="0">
+              <a:buNone/>
+            </a:pPr>
+            <a:r>
+              <a:rPr/>
+              <a:t>Accuracy is dominated by the class nobody is looking for. Ask them what metric they would report to someone deploying this, and steer towards recall on the positive class - then note that recall alone is also gameable, by flagging everything, which is why lesson 4 needs a whole session.</a:t>
             </a:r>
           </a:p>
         </p:txBody>
@@ -6991,49 +6979,35 @@
             </a:pPr>
             <a:r>
               <a:rPr/>
-              <a:t>A timeline, with the moment of prediction marked, and everything that happens after it shaded.</a:t>
-            </a:r>
-          </a:p>
-          <a:p>
-            <a:pPr lvl="0" indent="0" marL="0">
-              <a:buNone/>
-            </a:pPr>
-          </a:p>
-          <a:p>
-            <a:pPr lvl="0" indent="0" marL="0">
-              <a:buNone/>
-            </a:pPr>
-            <a:r>
-              <a:rPr/>
-              <a:t>Walk left to right: the scan is taken, measurements are recorded - both before the prediction is needed, both usable. Then the shaded region: the diagnosis is made, the biopsy is scheduled. A model leaning on biopsy_scheduled scores beautifully in the notebook and has nothing to read at the moment it would actually be used.</a:t>
-            </a:r>
-          </a:p>
-          <a:p>
-            <a:pPr lvl="0" indent="0" marL="0">
-              <a:buNone/>
-            </a:pPr>
-          </a:p>
-          <a:p>
-            <a:pPr lvl="0" indent="0" marL="0">
-              <a:buNone/>
-            </a:pPr>
-            <a:r>
-              <a:rPr/>
-              <a:t>The shaded region is the trap: everything to the right of the marked moment happens after a prediction is needed, so none of it can be an input.</a:t>
-            </a:r>
-          </a:p>
-          <a:p>
-            <a:pPr lvl="0" indent="0" marL="0">
-              <a:buNone/>
-            </a:pPr>
-          </a:p>
-          <a:p>
-            <a:pPr lvl="0" indent="0" marL="0">
-              <a:buNone/>
-            </a:pPr>
-            <a:r>
-              <a:rPr/>
-              <a:t>The question in the title is the one to make a habit of, and it is worth saying that it cannot be answered by looking at the data. It is answered by asking somebody who knows how the data is produced. Put it to them as the thing to ask of every column in every dataset they are handed.</a:t>
+              <a:t>Two confusion matrices side by side. Give them a moment to spot that the accuracies agree to three decimal places.</a:t>
+            </a:r>
+          </a:p>
+          <a:p>
+            <a:pPr lvl="0" indent="0" marL="0">
+              <a:buNone/>
+            </a:pPr>
+          </a:p>
+          <a:p>
+            <a:pPr lvl="0" indent="0" marL="0">
+              <a:buNone/>
+            </a:pPr>
+            <a:r>
+              <a:rPr/>
+              <a:t>Left is the model that answers negative every time and has learned nothing whatever. Right is a trained model. 0.986 against 0.987 - and the one on the right finds a single positive out of twenty-one, which is barely better than nothing but is not nothing.</a:t>
+            </a:r>
+          </a:p>
+          <a:p>
+            <a:pPr lvl="0" indent="0" marL="0">
+              <a:buNone/>
+            </a:pPr>
+          </a:p>
+          <a:p>
+            <a:pPr lvl="0" indent="0" marL="0">
+              <a:buNone/>
+            </a:pPr>
+            <a:r>
+              <a:rPr/>
+              <a:t>Ask what a report containing only the accuracy would say about these two, and let the silence do the work. Then point at the bottom-left cell of each: 21 missed, then 20 missed. That is the number the application cares about, and it is the one accuracy averages away.</a:t>
             </a:r>
           </a:p>
         </p:txBody>
@@ -7115,63 +7089,49 @@
             </a:pPr>
             <a:r>
               <a:rPr/>
-              <a:t>Same model, same data, 30 different random seeds. Accuracy ranges from 0.917 to 1.000 - a spread of 0.083.</a:t>
-            </a:r>
-          </a:p>
-          <a:p>
-            <a:pPr lvl="0" indent="0" marL="0">
-              <a:buNone/>
-            </a:pPr>
-          </a:p>
-          <a:p>
-            <a:pPr lvl="0" indent="0" marL="0">
-              <a:buNone/>
-            </a:pPr>
-            <a:r>
-              <a:rPr/>
-              <a:t>That is larger than most claimed improvements between competing methods in published work. Let that land.</a:t>
-            </a:r>
-          </a:p>
-          <a:p>
-            <a:pPr lvl="0" indent="0" marL="0">
-              <a:buNone/>
-            </a:pPr>
-          </a:p>
-          <a:p>
-            <a:pPr lvl="0" indent="0" marL="0">
-              <a:buNone/>
-            </a:pPr>
-            <a:r>
-              <a:rPr/>
-              <a:t>Pick your favourite seed and you can report anything in that range, and a reader seeing one number cannot tell which you got. This is not fraud; it is the default behaviour of anyone who runs the code once.</a:t>
-            </a:r>
-          </a:p>
-          <a:p>
-            <a:pPr lvl="0" indent="0" marL="0">
-              <a:buNone/>
-            </a:pPr>
-          </a:p>
-          <a:p>
-            <a:pPr lvl="0" indent="0" marL="0">
-              <a:buNone/>
-            </a:pPr>
-            <a:r>
-              <a:rPr/>
-              <a:t>Cross-validation replaces the single draw with an average and - more usefully - reports the spread. On this data, 5-fold gives 0.960 ± 0.030.</a:t>
-            </a:r>
-          </a:p>
-          <a:p>
-            <a:pPr lvl="0" indent="0" marL="0">
-              <a:buNone/>
-            </a:pPr>
-          </a:p>
-          <a:p>
-            <a:pPr lvl="0" indent="0" marL="0">
-              <a:buNone/>
-            </a:pPr>
-            <a:r>
-              <a:rPr/>
-              <a:t>A result quoted with no indication of variability is incomplete. Lesson 5 makes this the centre of the course.</a:t>
+              <a:t>Explain why it is worthless: biopsies are scheduled once malignancy is already suspected, so the field is populated AFTER the diagnosis it is supposed to predict. At prediction time for a new patient it is empty.</a:t>
+            </a:r>
+          </a:p>
+          <a:p>
+            <a:pPr lvl="0" indent="0" marL="0">
+              <a:buNone/>
+            </a:pPr>
+          </a:p>
+          <a:p>
+            <a:pPr lvl="0" indent="0" marL="0">
+              <a:buNone/>
+            </a:pPr>
+            <a:r>
+              <a:rPr/>
+              <a:t>Then the point that makes this different from the others: no metric detects it, including cross-validated ones, because the information genuinely IS in the training data. The model is not cheating; the data is.</a:t>
+            </a:r>
+          </a:p>
+          <a:p>
+            <a:pPr lvl="0" indent="0" marL="0">
+              <a:buNone/>
+            </a:pPr>
+          </a:p>
+          <a:p>
+            <a:pPr lvl="0" indent="0" marL="0">
+              <a:buNone/>
+            </a:pPr>
+            <a:r>
+              <a:rPr/>
+              <a:t>Only knowing how the data was recorded catches it. Ask them to imagine a hospital extract with 200 columns and no documentation - which is the normal case - and to think about how they would find this.</a:t>
+            </a:r>
+          </a:p>
+          <a:p>
+            <a:pPr lvl="0" indent="0" marL="0">
+              <a:buNone/>
+            </a:pPr>
+          </a:p>
+          <a:p>
+            <a:pPr lvl="0" indent="0" marL="0">
+              <a:buNone/>
+            </a:pPr>
+            <a:r>
+              <a:rPr/>
+              <a:t>The question to carry: at the moment a prediction is needed, does this value exist yet?</a:t>
             </a:r>
           </a:p>
         </p:txBody>
@@ -7377,35 +7337,49 @@
             </a:pPr>
             <a:r>
               <a:rPr/>
-              <a:t>They are caught by asking questions about the data and the process, not by reading the metric.</a:t>
-            </a:r>
-          </a:p>
-          <a:p>
-            <a:pPr lvl="0" indent="0" marL="0">
-              <a:buNone/>
-            </a:pPr>
-          </a:p>
-          <a:p>
-            <a:pPr lvl="0" indent="0" marL="0">
-              <a:buNone/>
-            </a:pPr>
-            <a:r>
-              <a:rPr/>
-              <a:t>Give them the three questions to carry out of this room: where did this number come from, what does it leave out, and would it still hold on data I have never touched?</a:t>
-            </a:r>
-          </a:p>
-          <a:p>
-            <a:pPr lvl="0" indent="0" marL="0">
-              <a:buNone/>
-            </a:pPr>
-          </a:p>
-          <a:p>
-            <a:pPr lvl="0" indent="0" marL="0">
-              <a:buNone/>
-            </a:pPr>
-            <a:r>
-              <a:rPr/>
-              <a:t>Then the professional version, connecting back to the history section: the habit of distinguishing what was demonstrated from what was extrapolated is the same habit, applied to your own work instead of someone else’s.</a:t>
+              <a:t>A timeline, with the moment of prediction marked, and everything that happens after it shaded.</a:t>
+            </a:r>
+          </a:p>
+          <a:p>
+            <a:pPr lvl="0" indent="0" marL="0">
+              <a:buNone/>
+            </a:pPr>
+          </a:p>
+          <a:p>
+            <a:pPr lvl="0" indent="0" marL="0">
+              <a:buNone/>
+            </a:pPr>
+            <a:r>
+              <a:rPr/>
+              <a:t>Walk left to right: the scan is taken, measurements are recorded - both before the prediction is needed, both usable. Then the shaded region: the diagnosis is made, the biopsy is scheduled. A model leaning on biopsy_scheduled scores beautifully in the notebook and has nothing to read at the moment it would actually be used.</a:t>
+            </a:r>
+          </a:p>
+          <a:p>
+            <a:pPr lvl="0" indent="0" marL="0">
+              <a:buNone/>
+            </a:pPr>
+          </a:p>
+          <a:p>
+            <a:pPr lvl="0" indent="0" marL="0">
+              <a:buNone/>
+            </a:pPr>
+            <a:r>
+              <a:rPr/>
+              <a:t>The shaded region is the trap: everything to the right of the marked moment happens after a prediction is needed, so none of it can be an input.</a:t>
+            </a:r>
+          </a:p>
+          <a:p>
+            <a:pPr lvl="0" indent="0" marL="0">
+              <a:buNone/>
+            </a:pPr>
+          </a:p>
+          <a:p>
+            <a:pPr lvl="0" indent="0" marL="0">
+              <a:buNone/>
+            </a:pPr>
+            <a:r>
+              <a:rPr/>
+              <a:t>The question in the title is the one to make a habit of, and it is worth saying that it cannot be answered by looking at the data. It is answered by asking somebody who knows how the data is produced. Put it to them as the thing to ask of every column in every dataset they are handed.</a:t>
             </a:r>
           </a:p>
         </p:txBody>
@@ -7487,63 +7461,63 @@
             </a:pPr>
             <a:r>
               <a:rPr/>
-              <a:t>Close the loop with the “when not to use ML” slide. Handout section 8.</a:t>
-            </a:r>
-          </a:p>
-          <a:p>
-            <a:pPr lvl="0" indent="0" marL="0">
-              <a:buNone/>
-            </a:pPr>
-          </a:p>
-          <a:p>
-            <a:pPr lvl="0" indent="0" marL="0">
-              <a:buNone/>
-            </a:pPr>
-            <a:r>
-              <a:rPr/>
-              <a:t>If past decisions discriminated, a model fitted to them discriminates too - and it does so with an appearance of objectivity that makes it HARDER to contest than a human decision would be. “The algorithm decided” is a much harder claim to argue with than “the manager decided”.</a:t>
-            </a:r>
-          </a:p>
-          <a:p>
-            <a:pPr lvl="0" indent="0" marL="0">
-              <a:buNone/>
-            </a:pPr>
-          </a:p>
-          <a:p>
-            <a:pPr lvl="0" indent="0" marL="0">
-              <a:buNone/>
-            </a:pPr>
-            <a:r>
-              <a:rPr/>
-              <a:t>Second point: nothing in empirical risk minimisation distinguishes a cause from a coincidence that predicts well in this sample. A model can be highly accurate and completely wrong about why - which is exactly why it fails abruptly when conditions change.</a:t>
-            </a:r>
-          </a:p>
-          <a:p>
-            <a:pPr lvl="0" indent="0" marL="0">
-              <a:buNone/>
-            </a:pPr>
-          </a:p>
-          <a:p>
-            <a:pPr lvl="0" indent="0" marL="0">
-              <a:buNone/>
-            </a:pPr>
-            <a:r>
-              <a:rPr/>
-              <a:t>Third: whether a decision can be explained to the person affected, whether errors are recoverable, and who bears the cost of being wrong are engineering requirements. They belong in step 1, where they can still change what you build, not in a paragraph at the end of a report.</a:t>
-            </a:r>
-          </a:p>
-          <a:p>
-            <a:pPr lvl="0" indent="0" marL="0">
-              <a:buNone/>
-            </a:pPr>
-          </a:p>
-          <a:p>
-            <a:pPr lvl="0" indent="0" marL="0">
-              <a:buNone/>
-            </a:pPr>
-            <a:r>
-              <a:rPr/>
-              <a:t>Keep this short and serious. Do not moralise - state it and move on.</a:t>
+              <a:t>Same model, same data, 30 different random seeds. Accuracy ranges from 0.917 to 1.000 - a spread of 0.083.</a:t>
+            </a:r>
+          </a:p>
+          <a:p>
+            <a:pPr lvl="0" indent="0" marL="0">
+              <a:buNone/>
+            </a:pPr>
+          </a:p>
+          <a:p>
+            <a:pPr lvl="0" indent="0" marL="0">
+              <a:buNone/>
+            </a:pPr>
+            <a:r>
+              <a:rPr/>
+              <a:t>That is larger than most claimed improvements between competing methods in published work. Let that land.</a:t>
+            </a:r>
+          </a:p>
+          <a:p>
+            <a:pPr lvl="0" indent="0" marL="0">
+              <a:buNone/>
+            </a:pPr>
+          </a:p>
+          <a:p>
+            <a:pPr lvl="0" indent="0" marL="0">
+              <a:buNone/>
+            </a:pPr>
+            <a:r>
+              <a:rPr/>
+              <a:t>Pick your favourite seed and you can report anything in that range, and a reader seeing one number cannot tell which you got. This is not fraud; it is the default behaviour of anyone who runs the code once.</a:t>
+            </a:r>
+          </a:p>
+          <a:p>
+            <a:pPr lvl="0" indent="0" marL="0">
+              <a:buNone/>
+            </a:pPr>
+          </a:p>
+          <a:p>
+            <a:pPr lvl="0" indent="0" marL="0">
+              <a:buNone/>
+            </a:pPr>
+            <a:r>
+              <a:rPr/>
+              <a:t>Cross-validation replaces the single draw with an average and - more usefully - reports the spread. On this data, 5-fold gives 0.960 ± 0.030.</a:t>
+            </a:r>
+          </a:p>
+          <a:p>
+            <a:pPr lvl="0" indent="0" marL="0">
+              <a:buNone/>
+            </a:pPr>
+          </a:p>
+          <a:p>
+            <a:pPr lvl="0" indent="0" marL="0">
+              <a:buNone/>
+            </a:pPr>
+            <a:r>
+              <a:rPr/>
+              <a:t>A result quoted with no indication of variability is incomplete. Lesson 5 makes this the centre of the course.</a:t>
             </a:r>
           </a:p>
         </p:txBody>
@@ -7625,49 +7599,35 @@
             </a:pPr>
             <a:r>
               <a:rPr/>
-              <a:t>Set it explicitly - do not let anyone leave without knowing it exists and when it is due.</a:t>
-            </a:r>
-          </a:p>
-          <a:p>
-            <a:pPr lvl="0" indent="0" marL="0">
-              <a:buNone/>
-            </a:pPr>
-          </a:p>
-          <a:p>
-            <a:pPr lvl="0" indent="0" marL="0">
-              <a:buNone/>
-            </a:pPr>
-            <a:r>
-              <a:rPr/>
-              <a:t>Walk the tasks briefly. Task 1 is framing, and there is no single right answer: quality is an integer from 3 to 9, so they must decide how to treat it and defend the choice. Task 7 - repeat the split with ten seeds - connects directly to the figure they just saw.</a:t>
-            </a:r>
-          </a:p>
-          <a:p>
-            <a:pPr lvl="0" indent="0" marL="0">
-              <a:buNone/>
-            </a:pPr>
-          </a:p>
-          <a:p>
-            <a:pPr lvl="0" indent="0" marL="0">
-              <a:buNone/>
-            </a:pPr>
-            <a:r>
-              <a:rPr/>
-              <a:t>Remind them: scaling the full dataset before splitting loses the methodology marks regardless of the score. And there are no marks for accuracy anywhere in this course.</a:t>
-            </a:r>
-          </a:p>
-          <a:p>
-            <a:pPr lvl="0" indent="0" marL="0">
-              <a:buNone/>
-            </a:pPr>
-          </a:p>
-          <a:p>
-            <a:pPr lvl="0" indent="0" marL="0">
-              <a:buNone/>
-            </a:pPr>
-            <a:r>
-              <a:rPr/>
-              <a:t>Also point them at the quiz - 20 questions, ungraded, and the ones marked “reasoning” are the closest thing there is to the exam, because they ask why rather than what.</a:t>
+              <a:t>They are caught by asking questions about the data and the process, not by reading the metric.</a:t>
+            </a:r>
+          </a:p>
+          <a:p>
+            <a:pPr lvl="0" indent="0" marL="0">
+              <a:buNone/>
+            </a:pPr>
+          </a:p>
+          <a:p>
+            <a:pPr lvl="0" indent="0" marL="0">
+              <a:buNone/>
+            </a:pPr>
+            <a:r>
+              <a:rPr/>
+              <a:t>Give them the three questions to carry out of this room: where did this number come from, what does it leave out, and would it still hold on data I have never touched?</a:t>
+            </a:r>
+          </a:p>
+          <a:p>
+            <a:pPr lvl="0" indent="0" marL="0">
+              <a:buNone/>
+            </a:pPr>
+          </a:p>
+          <a:p>
+            <a:pPr lvl="0" indent="0" marL="0">
+              <a:buNone/>
+            </a:pPr>
+            <a:r>
+              <a:rPr/>
+              <a:t>Then the professional version, connecting back to the history section: the habit of distinguishing what was demonstrated from what was extrapolated is the same habit, applied to your own work instead of someone else’s.</a:t>
             </a:r>
           </a:p>
         </p:txBody>
@@ -7749,35 +7709,63 @@
             </a:pPr>
             <a:r>
               <a:rPr/>
-              <a:t>Close on time and offer to stay for setup problems - it is worth twenty minutes now to avoid three people stuck for a fortnight.</a:t>
-            </a:r>
-          </a:p>
-          <a:p>
-            <a:pPr lvl="0" indent="0" marL="0">
-              <a:buNone/>
-            </a:pPr>
-          </a:p>
-          <a:p>
-            <a:pPr lvl="0" indent="0" marL="0">
-              <a:buNone/>
-            </a:pPr>
-            <a:r>
-              <a:rPr/>
-              <a:t>Tell them lesson 2 goes deeper into data preparation, and that the leakage they saw today was the simple, visible version. The next one is subtler.</a:t>
-            </a:r>
-          </a:p>
-          <a:p>
-            <a:pPr lvl="0" indent="0" marL="0">
-              <a:buNone/>
-            </a:pPr>
-          </a:p>
-          <a:p>
-            <a:pPr lvl="0" indent="0" marL="0">
-              <a:buNone/>
-            </a:pPr>
-            <a:r>
-              <a:rPr/>
-              <a:t>If anyone asks what to read beyond the handout: Resources/history_of_ai.md for context, and the scikit-learn “common pitfalls” page, which is the library’s own account of everything in notebook 03.</a:t>
+              <a:t>Close the loop with the “when not to use ML” slide. Handout section 8.</a:t>
+            </a:r>
+          </a:p>
+          <a:p>
+            <a:pPr lvl="0" indent="0" marL="0">
+              <a:buNone/>
+            </a:pPr>
+          </a:p>
+          <a:p>
+            <a:pPr lvl="0" indent="0" marL="0">
+              <a:buNone/>
+            </a:pPr>
+            <a:r>
+              <a:rPr/>
+              <a:t>If past decisions discriminated, a model fitted to them discriminates too - and it does so with an appearance of objectivity that makes it HARDER to contest than a human decision would be. “The algorithm decided” is a much harder claim to argue with than “the manager decided”.</a:t>
+            </a:r>
+          </a:p>
+          <a:p>
+            <a:pPr lvl="0" indent="0" marL="0">
+              <a:buNone/>
+            </a:pPr>
+          </a:p>
+          <a:p>
+            <a:pPr lvl="0" indent="0" marL="0">
+              <a:buNone/>
+            </a:pPr>
+            <a:r>
+              <a:rPr/>
+              <a:t>Second point: nothing in empirical risk minimisation distinguishes a cause from a coincidence that predicts well in this sample. A model can be highly accurate and completely wrong about why - which is exactly why it fails abruptly when conditions change.</a:t>
+            </a:r>
+          </a:p>
+          <a:p>
+            <a:pPr lvl="0" indent="0" marL="0">
+              <a:buNone/>
+            </a:pPr>
+          </a:p>
+          <a:p>
+            <a:pPr lvl="0" indent="0" marL="0">
+              <a:buNone/>
+            </a:pPr>
+            <a:r>
+              <a:rPr/>
+              <a:t>Third: whether a decision can be explained to the person affected, whether errors are recoverable, and who bears the cost of being wrong are engineering requirements. They belong in step 1, where they can still change what you build, not in a paragraph at the end of a report.</a:t>
+            </a:r>
+          </a:p>
+          <a:p>
+            <a:pPr lvl="0" indent="0" marL="0">
+              <a:buNone/>
+            </a:pPr>
+          </a:p>
+          <a:p>
+            <a:pPr lvl="0" indent="0" marL="0">
+              <a:buNone/>
+            </a:pPr>
+            <a:r>
+              <a:rPr/>
+              <a:t>Keep this short and serious. Do not moralise - state it and move on.</a:t>
             </a:r>
           </a:p>
         </p:txBody>
@@ -7800,6 +7788,240 @@
             <a:fld id="{18BDFEC3-8487-43E8-A154-7C12CBC1FFF2}" type="slidenum">
               <a:rPr lang="en-US"/>
               <a:t>64</a:t>
+            </a:fld>
+            <a:endParaRPr lang="en-US"/>
+          </a:p>
+        </p:txBody>
+      </p:sp>
+    </p:spTree>
+  </p:cSld>
+</p:notes>
+</file>
+
+<file path=ppt/notesSlides/notesSlide64.xml><?xml version="1.0" encoding="utf-8"?>
+<p:notes xmlns:a="http://schemas.openxmlformats.org/drawingml/2006/main" xmlns:r="http://schemas.openxmlformats.org/officeDocument/2006/relationships" xmlns:p="http://schemas.openxmlformats.org/presentationml/2006/main">
+  <p:cSld>
+    <p:spTree>
+      <p:nvGrpSpPr>
+        <p:cNvPr id="1" name=""/>
+        <p:cNvGrpSpPr/>
+        <p:nvPr/>
+      </p:nvGrpSpPr>
+      <p:grpSpPr>
+        <a:xfrm>
+          <a:off x="0" y="0"/>
+          <a:ext cx="0" cy="0"/>
+          <a:chOff x="0" y="0"/>
+          <a:chExt cx="0" cy="0"/>
+        </a:xfrm>
+      </p:grpSpPr>
+      <p:sp>
+        <p:nvSpPr>
+          <p:cNvPr id="2" name="Slide Image Placeholder 1"/>
+          <p:cNvSpPr>
+            <a:spLocks noGrp="1" noRot="1" noChangeAspect="1"/>
+          </p:cNvSpPr>
+          <p:nvPr>
+            <p:ph type="sldImg"/>
+          </p:nvPr>
+        </p:nvSpPr>
+        <p:spPr/>
+      </p:sp>
+      <p:sp>
+        <p:nvSpPr>
+          <p:cNvPr id="3" name="Notes Placeholder 2"/>
+          <p:cNvSpPr>
+            <a:spLocks noGrp="1"/>
+          </p:cNvSpPr>
+          <p:nvPr>
+            <p:ph type="body" idx="1"/>
+          </p:nvPr>
+        </p:nvSpPr>
+        <p:spPr/>
+        <p:txBody>
+          <a:bodyPr/>
+          <a:lstStyle/>
+          <a:p>
+            <a:pPr lvl="0" indent="0" marL="0">
+              <a:buNone/>
+            </a:pPr>
+            <a:r>
+              <a:rPr/>
+              <a:t>Set it explicitly - do not let anyone leave without knowing it exists and when it is due.</a:t>
+            </a:r>
+          </a:p>
+          <a:p>
+            <a:pPr lvl="0" indent="0" marL="0">
+              <a:buNone/>
+            </a:pPr>
+          </a:p>
+          <a:p>
+            <a:pPr lvl="0" indent="0" marL="0">
+              <a:buNone/>
+            </a:pPr>
+            <a:r>
+              <a:rPr/>
+              <a:t>Walk the tasks briefly. Task 1 is framing, and there is no single right answer: quality is an integer from 3 to 9, so they must decide how to treat it and defend the choice. Task 7 - repeat the split with ten seeds - connects directly to the figure they just saw.</a:t>
+            </a:r>
+          </a:p>
+          <a:p>
+            <a:pPr lvl="0" indent="0" marL="0">
+              <a:buNone/>
+            </a:pPr>
+          </a:p>
+          <a:p>
+            <a:pPr lvl="0" indent="0" marL="0">
+              <a:buNone/>
+            </a:pPr>
+            <a:r>
+              <a:rPr/>
+              <a:t>Remind them: scaling the full dataset before splitting loses the methodology marks regardless of the score. And there are no marks for accuracy anywhere in this course.</a:t>
+            </a:r>
+          </a:p>
+          <a:p>
+            <a:pPr lvl="0" indent="0" marL="0">
+              <a:buNone/>
+            </a:pPr>
+          </a:p>
+          <a:p>
+            <a:pPr lvl="0" indent="0" marL="0">
+              <a:buNone/>
+            </a:pPr>
+            <a:r>
+              <a:rPr/>
+              <a:t>Also point them at the quiz - 20 questions, ungraded, and the ones marked “reasoning” are the closest thing there is to the exam, because they ask why rather than what.</a:t>
+            </a:r>
+          </a:p>
+        </p:txBody>
+      </p:sp>
+      <p:sp>
+        <p:nvSpPr>
+          <p:cNvPr id="4" name="Slide Number Placeholder 3"/>
+          <p:cNvSpPr>
+            <a:spLocks noGrp="1"/>
+          </p:cNvSpPr>
+          <p:nvPr>
+            <p:ph type="sldNum" sz="quarter" idx="10"/>
+          </p:nvPr>
+        </p:nvSpPr>
+        <p:spPr/>
+        <p:txBody>
+          <a:bodyPr/>
+          <a:lstStyle/>
+          <a:p>
+            <a:fld id="{18BDFEC3-8487-43E8-A154-7C12CBC1FFF2}" type="slidenum">
+              <a:rPr lang="en-US"/>
+              <a:t>65</a:t>
+            </a:fld>
+            <a:endParaRPr lang="en-US"/>
+          </a:p>
+        </p:txBody>
+      </p:sp>
+    </p:spTree>
+  </p:cSld>
+</p:notes>
+</file>
+
+<file path=ppt/notesSlides/notesSlide65.xml><?xml version="1.0" encoding="utf-8"?>
+<p:notes xmlns:a="http://schemas.openxmlformats.org/drawingml/2006/main" xmlns:r="http://schemas.openxmlformats.org/officeDocument/2006/relationships" xmlns:p="http://schemas.openxmlformats.org/presentationml/2006/main">
+  <p:cSld>
+    <p:spTree>
+      <p:nvGrpSpPr>
+        <p:cNvPr id="1" name=""/>
+        <p:cNvGrpSpPr/>
+        <p:nvPr/>
+      </p:nvGrpSpPr>
+      <p:grpSpPr>
+        <a:xfrm>
+          <a:off x="0" y="0"/>
+          <a:ext cx="0" cy="0"/>
+          <a:chOff x="0" y="0"/>
+          <a:chExt cx="0" cy="0"/>
+        </a:xfrm>
+      </p:grpSpPr>
+      <p:sp>
+        <p:nvSpPr>
+          <p:cNvPr id="2" name="Slide Image Placeholder 1"/>
+          <p:cNvSpPr>
+            <a:spLocks noGrp="1" noRot="1" noChangeAspect="1"/>
+          </p:cNvSpPr>
+          <p:nvPr>
+            <p:ph type="sldImg"/>
+          </p:nvPr>
+        </p:nvSpPr>
+        <p:spPr/>
+      </p:sp>
+      <p:sp>
+        <p:nvSpPr>
+          <p:cNvPr id="3" name="Notes Placeholder 2"/>
+          <p:cNvSpPr>
+            <a:spLocks noGrp="1"/>
+          </p:cNvSpPr>
+          <p:nvPr>
+            <p:ph type="body" idx="1"/>
+          </p:nvPr>
+        </p:nvSpPr>
+        <p:spPr/>
+        <p:txBody>
+          <a:bodyPr/>
+          <a:lstStyle/>
+          <a:p>
+            <a:pPr lvl="0" indent="0" marL="0">
+              <a:buNone/>
+            </a:pPr>
+            <a:r>
+              <a:rPr/>
+              <a:t>Close on time and offer to stay for setup problems - it is worth twenty minutes now to avoid three people stuck for a fortnight.</a:t>
+            </a:r>
+          </a:p>
+          <a:p>
+            <a:pPr lvl="0" indent="0" marL="0">
+              <a:buNone/>
+            </a:pPr>
+          </a:p>
+          <a:p>
+            <a:pPr lvl="0" indent="0" marL="0">
+              <a:buNone/>
+            </a:pPr>
+            <a:r>
+              <a:rPr/>
+              <a:t>Tell them lesson 2 goes deeper into data preparation, and that the leakage they saw today was the simple, visible version. The next one is subtler.</a:t>
+            </a:r>
+          </a:p>
+          <a:p>
+            <a:pPr lvl="0" indent="0" marL="0">
+              <a:buNone/>
+            </a:pPr>
+          </a:p>
+          <a:p>
+            <a:pPr lvl="0" indent="0" marL="0">
+              <a:buNone/>
+            </a:pPr>
+            <a:r>
+              <a:rPr/>
+              <a:t>If anyone asks what to read beyond the handout: Resources/history_of_ai.md for context, and the scikit-learn “common pitfalls” page, which is the library’s own account of everything in notebook 03.</a:t>
+            </a:r>
+          </a:p>
+        </p:txBody>
+      </p:sp>
+      <p:sp>
+        <p:nvSpPr>
+          <p:cNvPr id="4" name="Slide Number Placeholder 3"/>
+          <p:cNvSpPr>
+            <a:spLocks noGrp="1"/>
+          </p:cNvSpPr>
+          <p:nvPr>
+            <p:ph type="sldNum" sz="quarter" idx="10"/>
+          </p:nvPr>
+        </p:nvSpPr>
+        <p:spPr/>
+        <p:txBody>
+          <a:bodyPr/>
+          <a:lstStyle/>
+          <a:p>
+            <a:fld id="{18BDFEC3-8487-43E8-A154-7C12CBC1FFF2}" type="slidenum">
+              <a:rPr lang="en-US"/>
+              <a:t>66</a:t>
             </a:fld>
             <a:endParaRPr lang="en-US"/>
           </a:p>
@@ -15564,7 +15786,7 @@
             </a:pPr>
             <a:r>
               <a:rPr/>
-              <a:t>Step 1: frame it</a:t>
+              <a:t>Notebook 1, live</a:t>
             </a:r>
           </a:p>
         </p:txBody>
@@ -15589,24 +15811,12 @@
           <a:bodyPr/>
           <a:lstStyle/>
           <a:p>
-            <a:pPr lvl="0"/>
-            <a:r>
-              <a:rPr/>
-              <a:t>What is predicted, from what?</a:t>
-            </a:r>
-          </a:p>
-          <a:p>
-            <a:pPr lvl="0"/>
-            <a:r>
-              <a:rPr/>
-              <a:t>Who would use it, for what decision?</a:t>
-            </a:r>
-          </a:p>
-          <a:p>
-            <a:pPr lvl="0"/>
-            <a:r>
-              <a:rPr b="1"/>
-              <a:t>Which error is worse?</a:t>
+            <a:pPr lvl="0" indent="0" marL="0">
+              <a:buNone/>
+            </a:pPr>
+            <a:r>
+              <a:rPr/>
+              <a:t>A question, a dataset, a split, a baseline, a model, and a number you can defend.</a:t>
             </a:r>
           </a:p>
         </p:txBody>
@@ -15617,6 +15827,100 @@
 </file>
 
 <file path=ppt/slides/slide41.xml><?xml version="1.0" encoding="utf-8"?>
+<p:sld xmlns:a="http://schemas.openxmlformats.org/drawingml/2006/main" xmlns:r="http://schemas.openxmlformats.org/officeDocument/2006/relationships" xmlns:p="http://schemas.openxmlformats.org/presentationml/2006/main">
+  <p:cSld>
+    <p:spTree>
+      <p:nvGrpSpPr>
+        <p:cNvPr id="1" name=""/>
+        <p:cNvGrpSpPr/>
+        <p:nvPr/>
+      </p:nvGrpSpPr>
+      <p:grpSpPr>
+        <a:xfrm>
+          <a:off x="0" y="0"/>
+          <a:ext cx="0" cy="0"/>
+          <a:chOff x="0" y="0"/>
+          <a:chExt cx="0" cy="0"/>
+        </a:xfrm>
+      </p:grpSpPr>
+      <p:sp>
+        <p:nvSpPr>
+          <p:cNvPr id="2" name="Title 1"/>
+          <p:cNvSpPr>
+            <a:spLocks noGrp="1"/>
+          </p:cNvSpPr>
+          <p:nvPr>
+            <p:ph type="title"/>
+          </p:nvPr>
+        </p:nvSpPr>
+        <p:spPr>
+          <a:xfrm>
+            <a:off x="457200" y="205979"/>
+            <a:ext cx="8229600" cy="857250"/>
+          </a:xfrm>
+        </p:spPr>
+        <p:txBody>
+          <a:bodyPr/>
+          <a:lstStyle/>
+          <a:p>
+            <a:pPr lvl="0" indent="0" marL="0">
+              <a:buNone/>
+            </a:pPr>
+            <a:r>
+              <a:rPr/>
+              <a:t>Step 1: frame it</a:t>
+            </a:r>
+          </a:p>
+        </p:txBody>
+      </p:sp>
+      <p:sp>
+        <p:nvSpPr>
+          <p:cNvPr id="3" name="Content Placeholder 2"/>
+          <p:cNvSpPr>
+            <a:spLocks noGrp="1"/>
+          </p:cNvSpPr>
+          <p:nvPr>
+            <p:ph idx="1"/>
+          </p:nvPr>
+        </p:nvSpPr>
+        <p:spPr>
+          <a:xfrm>
+            <a:off x="457200" y="1200151"/>
+            <a:ext cx="8229600" cy="3394472"/>
+          </a:xfrm>
+        </p:spPr>
+        <p:txBody>
+          <a:bodyPr/>
+          <a:lstStyle/>
+          <a:p>
+            <a:pPr lvl="0"/>
+            <a:r>
+              <a:rPr/>
+              <a:t>What is predicted, from what?</a:t>
+            </a:r>
+          </a:p>
+          <a:p>
+            <a:pPr lvl="0"/>
+            <a:r>
+              <a:rPr/>
+              <a:t>Who would use it, for what decision?</a:t>
+            </a:r>
+          </a:p>
+          <a:p>
+            <a:pPr lvl="0"/>
+            <a:r>
+              <a:rPr b="1"/>
+              <a:t>Which error is worse?</a:t>
+            </a:r>
+          </a:p>
+        </p:txBody>
+      </p:sp>
+    </p:spTree>
+  </p:cSld>
+</p:sld>
+</file>
+
+<file path=ppt/slides/slide42.xml><?xml version="1.0" encoding="utf-8"?>
 <p:sld xmlns:a="http://schemas.openxmlformats.org/drawingml/2006/main" xmlns:r="http://schemas.openxmlformats.org/officeDocument/2006/relationships" xmlns:p="http://schemas.openxmlformats.org/presentationml/2006/main">
   <p:cSld>
     <p:spTree>
@@ -15698,7 +16002,7 @@
 </p:sld>
 </file>
 
-<file path=ppt/slides/slide42.xml><?xml version="1.0" encoding="utf-8"?>
+<file path=ppt/slides/slide43.xml><?xml version="1.0" encoding="utf-8"?>
 <p:sld xmlns:a="http://schemas.openxmlformats.org/drawingml/2006/main" xmlns:r="http://schemas.openxmlformats.org/officeDocument/2006/relationships" xmlns:p="http://schemas.openxmlformats.org/presentationml/2006/main">
   <p:cSld>
     <p:spTree>
@@ -15780,7 +16084,7 @@
 </p:sld>
 </file>
 
-<file path=ppt/slides/slide43.xml><?xml version="1.0" encoding="utf-8"?>
+<file path=ppt/slides/slide44.xml><?xml version="1.0" encoding="utf-8"?>
 <p:sld xmlns:a="http://schemas.openxmlformats.org/drawingml/2006/main" xmlns:r="http://schemas.openxmlformats.org/officeDocument/2006/relationships" xmlns:p="http://schemas.openxmlformats.org/presentationml/2006/main">
   <p:cSld>
     <p:spTree>
@@ -15892,106 +16196,6 @@
 </p:sld>
 </file>
 
-<file path=ppt/slides/slide44.xml><?xml version="1.0" encoding="utf-8"?>
-<p:sld xmlns:a="http://schemas.openxmlformats.org/drawingml/2006/main" xmlns:r="http://schemas.openxmlformats.org/officeDocument/2006/relationships" xmlns:p="http://schemas.openxmlformats.org/presentationml/2006/main">
-  <p:cSld>
-    <p:spTree>
-      <p:nvGrpSpPr>
-        <p:cNvPr id="1" name=""/>
-        <p:cNvGrpSpPr/>
-        <p:nvPr/>
-      </p:nvGrpSpPr>
-      <p:grpSpPr>
-        <a:xfrm>
-          <a:off x="0" y="0"/>
-          <a:ext cx="0" cy="0"/>
-          <a:chOff x="0" y="0"/>
-          <a:chExt cx="0" cy="0"/>
-        </a:xfrm>
-      </p:grpSpPr>
-      <p:sp>
-        <p:nvSpPr>
-          <p:cNvPr id="2" name="Title 1"/>
-          <p:cNvSpPr>
-            <a:spLocks noGrp="1"/>
-          </p:cNvSpPr>
-          <p:nvPr>
-            <p:ph type="title"/>
-          </p:nvPr>
-        </p:nvSpPr>
-        <p:spPr>
-          <a:xfrm>
-            <a:off x="457200" y="205979"/>
-            <a:ext cx="8229600" cy="857250"/>
-          </a:xfrm>
-        </p:spPr>
-        <p:txBody>
-          <a:bodyPr/>
-          <a:lstStyle/>
-          <a:p>
-            <a:pPr lvl="0" indent="0" marL="0">
-              <a:buNone/>
-            </a:pPr>
-            <a:r>
-              <a:rPr/>
-              <a:t>Step 4: baseline first</a:t>
-            </a:r>
-          </a:p>
-        </p:txBody>
-      </p:sp>
-      <p:sp>
-        <p:nvSpPr>
-          <p:cNvPr id="3" name="Content Placeholder 2"/>
-          <p:cNvSpPr>
-            <a:spLocks noGrp="1"/>
-          </p:cNvSpPr>
-          <p:nvPr>
-            <p:ph idx="1"/>
-          </p:nvPr>
-        </p:nvSpPr>
-        <p:spPr>
-          <a:xfrm>
-            <a:off x="457200" y="1200151"/>
-            <a:ext cx="8229600" cy="3394472"/>
-          </a:xfrm>
-        </p:spPr>
-        <p:txBody>
-          <a:bodyPr/>
-          <a:lstStyle/>
-          <a:p>
-            <a:pPr lvl="0" indent="0" marL="0">
-              <a:buNone/>
-            </a:pPr>
-            <a:r>
-              <a:rPr/>
-              <a:t>Predict the majority class. Nothing else.</a:t>
-            </a:r>
-          </a:p>
-          <a:p>
-            <a:pPr lvl="0" indent="0" marL="0">
-              <a:buNone/>
-            </a:pPr>
-            <a:r>
-              <a:rPr b="1"/>
-              <a:t>62.7%</a:t>
-            </a:r>
-          </a:p>
-          <a:p>
-            <a:pPr lvl="0" indent="0" marL="0">
-              <a:buNone/>
-            </a:pPr>
-            <a:r>
-              <a:rPr/>
-              <a:t>Everything from here is measured against that.</a:t>
-            </a:r>
-          </a:p>
-        </p:txBody>
-      </p:sp>
-    </p:spTree>
-  </p:cSld>
-</p:sld>
-</file>
-
 <file path=ppt/slides/slide45.xml><?xml version="1.0" encoding="utf-8"?>
 <p:sld xmlns:a="http://schemas.openxmlformats.org/drawingml/2006/main" xmlns:r="http://schemas.openxmlformats.org/officeDocument/2006/relationships" xmlns:p="http://schemas.openxmlformats.org/presentationml/2006/main">
   <p:cSld>
@@ -16034,6 +16238,106 @@
             </a:pPr>
             <a:r>
               <a:rPr/>
+              <a:t>Step 4: baseline first</a:t>
+            </a:r>
+          </a:p>
+        </p:txBody>
+      </p:sp>
+      <p:sp>
+        <p:nvSpPr>
+          <p:cNvPr id="3" name="Content Placeholder 2"/>
+          <p:cNvSpPr>
+            <a:spLocks noGrp="1"/>
+          </p:cNvSpPr>
+          <p:nvPr>
+            <p:ph idx="1"/>
+          </p:nvPr>
+        </p:nvSpPr>
+        <p:spPr>
+          <a:xfrm>
+            <a:off x="457200" y="1200151"/>
+            <a:ext cx="8229600" cy="3394472"/>
+          </a:xfrm>
+        </p:spPr>
+        <p:txBody>
+          <a:bodyPr/>
+          <a:lstStyle/>
+          <a:p>
+            <a:pPr lvl="0" indent="0" marL="0">
+              <a:buNone/>
+            </a:pPr>
+            <a:r>
+              <a:rPr/>
+              <a:t>Predict the majority class. Nothing else.</a:t>
+            </a:r>
+          </a:p>
+          <a:p>
+            <a:pPr lvl="0" indent="0" marL="0">
+              <a:buNone/>
+            </a:pPr>
+            <a:r>
+              <a:rPr b="1"/>
+              <a:t>62.7%</a:t>
+            </a:r>
+          </a:p>
+          <a:p>
+            <a:pPr lvl="0" indent="0" marL="0">
+              <a:buNone/>
+            </a:pPr>
+            <a:r>
+              <a:rPr/>
+              <a:t>Everything from here is measured against that.</a:t>
+            </a:r>
+          </a:p>
+        </p:txBody>
+      </p:sp>
+    </p:spTree>
+  </p:cSld>
+</p:sld>
+</file>
+
+<file path=ppt/slides/slide46.xml><?xml version="1.0" encoding="utf-8"?>
+<p:sld xmlns:a="http://schemas.openxmlformats.org/drawingml/2006/main" xmlns:r="http://schemas.openxmlformats.org/officeDocument/2006/relationships" xmlns:p="http://schemas.openxmlformats.org/presentationml/2006/main">
+  <p:cSld>
+    <p:spTree>
+      <p:nvGrpSpPr>
+        <p:cNvPr id="1" name=""/>
+        <p:cNvGrpSpPr/>
+        <p:nvPr/>
+      </p:nvGrpSpPr>
+      <p:grpSpPr>
+        <a:xfrm>
+          <a:off x="0" y="0"/>
+          <a:ext cx="0" cy="0"/>
+          <a:chOff x="0" y="0"/>
+          <a:chExt cx="0" cy="0"/>
+        </a:xfrm>
+      </p:grpSpPr>
+      <p:sp>
+        <p:nvSpPr>
+          <p:cNvPr id="2" name="Title 1"/>
+          <p:cNvSpPr>
+            <a:spLocks noGrp="1"/>
+          </p:cNvSpPr>
+          <p:nvPr>
+            <p:ph type="title"/>
+          </p:nvPr>
+        </p:nvSpPr>
+        <p:spPr>
+          <a:xfrm>
+            <a:off x="457200" y="205979"/>
+            <a:ext cx="8229600" cy="857250"/>
+          </a:xfrm>
+        </p:spPr>
+        <p:txBody>
+          <a:bodyPr/>
+          <a:lstStyle/>
+          <a:p>
+            <a:pPr lvl="0" indent="0" marL="0">
+              <a:buNone/>
+            </a:pPr>
+            <a:r>
+              <a:rPr/>
               <a:t>Step 5: pipeline, not two steps</a:t>
             </a:r>
           </a:p>
@@ -16143,7 +16447,7 @@
 </p:sld>
 </file>
 
-<file path=ppt/slides/slide46.xml><?xml version="1.0" encoding="utf-8"?>
+<file path=ppt/slides/slide47.xml><?xml version="1.0" encoding="utf-8"?>
 <p:sld xmlns:a="http://schemas.openxmlformats.org/drawingml/2006/main" xmlns:r="http://schemas.openxmlformats.org/officeDocument/2006/relationships" xmlns:p="http://schemas.openxmlformats.org/presentationml/2006/main">
   <p:cSld>
     <p:spTree>
@@ -16225,7 +16529,7 @@
 </p:sld>
 </file>
 
-<file path=ppt/slides/slide47.xml><?xml version="1.0" encoding="utf-8"?>
+<file path=ppt/slides/slide48.xml><?xml version="1.0" encoding="utf-8"?>
 <p:sld xmlns:a="http://schemas.openxmlformats.org/drawingml/2006/main" xmlns:r="http://schemas.openxmlformats.org/officeDocument/2006/relationships" xmlns:p="http://schemas.openxmlformats.org/presentationml/2006/main">
   <p:cSld>
     <p:spTree>
@@ -16325,7 +16629,7 @@
 </p:sld>
 </file>
 
-<file path=ppt/slides/slide48.xml><?xml version="1.0" encoding="utf-8"?>
+<file path=ppt/slides/slide49.xml><?xml version="1.0" encoding="utf-8"?>
 <p:sld xmlns:a="http://schemas.openxmlformats.org/drawingml/2006/main" xmlns:r="http://schemas.openxmlformats.org/officeDocument/2006/relationships" xmlns:p="http://schemas.openxmlformats.org/presentationml/2006/main">
   <p:cSld>
     <p:spTree>
@@ -16407,108 +16711,6 @@
 </p:sld>
 </file>
 
-<file path=ppt/slides/slide49.xml><?xml version="1.0" encoding="utf-8"?>
-<p:sld xmlns:a="http://schemas.openxmlformats.org/drawingml/2006/main" xmlns:r="http://schemas.openxmlformats.org/officeDocument/2006/relationships" xmlns:p="http://schemas.openxmlformats.org/presentationml/2006/main">
-  <p:cSld>
-    <p:spTree>
-      <p:nvGrpSpPr>
-        <p:cNvPr id="1" name=""/>
-        <p:cNvGrpSpPr/>
-        <p:nvPr/>
-      </p:nvGrpSpPr>
-      <p:grpSpPr>
-        <a:xfrm>
-          <a:off x="0" y="0"/>
-          <a:ext cx="0" cy="0"/>
-          <a:chOff x="0" y="0"/>
-          <a:chExt cx="0" cy="0"/>
-        </a:xfrm>
-      </p:grpSpPr>
-      <p:sp>
-        <p:nvSpPr>
-          <p:cNvPr id="2" name="Title 1"/>
-          <p:cNvSpPr>
-            <a:spLocks noGrp="1"/>
-          </p:cNvSpPr>
-          <p:nvPr>
-            <p:ph type="title"/>
-          </p:nvPr>
-        </p:nvSpPr>
-        <p:spPr>
-          <a:xfrm>
-            <a:off x="457200" y="205979"/>
-            <a:ext cx="8229600" cy="857250"/>
-          </a:xfrm>
-        </p:spPr>
-        <p:txBody>
-          <a:bodyPr/>
-          <a:lstStyle/>
-          <a:p>
-            <a:pPr lvl="0" indent="0" marL="0">
-              <a:buNone/>
-            </a:pPr>
-            <a:r>
-              <a:rPr/>
-              <a:t>Precision and recall</a:t>
-            </a:r>
-          </a:p>
-        </p:txBody>
-      </p:sp>
-      <p:sp>
-        <p:nvSpPr>
-          <p:cNvPr id="3" name="Content Placeholder 2"/>
-          <p:cNvSpPr>
-            <a:spLocks noGrp="1"/>
-          </p:cNvSpPr>
-          <p:nvPr>
-            <p:ph idx="1"/>
-          </p:nvPr>
-        </p:nvSpPr>
-        <p:spPr>
-          <a:xfrm>
-            <a:off x="457200" y="1200151"/>
-            <a:ext cx="8229600" cy="3394472"/>
-          </a:xfrm>
-        </p:spPr>
-        <p:txBody>
-          <a:bodyPr/>
-          <a:lstStyle/>
-          <a:p>
-            <a:pPr lvl="0"/>
-            <a:r>
-              <a:rPr b="1"/>
-              <a:t>Recall</a:t>
-            </a:r>
-            <a:r>
-              <a:rPr/>
-              <a:t> (malignant): how many malignant tumours we caught</a:t>
-            </a:r>
-          </a:p>
-          <a:p>
-            <a:pPr lvl="0"/>
-            <a:r>
-              <a:rPr b="1"/>
-              <a:t>Precision</a:t>
-            </a:r>
-            <a:r>
-              <a:rPr/>
-              <a:t> (malignant): how often an alert is correct</a:t>
-            </a:r>
-          </a:p>
-          <a:p>
-            <a:pPr lvl="0"/>
-            <a:r>
-              <a:rPr/>
-              <a:t>They trade off against each other</a:t>
-            </a:r>
-          </a:p>
-        </p:txBody>
-      </p:sp>
-    </p:spTree>
-  </p:cSld>
-</p:sld>
-</file>
-
 <file path=ppt/slides/slide5.xml><?xml version="1.0" encoding="utf-8"?>
 <p:sld xmlns:a="http://schemas.openxmlformats.org/drawingml/2006/main" xmlns:r="http://schemas.openxmlformats.org/officeDocument/2006/relationships" xmlns:p="http://schemas.openxmlformats.org/presentationml/2006/main">
   <p:cSld>
@@ -16609,6 +16811,108 @@
 </file>
 
 <file path=ppt/slides/slide50.xml><?xml version="1.0" encoding="utf-8"?>
+<p:sld xmlns:a="http://schemas.openxmlformats.org/drawingml/2006/main" xmlns:r="http://schemas.openxmlformats.org/officeDocument/2006/relationships" xmlns:p="http://schemas.openxmlformats.org/presentationml/2006/main">
+  <p:cSld>
+    <p:spTree>
+      <p:nvGrpSpPr>
+        <p:cNvPr id="1" name=""/>
+        <p:cNvGrpSpPr/>
+        <p:nvPr/>
+      </p:nvGrpSpPr>
+      <p:grpSpPr>
+        <a:xfrm>
+          <a:off x="0" y="0"/>
+          <a:ext cx="0" cy="0"/>
+          <a:chOff x="0" y="0"/>
+          <a:chExt cx="0" cy="0"/>
+        </a:xfrm>
+      </p:grpSpPr>
+      <p:sp>
+        <p:nvSpPr>
+          <p:cNvPr id="2" name="Title 1"/>
+          <p:cNvSpPr>
+            <a:spLocks noGrp="1"/>
+          </p:cNvSpPr>
+          <p:nvPr>
+            <p:ph type="title"/>
+          </p:nvPr>
+        </p:nvSpPr>
+        <p:spPr>
+          <a:xfrm>
+            <a:off x="457200" y="205979"/>
+            <a:ext cx="8229600" cy="857250"/>
+          </a:xfrm>
+        </p:spPr>
+        <p:txBody>
+          <a:bodyPr/>
+          <a:lstStyle/>
+          <a:p>
+            <a:pPr lvl="0" indent="0" marL="0">
+              <a:buNone/>
+            </a:pPr>
+            <a:r>
+              <a:rPr/>
+              <a:t>Precision and recall</a:t>
+            </a:r>
+          </a:p>
+        </p:txBody>
+      </p:sp>
+      <p:sp>
+        <p:nvSpPr>
+          <p:cNvPr id="3" name="Content Placeholder 2"/>
+          <p:cNvSpPr>
+            <a:spLocks noGrp="1"/>
+          </p:cNvSpPr>
+          <p:nvPr>
+            <p:ph idx="1"/>
+          </p:nvPr>
+        </p:nvSpPr>
+        <p:spPr>
+          <a:xfrm>
+            <a:off x="457200" y="1200151"/>
+            <a:ext cx="8229600" cy="3394472"/>
+          </a:xfrm>
+        </p:spPr>
+        <p:txBody>
+          <a:bodyPr/>
+          <a:lstStyle/>
+          <a:p>
+            <a:pPr lvl="0"/>
+            <a:r>
+              <a:rPr b="1"/>
+              <a:t>Recall</a:t>
+            </a:r>
+            <a:r>
+              <a:rPr/>
+              <a:t> (malignant): how many malignant tumours we caught</a:t>
+            </a:r>
+          </a:p>
+          <a:p>
+            <a:pPr lvl="0"/>
+            <a:r>
+              <a:rPr b="1"/>
+              <a:t>Precision</a:t>
+            </a:r>
+            <a:r>
+              <a:rPr/>
+              <a:t> (malignant): how often an alert is correct</a:t>
+            </a:r>
+          </a:p>
+          <a:p>
+            <a:pPr lvl="0"/>
+            <a:r>
+              <a:rPr/>
+              <a:t>They trade off against each other</a:t>
+            </a:r>
+          </a:p>
+        </p:txBody>
+      </p:sp>
+    </p:spTree>
+  </p:cSld>
+</p:sld>
+</file>
+
+<file path=ppt/slides/slide51.xml><?xml version="1.0" encoding="utf-8"?>
 <p:sld xmlns:a="http://schemas.openxmlformats.org/drawingml/2006/main" xmlns:r="http://schemas.openxmlformats.org/officeDocument/2006/relationships" xmlns:p="http://schemas.openxmlformats.org/presentationml/2006/main">
   <p:cSld>
     <p:spTree>
@@ -16690,109 +16994,6 @@
 </p:sld>
 </file>
 
-<file path=ppt/slides/slide51.xml><?xml version="1.0" encoding="utf-8"?>
-<p:sld xmlns:a="http://schemas.openxmlformats.org/drawingml/2006/main" xmlns:r="http://schemas.openxmlformats.org/officeDocument/2006/relationships" xmlns:p="http://schemas.openxmlformats.org/presentationml/2006/main">
-  <p:cSld>
-    <p:spTree>
-      <p:nvGrpSpPr>
-        <p:cNvPr id="1" name=""/>
-        <p:cNvGrpSpPr/>
-        <p:nvPr/>
-      </p:nvGrpSpPr>
-      <p:grpSpPr>
-        <a:xfrm>
-          <a:off x="0" y="0"/>
-          <a:ext cx="0" cy="0"/>
-          <a:chOff x="0" y="0"/>
-          <a:chExt cx="0" cy="0"/>
-        </a:xfrm>
-      </p:grpSpPr>
-      <p:sp>
-        <p:nvSpPr>
-          <p:cNvPr id="2" name="Title 1"/>
-          <p:cNvSpPr>
-            <a:spLocks noGrp="1"/>
-          </p:cNvSpPr>
-          <p:nvPr>
-            <p:ph type="title"/>
-          </p:nvPr>
-        </p:nvSpPr>
-        <p:spPr>
-          <a:xfrm>
-            <a:off x="457200" y="205979"/>
-            <a:ext cx="8229600" cy="857250"/>
-          </a:xfrm>
-        </p:spPr>
-        <p:txBody>
-          <a:bodyPr/>
-          <a:lstStyle/>
-          <a:p>
-            <a:pPr lvl="0" indent="0" marL="0">
-              <a:buNone/>
-            </a:pPr>
-            <a:r>
-              <a:rPr/>
-              <a:t>What we did not do</a:t>
-            </a:r>
-          </a:p>
-        </p:txBody>
-      </p:sp>
-      <p:sp>
-        <p:nvSpPr>
-          <p:cNvPr id="3" name="Content Placeholder 2"/>
-          <p:cNvSpPr>
-            <a:spLocks noGrp="1"/>
-          </p:cNvSpPr>
-          <p:nvPr>
-            <p:ph idx="1"/>
-          </p:nvPr>
-        </p:nvSpPr>
-        <p:spPr>
-          <a:xfrm>
-            <a:off x="457200" y="1200151"/>
-            <a:ext cx="8229600" cy="3394472"/>
-          </a:xfrm>
-        </p:spPr>
-        <p:txBody>
-          <a:bodyPr/>
-          <a:lstStyle/>
-          <a:p>
-            <a:pPr lvl="0"/>
-            <a:r>
-              <a:rPr/>
-              <a:t>No tuning</a:t>
-            </a:r>
-          </a:p>
-          <a:p>
-            <a:pPr lvl="0"/>
-            <a:r>
-              <a:rPr/>
-              <a:t>No comparison of model families</a:t>
-            </a:r>
-          </a:p>
-          <a:p>
-            <a:pPr lvl="0"/>
-            <a:r>
-              <a:rPr/>
-              <a:t>No check of stability across splits</a:t>
-            </a:r>
-          </a:p>
-          <a:p>
-            <a:pPr lvl="0" indent="0" marL="0">
-              <a:buNone/>
-            </a:pPr>
-            <a:r>
-              <a:rPr/>
-              <a:t>And: we never looked at the test set to make a decision.</a:t>
-            </a:r>
-          </a:p>
-        </p:txBody>
-      </p:sp>
-    </p:spTree>
-  </p:cSld>
-</p:sld>
-</file>
-
 <file path=ppt/slides/slide52.xml><?xml version="1.0" encoding="utf-8"?>
 <p:sld xmlns:a="http://schemas.openxmlformats.org/drawingml/2006/main" xmlns:r="http://schemas.openxmlformats.org/officeDocument/2006/relationships" xmlns:p="http://schemas.openxmlformats.org/presentationml/2006/main">
   <p:cSld>
@@ -16835,7 +17036,7 @@
             </a:pPr>
             <a:r>
               <a:rPr/>
-              <a:t>Four ways a model misleads you</a:t>
+              <a:t>What we did not do</a:t>
             </a:r>
           </a:p>
         </p:txBody>
@@ -16863,37 +17064,30 @@
             <a:pPr lvl="0"/>
             <a:r>
               <a:rPr/>
-              <a:t>Leakage</a:t>
+              <a:t>No tuning</a:t>
             </a:r>
           </a:p>
           <a:p>
             <a:pPr lvl="0"/>
             <a:r>
               <a:rPr/>
-              <a:t>Imbalance</a:t>
+              <a:t>No comparison of model families</a:t>
             </a:r>
           </a:p>
           <a:p>
             <a:pPr lvl="0"/>
             <a:r>
               <a:rPr/>
-              <a:t>Shortcut features</a:t>
-            </a:r>
-          </a:p>
-          <a:p>
-            <a:pPr lvl="0"/>
-            <a:r>
-              <a:rPr/>
-              <a:t>Single-split noise</a:t>
-            </a:r>
-          </a:p>
-          <a:p>
-            <a:pPr lvl="0" indent="0" marL="0">
-              <a:buNone/>
-            </a:pPr>
-            <a:r>
-              <a:rPr/>
-              <a:t>All produce numbers that pass a casual review.</a:t>
+              <a:t>No check of stability across splits</a:t>
+            </a:r>
+          </a:p>
+          <a:p>
+            <a:pPr lvl="0" indent="0" marL="0">
+              <a:buNone/>
+            </a:pPr>
+            <a:r>
+              <a:rPr/>
+              <a:t>And: we never looked at the test set to make a decision.</a:t>
             </a:r>
           </a:p>
         </p:txBody>
@@ -16945,7 +17139,7 @@
             </a:pPr>
             <a:r>
               <a:rPr/>
-              <a:t>200 samples. 5000 random features. Coin-flip labels.</a:t>
+              <a:t>Four ways a model misleads you</a:t>
             </a:r>
           </a:p>
         </p:txBody>
@@ -16970,21 +17164,40 @@
           <a:bodyPr/>
           <a:lstStyle/>
           <a:p>
-            <a:pPr lvl="0" indent="0" marL="0">
-              <a:buNone/>
-            </a:pPr>
-            <a:r>
-              <a:rPr/>
-              <a:t>There is nothing to learn.</a:t>
-            </a:r>
-          </a:p>
-          <a:p>
-            <a:pPr lvl="0" indent="0" marL="0">
-              <a:buNone/>
-            </a:pPr>
-            <a:r>
-              <a:rPr/>
-              <a:t>Anything above 50% is an artefact.</a:t>
+            <a:pPr lvl="0"/>
+            <a:r>
+              <a:rPr/>
+              <a:t>Leakage</a:t>
+            </a:r>
+          </a:p>
+          <a:p>
+            <a:pPr lvl="0"/>
+            <a:r>
+              <a:rPr/>
+              <a:t>Imbalance</a:t>
+            </a:r>
+          </a:p>
+          <a:p>
+            <a:pPr lvl="0"/>
+            <a:r>
+              <a:rPr/>
+              <a:t>Shortcut features</a:t>
+            </a:r>
+          </a:p>
+          <a:p>
+            <a:pPr lvl="0"/>
+            <a:r>
+              <a:rPr/>
+              <a:t>Single-split noise</a:t>
+            </a:r>
+          </a:p>
+          <a:p>
+            <a:pPr lvl="0" indent="0" marL="0">
+              <a:buNone/>
+            </a:pPr>
+            <a:r>
+              <a:rPr/>
+              <a:t>All produce numbers that pass a casual review.</a:t>
             </a:r>
           </a:p>
         </p:txBody>
@@ -16995,6 +17208,179 @@
 </file>
 
 <file path=ppt/slides/slide54.xml><?xml version="1.0" encoding="utf-8"?>
+<p:sld xmlns:a="http://schemas.openxmlformats.org/drawingml/2006/main" xmlns:r="http://schemas.openxmlformats.org/officeDocument/2006/relationships" xmlns:p="http://schemas.openxmlformats.org/presentationml/2006/main">
+  <p:cSld>
+    <p:spTree>
+      <p:nvGrpSpPr>
+        <p:cNvPr id="1" name=""/>
+        <p:cNvGrpSpPr/>
+        <p:nvPr/>
+      </p:nvGrpSpPr>
+      <p:grpSpPr>
+        <a:xfrm>
+          <a:off x="0" y="0"/>
+          <a:ext cx="0" cy="0"/>
+          <a:chOff x="0" y="0"/>
+          <a:chExt cx="0" cy="0"/>
+        </a:xfrm>
+      </p:grpSpPr>
+      <p:sp>
+        <p:nvSpPr>
+          <p:cNvPr id="2" name="Title 1"/>
+          <p:cNvSpPr>
+            <a:spLocks noGrp="1"/>
+          </p:cNvSpPr>
+          <p:nvPr>
+            <p:ph type="title"/>
+          </p:nvPr>
+        </p:nvSpPr>
+        <p:spPr>
+          <a:xfrm>
+            <a:off x="457200" y="205979"/>
+            <a:ext cx="8229600" cy="857250"/>
+          </a:xfrm>
+        </p:spPr>
+        <p:txBody>
+          <a:bodyPr/>
+          <a:lstStyle/>
+          <a:p>
+            <a:pPr lvl="0" indent="0" marL="0">
+              <a:buNone/>
+            </a:pPr>
+            <a:r>
+              <a:rPr/>
+              <a:t>Notebook 3, live</a:t>
+            </a:r>
+          </a:p>
+        </p:txBody>
+      </p:sp>
+      <p:sp>
+        <p:nvSpPr>
+          <p:cNvPr id="3" name="Content Placeholder 2"/>
+          <p:cNvSpPr>
+            <a:spLocks noGrp="1"/>
+          </p:cNvSpPr>
+          <p:nvPr>
+            <p:ph idx="1"/>
+          </p:nvPr>
+        </p:nvSpPr>
+        <p:spPr>
+          <a:xfrm>
+            <a:off x="457200" y="1200151"/>
+            <a:ext cx="8229600" cy="3394472"/>
+          </a:xfrm>
+        </p:spPr>
+        <p:txBody>
+          <a:bodyPr/>
+          <a:lstStyle/>
+          <a:p>
+            <a:pPr lvl="0" indent="0" marL="0">
+              <a:buNone/>
+            </a:pPr>
+            <a:r>
+              <a:rPr/>
+              <a:t>Four failures, four plausible numbers, and not one bug among them.</a:t>
+            </a:r>
+          </a:p>
+        </p:txBody>
+      </p:sp>
+    </p:spTree>
+  </p:cSld>
+</p:sld>
+</file>
+
+<file path=ppt/slides/slide55.xml><?xml version="1.0" encoding="utf-8"?>
+<p:sld xmlns:a="http://schemas.openxmlformats.org/drawingml/2006/main" xmlns:r="http://schemas.openxmlformats.org/officeDocument/2006/relationships" xmlns:p="http://schemas.openxmlformats.org/presentationml/2006/main">
+  <p:cSld>
+    <p:spTree>
+      <p:nvGrpSpPr>
+        <p:cNvPr id="1" name=""/>
+        <p:cNvGrpSpPr/>
+        <p:nvPr/>
+      </p:nvGrpSpPr>
+      <p:grpSpPr>
+        <a:xfrm>
+          <a:off x="0" y="0"/>
+          <a:ext cx="0" cy="0"/>
+          <a:chOff x="0" y="0"/>
+          <a:chExt cx="0" cy="0"/>
+        </a:xfrm>
+      </p:grpSpPr>
+      <p:sp>
+        <p:nvSpPr>
+          <p:cNvPr id="2" name="Title 1"/>
+          <p:cNvSpPr>
+            <a:spLocks noGrp="1"/>
+          </p:cNvSpPr>
+          <p:nvPr>
+            <p:ph type="title"/>
+          </p:nvPr>
+        </p:nvSpPr>
+        <p:spPr>
+          <a:xfrm>
+            <a:off x="457200" y="205979"/>
+            <a:ext cx="8229600" cy="857250"/>
+          </a:xfrm>
+        </p:spPr>
+        <p:txBody>
+          <a:bodyPr/>
+          <a:lstStyle/>
+          <a:p>
+            <a:pPr lvl="0" indent="0" marL="0">
+              <a:buNone/>
+            </a:pPr>
+            <a:r>
+              <a:rPr/>
+              <a:t>200 samples. 5000 random features. Coin-flip labels.</a:t>
+            </a:r>
+          </a:p>
+        </p:txBody>
+      </p:sp>
+      <p:sp>
+        <p:nvSpPr>
+          <p:cNvPr id="3" name="Content Placeholder 2"/>
+          <p:cNvSpPr>
+            <a:spLocks noGrp="1"/>
+          </p:cNvSpPr>
+          <p:nvPr>
+            <p:ph idx="1"/>
+          </p:nvPr>
+        </p:nvSpPr>
+        <p:spPr>
+          <a:xfrm>
+            <a:off x="457200" y="1200151"/>
+            <a:ext cx="8229600" cy="3394472"/>
+          </a:xfrm>
+        </p:spPr>
+        <p:txBody>
+          <a:bodyPr/>
+          <a:lstStyle/>
+          <a:p>
+            <a:pPr lvl="0" indent="0" marL="0">
+              <a:buNone/>
+            </a:pPr>
+            <a:r>
+              <a:rPr/>
+              <a:t>There is nothing to learn.</a:t>
+            </a:r>
+          </a:p>
+          <a:p>
+            <a:pPr lvl="0" indent="0" marL="0">
+              <a:buNone/>
+            </a:pPr>
+            <a:r>
+              <a:rPr/>
+              <a:t>Anything above 50% is an artefact.</a:t>
+            </a:r>
+          </a:p>
+        </p:txBody>
+      </p:sp>
+    </p:spTree>
+  </p:cSld>
+</p:sld>
+</file>
+
+<file path=ppt/slides/slide56.xml><?xml version="1.0" encoding="utf-8"?>
 <p:sld xmlns:a="http://schemas.openxmlformats.org/drawingml/2006/main" xmlns:r="http://schemas.openxmlformats.org/officeDocument/2006/relationships" xmlns:p="http://schemas.openxmlformats.org/presentationml/2006/main">
   <p:cSld>
     <p:spTree>
@@ -17076,7 +17462,7 @@
 </p:sld>
 </file>
 
-<file path=ppt/slides/slide55.xml><?xml version="1.0" encoding="utf-8"?>
+<file path=ppt/slides/slide57.xml><?xml version="1.0" encoding="utf-8"?>
 <p:sld xmlns:a="http://schemas.openxmlformats.org/drawingml/2006/main" xmlns:r="http://schemas.openxmlformats.org/officeDocument/2006/relationships" xmlns:p="http://schemas.openxmlformats.org/presentationml/2006/main">
   <p:cSld>
     <p:spTree>
@@ -17175,7 +17561,7 @@
 </p:sld>
 </file>
 
-<file path=ppt/slides/slide56.xml><?xml version="1.0" encoding="utf-8"?>
+<file path=ppt/slides/slide58.xml><?xml version="1.0" encoding="utf-8"?>
 <p:sld xmlns:a="http://schemas.openxmlformats.org/drawingml/2006/main" xmlns:r="http://schemas.openxmlformats.org/officeDocument/2006/relationships" xmlns:p="http://schemas.openxmlformats.org/presentationml/2006/main">
   <p:cSld>
     <p:spTree>
@@ -17279,7 +17665,7 @@
 </p:sld>
 </file>
 
-<file path=ppt/slides/slide57.xml><?xml version="1.0" encoding="utf-8"?>
+<file path=ppt/slides/slide59.xml><?xml version="1.0" encoding="utf-8"?>
 <p:sld xmlns:a="http://schemas.openxmlformats.org/drawingml/2006/main" xmlns:r="http://schemas.openxmlformats.org/officeDocument/2006/relationships" xmlns:p="http://schemas.openxmlformats.org/presentationml/2006/main">
   <p:cSld>
     <p:spTree>
@@ -17361,7 +17747,7 @@
 </p:sld>
 </file>
 
-<file path=ppt/slides/slide58.xml><?xml version="1.0" encoding="utf-8"?>
+<file path=ppt/slides/slide6.xml><?xml version="1.0" encoding="utf-8"?>
 <p:sld xmlns:a="http://schemas.openxmlformats.org/drawingml/2006/main" xmlns:r="http://schemas.openxmlformats.org/officeDocument/2006/relationships" xmlns:p="http://schemas.openxmlformats.org/presentationml/2006/main">
   <p:cSld>
     <p:spTree>
@@ -17403,7 +17789,7 @@
             </a:pPr>
             <a:r>
               <a:rPr/>
-              <a:t>Shortcut features</a:t>
+              <a:t>How you will be assessed</a:t>
             </a:r>
           </a:p>
         </p:txBody>
@@ -17428,35 +17814,40 @@
           <a:bodyPr/>
           <a:lstStyle/>
           <a:p>
-            <a:pPr lvl="0" indent="0" marL="0">
-              <a:buNone/>
-            </a:pPr>
-            <a:r>
-              <a:rPr/>
-              <a:t>A column that is a </a:t>
-            </a:r>
+            <a:pPr lvl="0"/>
             <a:r>
               <a:rPr b="1"/>
-              <a:t>consequence</a:t>
-            </a:r>
-            <a:r>
-              <a:rPr/>
-              <a:t> of the label, not a predictor of it.</a:t>
-            </a:r>
-          </a:p>
-          <a:p>
-            <a:pPr lvl="0" indent="0" marL="0">
-              <a:buNone/>
-            </a:pPr>
-            <a:r>
-              <a:rPr>
-                <a:latin typeface="Courier"/>
-              </a:rPr>
-              <a:t>biopsy_scheduled</a:t>
-            </a:r>
-            <a:r>
-              <a:rPr/>
-              <a:t> → accuracy rises → model is worthless</a:t>
+              <a:t>Weekly exercises</a:t>
+            </a:r>
+            <a:r>
+              <a:rPr/>
+              <a:t>: set each Friday, discussed the next. Never collected</a:t>
+            </a:r>
+          </a:p>
+          <a:p>
+            <a:pPr lvl="0"/>
+            <a:r>
+              <a:rPr b="1"/>
+              <a:t>Exam</a:t>
+            </a:r>
+            <a:r>
+              <a:rPr/>
+              <a:t>: </a:t>
+            </a:r>
+            <a:r>
+              <a:rPr b="1"/>
+              <a:t>one of the ten is drawn</a:t>
+            </a:r>
+            <a:r>
+              <a:rPr/>
+              <a:t>, and you talk through your own notebook</a:t>
+            </a:r>
+          </a:p>
+          <a:p>
+            <a:pPr lvl="0"/>
+            <a:r>
+              <a:rPr/>
+              <a:t>No written paper, no project. Keep all ten</a:t>
             </a:r>
           </a:p>
         </p:txBody>
@@ -17466,7 +17857,112 @@
 </p:sld>
 </file>
 
-<file path=ppt/slides/slide59.xml><?xml version="1.0" encoding="utf-8"?>
+<file path=ppt/slides/slide60.xml><?xml version="1.0" encoding="utf-8"?>
+<p:sld xmlns:a="http://schemas.openxmlformats.org/drawingml/2006/main" xmlns:r="http://schemas.openxmlformats.org/officeDocument/2006/relationships" xmlns:p="http://schemas.openxmlformats.org/presentationml/2006/main">
+  <p:cSld>
+    <p:spTree>
+      <p:nvGrpSpPr>
+        <p:cNvPr id="1" name=""/>
+        <p:cNvGrpSpPr/>
+        <p:nvPr/>
+      </p:nvGrpSpPr>
+      <p:grpSpPr>
+        <a:xfrm>
+          <a:off x="0" y="0"/>
+          <a:ext cx="0" cy="0"/>
+          <a:chOff x="0" y="0"/>
+          <a:chExt cx="0" cy="0"/>
+        </a:xfrm>
+      </p:grpSpPr>
+      <p:sp>
+        <p:nvSpPr>
+          <p:cNvPr id="2" name="Title 1"/>
+          <p:cNvSpPr>
+            <a:spLocks noGrp="1"/>
+          </p:cNvSpPr>
+          <p:nvPr>
+            <p:ph type="title"/>
+          </p:nvPr>
+        </p:nvSpPr>
+        <p:spPr>
+          <a:xfrm>
+            <a:off x="457200" y="205979"/>
+            <a:ext cx="8229600" cy="857250"/>
+          </a:xfrm>
+        </p:spPr>
+        <p:txBody>
+          <a:bodyPr/>
+          <a:lstStyle/>
+          <a:p>
+            <a:pPr lvl="0" indent="0" marL="0">
+              <a:buNone/>
+            </a:pPr>
+            <a:r>
+              <a:rPr/>
+              <a:t>Shortcut features</a:t>
+            </a:r>
+          </a:p>
+        </p:txBody>
+      </p:sp>
+      <p:sp>
+        <p:nvSpPr>
+          <p:cNvPr id="3" name="Content Placeholder 2"/>
+          <p:cNvSpPr>
+            <a:spLocks noGrp="1"/>
+          </p:cNvSpPr>
+          <p:nvPr>
+            <p:ph idx="1"/>
+          </p:nvPr>
+        </p:nvSpPr>
+        <p:spPr>
+          <a:xfrm>
+            <a:off x="457200" y="1200151"/>
+            <a:ext cx="8229600" cy="3394472"/>
+          </a:xfrm>
+        </p:spPr>
+        <p:txBody>
+          <a:bodyPr/>
+          <a:lstStyle/>
+          <a:p>
+            <a:pPr lvl="0" indent="0" marL="0">
+              <a:buNone/>
+            </a:pPr>
+            <a:r>
+              <a:rPr/>
+              <a:t>A column that is a </a:t>
+            </a:r>
+            <a:r>
+              <a:rPr b="1"/>
+              <a:t>consequence</a:t>
+            </a:r>
+            <a:r>
+              <a:rPr/>
+              <a:t> of the label, not a predictor of it.</a:t>
+            </a:r>
+          </a:p>
+          <a:p>
+            <a:pPr lvl="0" indent="0" marL="0">
+              <a:buNone/>
+            </a:pPr>
+            <a:r>
+              <a:rPr>
+                <a:latin typeface="Courier"/>
+              </a:rPr>
+              <a:t>biopsy_scheduled</a:t>
+            </a:r>
+            <a:r>
+              <a:rPr/>
+              <a:t> → accuracy rises → model is worthless</a:t>
+            </a:r>
+          </a:p>
+        </p:txBody>
+      </p:sp>
+    </p:spTree>
+  </p:cSld>
+</p:sld>
+</file>
+
+<file path=ppt/slides/slide61.xml><?xml version="1.0" encoding="utf-8"?>
 <p:sld xmlns:a="http://schemas.openxmlformats.org/drawingml/2006/main" xmlns:r="http://schemas.openxmlformats.org/officeDocument/2006/relationships" xmlns:p="http://schemas.openxmlformats.org/presentationml/2006/main">
   <p:cSld>
     <p:spTree>
@@ -17548,117 +18044,7 @@
 </p:sld>
 </file>
 
-<file path=ppt/slides/slide6.xml><?xml version="1.0" encoding="utf-8"?>
-<p:sld xmlns:a="http://schemas.openxmlformats.org/drawingml/2006/main" xmlns:r="http://schemas.openxmlformats.org/officeDocument/2006/relationships" xmlns:p="http://schemas.openxmlformats.org/presentationml/2006/main">
-  <p:cSld>
-    <p:spTree>
-      <p:nvGrpSpPr>
-        <p:cNvPr id="1" name=""/>
-        <p:cNvGrpSpPr/>
-        <p:nvPr/>
-      </p:nvGrpSpPr>
-      <p:grpSpPr>
-        <a:xfrm>
-          <a:off x="0" y="0"/>
-          <a:ext cx="0" cy="0"/>
-          <a:chOff x="0" y="0"/>
-          <a:chExt cx="0" cy="0"/>
-        </a:xfrm>
-      </p:grpSpPr>
-      <p:sp>
-        <p:nvSpPr>
-          <p:cNvPr id="2" name="Title 1"/>
-          <p:cNvSpPr>
-            <a:spLocks noGrp="1"/>
-          </p:cNvSpPr>
-          <p:nvPr>
-            <p:ph type="title"/>
-          </p:nvPr>
-        </p:nvSpPr>
-        <p:spPr>
-          <a:xfrm>
-            <a:off x="457200" y="205979"/>
-            <a:ext cx="8229600" cy="857250"/>
-          </a:xfrm>
-        </p:spPr>
-        <p:txBody>
-          <a:bodyPr/>
-          <a:lstStyle/>
-          <a:p>
-            <a:pPr lvl="0" indent="0" marL="0">
-              <a:buNone/>
-            </a:pPr>
-            <a:r>
-              <a:rPr/>
-              <a:t>How you will be assessed</a:t>
-            </a:r>
-          </a:p>
-        </p:txBody>
-      </p:sp>
-      <p:sp>
-        <p:nvSpPr>
-          <p:cNvPr id="3" name="Content Placeholder 2"/>
-          <p:cNvSpPr>
-            <a:spLocks noGrp="1"/>
-          </p:cNvSpPr>
-          <p:nvPr>
-            <p:ph idx="1"/>
-          </p:nvPr>
-        </p:nvSpPr>
-        <p:spPr>
-          <a:xfrm>
-            <a:off x="457200" y="1200151"/>
-            <a:ext cx="8229600" cy="3394472"/>
-          </a:xfrm>
-        </p:spPr>
-        <p:txBody>
-          <a:bodyPr/>
-          <a:lstStyle/>
-          <a:p>
-            <a:pPr lvl="0"/>
-            <a:r>
-              <a:rPr b="1"/>
-              <a:t>Weekly exercises</a:t>
-            </a:r>
-            <a:r>
-              <a:rPr/>
-              <a:t>: set each Friday, discussed the next. Never collected</a:t>
-            </a:r>
-          </a:p>
-          <a:p>
-            <a:pPr lvl="0"/>
-            <a:r>
-              <a:rPr b="1"/>
-              <a:t>Exam</a:t>
-            </a:r>
-            <a:r>
-              <a:rPr/>
-              <a:t>: </a:t>
-            </a:r>
-            <a:r>
-              <a:rPr b="1"/>
-              <a:t>one of the ten is drawn</a:t>
-            </a:r>
-            <a:r>
-              <a:rPr/>
-              <a:t>, and you talk through your own notebook</a:t>
-            </a:r>
-          </a:p>
-          <a:p>
-            <a:pPr lvl="0"/>
-            <a:r>
-              <a:rPr/>
-              <a:t>No written paper, no project. Keep all ten</a:t>
-            </a:r>
-          </a:p>
-        </p:txBody>
-      </p:sp>
-    </p:spTree>
-  </p:cSld>
-</p:sld>
-</file>
-
-<file path=ppt/slides/slide60.xml><?xml version="1.0" encoding="utf-8"?>
+<file path=ppt/slides/slide62.xml><?xml version="1.0" encoding="utf-8"?>
 <p:sld xmlns:a="http://schemas.openxmlformats.org/drawingml/2006/main" xmlns:r="http://schemas.openxmlformats.org/officeDocument/2006/relationships" xmlns:p="http://schemas.openxmlformats.org/presentationml/2006/main">
   <p:cSld>
     <p:spTree>
@@ -17740,203 +18126,6 @@
 </p:sld>
 </file>
 
-<file path=ppt/slides/slide61.xml><?xml version="1.0" encoding="utf-8"?>
-<p:sld xmlns:a="http://schemas.openxmlformats.org/drawingml/2006/main" xmlns:r="http://schemas.openxmlformats.org/officeDocument/2006/relationships" xmlns:p="http://schemas.openxmlformats.org/presentationml/2006/main">
-  <p:cSld>
-    <p:spTree>
-      <p:nvGrpSpPr>
-        <p:cNvPr id="1" name=""/>
-        <p:cNvGrpSpPr/>
-        <p:nvPr/>
-      </p:nvGrpSpPr>
-      <p:grpSpPr>
-        <a:xfrm>
-          <a:off x="0" y="0"/>
-          <a:ext cx="0" cy="0"/>
-          <a:chOff x="0" y="0"/>
-          <a:chExt cx="0" cy="0"/>
-        </a:xfrm>
-      </p:grpSpPr>
-      <p:sp>
-        <p:nvSpPr>
-          <p:cNvPr id="2" name="Title 1"/>
-          <p:cNvSpPr>
-            <a:spLocks noGrp="1"/>
-          </p:cNvSpPr>
-          <p:nvPr>
-            <p:ph type="title"/>
-          </p:nvPr>
-        </p:nvSpPr>
-        <p:spPr>
-          <a:xfrm>
-            <a:off x="457200" y="205979"/>
-            <a:ext cx="8229600" cy="857250"/>
-          </a:xfrm>
-        </p:spPr>
-        <p:txBody>
-          <a:bodyPr/>
-          <a:lstStyle/>
-          <a:p>
-            <a:pPr lvl="0" indent="0" marL="0">
-              <a:buNone/>
-            </a:pPr>
-            <a:r>
-              <a:rPr/>
-              <a:t>What the four have in common</a:t>
-            </a:r>
-          </a:p>
-        </p:txBody>
-      </p:sp>
-      <p:sp>
-        <p:nvSpPr>
-          <p:cNvPr id="3" name="Content Placeholder 2"/>
-          <p:cNvSpPr>
-            <a:spLocks noGrp="1"/>
-          </p:cNvSpPr>
-          <p:nvPr>
-            <p:ph idx="1"/>
-          </p:nvPr>
-        </p:nvSpPr>
-        <p:spPr>
-          <a:xfrm>
-            <a:off x="457200" y="1200151"/>
-            <a:ext cx="8229600" cy="3394472"/>
-          </a:xfrm>
-        </p:spPr>
-        <p:txBody>
-          <a:bodyPr/>
-          <a:lstStyle/>
-          <a:p>
-            <a:pPr lvl="0" indent="0" marL="0">
-              <a:buNone/>
-            </a:pPr>
-            <a:r>
-              <a:rPr/>
-              <a:t>None is a coding error.</a:t>
-            </a:r>
-          </a:p>
-          <a:p>
-            <a:pPr lvl="0" indent="0" marL="0">
-              <a:buNone/>
-            </a:pPr>
-            <a:r>
-              <a:rPr/>
-              <a:t>All four run exactly as written and return a plausible number.</a:t>
-            </a:r>
-          </a:p>
-        </p:txBody>
-      </p:sp>
-    </p:spTree>
-  </p:cSld>
-</p:sld>
-</file>
-
-<file path=ppt/slides/slide62.xml><?xml version="1.0" encoding="utf-8"?>
-<p:sld xmlns:a="http://schemas.openxmlformats.org/drawingml/2006/main" xmlns:r="http://schemas.openxmlformats.org/officeDocument/2006/relationships" xmlns:p="http://schemas.openxmlformats.org/presentationml/2006/main">
-  <p:cSld>
-    <p:spTree>
-      <p:nvGrpSpPr>
-        <p:cNvPr id="1" name=""/>
-        <p:cNvGrpSpPr/>
-        <p:nvPr/>
-      </p:nvGrpSpPr>
-      <p:grpSpPr>
-        <a:xfrm>
-          <a:off x="0" y="0"/>
-          <a:ext cx="0" cy="0"/>
-          <a:chOff x="0" y="0"/>
-          <a:chExt cx="0" cy="0"/>
-        </a:xfrm>
-      </p:grpSpPr>
-      <p:sp>
-        <p:nvSpPr>
-          <p:cNvPr id="2" name="Title 1"/>
-          <p:cNvSpPr>
-            <a:spLocks noGrp="1"/>
-          </p:cNvSpPr>
-          <p:nvPr>
-            <p:ph type="title"/>
-          </p:nvPr>
-        </p:nvSpPr>
-        <p:spPr>
-          <a:xfrm>
-            <a:off x="457200" y="205979"/>
-            <a:ext cx="8229600" cy="857250"/>
-          </a:xfrm>
-        </p:spPr>
-        <p:txBody>
-          <a:bodyPr/>
-          <a:lstStyle/>
-          <a:p>
-            <a:pPr lvl="0" indent="0" marL="0">
-              <a:buNone/>
-            </a:pPr>
-            <a:r>
-              <a:rPr/>
-              <a:t>A model is not objective</a:t>
-            </a:r>
-          </a:p>
-        </p:txBody>
-      </p:sp>
-      <p:sp>
-        <p:nvSpPr>
-          <p:cNvPr id="3" name="Content Placeholder 2"/>
-          <p:cNvSpPr>
-            <a:spLocks noGrp="1"/>
-          </p:cNvSpPr>
-          <p:nvPr>
-            <p:ph idx="1"/>
-          </p:nvPr>
-        </p:nvSpPr>
-        <p:spPr>
-          <a:xfrm>
-            <a:off x="457200" y="1200151"/>
-            <a:ext cx="8229600" cy="3394472"/>
-          </a:xfrm>
-        </p:spPr>
-        <p:txBody>
-          <a:bodyPr/>
-          <a:lstStyle/>
-          <a:p>
-            <a:pPr lvl="0"/>
-            <a:r>
-              <a:rPr/>
-              <a:t>It is a compressed summary of its training data, </a:t>
-            </a:r>
-            <a:r>
-              <a:rPr b="1"/>
-              <a:t>including its injustices</a:t>
-            </a:r>
-          </a:p>
-          <a:p>
-            <a:pPr lvl="0"/>
-            <a:r>
-              <a:rPr/>
-              <a:t>These methods find </a:t>
-            </a:r>
-            <a:r>
-              <a:rPr b="1"/>
-              <a:t>correlation</a:t>
-            </a:r>
-            <a:r>
-              <a:rPr/>
-              <a:t>, not cause</a:t>
-            </a:r>
-          </a:p>
-          <a:p>
-            <a:pPr lvl="0"/>
-            <a:r>
-              <a:rPr/>
-              <a:t>Accuracy is not the only property that matters</a:t>
-            </a:r>
-          </a:p>
-        </p:txBody>
-      </p:sp>
-    </p:spTree>
-  </p:cSld>
-</p:sld>
-</file>
-
 <file path=ppt/slides/slide63.xml><?xml version="1.0" encoding="utf-8"?>
 <p:sld xmlns:a="http://schemas.openxmlformats.org/drawingml/2006/main" xmlns:r="http://schemas.openxmlformats.org/officeDocument/2006/relationships" xmlns:p="http://schemas.openxmlformats.org/presentationml/2006/main">
   <p:cSld>
@@ -17979,7 +18168,7 @@
             </a:pPr>
             <a:r>
               <a:rPr/>
-              <a:t>Homework: we discuss it on Friday 2 October</a:t>
+              <a:t>What the four have in common</a:t>
             </a:r>
           </a:p>
         </p:txBody>
@@ -18008,41 +18197,17 @@
               <a:buNone/>
             </a:pPr>
             <a:r>
-              <a:rPr>
-                <a:latin typeface="Courier"/>
-              </a:rPr>
-              <a:t>Exercises/01_first_workflow.md</a:t>
-            </a:r>
-          </a:p>
-          <a:p>
-            <a:pPr lvl="0" indent="0" marL="0">
-              <a:buNone/>
-            </a:pPr>
-            <a:r>
-              <a:rPr/>
-              <a:t>Wine quality: run the workflow yourself, and </a:t>
-            </a:r>
-            <a:r>
-              <a:rPr b="1"/>
-              <a:t>justify every decision</a:t>
-            </a:r>
-            <a:r>
-              <a:rPr/>
-              <a:t>.</a:t>
-            </a:r>
-          </a:p>
-          <a:p>
-            <a:pPr lvl="0"/>
-            <a:r>
-              <a:rPr/>
-              <a:t>No marks for accuracy</a:t>
-            </a:r>
-          </a:p>
-          <a:p>
-            <a:pPr lvl="0"/>
-            <a:r>
-              <a:rPr/>
-              <a:t>Marks for methodology, and for saying what your number does not mean</a:t>
+              <a:rPr/>
+              <a:t>None is a coding error.</a:t>
+            </a:r>
+          </a:p>
+          <a:p>
+            <a:pPr lvl="0" indent="0" marL="0">
+              <a:buNone/>
+            </a:pPr>
+            <a:r>
+              <a:rPr/>
+              <a:t>All four run exactly as written and return a plausible number.</a:t>
             </a:r>
           </a:p>
         </p:txBody>
@@ -18053,6 +18218,227 @@
 </file>
 
 <file path=ppt/slides/slide64.xml><?xml version="1.0" encoding="utf-8"?>
+<p:sld xmlns:a="http://schemas.openxmlformats.org/drawingml/2006/main" xmlns:r="http://schemas.openxmlformats.org/officeDocument/2006/relationships" xmlns:p="http://schemas.openxmlformats.org/presentationml/2006/main">
+  <p:cSld>
+    <p:spTree>
+      <p:nvGrpSpPr>
+        <p:cNvPr id="1" name=""/>
+        <p:cNvGrpSpPr/>
+        <p:nvPr/>
+      </p:nvGrpSpPr>
+      <p:grpSpPr>
+        <a:xfrm>
+          <a:off x="0" y="0"/>
+          <a:ext cx="0" cy="0"/>
+          <a:chOff x="0" y="0"/>
+          <a:chExt cx="0" cy="0"/>
+        </a:xfrm>
+      </p:grpSpPr>
+      <p:sp>
+        <p:nvSpPr>
+          <p:cNvPr id="2" name="Title 1"/>
+          <p:cNvSpPr>
+            <a:spLocks noGrp="1"/>
+          </p:cNvSpPr>
+          <p:nvPr>
+            <p:ph type="title"/>
+          </p:nvPr>
+        </p:nvSpPr>
+        <p:spPr>
+          <a:xfrm>
+            <a:off x="457200" y="205979"/>
+            <a:ext cx="8229600" cy="857250"/>
+          </a:xfrm>
+        </p:spPr>
+        <p:txBody>
+          <a:bodyPr/>
+          <a:lstStyle/>
+          <a:p>
+            <a:pPr lvl="0" indent="0" marL="0">
+              <a:buNone/>
+            </a:pPr>
+            <a:r>
+              <a:rPr/>
+              <a:t>A model is not objective</a:t>
+            </a:r>
+          </a:p>
+        </p:txBody>
+      </p:sp>
+      <p:sp>
+        <p:nvSpPr>
+          <p:cNvPr id="3" name="Content Placeholder 2"/>
+          <p:cNvSpPr>
+            <a:spLocks noGrp="1"/>
+          </p:cNvSpPr>
+          <p:nvPr>
+            <p:ph idx="1"/>
+          </p:nvPr>
+        </p:nvSpPr>
+        <p:spPr>
+          <a:xfrm>
+            <a:off x="457200" y="1200151"/>
+            <a:ext cx="8229600" cy="3394472"/>
+          </a:xfrm>
+        </p:spPr>
+        <p:txBody>
+          <a:bodyPr/>
+          <a:lstStyle/>
+          <a:p>
+            <a:pPr lvl="0"/>
+            <a:r>
+              <a:rPr/>
+              <a:t>It is a compressed summary of its training data, </a:t>
+            </a:r>
+            <a:r>
+              <a:rPr b="1"/>
+              <a:t>including its injustices</a:t>
+            </a:r>
+          </a:p>
+          <a:p>
+            <a:pPr lvl="0"/>
+            <a:r>
+              <a:rPr/>
+              <a:t>These methods find </a:t>
+            </a:r>
+            <a:r>
+              <a:rPr b="1"/>
+              <a:t>correlation</a:t>
+            </a:r>
+            <a:r>
+              <a:rPr/>
+              <a:t>, not cause</a:t>
+            </a:r>
+          </a:p>
+          <a:p>
+            <a:pPr lvl="0"/>
+            <a:r>
+              <a:rPr/>
+              <a:t>Accuracy is not the only property that matters</a:t>
+            </a:r>
+          </a:p>
+        </p:txBody>
+      </p:sp>
+    </p:spTree>
+  </p:cSld>
+</p:sld>
+</file>
+
+<file path=ppt/slides/slide65.xml><?xml version="1.0" encoding="utf-8"?>
+<p:sld xmlns:a="http://schemas.openxmlformats.org/drawingml/2006/main" xmlns:r="http://schemas.openxmlformats.org/officeDocument/2006/relationships" xmlns:p="http://schemas.openxmlformats.org/presentationml/2006/main">
+  <p:cSld>
+    <p:spTree>
+      <p:nvGrpSpPr>
+        <p:cNvPr id="1" name=""/>
+        <p:cNvGrpSpPr/>
+        <p:nvPr/>
+      </p:nvGrpSpPr>
+      <p:grpSpPr>
+        <a:xfrm>
+          <a:off x="0" y="0"/>
+          <a:ext cx="0" cy="0"/>
+          <a:chOff x="0" y="0"/>
+          <a:chExt cx="0" cy="0"/>
+        </a:xfrm>
+      </p:grpSpPr>
+      <p:sp>
+        <p:nvSpPr>
+          <p:cNvPr id="2" name="Title 1"/>
+          <p:cNvSpPr>
+            <a:spLocks noGrp="1"/>
+          </p:cNvSpPr>
+          <p:nvPr>
+            <p:ph type="title"/>
+          </p:nvPr>
+        </p:nvSpPr>
+        <p:spPr>
+          <a:xfrm>
+            <a:off x="457200" y="205979"/>
+            <a:ext cx="8229600" cy="857250"/>
+          </a:xfrm>
+        </p:spPr>
+        <p:txBody>
+          <a:bodyPr/>
+          <a:lstStyle/>
+          <a:p>
+            <a:pPr lvl="0" indent="0" marL="0">
+              <a:buNone/>
+            </a:pPr>
+            <a:r>
+              <a:rPr/>
+              <a:t>Homework: we discuss it on Friday 2 October</a:t>
+            </a:r>
+          </a:p>
+        </p:txBody>
+      </p:sp>
+      <p:sp>
+        <p:nvSpPr>
+          <p:cNvPr id="3" name="Content Placeholder 2"/>
+          <p:cNvSpPr>
+            <a:spLocks noGrp="1"/>
+          </p:cNvSpPr>
+          <p:nvPr>
+            <p:ph idx="1"/>
+          </p:nvPr>
+        </p:nvSpPr>
+        <p:spPr>
+          <a:xfrm>
+            <a:off x="457200" y="1200151"/>
+            <a:ext cx="8229600" cy="3394472"/>
+          </a:xfrm>
+        </p:spPr>
+        <p:txBody>
+          <a:bodyPr/>
+          <a:lstStyle/>
+          <a:p>
+            <a:pPr lvl="0" indent="0" marL="0">
+              <a:buNone/>
+            </a:pPr>
+            <a:r>
+              <a:rPr>
+                <a:latin typeface="Courier"/>
+              </a:rPr>
+              <a:t>Exercises/01_first_workflow.md</a:t>
+            </a:r>
+          </a:p>
+          <a:p>
+            <a:pPr lvl="0" indent="0" marL="0">
+              <a:buNone/>
+            </a:pPr>
+            <a:r>
+              <a:rPr/>
+              <a:t>Wine quality: run the workflow yourself, and </a:t>
+            </a:r>
+            <a:r>
+              <a:rPr b="1"/>
+              <a:t>justify every decision</a:t>
+            </a:r>
+            <a:r>
+              <a:rPr/>
+              <a:t>.</a:t>
+            </a:r>
+          </a:p>
+          <a:p>
+            <a:pPr lvl="0"/>
+            <a:r>
+              <a:rPr/>
+              <a:t>No marks for accuracy</a:t>
+            </a:r>
+          </a:p>
+          <a:p>
+            <a:pPr lvl="0"/>
+            <a:r>
+              <a:rPr/>
+              <a:t>Marks for methodology, and for saying what your number does not mean</a:t>
+            </a:r>
+          </a:p>
+        </p:txBody>
+      </p:sp>
+    </p:spTree>
+  </p:cSld>
+</p:sld>
+</file>
+
+<file path=ppt/slides/slide66.xml><?xml version="1.0" encoding="utf-8"?>
 <p:sld xmlns:a="http://schemas.openxmlformats.org/drawingml/2006/main" xmlns:r="http://schemas.openxmlformats.org/officeDocument/2006/relationships" xmlns:p="http://schemas.openxmlformats.org/presentationml/2006/main">
   <p:cSld>
     <p:spTree>

</xml_diff>

<commit_message>
Move the course a week later, to start on 2 October
The first lesson moves from 25 September to 2 October 2026, and every lesson
after it follows by one week: the course now runs every Friday to 4 December,
and exercise 10 is worked by 11 December. Dates are updated in the schedule,
the README, every lesson's front matter, the homework announcements in
handouts, slides, speaker notes and notebooks, and release.py's note on when
the TensorFlow image is first needed. Slides and PDFs rebuilt.

Co-Authored-By: Claude Opus 5.5 <noreply@anthropic.com>
</commit_message>
<xml_diff>
--- a/Lessons/01_introduction_and_workflow/Slides/introduction_and_workflow_slides.pptx
+++ b/Lessons/01_introduction_and_workflow/Slides/introduction_and_workflow_slides.pptx
@@ -11600,7 +11600,7 @@
             </a:pPr>
             <a:r>
               <a:rPr/>
-              <a:t>25 September 2026</a:t>
+              <a:t>2 October 2026</a:t>
             </a:r>
           </a:p>
         </p:txBody>
@@ -12762,7 +12762,7 @@
             <a:pPr lvl="0"/>
             <a:r>
               <a:rPr/>
-              <a:t>10 lessons, 3 hours each, every Friday until 27 November</a:t>
+              <a:t>10 lessons, 3 hours each, every Friday until 4 December</a:t>
             </a:r>
           </a:p>
           <a:p>
@@ -18336,7 +18336,7 @@
             </a:pPr>
             <a:r>
               <a:rPr/>
-              <a:t>Homework: we discuss it on Friday 2 October</a:t>
+              <a:t>Homework: we discuss it on Friday 9 October</a:t>
             </a:r>
           </a:p>
         </p:txBody>

</xml_diff>

<commit_message>
Number lesson 1's notebooks in the order they are taught
The kinds-of-learning notebook runs at slide 38, before the workflow
notebook at slide 40, yet carried the number 02 while the workflow carried
01. Rename them so the file order is the lecture order (01 kinds of
learning, 02 workflow, 03 unchanged), and swap every "notebook 01/02"
reference in the slides, handout, exercise, quiz, resource and notebooks
to match. Lesson 3's pointer to where R^2 was defined follows the rename;
references to lesson 5's notebook 02 are untouched.

Co-Authored-By: Claude Opus 5.5 <noreply@anthropic.com>
</commit_message>
<xml_diff>
--- a/Lessons/01_introduction_and_workflow/Slides/introduction_and_workflow_slides.pptx
+++ b/Lessons/01_introduction_and_workflow/Slides/introduction_and_workflow_slides.pptx
@@ -947,7 +947,7 @@
             </a:pPr>
             <a:r>
               <a:rPr/>
-              <a:t>Point at the numbers first. One tumour, thirty measurements taken from a digitised image of a tissue sample - radius, texture, perimeter, area and 26 more. THAT list is x. The thing we want to predict, malignant or benign, is y. Notebook 01 prints exactly this table in its second cell, and it is the dataset we use for the whole workflow later today.</a:t>
+              <a:t>Point at the numbers first. One tumour, thirty measurements taken from a digitised image of a tissue sample - radius, texture, perimeter, area and 26 more. THAT list is x. The thing we want to predict, malignant or benign, is y. Notebook 02 prints exactly this table in its second cell, and it is the dataset we use for the whole workflow later today.</a:t>
             </a:r>
           </a:p>
           <a:p>
@@ -1415,7 +1415,7 @@
             </a:pPr>
             <a:r>
               <a:rPr/>
-              <a:t>Say what L is, or it stays a placeholder all lesson. Simplest choice, the zero-one loss: 0 when right, 1 when wrong. Then the empirical risk IS the error rate, and accuracy is one minus it - so every score in today’s notebooks is an empirical risk under a friendlier name. Notebook 01: 0.986 on 143 examples is two mistakes, an empirical risk of 0.014.</a:t>
+              <a:t>Say what L is, or it stays a placeholder all lesson. Simplest choice, the zero-one loss: 0 when right, 1 when wrong. Then the empirical risk IS the error rate, and accuracy is one minus it - so every score in today’s notebooks is an empirical risk under a friendlier name. Notebook 02: 0.986 on 143 examples is two mistakes, an empirical risk of 0.014.</a:t>
             </a:r>
           </a:p>
           <a:p>
@@ -1871,7 +1871,7 @@
             </a:pPr>
             <a:r>
               <a:rPr/>
-              <a:t>If someone asks “how much do we hold out?” - typically 20-30%, and the trade-off is real in both directions. A bigger test set gives a more stable estimate; a bigger training set gives a better model. Say what “more stable” means before using it: the standard error is how far the measured accuracy would typically move if you drew a different test set of the same size, and it shrinks as one over the square root of m, the number of TEST examples - so quadrupling the test set halves the error bar, and that is the only way to buy precision. Give them the concrete number from notebook 01: 143 test examples at 0.986 accuracy carries a standard error of about one percentage point, so the third decimal place is noise. If anyone presses on the interval, concede it: 0.986 of 143 is two errors, the normal approximation is not admissible there - it returns an upper limit of 100.5% - and the honest lower bound is 95.0%, not the approximation’s 96.7%. Handout section 2.4 works it through. With a few hundred examples both sides hurt at once, which is what cross-validation exists for - lesson 5.</a:t>
+              <a:t>If someone asks “how much do we hold out?” - typically 20-30%, and the trade-off is real in both directions. A bigger test set gives a more stable estimate; a bigger training set gives a better model. Say what “more stable” means before using it: the standard error is how far the measured accuracy would typically move if you drew a different test set of the same size, and it shrinks as one over the square root of m, the number of TEST examples - so quadrupling the test set halves the error bar, and that is the only way to buy precision. Give them the concrete number from notebook 02: 143 test examples at 0.986 accuracy carries a standard error of about one percentage point, so the third decimal place is noise. If anyone presses on the interval, concede it: 0.986 of 143 is two errors, the normal approximation is not admissible there - it returns an upper limit of 100.5% - and the honest lower bound is 95.0%, not the approximation’s 96.7%. Handout section 2.4 works it through. With a few hundred examples both sides hurt at once, which is what cross-validation exists for - lesson 5.</a:t>
             </a:r>
           </a:p>
           <a:p>
@@ -3565,7 +3565,7 @@
             </a:pPr>
             <a:r>
               <a:rPr/>
-              <a:t>Correct the common misconception immediately, before it takes hold. It is not about which algorithm you use: the same estimator can serve more than one setting, and they will see exactly that in notebook 02 where the supervised regression and the self-supervised task run identical code.</a:t>
+              <a:t>Correct the common misconception immediately, before it takes hold. It is not about which algorithm you use: the same estimator can serve more than one setting, and they will see exactly that in notebook 01 where the supervised regression and the self-supervised task run identical code.</a:t>
             </a:r>
           </a:p>
           <a:p>
@@ -4047,7 +4047,7 @@
             </a:pPr>
             <a:r>
               <a:rPr/>
-              <a:t>Work notebook 02 here, live. The same 178 wines appear in all three panels.</a:t>
+              <a:t>Work notebook 01 here, live. The same 178 wines appear in all three panels.</a:t>
             </a:r>
           </a:p>
           <a:p>
@@ -4267,7 +4267,7 @@
             </a:pPr>
             <a:r>
               <a:rPr/>
-              <a:t>Open notebook 02 and run it. Twenty minutes, and it is the only place today where all three kinds appear on identical data, which is the whole argument of this segment made operational.</a:t>
+              <a:t>Open notebook 01 and run it. Twenty minutes, and it is the only place today where all three kinds appear on identical data, which is the whole argument of this segment made operational.</a:t>
             </a:r>
           </a:p>
           <a:p>
@@ -4433,7 +4433,7 @@
             </a:pPr>
             <a:r>
               <a:rPr/>
-              <a:t>This is the map for notebook 01, which the next slide starts. Tell them to open it and follow along rather than watch.</a:t>
+              <a:t>This is the map for notebook 02, which the next slide starts. Tell them to open it and follow along rather than watch.</a:t>
             </a:r>
           </a:p>
           <a:p>
@@ -15443,7 +15443,7 @@
             </a:pPr>
             <a:r>
               <a:rPr/>
-              <a:t>Notebook 02, live</a:t>
+              <a:t>Notebook 1, live</a:t>
             </a:r>
           </a:p>
         </p:txBody>
@@ -15757,7 +15757,7 @@
             </a:pPr>
             <a:r>
               <a:rPr/>
-              <a:t>Notebook 1, live</a:t>
+              <a:t>Notebook 2, live</a:t>
             </a:r>
           </a:p>
         </p:txBody>

</xml_diff>

<commit_message>
Show the course's Microsoft Teams code on lesson 1's welcome slide
Students need the team code in the first minutes of the course, so it
goes on the welcome slide as a fourth bullet rather than on a new slide.
Set in bold monospace so the zero cannot be read as the letter o, and the
speaker notes ask the room to join before the lesson moves on.

Co-Authored-By: Claude Opus 5.5 <noreply@anthropic.com>
</commit_message>
<xml_diff>
--- a/Lessons/01_introduction_and_workflow/Slides/introduction_and_workflow_slides.pptx
+++ b/Lessons/01_introduction_and_workflow/Slides/introduction_and_workflow_slides.pptx
@@ -618,6 +618,20 @@
             <a:r>
               <a:rPr/>
               <a:t>Practical notes to give now: the repository is public to them via git, everything runs offline in Docker, and there is no cost attached to any part of this course. Nobody needs an application programming interface (API) key, a cloud account or a graphics processing unit (GPU).</a:t>
+            </a:r>
+          </a:p>
+          <a:p>
+            <a:pPr lvl="0" indent="0" marL="0">
+              <a:buNone/>
+            </a:pPr>
+          </a:p>
+          <a:p>
+            <a:pPr lvl="0" indent="0" marL="0">
+              <a:buNone/>
+            </a:pPr>
+            <a:r>
+              <a:rPr/>
+              <a:t>Ask them to join the course team on Microsoft Teams now, with the code on the slide - v0t2gvu, zero not the letter o - so that announcements reach everyone from the first week.</a:t>
             </a:r>
           </a:p>
         </p:txBody>
@@ -12785,6 +12799,19 @@
             <a:r>
               <a:rPr/>
               <a:t>Foundations, not products</a:t>
+            </a:r>
+          </a:p>
+          <a:p>
+            <a:pPr lvl="0"/>
+            <a:r>
+              <a:rPr/>
+              <a:t>Course team on Microsoft Teams: code </a:t>
+            </a:r>
+            <a:r>
+              <a:rPr b="1">
+                <a:latin typeface="Courier"/>
+              </a:rPr>
+              <a:t>v0t2gvu</a:t>
             </a:r>
           </a:p>
         </p:txBody>

</xml_diff>

<commit_message>
Quote lesson 1's baseline on the test set, and drop projected em dashes
The baseline slide quoted 62.7%, the benign share across all 569 tumours,
while the result slide two slides later quoted 0.629, the same rule scored
on the 143 test tumours - which is what the notebook prints at its baseline
step. The baseline slide now says 62.9% on the test set, and its notes
explain the 62.7% for anyone who remembers it from the class-balance step.

Also remove the last em dashes from projected text: two on slides 13 and
33, and two in the risk-gap figure's legend, regenerated in the container.

Co-Authored-By: Claude Opus 5.5 <noreply@anthropic.com>
</commit_message>
<xml_diff>
--- a/Lessons/01_introduction_and_workflow/Slides/introduction_and_workflow_slides.pptx
+++ b/Lessons/01_introduction_and_workflow/Slides/introduction_and_workflow_slides.pptx
@@ -5253,6 +5253,20 @@
         <p:txBody>
           <a:bodyPr/>
           <a:lstStyle/>
+          <a:p>
+            <a:pPr lvl="0" indent="0" marL="0">
+              <a:buNone/>
+            </a:pPr>
+            <a:r>
+              <a:rPr/>
+              <a:t>If someone remembers 62.7% from the class-balance step: that is the share of benign tumours in all 569. The baseline is scored like the model, on the 143 test tumours, where 90 are benign - 62.9%, the 0.629 the result slide quotes. The stratified split keeps the two close; they differ only because 143 is a small sample.</a:t>
+            </a:r>
+          </a:p>
+          <a:p>
+            <a:pPr lvl="0" indent="0" marL="0">
+              <a:buNone/>
+            </a:pPr>
+          </a:p>
           <a:p>
             <a:pPr lvl="0" indent="0" marL="0">
               <a:buNone/>
@@ -12042,7 +12056,7 @@
             </a:r>
             <a:r>
               <a:rPr/>
-              <a:t> (columns) — all course long</a:t>
+              <a:t> (columns), all course long</a:t>
             </a:r>
           </a:p>
         </p:txBody>
@@ -14784,7 +14798,7 @@
             <a:pPr lvl="0"/>
             <a:r>
               <a:rPr/>
-              <a:t>The cultivar is not a measurement — it is an answer written down</a:t>
+              <a:t>The cultivar is not a measurement: it is an answer written down</a:t>
             </a:r>
           </a:p>
         </p:txBody>
@@ -16275,7 +16289,11 @@
             </a:pPr>
             <a:r>
               <a:rPr b="1"/>
-              <a:t>62.7%</a:t>
+              <a:t>62.9%</a:t>
+            </a:r>
+            <a:r>
+              <a:rPr/>
+              <a:t> on the test set</a:t>
             </a:r>
           </a:p>
           <a:p>

</xml_diff>

<commit_message>
Give lesson 1 the formulas for precision and recall
The lesson defined precision and recall in words but never wrote them down,
and the handout did not either. A new slide after the definitions counts
them on the confusion matrix: TP 52, FN 1, FP 1, so recall = TP/(TP+FN) and
precision = TP/(TP+FP) both come to 52/53 = 0.981 - equal only because one
miss balances one false alarm, as the notes say, while at threshold 0.10
they part (1.000 against 53/64 = 0.828). Handout section 7 gains the same
formulas and numbers; worked_examples.py recomputes all six from the model.
The lesson plan shifts by one slide (67).

Co-Authored-By: Claude Opus 5.5 <noreply@anthropic.com>
</commit_message>
<xml_diff>
--- a/Lessons/01_introduction_and_workflow/Slides/introduction_and_workflow_slides.pptx
+++ b/Lessons/01_introduction_and_workflow/Slides/introduction_and_workflow_slides.pptx
@@ -5,7 +5,7 @@
     <p:sldMasterId id="2147483648" r:id="rId1"/>
   </p:sldMasterIdLst>
   <p:notesMasterIdLst>
-    <p:notesMasterId r:id="rId68"/>
+    <p:notesMasterId r:id="rId69"/>
   </p:notesMasterIdLst>
   <p:sldIdLst>
     <p:sldId id="256" r:id="rId2"/>
@@ -74,6 +74,7 @@
     <p:sldId id="319" r:id="rId65"/>
     <p:sldId id="320" r:id="rId66"/>
     <p:sldId id="321" r:id="rId67"/>
+    <p:sldId id="322" r:id="rId68"/>
   </p:sldIdLst>
   <p:sldSz cx="9144000" cy="5143500" type="screen16x9"/>
   <p:notesSz cx="6858000" cy="9144000"/>
@@ -6113,63 +6114,35 @@
             </a:pPr>
             <a:r>
               <a:rPr/>
-              <a:t>Say what the axis is before anything else, because nothing else makes sense without it: every dot is one of the 143 tumours in the test set, and its position is the probability our model gave to “malignant”. Not a distance, not a score - a probability, 0 to 1.</a:t>
-            </a:r>
-          </a:p>
-          <a:p>
-            <a:pPr lvl="0" indent="0" marL="0">
-              <a:buNone/>
-            </a:pPr>
-          </a:p>
-          <a:p>
-            <a:pPr lvl="0" indent="0" marL="0">
-              <a:buNone/>
-            </a:pPr>
-            <a:r>
-              <a:rPr/>
-              <a:t>The black line is 0.5, and it is worth saying out loud that nothing chose it. It is the default. Everything to the right of it we flag; everything to the left we send home.</a:t>
-            </a:r>
-          </a:p>
-          <a:p>
-            <a:pPr lvl="0" indent="0" marL="0">
-              <a:buNone/>
-            </a:pPr>
-          </a:p>
-          <a:p>
-            <a:pPr lvl="0" indent="0" marL="0">
-              <a:buNone/>
-            </a:pPr>
-            <a:r>
-              <a:rPr/>
-              <a:t>Now the point of the slide. Most of the picture is the model being certain: 105 of the 143 sit within 0.02 of one end, which is where 0.986 comes from. Tell them to ignore those and look at the middle. The band from 0.11 to 0.62 holds the 12 it was unsure about - 1 malignant, 11 benign - and at 0.5 only two of the twelve are on the wrong side: the malignancy at 0.11 that we missed, and the benign at 0.62 that we flagged.</a:t>
-            </a:r>
-          </a:p>
-          <a:p>
-            <a:pPr lvl="0" indent="0" marL="0">
-              <a:buNone/>
-            </a:pPr>
-          </a:p>
-          <a:p>
-            <a:pPr lvl="0" indent="0" marL="0">
-              <a:buNone/>
-            </a:pPr>
-            <a:r>
-              <a:rPr/>
-              <a:t>Then slide the line, and make them watch the band rather than the numbers. Down to 0.10 and it passes below the whole band: the missed malignancy is caught, and all 11 uncertain benign tumours turn into false alarms. Point at them - the eleven are countable on the slide, which is the whole reason this figure is here rather than a table. Up to 0.90 instead and no false alarm survives, at the price of 7 women sent home who should not have been.</a:t>
-            </a:r>
-          </a:p>
-          <a:p>
-            <a:pPr lvl="0" indent="0" marL="0">
-              <a:buNone/>
-            </a:pPr>
-          </a:p>
-          <a:p>
-            <a:pPr lvl="0" indent="0" marL="0">
-              <a:buNone/>
-            </a:pPr>
-            <a:r>
-              <a:rPr/>
-              <a:t>Nothing about the model changed between those two sentences. So the question of whether it is good has no answer until somebody says which error is worse - which is the earlier slide arriving again, now with a number attached. Lesson 4 spends an hour here.</a:t>
+              <a:t>The previous slide in words, this one in counts. Name the three counts against the confusion matrix two slides back - the class we care about, malignant, is the “positive” one - then read the two formulas as sentences: recall divides by everything that really was malignant, the row; precision divides by everything we flagged, the column. Same numerator, different denominator. That is the whole difference, and the one students mix up.</a:t>
+            </a:r>
+          </a:p>
+          <a:p>
+            <a:pPr lvl="0" indent="0" marL="0">
+              <a:buNone/>
+            </a:pPr>
+          </a:p>
+          <a:p>
+            <a:pPr lvl="0" indent="0" marL="0">
+              <a:buNone/>
+            </a:pPr>
+            <a:r>
+              <a:rPr/>
+              <a:t>Someone will notice the two values are identical and ask why. It is a coincidence of this threshold: one malignancy missed and one false alarm, so both denominators are 53. Move the threshold and they part company: at 0.10 the missed malignancy is caught - recall 53 / 53 = 1.000 - but eleven benign tumours join the alerts, and precision falls to 53 / 64 = 0.828. That is the next slide, drawn.</a:t>
+            </a:r>
+          </a:p>
+          <a:p>
+            <a:pPr lvl="0" indent="0" marL="0">
+              <a:buNone/>
+            </a:pPr>
+          </a:p>
+          <a:p>
+            <a:pPr lvl="0" indent="0" marL="0">
+              <a:buNone/>
+            </a:pPr>
+            <a:r>
+              <a:rPr/>
+              <a:t>Notebook 02, cell after the confusion matrix, prints the same numbers in its classification report. Handout section 7.</a:t>
             </a:r>
           </a:p>
         </p:txBody>
@@ -6251,21 +6224,63 @@
             </a:pPr>
             <a:r>
               <a:rPr/>
-              <a:t>Name where each omission gets addressed: tuning and stability in lesson 5, model families in 6 and 7.</a:t>
-            </a:r>
-          </a:p>
-          <a:p>
-            <a:pPr lvl="0" indent="0" marL="0">
-              <a:buNone/>
-            </a:pPr>
-          </a:p>
-          <a:p>
-            <a:pPr lvl="0" indent="0" marL="0">
-              <a:buNone/>
-            </a:pPr>
-            <a:r>
-              <a:rPr/>
-              <a:t>Then land the last line, which is the point of the slide: that discipline is the reason the 0.986 is worth anything at all. Every one of the four failures we are about to see comes from breaking it in some form.</a:t>
+              <a:t>Say what the axis is before anything else, because nothing else makes sense without it: every dot is one of the 143 tumours in the test set, and its position is the probability our model gave to “malignant”. Not a distance, not a score - a probability, 0 to 1.</a:t>
+            </a:r>
+          </a:p>
+          <a:p>
+            <a:pPr lvl="0" indent="0" marL="0">
+              <a:buNone/>
+            </a:pPr>
+          </a:p>
+          <a:p>
+            <a:pPr lvl="0" indent="0" marL="0">
+              <a:buNone/>
+            </a:pPr>
+            <a:r>
+              <a:rPr/>
+              <a:t>The black line is 0.5, and it is worth saying out loud that nothing chose it. It is the default. Everything to the right of it we flag; everything to the left we send home.</a:t>
+            </a:r>
+          </a:p>
+          <a:p>
+            <a:pPr lvl="0" indent="0" marL="0">
+              <a:buNone/>
+            </a:pPr>
+          </a:p>
+          <a:p>
+            <a:pPr lvl="0" indent="0" marL="0">
+              <a:buNone/>
+            </a:pPr>
+            <a:r>
+              <a:rPr/>
+              <a:t>Now the point of the slide. Most of the picture is the model being certain: 105 of the 143 sit within 0.02 of one end, which is where 0.986 comes from. Tell them to ignore those and look at the middle. The band from 0.11 to 0.62 holds the 12 it was unsure about - 1 malignant, 11 benign - and at 0.5 only two of the twelve are on the wrong side: the malignancy at 0.11 that we missed, and the benign at 0.62 that we flagged.</a:t>
+            </a:r>
+          </a:p>
+          <a:p>
+            <a:pPr lvl="0" indent="0" marL="0">
+              <a:buNone/>
+            </a:pPr>
+          </a:p>
+          <a:p>
+            <a:pPr lvl="0" indent="0" marL="0">
+              <a:buNone/>
+            </a:pPr>
+            <a:r>
+              <a:rPr/>
+              <a:t>Then slide the line, and make them watch the band rather than the numbers. Down to 0.10 and it passes below the whole band: the missed malignancy is caught, and all 11 uncertain benign tumours turn into false alarms. Point at them - the eleven are countable on the slide, which is the whole reason this figure is here rather than a table. Up to 0.90 instead and no false alarm survives, at the price of 7 women sent home who should not have been.</a:t>
+            </a:r>
+          </a:p>
+          <a:p>
+            <a:pPr lvl="0" indent="0" marL="0">
+              <a:buNone/>
+            </a:pPr>
+          </a:p>
+          <a:p>
+            <a:pPr lvl="0" indent="0" marL="0">
+              <a:buNone/>
+            </a:pPr>
+            <a:r>
+              <a:rPr/>
+              <a:t>Nothing about the model changed between those two sentences. So the question of whether it is good has no answer until somebody says which error is worse - which is the earlier slide arriving again, now with a number attached. Lesson 4 spends an hour here.</a:t>
             </a:r>
           </a:p>
         </p:txBody>
@@ -6347,21 +6362,21 @@
             </a:pPr>
             <a:r>
               <a:rPr/>
-              <a:t>The frame, and the next slide opens the notebook: none of these is a coding error. All four run exactly as written and return a number that a reviewer, a supervisor or a customer would accept.</a:t>
-            </a:r>
-          </a:p>
-          <a:p>
-            <a:pPr lvl="0" indent="0" marL="0">
-              <a:buNone/>
-            </a:pPr>
-          </a:p>
-          <a:p>
-            <a:pPr lvl="0" indent="0" marL="0">
-              <a:buNone/>
-            </a:pPr>
-            <a:r>
-              <a:rPr/>
-              <a:t>This is the section they should still remember in five years. Handout section 7 summarises it, and every one of the four has been found in published work and in shipped products.</a:t>
+              <a:t>Name where each omission gets addressed: tuning and stability in lesson 5, model families in 6 and 7.</a:t>
+            </a:r>
+          </a:p>
+          <a:p>
+            <a:pPr lvl="0" indent="0" marL="0">
+              <a:buNone/>
+            </a:pPr>
+          </a:p>
+          <a:p>
+            <a:pPr lvl="0" indent="0" marL="0">
+              <a:buNone/>
+            </a:pPr>
+            <a:r>
+              <a:rPr/>
+              <a:t>Then land the last line, which is the point of the slide: that discipline is the reason the 0.986 is worth anything at all. Every one of the four failures we are about to see comes from breaking it in some form.</a:t>
             </a:r>
           </a:p>
         </p:txBody>
@@ -6443,35 +6458,21 @@
             </a:pPr>
             <a:r>
               <a:rPr/>
-              <a:t>25 minutes, again alongside the slides that follow rather than instead of them.</a:t>
-            </a:r>
-          </a:p>
-          <a:p>
-            <a:pPr lvl="0" indent="0" marL="0">
-              <a:buNone/>
-            </a:pPr>
-          </a:p>
-          <a:p>
-            <a:pPr lvl="0" indent="0" marL="0">
-              <a:buNone/>
-            </a:pPr>
-            <a:r>
-              <a:rPr/>
-              <a:t>Say what to watch for before they start, because the notebook is deliberately undramatic: every cell runs, nothing raises, and every number it prints would pass a review. The work is reading them.</a:t>
-            </a:r>
-          </a:p>
-          <a:p>
-            <a:pPr lvl="0" indent="0" marL="0">
-              <a:buNone/>
-            </a:pPr>
-          </a:p>
-          <a:p>
-            <a:pPr lvl="0" indent="0" marL="0">
-              <a:buNone/>
-            </a:pPr>
-            <a:r>
-              <a:rPr/>
-              <a:t>The two cells to make sure nobody skips: the leaked selection reaching 77% on labels generated by a coin flip, and the four deployment scenarios for the shortcut column, where the two that raise an exception turn out to be the lucky ones.</a:t>
+              <a:t>The frame, and the next slide opens the notebook: none of these is a coding error. All four run exactly as written and return a number that a reviewer, a supervisor or a customer would accept.</a:t>
+            </a:r>
+          </a:p>
+          <a:p>
+            <a:pPr lvl="0" indent="0" marL="0">
+              <a:buNone/>
+            </a:pPr>
+          </a:p>
+          <a:p>
+            <a:pPr lvl="0" indent="0" marL="0">
+              <a:buNone/>
+            </a:pPr>
+            <a:r>
+              <a:rPr/>
+              <a:t>This is the section they should still remember in five years. Handout section 7 summarises it, and every one of the four has been found in published work and in shipped products.</a:t>
             </a:r>
           </a:p>
         </p:txBody>
@@ -6553,21 +6554,35 @@
             </a:pPr>
             <a:r>
               <a:rPr/>
-              <a:t>Set this up carefully before revealing anything. Make sure they understand the data is pure noise BY CONSTRUCTION - the labels come from a random number generator and no feature carries any information about them.</a:t>
-            </a:r>
-          </a:p>
-          <a:p>
-            <a:pPr lvl="0" indent="0" marL="0">
-              <a:buNone/>
-            </a:pPr>
-          </a:p>
-          <a:p>
-            <a:pPr lvl="0" indent="0" marL="0">
-              <a:buNone/>
-            </a:pPr>
-            <a:r>
-              <a:rPr/>
-              <a:t>Ask what accuracy they expect. The honest answer is 50%, chance.</a:t>
+              <a:t>25 minutes, again alongside the slides that follow rather than instead of them.</a:t>
+            </a:r>
+          </a:p>
+          <a:p>
+            <a:pPr lvl="0" indent="0" marL="0">
+              <a:buNone/>
+            </a:pPr>
+          </a:p>
+          <a:p>
+            <a:pPr lvl="0" indent="0" marL="0">
+              <a:buNone/>
+            </a:pPr>
+            <a:r>
+              <a:rPr/>
+              <a:t>Say what to watch for before they start, because the notebook is deliberately undramatic: every cell runs, nothing raises, and every number it prints would pass a review. The work is reading them.</a:t>
+            </a:r>
+          </a:p>
+          <a:p>
+            <a:pPr lvl="0" indent="0" marL="0">
+              <a:buNone/>
+            </a:pPr>
+          </a:p>
+          <a:p>
+            <a:pPr lvl="0" indent="0" marL="0">
+              <a:buNone/>
+            </a:pPr>
+            <a:r>
+              <a:rPr/>
+              <a:t>The two cells to make sure nobody skips: the leaked selection reaching 77% on labels generated by a coin flip, and the four deployment scenarios for the shortcut column, where the two that raise an exception turn out to be the lucky ones.</a:t>
             </a:r>
           </a:p>
         </p:txBody>
@@ -6649,49 +6664,21 @@
             </a:pPr>
             <a:r>
               <a:rPr/>
-              <a:t>77% on pure noise, against 50% for the honest pipeline.</a:t>
-            </a:r>
-          </a:p>
-          <a:p>
-            <a:pPr lvl="0" indent="0" marL="0">
-              <a:buNone/>
-            </a:pPr>
-          </a:p>
-          <a:p>
-            <a:pPr lvl="0" indent="0" marL="0">
-              <a:buNone/>
-            </a:pPr>
-            <a:r>
-              <a:rPr/>
-              <a:t>Explain the mechanism: with 5000 random features, some correlate with the labels by chance. Selecting the best 20 using the whole dataset picks exactly those - including the ones that correlate with the labels of rows that later become the test set. The selection encoded information about the test labels, and the model inherited it.</a:t>
-            </a:r>
-          </a:p>
-          <a:p>
-            <a:pPr lvl="0" indent="0" marL="0">
-              <a:buNone/>
-            </a:pPr>
-          </a:p>
-          <a:p>
-            <a:pPr lvl="0" indent="0" marL="0">
-              <a:buNone/>
-            </a:pPr>
-            <a:r>
-              <a:rPr/>
-              <a:t>Nobody wrote a bug. Selection feels harmless because it fits no model - but it LEARNS from data, so it belongs inside the training fold.</a:t>
-            </a:r>
-          </a:p>
-          <a:p>
-            <a:pPr lvl="0" indent="0" marL="0">
-              <a:buNone/>
-            </a:pPr>
-          </a:p>
-          <a:p>
-            <a:pPr lvl="0" indent="0" marL="0">
-              <a:buNone/>
-            </a:pPr>
-            <a:r>
-              <a:rPr/>
-              <a:t>Then ask what happens with 20000 features instead of 5000. The illusion gets STRONGER, because there are more opportunities for a spurious correlation. That is the “try this” at the end of the notebook.</a:t>
+              <a:t>Set this up carefully before revealing anything. Make sure they understand the data is pure noise BY CONSTRUCTION - the labels come from a random number generator and no feature carries any information about them.</a:t>
+            </a:r>
+          </a:p>
+          <a:p>
+            <a:pPr lvl="0" indent="0" marL="0">
+              <a:buNone/>
+            </a:pPr>
+          </a:p>
+          <a:p>
+            <a:pPr lvl="0" indent="0" marL="0">
+              <a:buNone/>
+            </a:pPr>
+            <a:r>
+              <a:rPr/>
+              <a:t>Ask what accuracy they expect. The honest answer is 50%, chance.</a:t>
             </a:r>
           </a:p>
         </p:txBody>
@@ -6773,35 +6760,49 @@
             </a:pPr>
             <a:r>
               <a:rPr/>
-              <a:t>The practical takeaway from the whole leakage section, and the thing to put on the board if anything goes on the board today.</a:t>
-            </a:r>
-          </a:p>
-          <a:p>
-            <a:pPr lvl="0" indent="0" marL="0">
-              <a:buNone/>
-            </a:pPr>
-          </a:p>
-          <a:p>
-            <a:pPr lvl="0" indent="0" marL="0">
-              <a:buNone/>
-            </a:pPr>
-            <a:r>
-              <a:rPr/>
-              <a:t>Pipelines enforce it structurally, which is why we used one from the first notebook.</a:t>
-            </a:r>
-          </a:p>
-          <a:p>
-            <a:pPr lvl="0" indent="0" marL="0">
-              <a:buNone/>
-            </a:pPr>
-          </a:p>
-          <a:p>
-            <a:pPr lvl="0" indent="0" marL="0">
-              <a:buNone/>
-            </a:pPr>
-            <a:r>
-              <a:rPr/>
-              <a:t>Tell them the exercise checks this: scaling the full dataset before splitting caps the methodology marks regardless of the result obtained.</a:t>
+              <a:t>77% on pure noise, against 50% for the honest pipeline.</a:t>
+            </a:r>
+          </a:p>
+          <a:p>
+            <a:pPr lvl="0" indent="0" marL="0">
+              <a:buNone/>
+            </a:pPr>
+          </a:p>
+          <a:p>
+            <a:pPr lvl="0" indent="0" marL="0">
+              <a:buNone/>
+            </a:pPr>
+            <a:r>
+              <a:rPr/>
+              <a:t>Explain the mechanism: with 5000 random features, some correlate with the labels by chance. Selecting the best 20 using the whole dataset picks exactly those - including the ones that correlate with the labels of rows that later become the test set. The selection encoded information about the test labels, and the model inherited it.</a:t>
+            </a:r>
+          </a:p>
+          <a:p>
+            <a:pPr lvl="0" indent="0" marL="0">
+              <a:buNone/>
+            </a:pPr>
+          </a:p>
+          <a:p>
+            <a:pPr lvl="0" indent="0" marL="0">
+              <a:buNone/>
+            </a:pPr>
+            <a:r>
+              <a:rPr/>
+              <a:t>Nobody wrote a bug. Selection feels harmless because it fits no model - but it LEARNS from data, so it belongs inside the training fold.</a:t>
+            </a:r>
+          </a:p>
+          <a:p>
+            <a:pPr lvl="0" indent="0" marL="0">
+              <a:buNone/>
+            </a:pPr>
+          </a:p>
+          <a:p>
+            <a:pPr lvl="0" indent="0" marL="0">
+              <a:buNone/>
+            </a:pPr>
+            <a:r>
+              <a:rPr/>
+              <a:t>Then ask what happens with 20000 features instead of 5000. The illusion gets STRONGER, because there are more opportunities for a spurious correlation. That is the “try this” at the end of the notebook.</a:t>
             </a:r>
           </a:p>
         </p:txBody>
@@ -6883,35 +6884,35 @@
             </a:pPr>
             <a:r>
               <a:rPr/>
-              <a:t>The trained model in the notebook reaches 0.987 accuracy - barely above the trivial one - while missing 20 of the 21 positives in the test set.</a:t>
-            </a:r>
-          </a:p>
-          <a:p>
-            <a:pPr lvl="0" indent="0" marL="0">
-              <a:buNone/>
-            </a:pPr>
-          </a:p>
-          <a:p>
-            <a:pPr lvl="0" indent="0" marL="0">
-              <a:buNone/>
-            </a:pPr>
-            <a:r>
-              <a:rPr/>
-              <a:t>On a problem where the positives are the entire reason the system exists.</a:t>
-            </a:r>
-          </a:p>
-          <a:p>
-            <a:pPr lvl="0" indent="0" marL="0">
-              <a:buNone/>
-            </a:pPr>
-          </a:p>
-          <a:p>
-            <a:pPr lvl="0" indent="0" marL="0">
-              <a:buNone/>
-            </a:pPr>
-            <a:r>
-              <a:rPr/>
-              <a:t>Accuracy is dominated by the class nobody is looking for. Ask them what metric they would report to someone deploying this, and steer towards recall on the positive class - then note that recall alone is also gameable, by flagging everything, which is why lesson 4 needs a whole session.</a:t>
+              <a:t>The practical takeaway from the whole leakage section, and the thing to put on the board if anything goes on the board today.</a:t>
+            </a:r>
+          </a:p>
+          <a:p>
+            <a:pPr lvl="0" indent="0" marL="0">
+              <a:buNone/>
+            </a:pPr>
+          </a:p>
+          <a:p>
+            <a:pPr lvl="0" indent="0" marL="0">
+              <a:buNone/>
+            </a:pPr>
+            <a:r>
+              <a:rPr/>
+              <a:t>Pipelines enforce it structurally, which is why we used one from the first notebook.</a:t>
+            </a:r>
+          </a:p>
+          <a:p>
+            <a:pPr lvl="0" indent="0" marL="0">
+              <a:buNone/>
+            </a:pPr>
+          </a:p>
+          <a:p>
+            <a:pPr lvl="0" indent="0" marL="0">
+              <a:buNone/>
+            </a:pPr>
+            <a:r>
+              <a:rPr/>
+              <a:t>Tell them the exercise checks this: scaling the full dataset before splitting caps the methodology marks regardless of the result obtained.</a:t>
             </a:r>
           </a:p>
         </p:txBody>
@@ -6993,35 +6994,35 @@
             </a:pPr>
             <a:r>
               <a:rPr/>
-              <a:t>Two confusion matrices side by side. Give them a moment to spot that the accuracies agree to three decimal places.</a:t>
-            </a:r>
-          </a:p>
-          <a:p>
-            <a:pPr lvl="0" indent="0" marL="0">
-              <a:buNone/>
-            </a:pPr>
-          </a:p>
-          <a:p>
-            <a:pPr lvl="0" indent="0" marL="0">
-              <a:buNone/>
-            </a:pPr>
-            <a:r>
-              <a:rPr/>
-              <a:t>Left is the model that answers negative every time and has learned nothing whatever. Right is a trained model. 0.986 against 0.987 - and the one on the right finds a single positive out of twenty-one, which is barely better than nothing but is not nothing.</a:t>
-            </a:r>
-          </a:p>
-          <a:p>
-            <a:pPr lvl="0" indent="0" marL="0">
-              <a:buNone/>
-            </a:pPr>
-          </a:p>
-          <a:p>
-            <a:pPr lvl="0" indent="0" marL="0">
-              <a:buNone/>
-            </a:pPr>
-            <a:r>
-              <a:rPr/>
-              <a:t>Ask what a report containing only the accuracy would say about these two, and let the silence do the work. Then point at the bottom-left cell of each: 21 missed, then 20 missed. That is the number the application cares about, and it is the one accuracy averages away.</a:t>
+              <a:t>The trained model in the notebook reaches 0.987 accuracy - barely above the trivial one - while missing 20 of the 21 positives in the test set.</a:t>
+            </a:r>
+          </a:p>
+          <a:p>
+            <a:pPr lvl="0" indent="0" marL="0">
+              <a:buNone/>
+            </a:pPr>
+          </a:p>
+          <a:p>
+            <a:pPr lvl="0" indent="0" marL="0">
+              <a:buNone/>
+            </a:pPr>
+            <a:r>
+              <a:rPr/>
+              <a:t>On a problem where the positives are the entire reason the system exists.</a:t>
+            </a:r>
+          </a:p>
+          <a:p>
+            <a:pPr lvl="0" indent="0" marL="0">
+              <a:buNone/>
+            </a:pPr>
+          </a:p>
+          <a:p>
+            <a:pPr lvl="0" indent="0" marL="0">
+              <a:buNone/>
+            </a:pPr>
+            <a:r>
+              <a:rPr/>
+              <a:t>Accuracy is dominated by the class nobody is looking for. Ask them what metric they would report to someone deploying this, and steer towards recall on the positive class - then note that recall alone is also gameable, by flagging everything, which is why lesson 4 needs a whole session.</a:t>
             </a:r>
           </a:p>
         </p:txBody>
@@ -7103,49 +7104,35 @@
             </a:pPr>
             <a:r>
               <a:rPr/>
-              <a:t>Explain why it is worthless: biopsies are scheduled once malignancy is already suspected, so the field is populated AFTER the diagnosis it is supposed to predict. At prediction time for a new patient it is empty.</a:t>
-            </a:r>
-          </a:p>
-          <a:p>
-            <a:pPr lvl="0" indent="0" marL="0">
-              <a:buNone/>
-            </a:pPr>
-          </a:p>
-          <a:p>
-            <a:pPr lvl="0" indent="0" marL="0">
-              <a:buNone/>
-            </a:pPr>
-            <a:r>
-              <a:rPr/>
-              <a:t>Then the point that makes this different from the others: no metric detects it, including cross-validated ones, because the information genuinely IS in the training data. The model is not cheating; the data is.</a:t>
-            </a:r>
-          </a:p>
-          <a:p>
-            <a:pPr lvl="0" indent="0" marL="0">
-              <a:buNone/>
-            </a:pPr>
-          </a:p>
-          <a:p>
-            <a:pPr lvl="0" indent="0" marL="0">
-              <a:buNone/>
-            </a:pPr>
-            <a:r>
-              <a:rPr/>
-              <a:t>Only knowing how the data was recorded catches it. Ask them to imagine a hospital extract with 200 columns and no documentation - which is the normal case - and to think about how they would find this.</a:t>
-            </a:r>
-          </a:p>
-          <a:p>
-            <a:pPr lvl="0" indent="0" marL="0">
-              <a:buNone/>
-            </a:pPr>
-          </a:p>
-          <a:p>
-            <a:pPr lvl="0" indent="0" marL="0">
-              <a:buNone/>
-            </a:pPr>
-            <a:r>
-              <a:rPr/>
-              <a:t>The question to carry: at the moment a prediction is needed, does this value exist yet?</a:t>
+              <a:t>Two confusion matrices side by side. Give them a moment to spot that the accuracies agree to three decimal places.</a:t>
+            </a:r>
+          </a:p>
+          <a:p>
+            <a:pPr lvl="0" indent="0" marL="0">
+              <a:buNone/>
+            </a:pPr>
+          </a:p>
+          <a:p>
+            <a:pPr lvl="0" indent="0" marL="0">
+              <a:buNone/>
+            </a:pPr>
+            <a:r>
+              <a:rPr/>
+              <a:t>Left is the model that answers negative every time and has learned nothing whatever. Right is a trained model. 0.986 against 0.987 - and the one on the right finds a single positive out of twenty-one, which is barely better than nothing but is not nothing.</a:t>
+            </a:r>
+          </a:p>
+          <a:p>
+            <a:pPr lvl="0" indent="0" marL="0">
+              <a:buNone/>
+            </a:pPr>
+          </a:p>
+          <a:p>
+            <a:pPr lvl="0" indent="0" marL="0">
+              <a:buNone/>
+            </a:pPr>
+            <a:r>
+              <a:rPr/>
+              <a:t>Ask what a report containing only the accuracy would say about these two, and let the silence do the work. Then point at the bottom-left cell of each: 21 missed, then 20 missed. That is the number the application cares about, and it is the one accuracy averages away.</a:t>
             </a:r>
           </a:p>
         </p:txBody>
@@ -7351,49 +7338,49 @@
             </a:pPr>
             <a:r>
               <a:rPr/>
-              <a:t>A timeline, with the moment of prediction marked, and everything that happens after it shaded.</a:t>
-            </a:r>
-          </a:p>
-          <a:p>
-            <a:pPr lvl="0" indent="0" marL="0">
-              <a:buNone/>
-            </a:pPr>
-          </a:p>
-          <a:p>
-            <a:pPr lvl="0" indent="0" marL="0">
-              <a:buNone/>
-            </a:pPr>
-            <a:r>
-              <a:rPr/>
-              <a:t>Walk left to right: the scan is taken, measurements are recorded - both before the prediction is needed, both usable. Then the shaded region: the diagnosis is made, the biopsy is scheduled. A model leaning on biopsy_scheduled scores beautifully in the notebook and has nothing to read at the moment it would actually be used.</a:t>
-            </a:r>
-          </a:p>
-          <a:p>
-            <a:pPr lvl="0" indent="0" marL="0">
-              <a:buNone/>
-            </a:pPr>
-          </a:p>
-          <a:p>
-            <a:pPr lvl="0" indent="0" marL="0">
-              <a:buNone/>
-            </a:pPr>
-            <a:r>
-              <a:rPr/>
-              <a:t>The shaded region is the trap: everything to the right of the marked moment happens after a prediction is needed, so none of it can be an input.</a:t>
-            </a:r>
-          </a:p>
-          <a:p>
-            <a:pPr lvl="0" indent="0" marL="0">
-              <a:buNone/>
-            </a:pPr>
-          </a:p>
-          <a:p>
-            <a:pPr lvl="0" indent="0" marL="0">
-              <a:buNone/>
-            </a:pPr>
-            <a:r>
-              <a:rPr/>
-              <a:t>The question in the title is the one to make a habit of, and it is worth saying that it cannot be answered by looking at the data. It is answered by asking somebody who knows how the data is produced. Put it to them as the thing to ask of every column in every dataset they are handed.</a:t>
+              <a:t>Explain why it is worthless: biopsies are scheduled once malignancy is already suspected, so the field is populated AFTER the diagnosis it is supposed to predict. At prediction time for a new patient it is empty.</a:t>
+            </a:r>
+          </a:p>
+          <a:p>
+            <a:pPr lvl="0" indent="0" marL="0">
+              <a:buNone/>
+            </a:pPr>
+          </a:p>
+          <a:p>
+            <a:pPr lvl="0" indent="0" marL="0">
+              <a:buNone/>
+            </a:pPr>
+            <a:r>
+              <a:rPr/>
+              <a:t>Then the point that makes this different from the others: no metric detects it, including cross-validated ones, because the information genuinely IS in the training data. The model is not cheating; the data is.</a:t>
+            </a:r>
+          </a:p>
+          <a:p>
+            <a:pPr lvl="0" indent="0" marL="0">
+              <a:buNone/>
+            </a:pPr>
+          </a:p>
+          <a:p>
+            <a:pPr lvl="0" indent="0" marL="0">
+              <a:buNone/>
+            </a:pPr>
+            <a:r>
+              <a:rPr/>
+              <a:t>Only knowing how the data was recorded catches it. Ask them to imagine a hospital extract with 200 columns and no documentation - which is the normal case - and to think about how they would find this.</a:t>
+            </a:r>
+          </a:p>
+          <a:p>
+            <a:pPr lvl="0" indent="0" marL="0">
+              <a:buNone/>
+            </a:pPr>
+          </a:p>
+          <a:p>
+            <a:pPr lvl="0" indent="0" marL="0">
+              <a:buNone/>
+            </a:pPr>
+            <a:r>
+              <a:rPr/>
+              <a:t>The question to carry: at the moment a prediction is needed, does this value exist yet?</a:t>
             </a:r>
           </a:p>
         </p:txBody>
@@ -7475,63 +7462,49 @@
             </a:pPr>
             <a:r>
               <a:rPr/>
-              <a:t>Same model, same data, 30 different random seeds. Accuracy ranges from 0.917 to 1.000 - a spread of 0.083.</a:t>
-            </a:r>
-          </a:p>
-          <a:p>
-            <a:pPr lvl="0" indent="0" marL="0">
-              <a:buNone/>
-            </a:pPr>
-          </a:p>
-          <a:p>
-            <a:pPr lvl="0" indent="0" marL="0">
-              <a:buNone/>
-            </a:pPr>
-            <a:r>
-              <a:rPr/>
-              <a:t>That is larger than most claimed improvements between competing methods in published work. Let that land.</a:t>
-            </a:r>
-          </a:p>
-          <a:p>
-            <a:pPr lvl="0" indent="0" marL="0">
-              <a:buNone/>
-            </a:pPr>
-          </a:p>
-          <a:p>
-            <a:pPr lvl="0" indent="0" marL="0">
-              <a:buNone/>
-            </a:pPr>
-            <a:r>
-              <a:rPr/>
-              <a:t>Pick your favourite seed and you can report anything in that range, and a reader seeing one number cannot tell which you got. This is not fraud; it is the default behaviour of anyone who runs the code once.</a:t>
-            </a:r>
-          </a:p>
-          <a:p>
-            <a:pPr lvl="0" indent="0" marL="0">
-              <a:buNone/>
-            </a:pPr>
-          </a:p>
-          <a:p>
-            <a:pPr lvl="0" indent="0" marL="0">
-              <a:buNone/>
-            </a:pPr>
-            <a:r>
-              <a:rPr/>
-              <a:t>Cross-validation replaces the single draw with an average and - more usefully - reports the spread. On this data, 5-fold gives 0.960 ± 0.030.</a:t>
-            </a:r>
-          </a:p>
-          <a:p>
-            <a:pPr lvl="0" indent="0" marL="0">
-              <a:buNone/>
-            </a:pPr>
-          </a:p>
-          <a:p>
-            <a:pPr lvl="0" indent="0" marL="0">
-              <a:buNone/>
-            </a:pPr>
-            <a:r>
-              <a:rPr/>
-              <a:t>A result quoted with no indication of variability is incomplete. Lesson 5 makes this the centre of the course.</a:t>
+              <a:t>A timeline, with the moment of prediction marked, and everything that happens after it shaded.</a:t>
+            </a:r>
+          </a:p>
+          <a:p>
+            <a:pPr lvl="0" indent="0" marL="0">
+              <a:buNone/>
+            </a:pPr>
+          </a:p>
+          <a:p>
+            <a:pPr lvl="0" indent="0" marL="0">
+              <a:buNone/>
+            </a:pPr>
+            <a:r>
+              <a:rPr/>
+              <a:t>Walk left to right: the scan is taken, measurements are recorded - both before the prediction is needed, both usable. Then the shaded region: the diagnosis is made, the biopsy is scheduled. A model leaning on biopsy_scheduled scores beautifully in the notebook and has nothing to read at the moment it would actually be used.</a:t>
+            </a:r>
+          </a:p>
+          <a:p>
+            <a:pPr lvl="0" indent="0" marL="0">
+              <a:buNone/>
+            </a:pPr>
+          </a:p>
+          <a:p>
+            <a:pPr lvl="0" indent="0" marL="0">
+              <a:buNone/>
+            </a:pPr>
+            <a:r>
+              <a:rPr/>
+              <a:t>The shaded region is the trap: everything to the right of the marked moment happens after a prediction is needed, so none of it can be an input.</a:t>
+            </a:r>
+          </a:p>
+          <a:p>
+            <a:pPr lvl="0" indent="0" marL="0">
+              <a:buNone/>
+            </a:pPr>
+          </a:p>
+          <a:p>
+            <a:pPr lvl="0" indent="0" marL="0">
+              <a:buNone/>
+            </a:pPr>
+            <a:r>
+              <a:rPr/>
+              <a:t>The question in the title is the one to make a habit of, and it is worth saying that it cannot be answered by looking at the data. It is answered by asking somebody who knows how the data is produced. Put it to them as the thing to ask of every column in every dataset they are handed.</a:t>
             </a:r>
           </a:p>
         </p:txBody>
@@ -7613,35 +7586,63 @@
             </a:pPr>
             <a:r>
               <a:rPr/>
-              <a:t>They are caught by asking questions about the data and the process, not by reading the metric.</a:t>
-            </a:r>
-          </a:p>
-          <a:p>
-            <a:pPr lvl="0" indent="0" marL="0">
-              <a:buNone/>
-            </a:pPr>
-          </a:p>
-          <a:p>
-            <a:pPr lvl="0" indent="0" marL="0">
-              <a:buNone/>
-            </a:pPr>
-            <a:r>
-              <a:rPr/>
-              <a:t>Give them the three questions to carry out of this room: where did this number come from, what does it leave out, and would it still hold on data I have never touched?</a:t>
-            </a:r>
-          </a:p>
-          <a:p>
-            <a:pPr lvl="0" indent="0" marL="0">
-              <a:buNone/>
-            </a:pPr>
-          </a:p>
-          <a:p>
-            <a:pPr lvl="0" indent="0" marL="0">
-              <a:buNone/>
-            </a:pPr>
-            <a:r>
-              <a:rPr/>
-              <a:t>Then the professional version, connecting back to the history section: the habit of distinguishing what was demonstrated from what was extrapolated is the same habit, applied to your own work instead of someone else’s.</a:t>
+              <a:t>Same model, same data, 30 different random seeds. Accuracy ranges from 0.917 to 1.000 - a spread of 0.083.</a:t>
+            </a:r>
+          </a:p>
+          <a:p>
+            <a:pPr lvl="0" indent="0" marL="0">
+              <a:buNone/>
+            </a:pPr>
+          </a:p>
+          <a:p>
+            <a:pPr lvl="0" indent="0" marL="0">
+              <a:buNone/>
+            </a:pPr>
+            <a:r>
+              <a:rPr/>
+              <a:t>That is larger than most claimed improvements between competing methods in published work. Let that land.</a:t>
+            </a:r>
+          </a:p>
+          <a:p>
+            <a:pPr lvl="0" indent="0" marL="0">
+              <a:buNone/>
+            </a:pPr>
+          </a:p>
+          <a:p>
+            <a:pPr lvl="0" indent="0" marL="0">
+              <a:buNone/>
+            </a:pPr>
+            <a:r>
+              <a:rPr/>
+              <a:t>Pick your favourite seed and you can report anything in that range, and a reader seeing one number cannot tell which you got. This is not fraud; it is the default behaviour of anyone who runs the code once.</a:t>
+            </a:r>
+          </a:p>
+          <a:p>
+            <a:pPr lvl="0" indent="0" marL="0">
+              <a:buNone/>
+            </a:pPr>
+          </a:p>
+          <a:p>
+            <a:pPr lvl="0" indent="0" marL="0">
+              <a:buNone/>
+            </a:pPr>
+            <a:r>
+              <a:rPr/>
+              <a:t>Cross-validation replaces the single draw with an average and - more usefully - reports the spread. On this data, 5-fold gives 0.960 ± 0.030.</a:t>
+            </a:r>
+          </a:p>
+          <a:p>
+            <a:pPr lvl="0" indent="0" marL="0">
+              <a:buNone/>
+            </a:pPr>
+          </a:p>
+          <a:p>
+            <a:pPr lvl="0" indent="0" marL="0">
+              <a:buNone/>
+            </a:pPr>
+            <a:r>
+              <a:rPr/>
+              <a:t>A result quoted with no indication of variability is incomplete. Lesson 5 makes this the centre of the course.</a:t>
             </a:r>
           </a:p>
         </p:txBody>
@@ -7723,63 +7724,35 @@
             </a:pPr>
             <a:r>
               <a:rPr/>
-              <a:t>Close the loop with the “when not to use ML” slide. Handout section 8.</a:t>
-            </a:r>
-          </a:p>
-          <a:p>
-            <a:pPr lvl="0" indent="0" marL="0">
-              <a:buNone/>
-            </a:pPr>
-          </a:p>
-          <a:p>
-            <a:pPr lvl="0" indent="0" marL="0">
-              <a:buNone/>
-            </a:pPr>
-            <a:r>
-              <a:rPr/>
-              <a:t>If past decisions discriminated, a model fitted to them discriminates too - and it does so with an appearance of objectivity that makes it HARDER to contest than a human decision would be. “The algorithm decided” is a much harder claim to argue with than “the manager decided”.</a:t>
-            </a:r>
-          </a:p>
-          <a:p>
-            <a:pPr lvl="0" indent="0" marL="0">
-              <a:buNone/>
-            </a:pPr>
-          </a:p>
-          <a:p>
-            <a:pPr lvl="0" indent="0" marL="0">
-              <a:buNone/>
-            </a:pPr>
-            <a:r>
-              <a:rPr/>
-              <a:t>Second point: nothing in empirical risk minimisation distinguishes a cause from a coincidence that predicts well in this sample. A model can be highly accurate and completely wrong about why - which is exactly why it fails abruptly when conditions change.</a:t>
-            </a:r>
-          </a:p>
-          <a:p>
-            <a:pPr lvl="0" indent="0" marL="0">
-              <a:buNone/>
-            </a:pPr>
-          </a:p>
-          <a:p>
-            <a:pPr lvl="0" indent="0" marL="0">
-              <a:buNone/>
-            </a:pPr>
-            <a:r>
-              <a:rPr/>
-              <a:t>Third: whether a decision can be explained to the person affected, whether errors are recoverable, and who bears the cost of being wrong are engineering requirements. They belong in step 1, where they can still change what you build, not in a paragraph at the end of a report.</a:t>
-            </a:r>
-          </a:p>
-          <a:p>
-            <a:pPr lvl="0" indent="0" marL="0">
-              <a:buNone/>
-            </a:pPr>
-          </a:p>
-          <a:p>
-            <a:pPr lvl="0" indent="0" marL="0">
-              <a:buNone/>
-            </a:pPr>
-            <a:r>
-              <a:rPr/>
-              <a:t>Keep this short and serious. Do not moralise - state it and move on.</a:t>
+              <a:t>They are caught by asking questions about the data and the process, not by reading the metric.</a:t>
+            </a:r>
+          </a:p>
+          <a:p>
+            <a:pPr lvl="0" indent="0" marL="0">
+              <a:buNone/>
+            </a:pPr>
+          </a:p>
+          <a:p>
+            <a:pPr lvl="0" indent="0" marL="0">
+              <a:buNone/>
+            </a:pPr>
+            <a:r>
+              <a:rPr/>
+              <a:t>Give them the three questions to carry out of this room: where did this number come from, what does it leave out, and would it still hold on data I have never touched?</a:t>
+            </a:r>
+          </a:p>
+          <a:p>
+            <a:pPr lvl="0" indent="0" marL="0">
+              <a:buNone/>
+            </a:pPr>
+          </a:p>
+          <a:p>
+            <a:pPr lvl="0" indent="0" marL="0">
+              <a:buNone/>
+            </a:pPr>
+            <a:r>
+              <a:rPr/>
+              <a:t>Then the professional version, connecting back to the history section: the habit of distinguishing what was demonstrated from what was extrapolated is the same habit, applied to your own work instead of someone else’s.</a:t>
             </a:r>
           </a:p>
         </p:txBody>
@@ -7861,49 +7834,63 @@
             </a:pPr>
             <a:r>
               <a:rPr/>
-              <a:t>Set it explicitly - do not let anyone leave without knowing it exists and when it is due.</a:t>
-            </a:r>
-          </a:p>
-          <a:p>
-            <a:pPr lvl="0" indent="0" marL="0">
-              <a:buNone/>
-            </a:pPr>
-          </a:p>
-          <a:p>
-            <a:pPr lvl="0" indent="0" marL="0">
-              <a:buNone/>
-            </a:pPr>
-            <a:r>
-              <a:rPr/>
-              <a:t>Walk the tasks briefly. Task 1 is framing, and there is no single right answer: quality is an integer from 3 to 9, so they must decide how to treat it and defend the choice. Task 7 - repeat the split with ten seeds - connects directly to the figure they just saw.</a:t>
-            </a:r>
-          </a:p>
-          <a:p>
-            <a:pPr lvl="0" indent="0" marL="0">
-              <a:buNone/>
-            </a:pPr>
-          </a:p>
-          <a:p>
-            <a:pPr lvl="0" indent="0" marL="0">
-              <a:buNone/>
-            </a:pPr>
-            <a:r>
-              <a:rPr/>
-              <a:t>Remind them: scaling the full dataset before splitting loses the methodology marks regardless of the score. And there are no marks for accuracy anywhere in this course.</a:t>
-            </a:r>
-          </a:p>
-          <a:p>
-            <a:pPr lvl="0" indent="0" marL="0">
-              <a:buNone/>
-            </a:pPr>
-          </a:p>
-          <a:p>
-            <a:pPr lvl="0" indent="0" marL="0">
-              <a:buNone/>
-            </a:pPr>
-            <a:r>
-              <a:rPr/>
-              <a:t>Also point them at the quiz - 20 questions, ungraded, and the ones marked “reasoning” are the closest thing there is to the exam, because they ask why rather than what.</a:t>
+              <a:t>Close the loop with the “when not to use ML” slide. Handout section 8.</a:t>
+            </a:r>
+          </a:p>
+          <a:p>
+            <a:pPr lvl="0" indent="0" marL="0">
+              <a:buNone/>
+            </a:pPr>
+          </a:p>
+          <a:p>
+            <a:pPr lvl="0" indent="0" marL="0">
+              <a:buNone/>
+            </a:pPr>
+            <a:r>
+              <a:rPr/>
+              <a:t>If past decisions discriminated, a model fitted to them discriminates too - and it does so with an appearance of objectivity that makes it HARDER to contest than a human decision would be. “The algorithm decided” is a much harder claim to argue with than “the manager decided”.</a:t>
+            </a:r>
+          </a:p>
+          <a:p>
+            <a:pPr lvl="0" indent="0" marL="0">
+              <a:buNone/>
+            </a:pPr>
+          </a:p>
+          <a:p>
+            <a:pPr lvl="0" indent="0" marL="0">
+              <a:buNone/>
+            </a:pPr>
+            <a:r>
+              <a:rPr/>
+              <a:t>Second point: nothing in empirical risk minimisation distinguishes a cause from a coincidence that predicts well in this sample. A model can be highly accurate and completely wrong about why - which is exactly why it fails abruptly when conditions change.</a:t>
+            </a:r>
+          </a:p>
+          <a:p>
+            <a:pPr lvl="0" indent="0" marL="0">
+              <a:buNone/>
+            </a:pPr>
+          </a:p>
+          <a:p>
+            <a:pPr lvl="0" indent="0" marL="0">
+              <a:buNone/>
+            </a:pPr>
+            <a:r>
+              <a:rPr/>
+              <a:t>Third: whether a decision can be explained to the person affected, whether errors are recoverable, and who bears the cost of being wrong are engineering requirements. They belong in step 1, where they can still change what you build, not in a paragraph at the end of a report.</a:t>
+            </a:r>
+          </a:p>
+          <a:p>
+            <a:pPr lvl="0" indent="0" marL="0">
+              <a:buNone/>
+            </a:pPr>
+          </a:p>
+          <a:p>
+            <a:pPr lvl="0" indent="0" marL="0">
+              <a:buNone/>
+            </a:pPr>
+            <a:r>
+              <a:rPr/>
+              <a:t>Keep this short and serious. Do not moralise - state it and move on.</a:t>
             </a:r>
           </a:p>
         </p:txBody>
@@ -7985,35 +7972,49 @@
             </a:pPr>
             <a:r>
               <a:rPr/>
-              <a:t>Close on time and offer to stay for setup problems - it is worth twenty minutes now to avoid three people stuck for a fortnight.</a:t>
-            </a:r>
-          </a:p>
-          <a:p>
-            <a:pPr lvl="0" indent="0" marL="0">
-              <a:buNone/>
-            </a:pPr>
-          </a:p>
-          <a:p>
-            <a:pPr lvl="0" indent="0" marL="0">
-              <a:buNone/>
-            </a:pPr>
-            <a:r>
-              <a:rPr/>
-              <a:t>Tell them lesson 2 goes deeper into data preparation, and that the leakage they saw today was the simple, visible version. The next one is subtler.</a:t>
-            </a:r>
-          </a:p>
-          <a:p>
-            <a:pPr lvl="0" indent="0" marL="0">
-              <a:buNone/>
-            </a:pPr>
-          </a:p>
-          <a:p>
-            <a:pPr lvl="0" indent="0" marL="0">
-              <a:buNone/>
-            </a:pPr>
-            <a:r>
-              <a:rPr/>
-              <a:t>If anyone asks what to read beyond the handout: Resources/history_of_ai.md for context, and the scikit-learn “common pitfalls” page, which is the library’s own account of everything in notebook 03.</a:t>
+              <a:t>Set it explicitly - do not let anyone leave without knowing it exists and when it is due.</a:t>
+            </a:r>
+          </a:p>
+          <a:p>
+            <a:pPr lvl="0" indent="0" marL="0">
+              <a:buNone/>
+            </a:pPr>
+          </a:p>
+          <a:p>
+            <a:pPr lvl="0" indent="0" marL="0">
+              <a:buNone/>
+            </a:pPr>
+            <a:r>
+              <a:rPr/>
+              <a:t>Walk the tasks briefly. Task 1 is framing, and there is no single right answer: quality is an integer from 3 to 9, so they must decide how to treat it and defend the choice. Task 7 - repeat the split with ten seeds - connects directly to the figure they just saw.</a:t>
+            </a:r>
+          </a:p>
+          <a:p>
+            <a:pPr lvl="0" indent="0" marL="0">
+              <a:buNone/>
+            </a:pPr>
+          </a:p>
+          <a:p>
+            <a:pPr lvl="0" indent="0" marL="0">
+              <a:buNone/>
+            </a:pPr>
+            <a:r>
+              <a:rPr/>
+              <a:t>Remind them: scaling the full dataset before splitting loses the methodology marks regardless of the score. And there are no marks for accuracy anywhere in this course.</a:t>
+            </a:r>
+          </a:p>
+          <a:p>
+            <a:pPr lvl="0" indent="0" marL="0">
+              <a:buNone/>
+            </a:pPr>
+          </a:p>
+          <a:p>
+            <a:pPr lvl="0" indent="0" marL="0">
+              <a:buNone/>
+            </a:pPr>
+            <a:r>
+              <a:rPr/>
+              <a:t>Also point them at the quiz - 20 questions, ungraded, and the ones marked “reasoning” are the closest thing there is to the exam, because they ask why rather than what.</a:t>
             </a:r>
           </a:p>
         </p:txBody>
@@ -8036,6 +8037,116 @@
             <a:fld id="{18BDFEC3-8487-43E8-A154-7C12CBC1FFF2}" type="slidenum">
               <a:rPr lang="en-US"/>
               <a:t>66</a:t>
+            </a:fld>
+            <a:endParaRPr lang="en-US"/>
+          </a:p>
+        </p:txBody>
+      </p:sp>
+    </p:spTree>
+  </p:cSld>
+</p:notes>
+</file>
+
+<file path=ppt/notesSlides/notesSlide66.xml><?xml version="1.0" encoding="utf-8"?>
+<p:notes xmlns:a="http://schemas.openxmlformats.org/drawingml/2006/main" xmlns:r="http://schemas.openxmlformats.org/officeDocument/2006/relationships" xmlns:p="http://schemas.openxmlformats.org/presentationml/2006/main">
+  <p:cSld>
+    <p:spTree>
+      <p:nvGrpSpPr>
+        <p:cNvPr id="1" name=""/>
+        <p:cNvGrpSpPr/>
+        <p:nvPr/>
+      </p:nvGrpSpPr>
+      <p:grpSpPr>
+        <a:xfrm>
+          <a:off x="0" y="0"/>
+          <a:ext cx="0" cy="0"/>
+          <a:chOff x="0" y="0"/>
+          <a:chExt cx="0" cy="0"/>
+        </a:xfrm>
+      </p:grpSpPr>
+      <p:sp>
+        <p:nvSpPr>
+          <p:cNvPr id="2" name="Slide Image Placeholder 1"/>
+          <p:cNvSpPr>
+            <a:spLocks noGrp="1" noRot="1" noChangeAspect="1"/>
+          </p:cNvSpPr>
+          <p:nvPr>
+            <p:ph type="sldImg"/>
+          </p:nvPr>
+        </p:nvSpPr>
+        <p:spPr/>
+      </p:sp>
+      <p:sp>
+        <p:nvSpPr>
+          <p:cNvPr id="3" name="Notes Placeholder 2"/>
+          <p:cNvSpPr>
+            <a:spLocks noGrp="1"/>
+          </p:cNvSpPr>
+          <p:nvPr>
+            <p:ph type="body" idx="1"/>
+          </p:nvPr>
+        </p:nvSpPr>
+        <p:spPr/>
+        <p:txBody>
+          <a:bodyPr/>
+          <a:lstStyle/>
+          <a:p>
+            <a:pPr lvl="0" indent="0" marL="0">
+              <a:buNone/>
+            </a:pPr>
+            <a:r>
+              <a:rPr/>
+              <a:t>Close on time and offer to stay for setup problems - it is worth twenty minutes now to avoid three people stuck for a fortnight.</a:t>
+            </a:r>
+          </a:p>
+          <a:p>
+            <a:pPr lvl="0" indent="0" marL="0">
+              <a:buNone/>
+            </a:pPr>
+          </a:p>
+          <a:p>
+            <a:pPr lvl="0" indent="0" marL="0">
+              <a:buNone/>
+            </a:pPr>
+            <a:r>
+              <a:rPr/>
+              <a:t>Tell them lesson 2 goes deeper into data preparation, and that the leakage they saw today was the simple, visible version. The next one is subtler.</a:t>
+            </a:r>
+          </a:p>
+          <a:p>
+            <a:pPr lvl="0" indent="0" marL="0">
+              <a:buNone/>
+            </a:pPr>
+          </a:p>
+          <a:p>
+            <a:pPr lvl="0" indent="0" marL="0">
+              <a:buNone/>
+            </a:pPr>
+            <a:r>
+              <a:rPr/>
+              <a:t>If anyone asks what to read beyond the handout: Resources/history_of_ai.md for context, and the scikit-learn “common pitfalls” page, which is the library’s own account of everything in notebook 03.</a:t>
+            </a:r>
+          </a:p>
+        </p:txBody>
+      </p:sp>
+      <p:sp>
+        <p:nvSpPr>
+          <p:cNvPr id="4" name="Slide Number Placeholder 3"/>
+          <p:cNvSpPr>
+            <a:spLocks noGrp="1"/>
+          </p:cNvSpPr>
+          <p:nvPr>
+            <p:ph type="sldNum" sz="quarter" idx="10"/>
+          </p:nvPr>
+        </p:nvSpPr>
+        <p:spPr/>
+        <p:txBody>
+          <a:bodyPr/>
+          <a:lstStyle/>
+          <a:p>
+            <a:fld id="{18BDFEC3-8487-43E8-A154-7C12CBC1FFF2}" type="slidenum">
+              <a:rPr lang="en-US"/>
+              <a:t>67</a:t>
             </a:fld>
             <a:endParaRPr lang="en-US"/>
           </a:p>
@@ -16970,6 +17081,382 @@
             </a:pPr>
             <a:r>
               <a:rPr/>
+              <a:t>Precision and recall, counted</a:t>
+            </a:r>
+          </a:p>
+        </p:txBody>
+      </p:sp>
+      <p:graphicFrame>
+        <p:nvGraphicFramePr>
+          <p:cNvPr id="6" name="Content Placeholder 5"/>
+          <p:cNvGraphicFramePr>
+            <a:graphicFrameLocks noGrp="1"/>
+          </p:cNvGraphicFramePr>
+          <p:nvPr>
+            <p:ph idx="1"/>
+          </p:nvPr>
+        </p:nvGraphicFramePr>
+        <p:xfrm>
+          <a:off x="457200" y="1166099"/>
+          <a:ext cx="8229600" cy="3390900"/>
+        </p:xfrm>
+        <a:graphic>
+          <a:graphicData uri="http://schemas.openxmlformats.org/drawingml/2006/table">
+            <a:tbl>
+              <a:tblPr firstRow="1" bandRow="1">
+                <a:tableStyleId>{5C22544A-7EE6-4342-B048-85BDC9FD1C3A}</a:tableStyleId>
+              </a:tblPr>
+              <a:tblGrid>
+                <a:gridCol w="2743200"/>
+                <a:gridCol w="2743200"/>
+                <a:gridCol w="2743200"/>
+              </a:tblGrid>
+              <a:tr h="0">
+                <a:tc>
+                  <a:txBody>
+                    <a:bodyPr/>
+                    <a:lstStyle/>
+                    <a:p>
+                      <a:endParaRPr/>
+                    </a:p>
+                  </a:txBody>
+                  <a:tcPr/>
+                </a:tc>
+                <a:tc>
+                  <a:txBody>
+                    <a:bodyPr/>
+                    <a:lstStyle/>
+                    <a:p>
+                      <a:pPr lvl="0" indent="0" marL="0">
+                        <a:buNone/>
+                      </a:pPr>
+                      <a:r>
+                        <a:rPr/>
+                        <a:t>what it counts</a:t>
+                      </a:r>
+                    </a:p>
+                  </a:txBody>
+                  <a:tcPr/>
+                </a:tc>
+                <a:tc>
+                  <a:txBody>
+                    <a:bodyPr/>
+                    <a:lstStyle/>
+                    <a:p>
+                      <a:pPr lvl="0" indent="0" marL="0">
+                        <a:buNone/>
+                      </a:pPr>
+                      <a:r>
+                        <a:rPr/>
+                        <a:t>threshold 0.5</a:t>
+                      </a:r>
+                    </a:p>
+                  </a:txBody>
+                  <a:tcPr/>
+                </a:tc>
+              </a:tr>
+              <a:tr h="0">
+                <a:tc>
+                  <a:txBody>
+                    <a:bodyPr/>
+                    <a:lstStyle/>
+                    <a:p>
+                      <a:pPr lvl="0" indent="0" marL="0">
+                        <a:buNone/>
+                      </a:pPr>
+                      <a:r>
+                        <a:rPr/>
+                        <a:t>true positives (TP)</a:t>
+                      </a:r>
+                    </a:p>
+                  </a:txBody>
+                </a:tc>
+                <a:tc>
+                  <a:txBody>
+                    <a:bodyPr/>
+                    <a:lstStyle/>
+                    <a:p>
+                      <a:pPr lvl="0" indent="0" marL="0">
+                        <a:buNone/>
+                      </a:pPr>
+                      <a:r>
+                        <a:rPr/>
+                        <a:t>malignant, flagged</a:t>
+                      </a:r>
+                    </a:p>
+                  </a:txBody>
+                </a:tc>
+                <a:tc>
+                  <a:txBody>
+                    <a:bodyPr/>
+                    <a:lstStyle/>
+                    <a:p>
+                      <a:pPr lvl="0" indent="0" marL="0">
+                        <a:buNone/>
+                      </a:pPr>
+                      <a:r>
+                        <a:rPr/>
+                        <a:t>52</a:t>
+                      </a:r>
+                    </a:p>
+                  </a:txBody>
+                </a:tc>
+              </a:tr>
+              <a:tr h="0">
+                <a:tc>
+                  <a:txBody>
+                    <a:bodyPr/>
+                    <a:lstStyle/>
+                    <a:p>
+                      <a:pPr lvl="0" indent="0" marL="0">
+                        <a:buNone/>
+                      </a:pPr>
+                      <a:r>
+                        <a:rPr/>
+                        <a:t>false negatives (FN)</a:t>
+                      </a:r>
+                    </a:p>
+                  </a:txBody>
+                </a:tc>
+                <a:tc>
+                  <a:txBody>
+                    <a:bodyPr/>
+                    <a:lstStyle/>
+                    <a:p>
+                      <a:pPr lvl="0" indent="0" marL="0">
+                        <a:buNone/>
+                      </a:pPr>
+                      <a:r>
+                        <a:rPr/>
+                        <a:t>malignant, missed</a:t>
+                      </a:r>
+                    </a:p>
+                  </a:txBody>
+                </a:tc>
+                <a:tc>
+                  <a:txBody>
+                    <a:bodyPr/>
+                    <a:lstStyle/>
+                    <a:p>
+                      <a:pPr lvl="0" indent="0" marL="0">
+                        <a:buNone/>
+                      </a:pPr>
+                      <a:r>
+                        <a:rPr/>
+                        <a:t>1</a:t>
+                      </a:r>
+                    </a:p>
+                  </a:txBody>
+                </a:tc>
+              </a:tr>
+              <a:tr h="0">
+                <a:tc>
+                  <a:txBody>
+                    <a:bodyPr/>
+                    <a:lstStyle/>
+                    <a:p>
+                      <a:pPr lvl="0" indent="0" marL="0">
+                        <a:buNone/>
+                      </a:pPr>
+                      <a:r>
+                        <a:rPr/>
+                        <a:t>false positives (FP)</a:t>
+                      </a:r>
+                    </a:p>
+                  </a:txBody>
+                </a:tc>
+                <a:tc>
+                  <a:txBody>
+                    <a:bodyPr/>
+                    <a:lstStyle/>
+                    <a:p>
+                      <a:pPr lvl="0" indent="0" marL="0">
+                        <a:buNone/>
+                      </a:pPr>
+                      <a:r>
+                        <a:rPr/>
+                        <a:t>benign, flagged</a:t>
+                      </a:r>
+                    </a:p>
+                  </a:txBody>
+                </a:tc>
+                <a:tc>
+                  <a:txBody>
+                    <a:bodyPr/>
+                    <a:lstStyle/>
+                    <a:p>
+                      <a:pPr lvl="0" indent="0" marL="0">
+                        <a:buNone/>
+                      </a:pPr>
+                      <a:r>
+                        <a:rPr/>
+                        <a:t>1</a:t>
+                      </a:r>
+                    </a:p>
+                  </a:txBody>
+                </a:tc>
+              </a:tr>
+              <a:tr h="0">
+                <a:tc>
+                  <a:txBody>
+                    <a:bodyPr/>
+                    <a:lstStyle/>
+                    <a:p>
+                      <a:pPr lvl="0" indent="0" marL="0">
+                        <a:buNone/>
+                      </a:pPr>
+                      <a:r>
+                        <a:rPr b="1"/>
+                        <a:t>recall</a:t>
+                      </a:r>
+                      <a:r>
+                        <a:rPr/>
+                        <a:t> = TP / (TP + FN)</a:t>
+                      </a:r>
+                    </a:p>
+                  </a:txBody>
+                </a:tc>
+                <a:tc>
+                  <a:txBody>
+                    <a:bodyPr/>
+                    <a:lstStyle/>
+                    <a:p>
+                      <a:pPr lvl="0" indent="0" marL="0">
+                        <a:buNone/>
+                      </a:pPr>
+                      <a:r>
+                        <a:rPr/>
+                        <a:t>malignant tumours we caught</a:t>
+                      </a:r>
+                    </a:p>
+                  </a:txBody>
+                </a:tc>
+                <a:tc>
+                  <a:txBody>
+                    <a:bodyPr/>
+                    <a:lstStyle/>
+                    <a:p>
+                      <a:pPr lvl="0" indent="0" marL="0">
+                        <a:buNone/>
+                      </a:pPr>
+                      <a:r>
+                        <a:rPr/>
+                        <a:t>52 / 53 = </a:t>
+                      </a:r>
+                      <a:r>
+                        <a:rPr b="1"/>
+                        <a:t>0.981</a:t>
+                      </a:r>
+                    </a:p>
+                  </a:txBody>
+                </a:tc>
+              </a:tr>
+              <a:tr h="0">
+                <a:tc>
+                  <a:txBody>
+                    <a:bodyPr/>
+                    <a:lstStyle/>
+                    <a:p>
+                      <a:pPr lvl="0" indent="0" marL="0">
+                        <a:buNone/>
+                      </a:pPr>
+                      <a:r>
+                        <a:rPr b="1"/>
+                        <a:t>precision</a:t>
+                      </a:r>
+                      <a:r>
+                        <a:rPr/>
+                        <a:t> = TP / (TP + FP)</a:t>
+                      </a:r>
+                    </a:p>
+                  </a:txBody>
+                </a:tc>
+                <a:tc>
+                  <a:txBody>
+                    <a:bodyPr/>
+                    <a:lstStyle/>
+                    <a:p>
+                      <a:pPr lvl="0" indent="0" marL="0">
+                        <a:buNone/>
+                      </a:pPr>
+                      <a:r>
+                        <a:rPr/>
+                        <a:t>alerts that were right</a:t>
+                      </a:r>
+                    </a:p>
+                  </a:txBody>
+                </a:tc>
+                <a:tc>
+                  <a:txBody>
+                    <a:bodyPr/>
+                    <a:lstStyle/>
+                    <a:p>
+                      <a:pPr lvl="0" indent="0" marL="0">
+                        <a:buNone/>
+                      </a:pPr>
+                      <a:r>
+                        <a:rPr/>
+                        <a:t>52 / 53 = </a:t>
+                      </a:r>
+                      <a:r>
+                        <a:rPr b="1"/>
+                        <a:t>0.981</a:t>
+                      </a:r>
+                    </a:p>
+                  </a:txBody>
+                </a:tc>
+              </a:tr>
+            </a:tbl>
+          </a:graphicData>
+        </a:graphic>
+      </p:graphicFrame>
+    </p:spTree>
+  </p:cSld>
+</p:sld>
+</file>
+
+<file path=ppt/slides/slide52.xml><?xml version="1.0" encoding="utf-8"?>
+<p:sld xmlns:a="http://schemas.openxmlformats.org/drawingml/2006/main" xmlns:r="http://schemas.openxmlformats.org/officeDocument/2006/relationships" xmlns:p="http://schemas.openxmlformats.org/presentationml/2006/main">
+  <p:cSld>
+    <p:spTree>
+      <p:nvGrpSpPr>
+        <p:cNvPr id="1" name=""/>
+        <p:cNvGrpSpPr/>
+        <p:nvPr/>
+      </p:nvGrpSpPr>
+      <p:grpSpPr>
+        <a:xfrm>
+          <a:off x="0" y="0"/>
+          <a:ext cx="0" cy="0"/>
+          <a:chOff x="0" y="0"/>
+          <a:chExt cx="0" cy="0"/>
+        </a:xfrm>
+      </p:grpSpPr>
+      <p:sp>
+        <p:nvSpPr>
+          <p:cNvPr id="2" name="Title 1"/>
+          <p:cNvSpPr>
+            <a:spLocks noGrp="1"/>
+          </p:cNvSpPr>
+          <p:nvPr>
+            <p:ph type="title"/>
+          </p:nvPr>
+        </p:nvSpPr>
+        <p:spPr>
+          <a:xfrm>
+            <a:off x="457200" y="205979"/>
+            <a:ext cx="8229600" cy="857250"/>
+          </a:xfrm>
+        </p:spPr>
+        <p:txBody>
+          <a:bodyPr/>
+          <a:lstStyle/>
+          <a:p>
+            <a:pPr lvl="0" indent="0" marL="0">
+              <a:buNone/>
+            </a:pPr>
+            <a:r>
+              <a:rPr/>
               <a:t>The trade-off, drawn</a:t>
             </a:r>
           </a:p>
@@ -17010,109 +17497,6 @@
 </p:sld>
 </file>
 
-<file path=ppt/slides/slide52.xml><?xml version="1.0" encoding="utf-8"?>
-<p:sld xmlns:a="http://schemas.openxmlformats.org/drawingml/2006/main" xmlns:r="http://schemas.openxmlformats.org/officeDocument/2006/relationships" xmlns:p="http://schemas.openxmlformats.org/presentationml/2006/main">
-  <p:cSld>
-    <p:spTree>
-      <p:nvGrpSpPr>
-        <p:cNvPr id="1" name=""/>
-        <p:cNvGrpSpPr/>
-        <p:nvPr/>
-      </p:nvGrpSpPr>
-      <p:grpSpPr>
-        <a:xfrm>
-          <a:off x="0" y="0"/>
-          <a:ext cx="0" cy="0"/>
-          <a:chOff x="0" y="0"/>
-          <a:chExt cx="0" cy="0"/>
-        </a:xfrm>
-      </p:grpSpPr>
-      <p:sp>
-        <p:nvSpPr>
-          <p:cNvPr id="2" name="Title 1"/>
-          <p:cNvSpPr>
-            <a:spLocks noGrp="1"/>
-          </p:cNvSpPr>
-          <p:nvPr>
-            <p:ph type="title"/>
-          </p:nvPr>
-        </p:nvSpPr>
-        <p:spPr>
-          <a:xfrm>
-            <a:off x="457200" y="205979"/>
-            <a:ext cx="8229600" cy="857250"/>
-          </a:xfrm>
-        </p:spPr>
-        <p:txBody>
-          <a:bodyPr/>
-          <a:lstStyle/>
-          <a:p>
-            <a:pPr lvl="0" indent="0" marL="0">
-              <a:buNone/>
-            </a:pPr>
-            <a:r>
-              <a:rPr/>
-              <a:t>What we did not do</a:t>
-            </a:r>
-          </a:p>
-        </p:txBody>
-      </p:sp>
-      <p:sp>
-        <p:nvSpPr>
-          <p:cNvPr id="3" name="Content Placeholder 2"/>
-          <p:cNvSpPr>
-            <a:spLocks noGrp="1"/>
-          </p:cNvSpPr>
-          <p:nvPr>
-            <p:ph idx="1"/>
-          </p:nvPr>
-        </p:nvSpPr>
-        <p:spPr>
-          <a:xfrm>
-            <a:off x="457200" y="1200151"/>
-            <a:ext cx="8229600" cy="3394472"/>
-          </a:xfrm>
-        </p:spPr>
-        <p:txBody>
-          <a:bodyPr/>
-          <a:lstStyle/>
-          <a:p>
-            <a:pPr lvl="0"/>
-            <a:r>
-              <a:rPr/>
-              <a:t>No tuning</a:t>
-            </a:r>
-          </a:p>
-          <a:p>
-            <a:pPr lvl="0"/>
-            <a:r>
-              <a:rPr/>
-              <a:t>No comparison of model families</a:t>
-            </a:r>
-          </a:p>
-          <a:p>
-            <a:pPr lvl="0"/>
-            <a:r>
-              <a:rPr/>
-              <a:t>No check of stability across splits</a:t>
-            </a:r>
-          </a:p>
-          <a:p>
-            <a:pPr lvl="0" indent="0" marL="0">
-              <a:buNone/>
-            </a:pPr>
-            <a:r>
-              <a:rPr/>
-              <a:t>And: we never looked at the test set to make a decision.</a:t>
-            </a:r>
-          </a:p>
-        </p:txBody>
-      </p:sp>
-    </p:spTree>
-  </p:cSld>
-</p:sld>
-</file>
-
 <file path=ppt/slides/slide53.xml><?xml version="1.0" encoding="utf-8"?>
 <p:sld xmlns:a="http://schemas.openxmlformats.org/drawingml/2006/main" xmlns:r="http://schemas.openxmlformats.org/officeDocument/2006/relationships" xmlns:p="http://schemas.openxmlformats.org/presentationml/2006/main">
   <p:cSld>
@@ -17155,7 +17539,7 @@
             </a:pPr>
             <a:r>
               <a:rPr/>
-              <a:t>Four ways a model misleads you</a:t>
+              <a:t>What we did not do</a:t>
             </a:r>
           </a:p>
         </p:txBody>
@@ -17183,37 +17567,30 @@
             <a:pPr lvl="0"/>
             <a:r>
               <a:rPr/>
-              <a:t>Leakage</a:t>
+              <a:t>No tuning</a:t>
             </a:r>
           </a:p>
           <a:p>
             <a:pPr lvl="0"/>
             <a:r>
               <a:rPr/>
-              <a:t>Imbalance</a:t>
+              <a:t>No comparison of model families</a:t>
             </a:r>
           </a:p>
           <a:p>
             <a:pPr lvl="0"/>
             <a:r>
               <a:rPr/>
-              <a:t>Shortcut features</a:t>
-            </a:r>
-          </a:p>
-          <a:p>
-            <a:pPr lvl="0"/>
-            <a:r>
-              <a:rPr/>
-              <a:t>Single-split noise</a:t>
-            </a:r>
-          </a:p>
-          <a:p>
-            <a:pPr lvl="0" indent="0" marL="0">
-              <a:buNone/>
-            </a:pPr>
-            <a:r>
-              <a:rPr/>
-              <a:t>All produce numbers that pass a casual review.</a:t>
+              <a:t>No check of stability across splits</a:t>
+            </a:r>
+          </a:p>
+          <a:p>
+            <a:pPr lvl="0" indent="0" marL="0">
+              <a:buNone/>
+            </a:pPr>
+            <a:r>
+              <a:rPr/>
+              <a:t>And: we never looked at the test set to make a decision.</a:t>
             </a:r>
           </a:p>
         </p:txBody>
@@ -17265,7 +17642,7 @@
             </a:pPr>
             <a:r>
               <a:rPr/>
-              <a:t>Notebook 3, live</a:t>
+              <a:t>Four ways a model misleads you</a:t>
             </a:r>
           </a:p>
         </p:txBody>
@@ -17290,12 +17667,40 @@
           <a:bodyPr/>
           <a:lstStyle/>
           <a:p>
-            <a:pPr lvl="0" indent="0" marL="0">
-              <a:buNone/>
-            </a:pPr>
-            <a:r>
-              <a:rPr/>
-              <a:t>Four failures, four plausible numbers, and not one bug among them.</a:t>
+            <a:pPr lvl="0"/>
+            <a:r>
+              <a:rPr/>
+              <a:t>Leakage</a:t>
+            </a:r>
+          </a:p>
+          <a:p>
+            <a:pPr lvl="0"/>
+            <a:r>
+              <a:rPr/>
+              <a:t>Imbalance</a:t>
+            </a:r>
+          </a:p>
+          <a:p>
+            <a:pPr lvl="0"/>
+            <a:r>
+              <a:rPr/>
+              <a:t>Shortcut features</a:t>
+            </a:r>
+          </a:p>
+          <a:p>
+            <a:pPr lvl="0"/>
+            <a:r>
+              <a:rPr/>
+              <a:t>Single-split noise</a:t>
+            </a:r>
+          </a:p>
+          <a:p>
+            <a:pPr lvl="0" indent="0" marL="0">
+              <a:buNone/>
+            </a:pPr>
+            <a:r>
+              <a:rPr/>
+              <a:t>All produce numbers that pass a casual review.</a:t>
             </a:r>
           </a:p>
         </p:txBody>
@@ -17347,7 +17752,7 @@
             </a:pPr>
             <a:r>
               <a:rPr/>
-              <a:t>200 samples. 5000 random features. Coin-flip labels.</a:t>
+              <a:t>Notebook 3, live</a:t>
             </a:r>
           </a:p>
         </p:txBody>
@@ -17377,16 +17782,7 @@
             </a:pPr>
             <a:r>
               <a:rPr/>
-              <a:t>There is nothing to learn.</a:t>
-            </a:r>
-          </a:p>
-          <a:p>
-            <a:pPr lvl="0" indent="0" marL="0">
-              <a:buNone/>
-            </a:pPr>
-            <a:r>
-              <a:rPr/>
-              <a:t>Anything above 50% is an artefact.</a:t>
+              <a:t>Four failures, four plausible numbers, and not one bug among them.</a:t>
             </a:r>
           </a:p>
         </p:txBody>
@@ -17397,6 +17793,97 @@
 </file>
 
 <file path=ppt/slides/slide56.xml><?xml version="1.0" encoding="utf-8"?>
+<p:sld xmlns:a="http://schemas.openxmlformats.org/drawingml/2006/main" xmlns:r="http://schemas.openxmlformats.org/officeDocument/2006/relationships" xmlns:p="http://schemas.openxmlformats.org/presentationml/2006/main">
+  <p:cSld>
+    <p:spTree>
+      <p:nvGrpSpPr>
+        <p:cNvPr id="1" name=""/>
+        <p:cNvGrpSpPr/>
+        <p:nvPr/>
+      </p:nvGrpSpPr>
+      <p:grpSpPr>
+        <a:xfrm>
+          <a:off x="0" y="0"/>
+          <a:ext cx="0" cy="0"/>
+          <a:chOff x="0" y="0"/>
+          <a:chExt cx="0" cy="0"/>
+        </a:xfrm>
+      </p:grpSpPr>
+      <p:sp>
+        <p:nvSpPr>
+          <p:cNvPr id="2" name="Title 1"/>
+          <p:cNvSpPr>
+            <a:spLocks noGrp="1"/>
+          </p:cNvSpPr>
+          <p:nvPr>
+            <p:ph type="title"/>
+          </p:nvPr>
+        </p:nvSpPr>
+        <p:spPr>
+          <a:xfrm>
+            <a:off x="457200" y="205979"/>
+            <a:ext cx="8229600" cy="857250"/>
+          </a:xfrm>
+        </p:spPr>
+        <p:txBody>
+          <a:bodyPr/>
+          <a:lstStyle/>
+          <a:p>
+            <a:pPr lvl="0" indent="0" marL="0">
+              <a:buNone/>
+            </a:pPr>
+            <a:r>
+              <a:rPr/>
+              <a:t>200 samples. 5000 random features. Coin-flip labels.</a:t>
+            </a:r>
+          </a:p>
+        </p:txBody>
+      </p:sp>
+      <p:sp>
+        <p:nvSpPr>
+          <p:cNvPr id="3" name="Content Placeholder 2"/>
+          <p:cNvSpPr>
+            <a:spLocks noGrp="1"/>
+          </p:cNvSpPr>
+          <p:nvPr>
+            <p:ph idx="1"/>
+          </p:nvPr>
+        </p:nvSpPr>
+        <p:spPr>
+          <a:xfrm>
+            <a:off x="457200" y="1200151"/>
+            <a:ext cx="8229600" cy="3394472"/>
+          </a:xfrm>
+        </p:spPr>
+        <p:txBody>
+          <a:bodyPr/>
+          <a:lstStyle/>
+          <a:p>
+            <a:pPr lvl="0" indent="0" marL="0">
+              <a:buNone/>
+            </a:pPr>
+            <a:r>
+              <a:rPr/>
+              <a:t>There is nothing to learn.</a:t>
+            </a:r>
+          </a:p>
+          <a:p>
+            <a:pPr lvl="0" indent="0" marL="0">
+              <a:buNone/>
+            </a:pPr>
+            <a:r>
+              <a:rPr/>
+              <a:t>Anything above 50% is an artefact.</a:t>
+            </a:r>
+          </a:p>
+        </p:txBody>
+      </p:sp>
+    </p:spTree>
+  </p:cSld>
+</p:sld>
+</file>
+
+<file path=ppt/slides/slide57.xml><?xml version="1.0" encoding="utf-8"?>
 <p:sld xmlns:a="http://schemas.openxmlformats.org/drawingml/2006/main" xmlns:r="http://schemas.openxmlformats.org/officeDocument/2006/relationships" xmlns:p="http://schemas.openxmlformats.org/presentationml/2006/main">
   <p:cSld>
     <p:spTree>
@@ -17478,105 +17965,6 @@
 </p:sld>
 </file>
 
-<file path=ppt/slides/slide57.xml><?xml version="1.0" encoding="utf-8"?>
-<p:sld xmlns:a="http://schemas.openxmlformats.org/drawingml/2006/main" xmlns:r="http://schemas.openxmlformats.org/officeDocument/2006/relationships" xmlns:p="http://schemas.openxmlformats.org/presentationml/2006/main">
-  <p:cSld>
-    <p:spTree>
-      <p:nvGrpSpPr>
-        <p:cNvPr id="1" name=""/>
-        <p:cNvGrpSpPr/>
-        <p:nvPr/>
-      </p:nvGrpSpPr>
-      <p:grpSpPr>
-        <a:xfrm>
-          <a:off x="0" y="0"/>
-          <a:ext cx="0" cy="0"/>
-          <a:chOff x="0" y="0"/>
-          <a:chExt cx="0" cy="0"/>
-        </a:xfrm>
-      </p:grpSpPr>
-      <p:sp>
-        <p:nvSpPr>
-          <p:cNvPr id="2" name="Title 1"/>
-          <p:cNvSpPr>
-            <a:spLocks noGrp="1"/>
-          </p:cNvSpPr>
-          <p:nvPr>
-            <p:ph type="title"/>
-          </p:nvPr>
-        </p:nvSpPr>
-        <p:spPr>
-          <a:xfrm>
-            <a:off x="457200" y="205979"/>
-            <a:ext cx="8229600" cy="857250"/>
-          </a:xfrm>
-        </p:spPr>
-        <p:txBody>
-          <a:bodyPr/>
-          <a:lstStyle/>
-          <a:p>
-            <a:pPr lvl="0" indent="0" marL="0">
-              <a:buNone/>
-            </a:pPr>
-            <a:r>
-              <a:rPr/>
-              <a:t>The rule</a:t>
-            </a:r>
-          </a:p>
-        </p:txBody>
-      </p:sp>
-      <p:sp>
-        <p:nvSpPr>
-          <p:cNvPr id="3" name="Content Placeholder 2"/>
-          <p:cNvSpPr>
-            <a:spLocks noGrp="1"/>
-          </p:cNvSpPr>
-          <p:nvPr>
-            <p:ph idx="1"/>
-          </p:nvPr>
-        </p:nvSpPr>
-        <p:spPr>
-          <a:xfrm>
-            <a:off x="457200" y="1200151"/>
-            <a:ext cx="8229600" cy="3394472"/>
-          </a:xfrm>
-        </p:spPr>
-        <p:txBody>
-          <a:bodyPr/>
-          <a:lstStyle/>
-          <a:p>
-            <a:pPr lvl="0" indent="0" marL="0">
-              <a:buNone/>
-            </a:pPr>
-            <a:r>
-              <a:rPr/>
-              <a:t>Every step that </a:t>
-            </a:r>
-            <a:r>
-              <a:rPr b="1"/>
-              <a:t>learns anything</a:t>
-            </a:r>
-            <a:r>
-              <a:rPr/>
-              <a:t> must be fitted inside the training fold.</a:t>
-            </a:r>
-          </a:p>
-          <a:p>
-            <a:pPr lvl="0" indent="0" marL="0">
-              <a:buNone/>
-            </a:pPr>
-            <a:r>
-              <a:rPr/>
-              <a:t>Scaling. Imputation. Encoding. Selection. Tuning.</a:t>
-            </a:r>
-          </a:p>
-        </p:txBody>
-      </p:sp>
-    </p:spTree>
-  </p:cSld>
-</p:sld>
-</file>
-
 <file path=ppt/slides/slide58.xml><?xml version="1.0" encoding="utf-8"?>
 <p:sld xmlns:a="http://schemas.openxmlformats.org/drawingml/2006/main" xmlns:r="http://schemas.openxmlformats.org/officeDocument/2006/relationships" xmlns:p="http://schemas.openxmlformats.org/presentationml/2006/main">
   <p:cSld>
@@ -17619,7 +18007,7 @@
             </a:pPr>
             <a:r>
               <a:rPr/>
-              <a:t>99% accuracy, detecting nothing</a:t>
+              <a:t>The rule</a:t>
             </a:r>
           </a:p>
         </p:txBody>
@@ -17649,29 +18037,24 @@
             </a:pPr>
             <a:r>
               <a:rPr/>
-              <a:t>1% positives. Answer “negative” every time.</a:t>
-            </a:r>
-          </a:p>
-          <a:p>
-            <a:pPr lvl="0"/>
-            <a:r>
-              <a:rPr/>
-              <a:t>Accuracy: </a:t>
+              <a:t>Every step that </a:t>
             </a:r>
             <a:r>
               <a:rPr b="1"/>
-              <a:t>0.986</a:t>
-            </a:r>
-          </a:p>
-          <a:p>
-            <a:pPr lvl="0"/>
-            <a:r>
-              <a:rPr/>
-              <a:t>Recall on positives: </a:t>
-            </a:r>
-            <a:r>
-              <a:rPr b="1"/>
-              <a:t>0.000</a:t>
+              <a:t>learns anything</a:t>
+            </a:r>
+            <a:r>
+              <a:rPr/>
+              <a:t> must be fitted inside the training fold.</a:t>
+            </a:r>
+          </a:p>
+          <a:p>
+            <a:pPr lvl="0" indent="0" marL="0">
+              <a:buNone/>
+            </a:pPr>
+            <a:r>
+              <a:rPr/>
+              <a:t>Scaling. Imputation. Encoding. Selection. Tuning.</a:t>
             </a:r>
           </a:p>
         </p:txBody>
@@ -17682,6 +18065,220 @@
 </file>
 
 <file path=ppt/slides/slide59.xml><?xml version="1.0" encoding="utf-8"?>
+<p:sld xmlns:a="http://schemas.openxmlformats.org/drawingml/2006/main" xmlns:r="http://schemas.openxmlformats.org/officeDocument/2006/relationships" xmlns:p="http://schemas.openxmlformats.org/presentationml/2006/main">
+  <p:cSld>
+    <p:spTree>
+      <p:nvGrpSpPr>
+        <p:cNvPr id="1" name=""/>
+        <p:cNvGrpSpPr/>
+        <p:nvPr/>
+      </p:nvGrpSpPr>
+      <p:grpSpPr>
+        <a:xfrm>
+          <a:off x="0" y="0"/>
+          <a:ext cx="0" cy="0"/>
+          <a:chOff x="0" y="0"/>
+          <a:chExt cx="0" cy="0"/>
+        </a:xfrm>
+      </p:grpSpPr>
+      <p:sp>
+        <p:nvSpPr>
+          <p:cNvPr id="2" name="Title 1"/>
+          <p:cNvSpPr>
+            <a:spLocks noGrp="1"/>
+          </p:cNvSpPr>
+          <p:nvPr>
+            <p:ph type="title"/>
+          </p:nvPr>
+        </p:nvSpPr>
+        <p:spPr>
+          <a:xfrm>
+            <a:off x="457200" y="205979"/>
+            <a:ext cx="8229600" cy="857250"/>
+          </a:xfrm>
+        </p:spPr>
+        <p:txBody>
+          <a:bodyPr/>
+          <a:lstStyle/>
+          <a:p>
+            <a:pPr lvl="0" indent="0" marL="0">
+              <a:buNone/>
+            </a:pPr>
+            <a:r>
+              <a:rPr/>
+              <a:t>99% accuracy, detecting nothing</a:t>
+            </a:r>
+          </a:p>
+        </p:txBody>
+      </p:sp>
+      <p:sp>
+        <p:nvSpPr>
+          <p:cNvPr id="3" name="Content Placeholder 2"/>
+          <p:cNvSpPr>
+            <a:spLocks noGrp="1"/>
+          </p:cNvSpPr>
+          <p:nvPr>
+            <p:ph idx="1"/>
+          </p:nvPr>
+        </p:nvSpPr>
+        <p:spPr>
+          <a:xfrm>
+            <a:off x="457200" y="1200151"/>
+            <a:ext cx="8229600" cy="3394472"/>
+          </a:xfrm>
+        </p:spPr>
+        <p:txBody>
+          <a:bodyPr/>
+          <a:lstStyle/>
+          <a:p>
+            <a:pPr lvl="0" indent="0" marL="0">
+              <a:buNone/>
+            </a:pPr>
+            <a:r>
+              <a:rPr/>
+              <a:t>1% positives. Answer “negative” every time.</a:t>
+            </a:r>
+          </a:p>
+          <a:p>
+            <a:pPr lvl="0"/>
+            <a:r>
+              <a:rPr/>
+              <a:t>Accuracy: </a:t>
+            </a:r>
+            <a:r>
+              <a:rPr b="1"/>
+              <a:t>0.986</a:t>
+            </a:r>
+          </a:p>
+          <a:p>
+            <a:pPr lvl="0"/>
+            <a:r>
+              <a:rPr/>
+              <a:t>Recall on positives: </a:t>
+            </a:r>
+            <a:r>
+              <a:rPr b="1"/>
+              <a:t>0.000</a:t>
+            </a:r>
+          </a:p>
+        </p:txBody>
+      </p:sp>
+    </p:spTree>
+  </p:cSld>
+</p:sld>
+</file>
+
+<file path=ppt/slides/slide6.xml><?xml version="1.0" encoding="utf-8"?>
+<p:sld xmlns:a="http://schemas.openxmlformats.org/drawingml/2006/main" xmlns:r="http://schemas.openxmlformats.org/officeDocument/2006/relationships" xmlns:p="http://schemas.openxmlformats.org/presentationml/2006/main">
+  <p:cSld>
+    <p:spTree>
+      <p:nvGrpSpPr>
+        <p:cNvPr id="1" name=""/>
+        <p:cNvGrpSpPr/>
+        <p:nvPr/>
+      </p:nvGrpSpPr>
+      <p:grpSpPr>
+        <a:xfrm>
+          <a:off x="0" y="0"/>
+          <a:ext cx="0" cy="0"/>
+          <a:chOff x="0" y="0"/>
+          <a:chExt cx="0" cy="0"/>
+        </a:xfrm>
+      </p:grpSpPr>
+      <p:sp>
+        <p:nvSpPr>
+          <p:cNvPr id="2" name="Title 1"/>
+          <p:cNvSpPr>
+            <a:spLocks noGrp="1"/>
+          </p:cNvSpPr>
+          <p:nvPr>
+            <p:ph type="title"/>
+          </p:nvPr>
+        </p:nvSpPr>
+        <p:spPr>
+          <a:xfrm>
+            <a:off x="457200" y="205979"/>
+            <a:ext cx="8229600" cy="857250"/>
+          </a:xfrm>
+        </p:spPr>
+        <p:txBody>
+          <a:bodyPr/>
+          <a:lstStyle/>
+          <a:p>
+            <a:pPr lvl="0" indent="0" marL="0">
+              <a:buNone/>
+            </a:pPr>
+            <a:r>
+              <a:rPr/>
+              <a:t>How you will be assessed</a:t>
+            </a:r>
+          </a:p>
+        </p:txBody>
+      </p:sp>
+      <p:sp>
+        <p:nvSpPr>
+          <p:cNvPr id="3" name="Content Placeholder 2"/>
+          <p:cNvSpPr>
+            <a:spLocks noGrp="1"/>
+          </p:cNvSpPr>
+          <p:nvPr>
+            <p:ph idx="1"/>
+          </p:nvPr>
+        </p:nvSpPr>
+        <p:spPr>
+          <a:xfrm>
+            <a:off x="457200" y="1200151"/>
+            <a:ext cx="8229600" cy="3394472"/>
+          </a:xfrm>
+        </p:spPr>
+        <p:txBody>
+          <a:bodyPr/>
+          <a:lstStyle/>
+          <a:p>
+            <a:pPr lvl="0"/>
+            <a:r>
+              <a:rPr b="1"/>
+              <a:t>Weekly exercises</a:t>
+            </a:r>
+            <a:r>
+              <a:rPr/>
+              <a:t>: set each Friday, discussed the next. Never collected</a:t>
+            </a:r>
+          </a:p>
+          <a:p>
+            <a:pPr lvl="0"/>
+            <a:r>
+              <a:rPr b="1"/>
+              <a:t>Exam</a:t>
+            </a:r>
+            <a:r>
+              <a:rPr/>
+              <a:t>: </a:t>
+            </a:r>
+            <a:r>
+              <a:rPr b="1"/>
+              <a:t>one of the ten is drawn</a:t>
+            </a:r>
+            <a:r>
+              <a:rPr/>
+              <a:t>, and you talk through your own notebook</a:t>
+            </a:r>
+          </a:p>
+          <a:p>
+            <a:pPr lvl="0"/>
+            <a:r>
+              <a:rPr/>
+              <a:t>No written paper, no project. Keep all ten</a:t>
+            </a:r>
+          </a:p>
+        </p:txBody>
+      </p:sp>
+    </p:spTree>
+  </p:cSld>
+</p:sld>
+</file>
+
+<file path=ppt/slides/slide60.xml><?xml version="1.0" encoding="utf-8"?>
 <p:sld xmlns:a="http://schemas.openxmlformats.org/drawingml/2006/main" xmlns:r="http://schemas.openxmlformats.org/officeDocument/2006/relationships" xmlns:p="http://schemas.openxmlformats.org/presentationml/2006/main">
   <p:cSld>
     <p:spTree>
@@ -17763,7 +18360,7 @@
 </p:sld>
 </file>
 
-<file path=ppt/slides/slide6.xml><?xml version="1.0" encoding="utf-8"?>
+<file path=ppt/slides/slide61.xml><?xml version="1.0" encoding="utf-8"?>
 <p:sld xmlns:a="http://schemas.openxmlformats.org/drawingml/2006/main" xmlns:r="http://schemas.openxmlformats.org/officeDocument/2006/relationships" xmlns:p="http://schemas.openxmlformats.org/presentationml/2006/main">
   <p:cSld>
     <p:spTree>
@@ -17805,7 +18402,7 @@
             </a:pPr>
             <a:r>
               <a:rPr/>
-              <a:t>How you will be assessed</a:t>
+              <a:t>Shortcut features</a:t>
             </a:r>
           </a:p>
         </p:txBody>
@@ -17830,40 +18427,35 @@
           <a:bodyPr/>
           <a:lstStyle/>
           <a:p>
-            <a:pPr lvl="0"/>
+            <a:pPr lvl="0" indent="0" marL="0">
+              <a:buNone/>
+            </a:pPr>
+            <a:r>
+              <a:rPr/>
+              <a:t>A column that is a </a:t>
+            </a:r>
             <a:r>
               <a:rPr b="1"/>
-              <a:t>Weekly exercises</a:t>
-            </a:r>
-            <a:r>
-              <a:rPr/>
-              <a:t>: set each Friday, discussed the next. Never collected</a:t>
-            </a:r>
-          </a:p>
-          <a:p>
-            <a:pPr lvl="0"/>
-            <a:r>
-              <a:rPr b="1"/>
-              <a:t>Exam</a:t>
-            </a:r>
-            <a:r>
-              <a:rPr/>
-              <a:t>: </a:t>
-            </a:r>
-            <a:r>
-              <a:rPr b="1"/>
-              <a:t>one of the ten is drawn</a:t>
-            </a:r>
-            <a:r>
-              <a:rPr/>
-              <a:t>, and you talk through your own notebook</a:t>
-            </a:r>
-          </a:p>
-          <a:p>
-            <a:pPr lvl="0"/>
-            <a:r>
-              <a:rPr/>
-              <a:t>No written paper, no project. Keep all ten</a:t>
+              <a:t>consequence</a:t>
+            </a:r>
+            <a:r>
+              <a:rPr/>
+              <a:t> of the label, not a predictor of it.</a:t>
+            </a:r>
+          </a:p>
+          <a:p>
+            <a:pPr lvl="0" indent="0" marL="0">
+              <a:buNone/>
+            </a:pPr>
+            <a:r>
+              <a:rPr>
+                <a:latin typeface="Courier"/>
+              </a:rPr>
+              <a:t>biopsy_scheduled</a:t>
+            </a:r>
+            <a:r>
+              <a:rPr/>
+              <a:t> → accuracy rises → model is worthless</a:t>
             </a:r>
           </a:p>
         </p:txBody>
@@ -17873,112 +18465,7 @@
 </p:sld>
 </file>
 
-<file path=ppt/slides/slide60.xml><?xml version="1.0" encoding="utf-8"?>
-<p:sld xmlns:a="http://schemas.openxmlformats.org/drawingml/2006/main" xmlns:r="http://schemas.openxmlformats.org/officeDocument/2006/relationships" xmlns:p="http://schemas.openxmlformats.org/presentationml/2006/main">
-  <p:cSld>
-    <p:spTree>
-      <p:nvGrpSpPr>
-        <p:cNvPr id="1" name=""/>
-        <p:cNvGrpSpPr/>
-        <p:nvPr/>
-      </p:nvGrpSpPr>
-      <p:grpSpPr>
-        <a:xfrm>
-          <a:off x="0" y="0"/>
-          <a:ext cx="0" cy="0"/>
-          <a:chOff x="0" y="0"/>
-          <a:chExt cx="0" cy="0"/>
-        </a:xfrm>
-      </p:grpSpPr>
-      <p:sp>
-        <p:nvSpPr>
-          <p:cNvPr id="2" name="Title 1"/>
-          <p:cNvSpPr>
-            <a:spLocks noGrp="1"/>
-          </p:cNvSpPr>
-          <p:nvPr>
-            <p:ph type="title"/>
-          </p:nvPr>
-        </p:nvSpPr>
-        <p:spPr>
-          <a:xfrm>
-            <a:off x="457200" y="205979"/>
-            <a:ext cx="8229600" cy="857250"/>
-          </a:xfrm>
-        </p:spPr>
-        <p:txBody>
-          <a:bodyPr/>
-          <a:lstStyle/>
-          <a:p>
-            <a:pPr lvl="0" indent="0" marL="0">
-              <a:buNone/>
-            </a:pPr>
-            <a:r>
-              <a:rPr/>
-              <a:t>Shortcut features</a:t>
-            </a:r>
-          </a:p>
-        </p:txBody>
-      </p:sp>
-      <p:sp>
-        <p:nvSpPr>
-          <p:cNvPr id="3" name="Content Placeholder 2"/>
-          <p:cNvSpPr>
-            <a:spLocks noGrp="1"/>
-          </p:cNvSpPr>
-          <p:nvPr>
-            <p:ph idx="1"/>
-          </p:nvPr>
-        </p:nvSpPr>
-        <p:spPr>
-          <a:xfrm>
-            <a:off x="457200" y="1200151"/>
-            <a:ext cx="8229600" cy="3394472"/>
-          </a:xfrm>
-        </p:spPr>
-        <p:txBody>
-          <a:bodyPr/>
-          <a:lstStyle/>
-          <a:p>
-            <a:pPr lvl="0" indent="0" marL="0">
-              <a:buNone/>
-            </a:pPr>
-            <a:r>
-              <a:rPr/>
-              <a:t>A column that is a </a:t>
-            </a:r>
-            <a:r>
-              <a:rPr b="1"/>
-              <a:t>consequence</a:t>
-            </a:r>
-            <a:r>
-              <a:rPr/>
-              <a:t> of the label, not a predictor of it.</a:t>
-            </a:r>
-          </a:p>
-          <a:p>
-            <a:pPr lvl="0" indent="0" marL="0">
-              <a:buNone/>
-            </a:pPr>
-            <a:r>
-              <a:rPr>
-                <a:latin typeface="Courier"/>
-              </a:rPr>
-              <a:t>biopsy_scheduled</a:t>
-            </a:r>
-            <a:r>
-              <a:rPr/>
-              <a:t> → accuracy rises → model is worthless</a:t>
-            </a:r>
-          </a:p>
-        </p:txBody>
-      </p:sp>
-    </p:spTree>
-  </p:cSld>
-</p:sld>
-</file>
-
-<file path=ppt/slides/slide61.xml><?xml version="1.0" encoding="utf-8"?>
+<file path=ppt/slides/slide62.xml><?xml version="1.0" encoding="utf-8"?>
 <p:sld xmlns:a="http://schemas.openxmlformats.org/drawingml/2006/main" xmlns:r="http://schemas.openxmlformats.org/officeDocument/2006/relationships" xmlns:p="http://schemas.openxmlformats.org/presentationml/2006/main">
   <p:cSld>
     <p:spTree>
@@ -18060,7 +18547,7 @@
 </p:sld>
 </file>
 
-<file path=ppt/slides/slide62.xml><?xml version="1.0" encoding="utf-8"?>
+<file path=ppt/slides/slide63.xml><?xml version="1.0" encoding="utf-8"?>
 <p:sld xmlns:a="http://schemas.openxmlformats.org/drawingml/2006/main" xmlns:r="http://schemas.openxmlformats.org/officeDocument/2006/relationships" xmlns:p="http://schemas.openxmlformats.org/presentationml/2006/main">
   <p:cSld>
     <p:spTree>
@@ -18142,97 +18629,6 @@
 </p:sld>
 </file>
 
-<file path=ppt/slides/slide63.xml><?xml version="1.0" encoding="utf-8"?>
-<p:sld xmlns:a="http://schemas.openxmlformats.org/drawingml/2006/main" xmlns:r="http://schemas.openxmlformats.org/officeDocument/2006/relationships" xmlns:p="http://schemas.openxmlformats.org/presentationml/2006/main">
-  <p:cSld>
-    <p:spTree>
-      <p:nvGrpSpPr>
-        <p:cNvPr id="1" name=""/>
-        <p:cNvGrpSpPr/>
-        <p:nvPr/>
-      </p:nvGrpSpPr>
-      <p:grpSpPr>
-        <a:xfrm>
-          <a:off x="0" y="0"/>
-          <a:ext cx="0" cy="0"/>
-          <a:chOff x="0" y="0"/>
-          <a:chExt cx="0" cy="0"/>
-        </a:xfrm>
-      </p:grpSpPr>
-      <p:sp>
-        <p:nvSpPr>
-          <p:cNvPr id="2" name="Title 1"/>
-          <p:cNvSpPr>
-            <a:spLocks noGrp="1"/>
-          </p:cNvSpPr>
-          <p:nvPr>
-            <p:ph type="title"/>
-          </p:nvPr>
-        </p:nvSpPr>
-        <p:spPr>
-          <a:xfrm>
-            <a:off x="457200" y="205979"/>
-            <a:ext cx="8229600" cy="857250"/>
-          </a:xfrm>
-        </p:spPr>
-        <p:txBody>
-          <a:bodyPr/>
-          <a:lstStyle/>
-          <a:p>
-            <a:pPr lvl="0" indent="0" marL="0">
-              <a:buNone/>
-            </a:pPr>
-            <a:r>
-              <a:rPr/>
-              <a:t>What the four have in common</a:t>
-            </a:r>
-          </a:p>
-        </p:txBody>
-      </p:sp>
-      <p:sp>
-        <p:nvSpPr>
-          <p:cNvPr id="3" name="Content Placeholder 2"/>
-          <p:cNvSpPr>
-            <a:spLocks noGrp="1"/>
-          </p:cNvSpPr>
-          <p:nvPr>
-            <p:ph idx="1"/>
-          </p:nvPr>
-        </p:nvSpPr>
-        <p:spPr>
-          <a:xfrm>
-            <a:off x="457200" y="1200151"/>
-            <a:ext cx="8229600" cy="3394472"/>
-          </a:xfrm>
-        </p:spPr>
-        <p:txBody>
-          <a:bodyPr/>
-          <a:lstStyle/>
-          <a:p>
-            <a:pPr lvl="0" indent="0" marL="0">
-              <a:buNone/>
-            </a:pPr>
-            <a:r>
-              <a:rPr/>
-              <a:t>None is a coding error.</a:t>
-            </a:r>
-          </a:p>
-          <a:p>
-            <a:pPr lvl="0" indent="0" marL="0">
-              <a:buNone/>
-            </a:pPr>
-            <a:r>
-              <a:rPr/>
-              <a:t>All four run exactly as written and return a plausible number.</a:t>
-            </a:r>
-          </a:p>
-        </p:txBody>
-      </p:sp>
-    </p:spTree>
-  </p:cSld>
-</p:sld>
-</file>
-
 <file path=ppt/slides/slide64.xml><?xml version="1.0" encoding="utf-8"?>
 <p:sld xmlns:a="http://schemas.openxmlformats.org/drawingml/2006/main" xmlns:r="http://schemas.openxmlformats.org/officeDocument/2006/relationships" xmlns:p="http://schemas.openxmlformats.org/presentationml/2006/main">
   <p:cSld>
@@ -18275,7 +18671,7 @@
             </a:pPr>
             <a:r>
               <a:rPr/>
-              <a:t>A model is not objective</a:t>
+              <a:t>What the four have in common</a:t>
             </a:r>
           </a:p>
         </p:txBody>
@@ -18300,36 +18696,21 @@
           <a:bodyPr/>
           <a:lstStyle/>
           <a:p>
-            <a:pPr lvl="0"/>
-            <a:r>
-              <a:rPr/>
-              <a:t>It is a compressed summary of its training data, </a:t>
-            </a:r>
-            <a:r>
-              <a:rPr b="1"/>
-              <a:t>including its injustices</a:t>
-            </a:r>
-          </a:p>
-          <a:p>
-            <a:pPr lvl="0"/>
-            <a:r>
-              <a:rPr/>
-              <a:t>These methods find </a:t>
-            </a:r>
-            <a:r>
-              <a:rPr b="1"/>
-              <a:t>correlation</a:t>
-            </a:r>
-            <a:r>
-              <a:rPr/>
-              <a:t>, not cause</a:t>
-            </a:r>
-          </a:p>
-          <a:p>
-            <a:pPr lvl="0"/>
-            <a:r>
-              <a:rPr/>
-              <a:t>Accuracy is not the only property that matters</a:t>
+            <a:pPr lvl="0" indent="0" marL="0">
+              <a:buNone/>
+            </a:pPr>
+            <a:r>
+              <a:rPr/>
+              <a:t>None is a coding error.</a:t>
+            </a:r>
+          </a:p>
+          <a:p>
+            <a:pPr lvl="0" indent="0" marL="0">
+              <a:buNone/>
+            </a:pPr>
+            <a:r>
+              <a:rPr/>
+              <a:t>All four run exactly as written and return a plausible number.</a:t>
             </a:r>
           </a:p>
         </p:txBody>
@@ -18381,7 +18762,7 @@
             </a:pPr>
             <a:r>
               <a:rPr/>
-              <a:t>Homework: we discuss it on Friday 9 October</a:t>
+              <a:t>A model is not objective</a:t>
             </a:r>
           </a:p>
         </p:txBody>
@@ -18406,45 +18787,36 @@
           <a:bodyPr/>
           <a:lstStyle/>
           <a:p>
-            <a:pPr lvl="0" indent="0" marL="0">
-              <a:buNone/>
-            </a:pPr>
-            <a:r>
-              <a:rPr>
-                <a:latin typeface="Courier"/>
-              </a:rPr>
-              <a:t>Exercises/01_first_workflow.md</a:t>
-            </a:r>
-          </a:p>
-          <a:p>
-            <a:pPr lvl="0" indent="0" marL="0">
-              <a:buNone/>
-            </a:pPr>
-            <a:r>
-              <a:rPr/>
-              <a:t>Wine quality: run the workflow yourself, and </a:t>
+            <a:pPr lvl="0"/>
+            <a:r>
+              <a:rPr/>
+              <a:t>It is a compressed summary of its training data, </a:t>
             </a:r>
             <a:r>
               <a:rPr b="1"/>
-              <a:t>justify every decision</a:t>
-            </a:r>
-            <a:r>
-              <a:rPr/>
-              <a:t>.</a:t>
+              <a:t>including its injustices</a:t>
             </a:r>
           </a:p>
           <a:p>
             <a:pPr lvl="0"/>
             <a:r>
               <a:rPr/>
-              <a:t>No marks for accuracy</a:t>
+              <a:t>These methods find </a:t>
+            </a:r>
+            <a:r>
+              <a:rPr b="1"/>
+              <a:t>correlation</a:t>
+            </a:r>
+            <a:r>
+              <a:rPr/>
+              <a:t>, not cause</a:t>
             </a:r>
           </a:p>
           <a:p>
             <a:pPr lvl="0"/>
             <a:r>
               <a:rPr/>
-              <a:t>Marks for methodology, and for saying what your number does not mean</a:t>
+              <a:t>Accuracy is not the only property that matters</a:t>
             </a:r>
           </a:p>
         </p:txBody>
@@ -18455,6 +18827,121 @@
 </file>
 
 <file path=ppt/slides/slide66.xml><?xml version="1.0" encoding="utf-8"?>
+<p:sld xmlns:a="http://schemas.openxmlformats.org/drawingml/2006/main" xmlns:r="http://schemas.openxmlformats.org/officeDocument/2006/relationships" xmlns:p="http://schemas.openxmlformats.org/presentationml/2006/main">
+  <p:cSld>
+    <p:spTree>
+      <p:nvGrpSpPr>
+        <p:cNvPr id="1" name=""/>
+        <p:cNvGrpSpPr/>
+        <p:nvPr/>
+      </p:nvGrpSpPr>
+      <p:grpSpPr>
+        <a:xfrm>
+          <a:off x="0" y="0"/>
+          <a:ext cx="0" cy="0"/>
+          <a:chOff x="0" y="0"/>
+          <a:chExt cx="0" cy="0"/>
+        </a:xfrm>
+      </p:grpSpPr>
+      <p:sp>
+        <p:nvSpPr>
+          <p:cNvPr id="2" name="Title 1"/>
+          <p:cNvSpPr>
+            <a:spLocks noGrp="1"/>
+          </p:cNvSpPr>
+          <p:nvPr>
+            <p:ph type="title"/>
+          </p:nvPr>
+        </p:nvSpPr>
+        <p:spPr>
+          <a:xfrm>
+            <a:off x="457200" y="205979"/>
+            <a:ext cx="8229600" cy="857250"/>
+          </a:xfrm>
+        </p:spPr>
+        <p:txBody>
+          <a:bodyPr/>
+          <a:lstStyle/>
+          <a:p>
+            <a:pPr lvl="0" indent="0" marL="0">
+              <a:buNone/>
+            </a:pPr>
+            <a:r>
+              <a:rPr/>
+              <a:t>Homework: we discuss it on Friday 9 October</a:t>
+            </a:r>
+          </a:p>
+        </p:txBody>
+      </p:sp>
+      <p:sp>
+        <p:nvSpPr>
+          <p:cNvPr id="3" name="Content Placeholder 2"/>
+          <p:cNvSpPr>
+            <a:spLocks noGrp="1"/>
+          </p:cNvSpPr>
+          <p:nvPr>
+            <p:ph idx="1"/>
+          </p:nvPr>
+        </p:nvSpPr>
+        <p:spPr>
+          <a:xfrm>
+            <a:off x="457200" y="1200151"/>
+            <a:ext cx="8229600" cy="3394472"/>
+          </a:xfrm>
+        </p:spPr>
+        <p:txBody>
+          <a:bodyPr/>
+          <a:lstStyle/>
+          <a:p>
+            <a:pPr lvl="0" indent="0" marL="0">
+              <a:buNone/>
+            </a:pPr>
+            <a:r>
+              <a:rPr>
+                <a:latin typeface="Courier"/>
+              </a:rPr>
+              <a:t>Exercises/01_first_workflow.md</a:t>
+            </a:r>
+          </a:p>
+          <a:p>
+            <a:pPr lvl="0" indent="0" marL="0">
+              <a:buNone/>
+            </a:pPr>
+            <a:r>
+              <a:rPr/>
+              <a:t>Wine quality: run the workflow yourself, and </a:t>
+            </a:r>
+            <a:r>
+              <a:rPr b="1"/>
+              <a:t>justify every decision</a:t>
+            </a:r>
+            <a:r>
+              <a:rPr/>
+              <a:t>.</a:t>
+            </a:r>
+          </a:p>
+          <a:p>
+            <a:pPr lvl="0"/>
+            <a:r>
+              <a:rPr/>
+              <a:t>No marks for accuracy</a:t>
+            </a:r>
+          </a:p>
+          <a:p>
+            <a:pPr lvl="0"/>
+            <a:r>
+              <a:rPr/>
+              <a:t>Marks for methodology, and for saying what your number does not mean</a:t>
+            </a:r>
+          </a:p>
+        </p:txBody>
+      </p:sp>
+    </p:spTree>
+  </p:cSld>
+</p:sld>
+</file>
+
+<file path=ppt/slides/slide67.xml><?xml version="1.0" encoding="utf-8"?>
 <p:sld xmlns:a="http://schemas.openxmlformats.org/drawingml/2006/main" xmlns:r="http://schemas.openxmlformats.org/officeDocument/2006/relationships" xmlns:p="http://schemas.openxmlformats.org/presentationml/2006/main">
   <p:cSld>
     <p:spTree>

</xml_diff>

<commit_message>
Say where lesson 1's labels come from before drawing the threshold
The trade-off slide put every tumour on an axis of predicted probability with
a line at 0.5, but nothing before it had said the model outputs a probability:
the confusion matrix and the precision/recall counts treat it as answering
with labels. A new slide bridges the two - predict_proba gives the probability,
predict compares it with 0.5, and the two errors just counted are a malignancy
at 0.11 and a benign tumour at 0.62. Handout section 7 gains the same
paragraph, the counts slide no longer cites a threshold it has not introduced,
and the plan shifts by one slide (68).

Co-Authored-By: Claude Opus 5.5 <noreply@anthropic.com>
</commit_message>
<xml_diff>
--- a/Lessons/01_introduction_and_workflow/Slides/introduction_and_workflow_slides.pptx
+++ b/Lessons/01_introduction_and_workflow/Slides/introduction_and_workflow_slides.pptx
@@ -5,7 +5,7 @@
     <p:sldMasterId id="2147483648" r:id="rId1"/>
   </p:sldMasterIdLst>
   <p:notesMasterIdLst>
-    <p:notesMasterId r:id="rId69"/>
+    <p:notesMasterId r:id="rId70"/>
   </p:notesMasterIdLst>
   <p:sldIdLst>
     <p:sldId id="256" r:id="rId2"/>
@@ -75,6 +75,7 @@
     <p:sldId id="320" r:id="rId66"/>
     <p:sldId id="321" r:id="rId67"/>
     <p:sldId id="322" r:id="rId68"/>
+    <p:sldId id="323" r:id="rId69"/>
   </p:sldIdLst>
   <p:sldSz cx="9144000" cy="5143500" type="screen16x9"/>
   <p:notesSz cx="6858000" cy="9144000"/>
@@ -6128,7 +6129,7 @@
             </a:pPr>
             <a:r>
               <a:rPr/>
-              <a:t>Someone will notice the two values are identical and ask why. It is a coincidence of this threshold: one malignancy missed and one false alarm, so both denominators are 53. Move the threshold and they part company: at 0.10 the missed malignancy is caught - recall 53 / 53 = 1.000 - but eleven benign tumours join the alerts, and precision falls to 53 / 64 = 0.828. That is the next slide, drawn.</a:t>
+              <a:t>Someone will notice the two values are identical and ask why. It is a coincidence: one malignancy missed and one false alarm, so both denominators are 53. The next slide shows where those labels come from - and that they can be moved, at which point the two numbers part company.</a:t>
             </a:r>
           </a:p>
           <a:p>
@@ -6224,63 +6225,55 @@
             </a:pPr>
             <a:r>
               <a:rPr/>
-              <a:t>Say what the axis is before anything else, because nothing else makes sense without it: every dot is one of the 143 tumours in the test set, and its position is the probability our model gave to “malignant”. Not a distance, not a score - a probability, 0 to 1.</a:t>
-            </a:r>
-          </a:p>
-          <a:p>
-            <a:pPr lvl="0" indent="0" marL="0">
-              <a:buNone/>
-            </a:pPr>
-          </a:p>
-          <a:p>
-            <a:pPr lvl="0" indent="0" marL="0">
-              <a:buNone/>
-            </a:pPr>
-            <a:r>
-              <a:rPr/>
-              <a:t>The black line is 0.5, and it is worth saying out loud that nothing chose it. It is the default. Everything to the right of it we flag; everything to the left we send home.</a:t>
-            </a:r>
-          </a:p>
-          <a:p>
-            <a:pPr lvl="0" indent="0" marL="0">
-              <a:buNone/>
-            </a:pPr>
-          </a:p>
-          <a:p>
-            <a:pPr lvl="0" indent="0" marL="0">
-              <a:buNone/>
-            </a:pPr>
-            <a:r>
-              <a:rPr/>
-              <a:t>Now the point of the slide. Most of the picture is the model being certain: 105 of the 143 sit within 0.02 of one end, which is where 0.986 comes from. Tell them to ignore those and look at the middle. The band from 0.11 to 0.62 holds the 12 it was unsure about - 1 malignant, 11 benign - and at 0.5 only two of the twelve are on the wrong side: the malignancy at 0.11 that we missed, and the benign at 0.62 that we flagged.</a:t>
-            </a:r>
-          </a:p>
-          <a:p>
-            <a:pPr lvl="0" indent="0" marL="0">
-              <a:buNone/>
-            </a:pPr>
-          </a:p>
-          <a:p>
-            <a:pPr lvl="0" indent="0" marL="0">
-              <a:buNone/>
-            </a:pPr>
-            <a:r>
-              <a:rPr/>
-              <a:t>Then slide the line, and make them watch the band rather than the numbers. Down to 0.10 and it passes below the whole band: the missed malignancy is caught, and all 11 uncertain benign tumours turn into false alarms. Point at them - the eleven are countable on the slide, which is the whole reason this figure is here rather than a table. Up to 0.90 instead and no false alarm survives, at the price of 7 women sent home who should not have been.</a:t>
-            </a:r>
-          </a:p>
-          <a:p>
-            <a:pPr lvl="0" indent="0" marL="0">
-              <a:buNone/>
-            </a:pPr>
-          </a:p>
-          <a:p>
-            <a:pPr lvl="0" indent="0" marL="0">
-              <a:buNone/>
-            </a:pPr>
-            <a:r>
-              <a:rPr/>
-              <a:t>Nothing about the model changed between those two sentences. So the question of whether it is good has no answer until somebody says which error is worse - which is the earlier slide arriving again, now with a number attached. Lesson 4 spends an hour here.</a:t>
+              <a:t>This is the step the confusion matrix hid. Until now the model has been treated as something that answers “malignant” or “benign”; it does not. It answers with a number between 0 and 1 - in scikit-learn, </a:t>
+            </a:r>
+            <a:r>
+              <a:rPr>
+                <a:latin typeface="Courier"/>
+              </a:rPr>
+              <a:t>predict_proba</a:t>
+            </a:r>
+            <a:r>
+              <a:rPr/>
+              <a:t> - and </a:t>
+            </a:r>
+            <a:r>
+              <a:rPr>
+                <a:latin typeface="Courier"/>
+              </a:rPr>
+              <a:t>predict</a:t>
+            </a:r>
+            <a:r>
+              <a:rPr/>
+              <a:t> is that number compared with 0.5. Where the probability comes from is lesson 4’s subject (logistic regression ends in a sigmoid); today it is enough that it exists.</a:t>
+            </a:r>
+          </a:p>
+          <a:p>
+            <a:pPr lvl="0" indent="0" marL="0">
+              <a:buNone/>
+            </a:pPr>
+          </a:p>
+          <a:p>
+            <a:pPr lvl="0" indent="0" marL="0">
+              <a:buNone/>
+            </a:pPr>
+            <a:r>
+              <a:rPr/>
+              <a:t>Ground it in the two errors they have just counted. The one malignancy we missed was not missed by a confused model: the model gave it 0.11, so the comparison with 0.5 called it benign. The one false alarm was a benign tumour the model gave 0.62. Those are the 1 and the 1 of the matrix.</a:t>
+            </a:r>
+          </a:p>
+          <a:p>
+            <a:pPr lvl="0" indent="0" marL="0">
+              <a:buNone/>
+            </a:pPr>
+          </a:p>
+          <a:p>
+            <a:pPr lvl="0" indent="0" marL="0">
+              <a:buNone/>
+            </a:pPr>
+            <a:r>
+              <a:rPr/>
+              <a:t>Then the question that sets up the next slide: if the label is a comparison with 0.5, what happens when we compare with something else? At 0.10 the missed malignancy is caught - recall 53 / 53 = 1.000 - but eleven benign tumours join the alerts and precision falls to 53 / 64 = 0.828. Nothing about the model changed; only the line moved. Handout section 7.</a:t>
             </a:r>
           </a:p>
         </p:txBody>
@@ -6362,21 +6355,63 @@
             </a:pPr>
             <a:r>
               <a:rPr/>
-              <a:t>Name where each omission gets addressed: tuning and stability in lesson 5, model families in 6 and 7.</a:t>
-            </a:r>
-          </a:p>
-          <a:p>
-            <a:pPr lvl="0" indent="0" marL="0">
-              <a:buNone/>
-            </a:pPr>
-          </a:p>
-          <a:p>
-            <a:pPr lvl="0" indent="0" marL="0">
-              <a:buNone/>
-            </a:pPr>
-            <a:r>
-              <a:rPr/>
-              <a:t>Then land the last line, which is the point of the slide: that discipline is the reason the 0.986 is worth anything at all. Every one of the four failures we are about to see comes from breaking it in some form.</a:t>
+              <a:t>Say what the axis is before anything else, because nothing else makes sense without it: every dot is one of the 143 tumours in the test set, and its position is the probability our model gave to “malignant”. Not a distance, not a score - a probability, 0 to 1.</a:t>
+            </a:r>
+          </a:p>
+          <a:p>
+            <a:pPr lvl="0" indent="0" marL="0">
+              <a:buNone/>
+            </a:pPr>
+          </a:p>
+          <a:p>
+            <a:pPr lvl="0" indent="0" marL="0">
+              <a:buNone/>
+            </a:pPr>
+            <a:r>
+              <a:rPr/>
+              <a:t>The black line is 0.5, and it is worth saying out loud that nothing chose it. It is the default. Everything to the right of it we flag; everything to the left we send home.</a:t>
+            </a:r>
+          </a:p>
+          <a:p>
+            <a:pPr lvl="0" indent="0" marL="0">
+              <a:buNone/>
+            </a:pPr>
+          </a:p>
+          <a:p>
+            <a:pPr lvl="0" indent="0" marL="0">
+              <a:buNone/>
+            </a:pPr>
+            <a:r>
+              <a:rPr/>
+              <a:t>Now the point of the slide. Most of the picture is the model being certain: 105 of the 143 sit within 0.02 of one end, which is where 0.986 comes from. Tell them to ignore those and look at the middle. The band from 0.11 to 0.62 holds the 12 it was unsure about - 1 malignant, 11 benign - and at 0.5 only two of the twelve are on the wrong side: the malignancy at 0.11 that we missed, and the benign at 0.62 that we flagged.</a:t>
+            </a:r>
+          </a:p>
+          <a:p>
+            <a:pPr lvl="0" indent="0" marL="0">
+              <a:buNone/>
+            </a:pPr>
+          </a:p>
+          <a:p>
+            <a:pPr lvl="0" indent="0" marL="0">
+              <a:buNone/>
+            </a:pPr>
+            <a:r>
+              <a:rPr/>
+              <a:t>Then slide the line, and make them watch the band rather than the numbers. Down to 0.10 and it passes below the whole band: the missed malignancy is caught, and all 11 uncertain benign tumours turn into false alarms. Point at them - the eleven are countable on the slide, which is the whole reason this figure is here rather than a table. Up to 0.90 instead and no false alarm survives, at the price of 7 women sent home who should not have been.</a:t>
+            </a:r>
+          </a:p>
+          <a:p>
+            <a:pPr lvl="0" indent="0" marL="0">
+              <a:buNone/>
+            </a:pPr>
+          </a:p>
+          <a:p>
+            <a:pPr lvl="0" indent="0" marL="0">
+              <a:buNone/>
+            </a:pPr>
+            <a:r>
+              <a:rPr/>
+              <a:t>Nothing about the model changed between those two sentences. So the question of whether it is good has no answer until somebody says which error is worse - which is the earlier slide arriving again, now with a number attached. Lesson 4 spends an hour here.</a:t>
             </a:r>
           </a:p>
         </p:txBody>
@@ -6458,21 +6493,21 @@
             </a:pPr>
             <a:r>
               <a:rPr/>
-              <a:t>The frame, and the next slide opens the notebook: none of these is a coding error. All four run exactly as written and return a number that a reviewer, a supervisor or a customer would accept.</a:t>
-            </a:r>
-          </a:p>
-          <a:p>
-            <a:pPr lvl="0" indent="0" marL="0">
-              <a:buNone/>
-            </a:pPr>
-          </a:p>
-          <a:p>
-            <a:pPr lvl="0" indent="0" marL="0">
-              <a:buNone/>
-            </a:pPr>
-            <a:r>
-              <a:rPr/>
-              <a:t>This is the section they should still remember in five years. Handout section 7 summarises it, and every one of the four has been found in published work and in shipped products.</a:t>
+              <a:t>Name where each omission gets addressed: tuning and stability in lesson 5, model families in 6 and 7.</a:t>
+            </a:r>
+          </a:p>
+          <a:p>
+            <a:pPr lvl="0" indent="0" marL="0">
+              <a:buNone/>
+            </a:pPr>
+          </a:p>
+          <a:p>
+            <a:pPr lvl="0" indent="0" marL="0">
+              <a:buNone/>
+            </a:pPr>
+            <a:r>
+              <a:rPr/>
+              <a:t>Then land the last line, which is the point of the slide: that discipline is the reason the 0.986 is worth anything at all. Every one of the four failures we are about to see comes from breaking it in some form.</a:t>
             </a:r>
           </a:p>
         </p:txBody>
@@ -6554,35 +6589,21 @@
             </a:pPr>
             <a:r>
               <a:rPr/>
-              <a:t>25 minutes, again alongside the slides that follow rather than instead of them.</a:t>
-            </a:r>
-          </a:p>
-          <a:p>
-            <a:pPr lvl="0" indent="0" marL="0">
-              <a:buNone/>
-            </a:pPr>
-          </a:p>
-          <a:p>
-            <a:pPr lvl="0" indent="0" marL="0">
-              <a:buNone/>
-            </a:pPr>
-            <a:r>
-              <a:rPr/>
-              <a:t>Say what to watch for before they start, because the notebook is deliberately undramatic: every cell runs, nothing raises, and every number it prints would pass a review. The work is reading them.</a:t>
-            </a:r>
-          </a:p>
-          <a:p>
-            <a:pPr lvl="0" indent="0" marL="0">
-              <a:buNone/>
-            </a:pPr>
-          </a:p>
-          <a:p>
-            <a:pPr lvl="0" indent="0" marL="0">
-              <a:buNone/>
-            </a:pPr>
-            <a:r>
-              <a:rPr/>
-              <a:t>The two cells to make sure nobody skips: the leaked selection reaching 77% on labels generated by a coin flip, and the four deployment scenarios for the shortcut column, where the two that raise an exception turn out to be the lucky ones.</a:t>
+              <a:t>The frame, and the next slide opens the notebook: none of these is a coding error. All four run exactly as written and return a number that a reviewer, a supervisor or a customer would accept.</a:t>
+            </a:r>
+          </a:p>
+          <a:p>
+            <a:pPr lvl="0" indent="0" marL="0">
+              <a:buNone/>
+            </a:pPr>
+          </a:p>
+          <a:p>
+            <a:pPr lvl="0" indent="0" marL="0">
+              <a:buNone/>
+            </a:pPr>
+            <a:r>
+              <a:rPr/>
+              <a:t>This is the section they should still remember in five years. Handout section 7 summarises it, and every one of the four has been found in published work and in shipped products.</a:t>
             </a:r>
           </a:p>
         </p:txBody>
@@ -6664,21 +6685,35 @@
             </a:pPr>
             <a:r>
               <a:rPr/>
-              <a:t>Set this up carefully before revealing anything. Make sure they understand the data is pure noise BY CONSTRUCTION - the labels come from a random number generator and no feature carries any information about them.</a:t>
-            </a:r>
-          </a:p>
-          <a:p>
-            <a:pPr lvl="0" indent="0" marL="0">
-              <a:buNone/>
-            </a:pPr>
-          </a:p>
-          <a:p>
-            <a:pPr lvl="0" indent="0" marL="0">
-              <a:buNone/>
-            </a:pPr>
-            <a:r>
-              <a:rPr/>
-              <a:t>Ask what accuracy they expect. The honest answer is 50%, chance.</a:t>
+              <a:t>25 minutes, again alongside the slides that follow rather than instead of them.</a:t>
+            </a:r>
+          </a:p>
+          <a:p>
+            <a:pPr lvl="0" indent="0" marL="0">
+              <a:buNone/>
+            </a:pPr>
+          </a:p>
+          <a:p>
+            <a:pPr lvl="0" indent="0" marL="0">
+              <a:buNone/>
+            </a:pPr>
+            <a:r>
+              <a:rPr/>
+              <a:t>Say what to watch for before they start, because the notebook is deliberately undramatic: every cell runs, nothing raises, and every number it prints would pass a review. The work is reading them.</a:t>
+            </a:r>
+          </a:p>
+          <a:p>
+            <a:pPr lvl="0" indent="0" marL="0">
+              <a:buNone/>
+            </a:pPr>
+          </a:p>
+          <a:p>
+            <a:pPr lvl="0" indent="0" marL="0">
+              <a:buNone/>
+            </a:pPr>
+            <a:r>
+              <a:rPr/>
+              <a:t>The two cells to make sure nobody skips: the leaked selection reaching 77% on labels generated by a coin flip, and the four deployment scenarios for the shortcut column, where the two that raise an exception turn out to be the lucky ones.</a:t>
             </a:r>
           </a:p>
         </p:txBody>
@@ -6760,49 +6795,21 @@
             </a:pPr>
             <a:r>
               <a:rPr/>
-              <a:t>77% on pure noise, against 50% for the honest pipeline.</a:t>
-            </a:r>
-          </a:p>
-          <a:p>
-            <a:pPr lvl="0" indent="0" marL="0">
-              <a:buNone/>
-            </a:pPr>
-          </a:p>
-          <a:p>
-            <a:pPr lvl="0" indent="0" marL="0">
-              <a:buNone/>
-            </a:pPr>
-            <a:r>
-              <a:rPr/>
-              <a:t>Explain the mechanism: with 5000 random features, some correlate with the labels by chance. Selecting the best 20 using the whole dataset picks exactly those - including the ones that correlate with the labels of rows that later become the test set. The selection encoded information about the test labels, and the model inherited it.</a:t>
-            </a:r>
-          </a:p>
-          <a:p>
-            <a:pPr lvl="0" indent="0" marL="0">
-              <a:buNone/>
-            </a:pPr>
-          </a:p>
-          <a:p>
-            <a:pPr lvl="0" indent="0" marL="0">
-              <a:buNone/>
-            </a:pPr>
-            <a:r>
-              <a:rPr/>
-              <a:t>Nobody wrote a bug. Selection feels harmless because it fits no model - but it LEARNS from data, so it belongs inside the training fold.</a:t>
-            </a:r>
-          </a:p>
-          <a:p>
-            <a:pPr lvl="0" indent="0" marL="0">
-              <a:buNone/>
-            </a:pPr>
-          </a:p>
-          <a:p>
-            <a:pPr lvl="0" indent="0" marL="0">
-              <a:buNone/>
-            </a:pPr>
-            <a:r>
-              <a:rPr/>
-              <a:t>Then ask what happens with 20000 features instead of 5000. The illusion gets STRONGER, because there are more opportunities for a spurious correlation. That is the “try this” at the end of the notebook.</a:t>
+              <a:t>Set this up carefully before revealing anything. Make sure they understand the data is pure noise BY CONSTRUCTION - the labels come from a random number generator and no feature carries any information about them.</a:t>
+            </a:r>
+          </a:p>
+          <a:p>
+            <a:pPr lvl="0" indent="0" marL="0">
+              <a:buNone/>
+            </a:pPr>
+          </a:p>
+          <a:p>
+            <a:pPr lvl="0" indent="0" marL="0">
+              <a:buNone/>
+            </a:pPr>
+            <a:r>
+              <a:rPr/>
+              <a:t>Ask what accuracy they expect. The honest answer is 50%, chance.</a:t>
             </a:r>
           </a:p>
         </p:txBody>
@@ -6884,35 +6891,49 @@
             </a:pPr>
             <a:r>
               <a:rPr/>
-              <a:t>The practical takeaway from the whole leakage section, and the thing to put on the board if anything goes on the board today.</a:t>
-            </a:r>
-          </a:p>
-          <a:p>
-            <a:pPr lvl="0" indent="0" marL="0">
-              <a:buNone/>
-            </a:pPr>
-          </a:p>
-          <a:p>
-            <a:pPr lvl="0" indent="0" marL="0">
-              <a:buNone/>
-            </a:pPr>
-            <a:r>
-              <a:rPr/>
-              <a:t>Pipelines enforce it structurally, which is why we used one from the first notebook.</a:t>
-            </a:r>
-          </a:p>
-          <a:p>
-            <a:pPr lvl="0" indent="0" marL="0">
-              <a:buNone/>
-            </a:pPr>
-          </a:p>
-          <a:p>
-            <a:pPr lvl="0" indent="0" marL="0">
-              <a:buNone/>
-            </a:pPr>
-            <a:r>
-              <a:rPr/>
-              <a:t>Tell them the exercise checks this: scaling the full dataset before splitting caps the methodology marks regardless of the result obtained.</a:t>
+              <a:t>77% on pure noise, against 50% for the honest pipeline.</a:t>
+            </a:r>
+          </a:p>
+          <a:p>
+            <a:pPr lvl="0" indent="0" marL="0">
+              <a:buNone/>
+            </a:pPr>
+          </a:p>
+          <a:p>
+            <a:pPr lvl="0" indent="0" marL="0">
+              <a:buNone/>
+            </a:pPr>
+            <a:r>
+              <a:rPr/>
+              <a:t>Explain the mechanism: with 5000 random features, some correlate with the labels by chance. Selecting the best 20 using the whole dataset picks exactly those - including the ones that correlate with the labels of rows that later become the test set. The selection encoded information about the test labels, and the model inherited it.</a:t>
+            </a:r>
+          </a:p>
+          <a:p>
+            <a:pPr lvl="0" indent="0" marL="0">
+              <a:buNone/>
+            </a:pPr>
+          </a:p>
+          <a:p>
+            <a:pPr lvl="0" indent="0" marL="0">
+              <a:buNone/>
+            </a:pPr>
+            <a:r>
+              <a:rPr/>
+              <a:t>Nobody wrote a bug. Selection feels harmless because it fits no model - but it LEARNS from data, so it belongs inside the training fold.</a:t>
+            </a:r>
+          </a:p>
+          <a:p>
+            <a:pPr lvl="0" indent="0" marL="0">
+              <a:buNone/>
+            </a:pPr>
+          </a:p>
+          <a:p>
+            <a:pPr lvl="0" indent="0" marL="0">
+              <a:buNone/>
+            </a:pPr>
+            <a:r>
+              <a:rPr/>
+              <a:t>Then ask what happens with 20000 features instead of 5000. The illusion gets STRONGER, because there are more opportunities for a spurious correlation. That is the “try this” at the end of the notebook.</a:t>
             </a:r>
           </a:p>
         </p:txBody>
@@ -6994,35 +7015,35 @@
             </a:pPr>
             <a:r>
               <a:rPr/>
-              <a:t>The trained model in the notebook reaches 0.987 accuracy - barely above the trivial one - while missing 20 of the 21 positives in the test set.</a:t>
-            </a:r>
-          </a:p>
-          <a:p>
-            <a:pPr lvl="0" indent="0" marL="0">
-              <a:buNone/>
-            </a:pPr>
-          </a:p>
-          <a:p>
-            <a:pPr lvl="0" indent="0" marL="0">
-              <a:buNone/>
-            </a:pPr>
-            <a:r>
-              <a:rPr/>
-              <a:t>On a problem where the positives are the entire reason the system exists.</a:t>
-            </a:r>
-          </a:p>
-          <a:p>
-            <a:pPr lvl="0" indent="0" marL="0">
-              <a:buNone/>
-            </a:pPr>
-          </a:p>
-          <a:p>
-            <a:pPr lvl="0" indent="0" marL="0">
-              <a:buNone/>
-            </a:pPr>
-            <a:r>
-              <a:rPr/>
-              <a:t>Accuracy is dominated by the class nobody is looking for. Ask them what metric they would report to someone deploying this, and steer towards recall on the positive class - then note that recall alone is also gameable, by flagging everything, which is why lesson 4 needs a whole session.</a:t>
+              <a:t>The practical takeaway from the whole leakage section, and the thing to put on the board if anything goes on the board today.</a:t>
+            </a:r>
+          </a:p>
+          <a:p>
+            <a:pPr lvl="0" indent="0" marL="0">
+              <a:buNone/>
+            </a:pPr>
+          </a:p>
+          <a:p>
+            <a:pPr lvl="0" indent="0" marL="0">
+              <a:buNone/>
+            </a:pPr>
+            <a:r>
+              <a:rPr/>
+              <a:t>Pipelines enforce it structurally, which is why we used one from the first notebook.</a:t>
+            </a:r>
+          </a:p>
+          <a:p>
+            <a:pPr lvl="0" indent="0" marL="0">
+              <a:buNone/>
+            </a:pPr>
+          </a:p>
+          <a:p>
+            <a:pPr lvl="0" indent="0" marL="0">
+              <a:buNone/>
+            </a:pPr>
+            <a:r>
+              <a:rPr/>
+              <a:t>Tell them the exercise checks this: scaling the full dataset before splitting caps the methodology marks regardless of the result obtained.</a:t>
             </a:r>
           </a:p>
         </p:txBody>
@@ -7104,35 +7125,35 @@
             </a:pPr>
             <a:r>
               <a:rPr/>
-              <a:t>Two confusion matrices side by side. Give them a moment to spot that the accuracies agree to three decimal places.</a:t>
-            </a:r>
-          </a:p>
-          <a:p>
-            <a:pPr lvl="0" indent="0" marL="0">
-              <a:buNone/>
-            </a:pPr>
-          </a:p>
-          <a:p>
-            <a:pPr lvl="0" indent="0" marL="0">
-              <a:buNone/>
-            </a:pPr>
-            <a:r>
-              <a:rPr/>
-              <a:t>Left is the model that answers negative every time and has learned nothing whatever. Right is a trained model. 0.986 against 0.987 - and the one on the right finds a single positive out of twenty-one, which is barely better than nothing but is not nothing.</a:t>
-            </a:r>
-          </a:p>
-          <a:p>
-            <a:pPr lvl="0" indent="0" marL="0">
-              <a:buNone/>
-            </a:pPr>
-          </a:p>
-          <a:p>
-            <a:pPr lvl="0" indent="0" marL="0">
-              <a:buNone/>
-            </a:pPr>
-            <a:r>
-              <a:rPr/>
-              <a:t>Ask what a report containing only the accuracy would say about these two, and let the silence do the work. Then point at the bottom-left cell of each: 21 missed, then 20 missed. That is the number the application cares about, and it is the one accuracy averages away.</a:t>
+              <a:t>The trained model in the notebook reaches 0.987 accuracy - barely above the trivial one - while missing 20 of the 21 positives in the test set.</a:t>
+            </a:r>
+          </a:p>
+          <a:p>
+            <a:pPr lvl="0" indent="0" marL="0">
+              <a:buNone/>
+            </a:pPr>
+          </a:p>
+          <a:p>
+            <a:pPr lvl="0" indent="0" marL="0">
+              <a:buNone/>
+            </a:pPr>
+            <a:r>
+              <a:rPr/>
+              <a:t>On a problem where the positives are the entire reason the system exists.</a:t>
+            </a:r>
+          </a:p>
+          <a:p>
+            <a:pPr lvl="0" indent="0" marL="0">
+              <a:buNone/>
+            </a:pPr>
+          </a:p>
+          <a:p>
+            <a:pPr lvl="0" indent="0" marL="0">
+              <a:buNone/>
+            </a:pPr>
+            <a:r>
+              <a:rPr/>
+              <a:t>Accuracy is dominated by the class nobody is looking for. Ask them what metric they would report to someone deploying this, and steer towards recall on the positive class - then note that recall alone is also gameable, by flagging everything, which is why lesson 4 needs a whole session.</a:t>
             </a:r>
           </a:p>
         </p:txBody>
@@ -7338,49 +7359,35 @@
             </a:pPr>
             <a:r>
               <a:rPr/>
-              <a:t>Explain why it is worthless: biopsies are scheduled once malignancy is already suspected, so the field is populated AFTER the diagnosis it is supposed to predict. At prediction time for a new patient it is empty.</a:t>
-            </a:r>
-          </a:p>
-          <a:p>
-            <a:pPr lvl="0" indent="0" marL="0">
-              <a:buNone/>
-            </a:pPr>
-          </a:p>
-          <a:p>
-            <a:pPr lvl="0" indent="0" marL="0">
-              <a:buNone/>
-            </a:pPr>
-            <a:r>
-              <a:rPr/>
-              <a:t>Then the point that makes this different from the others: no metric detects it, including cross-validated ones, because the information genuinely IS in the training data. The model is not cheating; the data is.</a:t>
-            </a:r>
-          </a:p>
-          <a:p>
-            <a:pPr lvl="0" indent="0" marL="0">
-              <a:buNone/>
-            </a:pPr>
-          </a:p>
-          <a:p>
-            <a:pPr lvl="0" indent="0" marL="0">
-              <a:buNone/>
-            </a:pPr>
-            <a:r>
-              <a:rPr/>
-              <a:t>Only knowing how the data was recorded catches it. Ask them to imagine a hospital extract with 200 columns and no documentation - which is the normal case - and to think about how they would find this.</a:t>
-            </a:r>
-          </a:p>
-          <a:p>
-            <a:pPr lvl="0" indent="0" marL="0">
-              <a:buNone/>
-            </a:pPr>
-          </a:p>
-          <a:p>
-            <a:pPr lvl="0" indent="0" marL="0">
-              <a:buNone/>
-            </a:pPr>
-            <a:r>
-              <a:rPr/>
-              <a:t>The question to carry: at the moment a prediction is needed, does this value exist yet?</a:t>
+              <a:t>Two confusion matrices side by side. Give them a moment to spot that the accuracies agree to three decimal places.</a:t>
+            </a:r>
+          </a:p>
+          <a:p>
+            <a:pPr lvl="0" indent="0" marL="0">
+              <a:buNone/>
+            </a:pPr>
+          </a:p>
+          <a:p>
+            <a:pPr lvl="0" indent="0" marL="0">
+              <a:buNone/>
+            </a:pPr>
+            <a:r>
+              <a:rPr/>
+              <a:t>Left is the model that answers negative every time and has learned nothing whatever. Right is a trained model. 0.986 against 0.987 - and the one on the right finds a single positive out of twenty-one, which is barely better than nothing but is not nothing.</a:t>
+            </a:r>
+          </a:p>
+          <a:p>
+            <a:pPr lvl="0" indent="0" marL="0">
+              <a:buNone/>
+            </a:pPr>
+          </a:p>
+          <a:p>
+            <a:pPr lvl="0" indent="0" marL="0">
+              <a:buNone/>
+            </a:pPr>
+            <a:r>
+              <a:rPr/>
+              <a:t>Ask what a report containing only the accuracy would say about these two, and let the silence do the work. Then point at the bottom-left cell of each: 21 missed, then 20 missed. That is the number the application cares about, and it is the one accuracy averages away.</a:t>
             </a:r>
           </a:p>
         </p:txBody>
@@ -7462,49 +7469,49 @@
             </a:pPr>
             <a:r>
               <a:rPr/>
-              <a:t>A timeline, with the moment of prediction marked, and everything that happens after it shaded.</a:t>
-            </a:r>
-          </a:p>
-          <a:p>
-            <a:pPr lvl="0" indent="0" marL="0">
-              <a:buNone/>
-            </a:pPr>
-          </a:p>
-          <a:p>
-            <a:pPr lvl="0" indent="0" marL="0">
-              <a:buNone/>
-            </a:pPr>
-            <a:r>
-              <a:rPr/>
-              <a:t>Walk left to right: the scan is taken, measurements are recorded - both before the prediction is needed, both usable. Then the shaded region: the diagnosis is made, the biopsy is scheduled. A model leaning on biopsy_scheduled scores beautifully in the notebook and has nothing to read at the moment it would actually be used.</a:t>
-            </a:r>
-          </a:p>
-          <a:p>
-            <a:pPr lvl="0" indent="0" marL="0">
-              <a:buNone/>
-            </a:pPr>
-          </a:p>
-          <a:p>
-            <a:pPr lvl="0" indent="0" marL="0">
-              <a:buNone/>
-            </a:pPr>
-            <a:r>
-              <a:rPr/>
-              <a:t>The shaded region is the trap: everything to the right of the marked moment happens after a prediction is needed, so none of it can be an input.</a:t>
-            </a:r>
-          </a:p>
-          <a:p>
-            <a:pPr lvl="0" indent="0" marL="0">
-              <a:buNone/>
-            </a:pPr>
-          </a:p>
-          <a:p>
-            <a:pPr lvl="0" indent="0" marL="0">
-              <a:buNone/>
-            </a:pPr>
-            <a:r>
-              <a:rPr/>
-              <a:t>The question in the title is the one to make a habit of, and it is worth saying that it cannot be answered by looking at the data. It is answered by asking somebody who knows how the data is produced. Put it to them as the thing to ask of every column in every dataset they are handed.</a:t>
+              <a:t>Explain why it is worthless: biopsies are scheduled once malignancy is already suspected, so the field is populated AFTER the diagnosis it is supposed to predict. At prediction time for a new patient it is empty.</a:t>
+            </a:r>
+          </a:p>
+          <a:p>
+            <a:pPr lvl="0" indent="0" marL="0">
+              <a:buNone/>
+            </a:pPr>
+          </a:p>
+          <a:p>
+            <a:pPr lvl="0" indent="0" marL="0">
+              <a:buNone/>
+            </a:pPr>
+            <a:r>
+              <a:rPr/>
+              <a:t>Then the point that makes this different from the others: no metric detects it, including cross-validated ones, because the information genuinely IS in the training data. The model is not cheating; the data is.</a:t>
+            </a:r>
+          </a:p>
+          <a:p>
+            <a:pPr lvl="0" indent="0" marL="0">
+              <a:buNone/>
+            </a:pPr>
+          </a:p>
+          <a:p>
+            <a:pPr lvl="0" indent="0" marL="0">
+              <a:buNone/>
+            </a:pPr>
+            <a:r>
+              <a:rPr/>
+              <a:t>Only knowing how the data was recorded catches it. Ask them to imagine a hospital extract with 200 columns and no documentation - which is the normal case - and to think about how they would find this.</a:t>
+            </a:r>
+          </a:p>
+          <a:p>
+            <a:pPr lvl="0" indent="0" marL="0">
+              <a:buNone/>
+            </a:pPr>
+          </a:p>
+          <a:p>
+            <a:pPr lvl="0" indent="0" marL="0">
+              <a:buNone/>
+            </a:pPr>
+            <a:r>
+              <a:rPr/>
+              <a:t>The question to carry: at the moment a prediction is needed, does this value exist yet?</a:t>
             </a:r>
           </a:p>
         </p:txBody>
@@ -7586,63 +7593,49 @@
             </a:pPr>
             <a:r>
               <a:rPr/>
-              <a:t>Same model, same data, 30 different random seeds. Accuracy ranges from 0.917 to 1.000 - a spread of 0.083.</a:t>
-            </a:r>
-          </a:p>
-          <a:p>
-            <a:pPr lvl="0" indent="0" marL="0">
-              <a:buNone/>
-            </a:pPr>
-          </a:p>
-          <a:p>
-            <a:pPr lvl="0" indent="0" marL="0">
-              <a:buNone/>
-            </a:pPr>
-            <a:r>
-              <a:rPr/>
-              <a:t>That is larger than most claimed improvements between competing methods in published work. Let that land.</a:t>
-            </a:r>
-          </a:p>
-          <a:p>
-            <a:pPr lvl="0" indent="0" marL="0">
-              <a:buNone/>
-            </a:pPr>
-          </a:p>
-          <a:p>
-            <a:pPr lvl="0" indent="0" marL="0">
-              <a:buNone/>
-            </a:pPr>
-            <a:r>
-              <a:rPr/>
-              <a:t>Pick your favourite seed and you can report anything in that range, and a reader seeing one number cannot tell which you got. This is not fraud; it is the default behaviour of anyone who runs the code once.</a:t>
-            </a:r>
-          </a:p>
-          <a:p>
-            <a:pPr lvl="0" indent="0" marL="0">
-              <a:buNone/>
-            </a:pPr>
-          </a:p>
-          <a:p>
-            <a:pPr lvl="0" indent="0" marL="0">
-              <a:buNone/>
-            </a:pPr>
-            <a:r>
-              <a:rPr/>
-              <a:t>Cross-validation replaces the single draw with an average and - more usefully - reports the spread. On this data, 5-fold gives 0.960 ± 0.030.</a:t>
-            </a:r>
-          </a:p>
-          <a:p>
-            <a:pPr lvl="0" indent="0" marL="0">
-              <a:buNone/>
-            </a:pPr>
-          </a:p>
-          <a:p>
-            <a:pPr lvl="0" indent="0" marL="0">
-              <a:buNone/>
-            </a:pPr>
-            <a:r>
-              <a:rPr/>
-              <a:t>A result quoted with no indication of variability is incomplete. Lesson 5 makes this the centre of the course.</a:t>
+              <a:t>A timeline, with the moment of prediction marked, and everything that happens after it shaded.</a:t>
+            </a:r>
+          </a:p>
+          <a:p>
+            <a:pPr lvl="0" indent="0" marL="0">
+              <a:buNone/>
+            </a:pPr>
+          </a:p>
+          <a:p>
+            <a:pPr lvl="0" indent="0" marL="0">
+              <a:buNone/>
+            </a:pPr>
+            <a:r>
+              <a:rPr/>
+              <a:t>Walk left to right: the scan is taken, measurements are recorded - both before the prediction is needed, both usable. Then the shaded region: the diagnosis is made, the biopsy is scheduled. A model leaning on biopsy_scheduled scores beautifully in the notebook and has nothing to read at the moment it would actually be used.</a:t>
+            </a:r>
+          </a:p>
+          <a:p>
+            <a:pPr lvl="0" indent="0" marL="0">
+              <a:buNone/>
+            </a:pPr>
+          </a:p>
+          <a:p>
+            <a:pPr lvl="0" indent="0" marL="0">
+              <a:buNone/>
+            </a:pPr>
+            <a:r>
+              <a:rPr/>
+              <a:t>The shaded region is the trap: everything to the right of the marked moment happens after a prediction is needed, so none of it can be an input.</a:t>
+            </a:r>
+          </a:p>
+          <a:p>
+            <a:pPr lvl="0" indent="0" marL="0">
+              <a:buNone/>
+            </a:pPr>
+          </a:p>
+          <a:p>
+            <a:pPr lvl="0" indent="0" marL="0">
+              <a:buNone/>
+            </a:pPr>
+            <a:r>
+              <a:rPr/>
+              <a:t>The question in the title is the one to make a habit of, and it is worth saying that it cannot be answered by looking at the data. It is answered by asking somebody who knows how the data is produced. Put it to them as the thing to ask of every column in every dataset they are handed.</a:t>
             </a:r>
           </a:p>
         </p:txBody>
@@ -7724,35 +7717,63 @@
             </a:pPr>
             <a:r>
               <a:rPr/>
-              <a:t>They are caught by asking questions about the data and the process, not by reading the metric.</a:t>
-            </a:r>
-          </a:p>
-          <a:p>
-            <a:pPr lvl="0" indent="0" marL="0">
-              <a:buNone/>
-            </a:pPr>
-          </a:p>
-          <a:p>
-            <a:pPr lvl="0" indent="0" marL="0">
-              <a:buNone/>
-            </a:pPr>
-            <a:r>
-              <a:rPr/>
-              <a:t>Give them the three questions to carry out of this room: where did this number come from, what does it leave out, and would it still hold on data I have never touched?</a:t>
-            </a:r>
-          </a:p>
-          <a:p>
-            <a:pPr lvl="0" indent="0" marL="0">
-              <a:buNone/>
-            </a:pPr>
-          </a:p>
-          <a:p>
-            <a:pPr lvl="0" indent="0" marL="0">
-              <a:buNone/>
-            </a:pPr>
-            <a:r>
-              <a:rPr/>
-              <a:t>Then the professional version, connecting back to the history section: the habit of distinguishing what was demonstrated from what was extrapolated is the same habit, applied to your own work instead of someone else’s.</a:t>
+              <a:t>Same model, same data, 30 different random seeds. Accuracy ranges from 0.917 to 1.000 - a spread of 0.083.</a:t>
+            </a:r>
+          </a:p>
+          <a:p>
+            <a:pPr lvl="0" indent="0" marL="0">
+              <a:buNone/>
+            </a:pPr>
+          </a:p>
+          <a:p>
+            <a:pPr lvl="0" indent="0" marL="0">
+              <a:buNone/>
+            </a:pPr>
+            <a:r>
+              <a:rPr/>
+              <a:t>That is larger than most claimed improvements between competing methods in published work. Let that land.</a:t>
+            </a:r>
+          </a:p>
+          <a:p>
+            <a:pPr lvl="0" indent="0" marL="0">
+              <a:buNone/>
+            </a:pPr>
+          </a:p>
+          <a:p>
+            <a:pPr lvl="0" indent="0" marL="0">
+              <a:buNone/>
+            </a:pPr>
+            <a:r>
+              <a:rPr/>
+              <a:t>Pick your favourite seed and you can report anything in that range, and a reader seeing one number cannot tell which you got. This is not fraud; it is the default behaviour of anyone who runs the code once.</a:t>
+            </a:r>
+          </a:p>
+          <a:p>
+            <a:pPr lvl="0" indent="0" marL="0">
+              <a:buNone/>
+            </a:pPr>
+          </a:p>
+          <a:p>
+            <a:pPr lvl="0" indent="0" marL="0">
+              <a:buNone/>
+            </a:pPr>
+            <a:r>
+              <a:rPr/>
+              <a:t>Cross-validation replaces the single draw with an average and - more usefully - reports the spread. On this data, 5-fold gives 0.960 ± 0.030.</a:t>
+            </a:r>
+          </a:p>
+          <a:p>
+            <a:pPr lvl="0" indent="0" marL="0">
+              <a:buNone/>
+            </a:pPr>
+          </a:p>
+          <a:p>
+            <a:pPr lvl="0" indent="0" marL="0">
+              <a:buNone/>
+            </a:pPr>
+            <a:r>
+              <a:rPr/>
+              <a:t>A result quoted with no indication of variability is incomplete. Lesson 5 makes this the centre of the course.</a:t>
             </a:r>
           </a:p>
         </p:txBody>
@@ -7834,63 +7855,35 @@
             </a:pPr>
             <a:r>
               <a:rPr/>
-              <a:t>Close the loop with the “when not to use ML” slide. Handout section 8.</a:t>
-            </a:r>
-          </a:p>
-          <a:p>
-            <a:pPr lvl="0" indent="0" marL="0">
-              <a:buNone/>
-            </a:pPr>
-          </a:p>
-          <a:p>
-            <a:pPr lvl="0" indent="0" marL="0">
-              <a:buNone/>
-            </a:pPr>
-            <a:r>
-              <a:rPr/>
-              <a:t>If past decisions discriminated, a model fitted to them discriminates too - and it does so with an appearance of objectivity that makes it HARDER to contest than a human decision would be. “The algorithm decided” is a much harder claim to argue with than “the manager decided”.</a:t>
-            </a:r>
-          </a:p>
-          <a:p>
-            <a:pPr lvl="0" indent="0" marL="0">
-              <a:buNone/>
-            </a:pPr>
-          </a:p>
-          <a:p>
-            <a:pPr lvl="0" indent="0" marL="0">
-              <a:buNone/>
-            </a:pPr>
-            <a:r>
-              <a:rPr/>
-              <a:t>Second point: nothing in empirical risk minimisation distinguishes a cause from a coincidence that predicts well in this sample. A model can be highly accurate and completely wrong about why - which is exactly why it fails abruptly when conditions change.</a:t>
-            </a:r>
-          </a:p>
-          <a:p>
-            <a:pPr lvl="0" indent="0" marL="0">
-              <a:buNone/>
-            </a:pPr>
-          </a:p>
-          <a:p>
-            <a:pPr lvl="0" indent="0" marL="0">
-              <a:buNone/>
-            </a:pPr>
-            <a:r>
-              <a:rPr/>
-              <a:t>Third: whether a decision can be explained to the person affected, whether errors are recoverable, and who bears the cost of being wrong are engineering requirements. They belong in step 1, where they can still change what you build, not in a paragraph at the end of a report.</a:t>
-            </a:r>
-          </a:p>
-          <a:p>
-            <a:pPr lvl="0" indent="0" marL="0">
-              <a:buNone/>
-            </a:pPr>
-          </a:p>
-          <a:p>
-            <a:pPr lvl="0" indent="0" marL="0">
-              <a:buNone/>
-            </a:pPr>
-            <a:r>
-              <a:rPr/>
-              <a:t>Keep this short and serious. Do not moralise - state it and move on.</a:t>
+              <a:t>They are caught by asking questions about the data and the process, not by reading the metric.</a:t>
+            </a:r>
+          </a:p>
+          <a:p>
+            <a:pPr lvl="0" indent="0" marL="0">
+              <a:buNone/>
+            </a:pPr>
+          </a:p>
+          <a:p>
+            <a:pPr lvl="0" indent="0" marL="0">
+              <a:buNone/>
+            </a:pPr>
+            <a:r>
+              <a:rPr/>
+              <a:t>Give them the three questions to carry out of this room: where did this number come from, what does it leave out, and would it still hold on data I have never touched?</a:t>
+            </a:r>
+          </a:p>
+          <a:p>
+            <a:pPr lvl="0" indent="0" marL="0">
+              <a:buNone/>
+            </a:pPr>
+          </a:p>
+          <a:p>
+            <a:pPr lvl="0" indent="0" marL="0">
+              <a:buNone/>
+            </a:pPr>
+            <a:r>
+              <a:rPr/>
+              <a:t>Then the professional version, connecting back to the history section: the habit of distinguishing what was demonstrated from what was extrapolated is the same habit, applied to your own work instead of someone else’s.</a:t>
             </a:r>
           </a:p>
         </p:txBody>
@@ -7972,49 +7965,63 @@
             </a:pPr>
             <a:r>
               <a:rPr/>
-              <a:t>Set it explicitly - do not let anyone leave without knowing it exists and when it is due.</a:t>
-            </a:r>
-          </a:p>
-          <a:p>
-            <a:pPr lvl="0" indent="0" marL="0">
-              <a:buNone/>
-            </a:pPr>
-          </a:p>
-          <a:p>
-            <a:pPr lvl="0" indent="0" marL="0">
-              <a:buNone/>
-            </a:pPr>
-            <a:r>
-              <a:rPr/>
-              <a:t>Walk the tasks briefly. Task 1 is framing, and there is no single right answer: quality is an integer from 3 to 9, so they must decide how to treat it and defend the choice. Task 7 - repeat the split with ten seeds - connects directly to the figure they just saw.</a:t>
-            </a:r>
-          </a:p>
-          <a:p>
-            <a:pPr lvl="0" indent="0" marL="0">
-              <a:buNone/>
-            </a:pPr>
-          </a:p>
-          <a:p>
-            <a:pPr lvl="0" indent="0" marL="0">
-              <a:buNone/>
-            </a:pPr>
-            <a:r>
-              <a:rPr/>
-              <a:t>Remind them: scaling the full dataset before splitting loses the methodology marks regardless of the score. And there are no marks for accuracy anywhere in this course.</a:t>
-            </a:r>
-          </a:p>
-          <a:p>
-            <a:pPr lvl="0" indent="0" marL="0">
-              <a:buNone/>
-            </a:pPr>
-          </a:p>
-          <a:p>
-            <a:pPr lvl="0" indent="0" marL="0">
-              <a:buNone/>
-            </a:pPr>
-            <a:r>
-              <a:rPr/>
-              <a:t>Also point them at the quiz - 20 questions, ungraded, and the ones marked “reasoning” are the closest thing there is to the exam, because they ask why rather than what.</a:t>
+              <a:t>Close the loop with the “when not to use ML” slide. Handout section 8.</a:t>
+            </a:r>
+          </a:p>
+          <a:p>
+            <a:pPr lvl="0" indent="0" marL="0">
+              <a:buNone/>
+            </a:pPr>
+          </a:p>
+          <a:p>
+            <a:pPr lvl="0" indent="0" marL="0">
+              <a:buNone/>
+            </a:pPr>
+            <a:r>
+              <a:rPr/>
+              <a:t>If past decisions discriminated, a model fitted to them discriminates too - and it does so with an appearance of objectivity that makes it HARDER to contest than a human decision would be. “The algorithm decided” is a much harder claim to argue with than “the manager decided”.</a:t>
+            </a:r>
+          </a:p>
+          <a:p>
+            <a:pPr lvl="0" indent="0" marL="0">
+              <a:buNone/>
+            </a:pPr>
+          </a:p>
+          <a:p>
+            <a:pPr lvl="0" indent="0" marL="0">
+              <a:buNone/>
+            </a:pPr>
+            <a:r>
+              <a:rPr/>
+              <a:t>Second point: nothing in empirical risk minimisation distinguishes a cause from a coincidence that predicts well in this sample. A model can be highly accurate and completely wrong about why - which is exactly why it fails abruptly when conditions change.</a:t>
+            </a:r>
+          </a:p>
+          <a:p>
+            <a:pPr lvl="0" indent="0" marL="0">
+              <a:buNone/>
+            </a:pPr>
+          </a:p>
+          <a:p>
+            <a:pPr lvl="0" indent="0" marL="0">
+              <a:buNone/>
+            </a:pPr>
+            <a:r>
+              <a:rPr/>
+              <a:t>Third: whether a decision can be explained to the person affected, whether errors are recoverable, and who bears the cost of being wrong are engineering requirements. They belong in step 1, where they can still change what you build, not in a paragraph at the end of a report.</a:t>
+            </a:r>
+          </a:p>
+          <a:p>
+            <a:pPr lvl="0" indent="0" marL="0">
+              <a:buNone/>
+            </a:pPr>
+          </a:p>
+          <a:p>
+            <a:pPr lvl="0" indent="0" marL="0">
+              <a:buNone/>
+            </a:pPr>
+            <a:r>
+              <a:rPr/>
+              <a:t>Keep this short and serious. Do not moralise - state it and move on.</a:t>
             </a:r>
           </a:p>
         </p:txBody>
@@ -8096,35 +8103,49 @@
             </a:pPr>
             <a:r>
               <a:rPr/>
-              <a:t>Close on time and offer to stay for setup problems - it is worth twenty minutes now to avoid three people stuck for a fortnight.</a:t>
-            </a:r>
-          </a:p>
-          <a:p>
-            <a:pPr lvl="0" indent="0" marL="0">
-              <a:buNone/>
-            </a:pPr>
-          </a:p>
-          <a:p>
-            <a:pPr lvl="0" indent="0" marL="0">
-              <a:buNone/>
-            </a:pPr>
-            <a:r>
-              <a:rPr/>
-              <a:t>Tell them lesson 2 goes deeper into data preparation, and that the leakage they saw today was the simple, visible version. The next one is subtler.</a:t>
-            </a:r>
-          </a:p>
-          <a:p>
-            <a:pPr lvl="0" indent="0" marL="0">
-              <a:buNone/>
-            </a:pPr>
-          </a:p>
-          <a:p>
-            <a:pPr lvl="0" indent="0" marL="0">
-              <a:buNone/>
-            </a:pPr>
-            <a:r>
-              <a:rPr/>
-              <a:t>If anyone asks what to read beyond the handout: Resources/history_of_ai.md for context, and the scikit-learn “common pitfalls” page, which is the library’s own account of everything in notebook 03.</a:t>
+              <a:t>Set it explicitly - do not let anyone leave without knowing it exists and when it is due.</a:t>
+            </a:r>
+          </a:p>
+          <a:p>
+            <a:pPr lvl="0" indent="0" marL="0">
+              <a:buNone/>
+            </a:pPr>
+          </a:p>
+          <a:p>
+            <a:pPr lvl="0" indent="0" marL="0">
+              <a:buNone/>
+            </a:pPr>
+            <a:r>
+              <a:rPr/>
+              <a:t>Walk the tasks briefly. Task 1 is framing, and there is no single right answer: quality is an integer from 3 to 9, so they must decide how to treat it and defend the choice. Task 7 - repeat the split with ten seeds - connects directly to the figure they just saw.</a:t>
+            </a:r>
+          </a:p>
+          <a:p>
+            <a:pPr lvl="0" indent="0" marL="0">
+              <a:buNone/>
+            </a:pPr>
+          </a:p>
+          <a:p>
+            <a:pPr lvl="0" indent="0" marL="0">
+              <a:buNone/>
+            </a:pPr>
+            <a:r>
+              <a:rPr/>
+              <a:t>Remind them: scaling the full dataset before splitting loses the methodology marks regardless of the score. And there are no marks for accuracy anywhere in this course.</a:t>
+            </a:r>
+          </a:p>
+          <a:p>
+            <a:pPr lvl="0" indent="0" marL="0">
+              <a:buNone/>
+            </a:pPr>
+          </a:p>
+          <a:p>
+            <a:pPr lvl="0" indent="0" marL="0">
+              <a:buNone/>
+            </a:pPr>
+            <a:r>
+              <a:rPr/>
+              <a:t>Also point them at the quiz - 20 questions, ungraded, and the ones marked “reasoning” are the closest thing there is to the exam, because they ask why rather than what.</a:t>
             </a:r>
           </a:p>
         </p:txBody>
@@ -8147,6 +8168,116 @@
             <a:fld id="{18BDFEC3-8487-43E8-A154-7C12CBC1FFF2}" type="slidenum">
               <a:rPr lang="en-US"/>
               <a:t>67</a:t>
+            </a:fld>
+            <a:endParaRPr lang="en-US"/>
+          </a:p>
+        </p:txBody>
+      </p:sp>
+    </p:spTree>
+  </p:cSld>
+</p:notes>
+</file>
+
+<file path=ppt/notesSlides/notesSlide67.xml><?xml version="1.0" encoding="utf-8"?>
+<p:notes xmlns:a="http://schemas.openxmlformats.org/drawingml/2006/main" xmlns:r="http://schemas.openxmlformats.org/officeDocument/2006/relationships" xmlns:p="http://schemas.openxmlformats.org/presentationml/2006/main">
+  <p:cSld>
+    <p:spTree>
+      <p:nvGrpSpPr>
+        <p:cNvPr id="1" name=""/>
+        <p:cNvGrpSpPr/>
+        <p:nvPr/>
+      </p:nvGrpSpPr>
+      <p:grpSpPr>
+        <a:xfrm>
+          <a:off x="0" y="0"/>
+          <a:ext cx="0" cy="0"/>
+          <a:chOff x="0" y="0"/>
+          <a:chExt cx="0" cy="0"/>
+        </a:xfrm>
+      </p:grpSpPr>
+      <p:sp>
+        <p:nvSpPr>
+          <p:cNvPr id="2" name="Slide Image Placeholder 1"/>
+          <p:cNvSpPr>
+            <a:spLocks noGrp="1" noRot="1" noChangeAspect="1"/>
+          </p:cNvSpPr>
+          <p:nvPr>
+            <p:ph type="sldImg"/>
+          </p:nvPr>
+        </p:nvSpPr>
+        <p:spPr/>
+      </p:sp>
+      <p:sp>
+        <p:nvSpPr>
+          <p:cNvPr id="3" name="Notes Placeholder 2"/>
+          <p:cNvSpPr>
+            <a:spLocks noGrp="1"/>
+          </p:cNvSpPr>
+          <p:nvPr>
+            <p:ph type="body" idx="1"/>
+          </p:nvPr>
+        </p:nvSpPr>
+        <p:spPr/>
+        <p:txBody>
+          <a:bodyPr/>
+          <a:lstStyle/>
+          <a:p>
+            <a:pPr lvl="0" indent="0" marL="0">
+              <a:buNone/>
+            </a:pPr>
+            <a:r>
+              <a:rPr/>
+              <a:t>Close on time and offer to stay for setup problems - it is worth twenty minutes now to avoid three people stuck for a fortnight.</a:t>
+            </a:r>
+          </a:p>
+          <a:p>
+            <a:pPr lvl="0" indent="0" marL="0">
+              <a:buNone/>
+            </a:pPr>
+          </a:p>
+          <a:p>
+            <a:pPr lvl="0" indent="0" marL="0">
+              <a:buNone/>
+            </a:pPr>
+            <a:r>
+              <a:rPr/>
+              <a:t>Tell them lesson 2 goes deeper into data preparation, and that the leakage they saw today was the simple, visible version. The next one is subtler.</a:t>
+            </a:r>
+          </a:p>
+          <a:p>
+            <a:pPr lvl="0" indent="0" marL="0">
+              <a:buNone/>
+            </a:pPr>
+          </a:p>
+          <a:p>
+            <a:pPr lvl="0" indent="0" marL="0">
+              <a:buNone/>
+            </a:pPr>
+            <a:r>
+              <a:rPr/>
+              <a:t>If anyone asks what to read beyond the handout: Resources/history_of_ai.md for context, and the scikit-learn “common pitfalls” page, which is the library’s own account of everything in notebook 03.</a:t>
+            </a:r>
+          </a:p>
+        </p:txBody>
+      </p:sp>
+      <p:sp>
+        <p:nvSpPr>
+          <p:cNvPr id="4" name="Slide Number Placeholder 3"/>
+          <p:cNvSpPr>
+            <a:spLocks noGrp="1"/>
+          </p:cNvSpPr>
+          <p:nvPr>
+            <p:ph type="sldNum" sz="quarter" idx="10"/>
+          </p:nvPr>
+        </p:nvSpPr>
+        <p:spPr/>
+        <p:txBody>
+          <a:bodyPr/>
+          <a:lstStyle/>
+          <a:p>
+            <a:fld id="{18BDFEC3-8487-43E8-A154-7C12CBC1FFF2}" type="slidenum">
+              <a:rPr lang="en-US"/>
+              <a:t>68</a:t>
             </a:fld>
             <a:endParaRPr lang="en-US"/>
           </a:p>
@@ -17148,7 +17279,7 @@
                       </a:pPr>
                       <a:r>
                         <a:rPr/>
-                        <a:t>threshold 0.5</a:t>
+                        <a:t>our model</a:t>
                       </a:r>
                     </a:p>
                   </a:txBody>
@@ -17457,6 +17588,148 @@
             </a:pPr>
             <a:r>
               <a:rPr/>
+              <a:t>Behind every label, a probability</a:t>
+            </a:r>
+          </a:p>
+        </p:txBody>
+      </p:sp>
+      <p:sp>
+        <p:nvSpPr>
+          <p:cNvPr id="3" name="Content Placeholder 2"/>
+          <p:cNvSpPr>
+            <a:spLocks noGrp="1"/>
+          </p:cNvSpPr>
+          <p:nvPr>
+            <p:ph idx="1"/>
+          </p:nvPr>
+        </p:nvSpPr>
+        <p:spPr>
+          <a:xfrm>
+            <a:off x="457200" y="1200151"/>
+            <a:ext cx="8229600" cy="3394472"/>
+          </a:xfrm>
+        </p:spPr>
+        <p:txBody>
+          <a:bodyPr/>
+          <a:lstStyle/>
+          <a:p>
+            <a:pPr lvl="0"/>
+            <a:r>
+              <a:rPr/>
+              <a:t>The model does not output a label: it outputs </a:t>
+            </a:r>
+            <a:r>
+              <a:rPr b="1"/>
+              <a:t>the probability</a:t>
+            </a:r>
+            <a:r>
+              <a:rPr/>
+              <a:t> that the tumour is malignant</a:t>
+            </a:r>
+          </a:p>
+          <a:p>
+            <a:pPr lvl="0"/>
+            <a:r>
+              <a:rPr>
+                <a:latin typeface="Courier"/>
+              </a:rPr>
+              <a:t>predict()</a:t>
+            </a:r>
+            <a:r>
+              <a:rPr/>
+              <a:t> turns it into a label by comparing it with </a:t>
+            </a:r>
+            <a:r>
+              <a:rPr b="1"/>
+              <a:t>0.5</a:t>
+            </a:r>
+          </a:p>
+          <a:p>
+            <a:pPr lvl="0"/>
+            <a:r>
+              <a:rPr/>
+              <a:t>The missed malignancy got </a:t>
+            </a:r>
+            <a:r>
+              <a:rPr b="1"/>
+              <a:t>0.11</a:t>
+            </a:r>
+            <a:r>
+              <a:rPr/>
+              <a:t>: called benign</a:t>
+            </a:r>
+          </a:p>
+          <a:p>
+            <a:pPr lvl="0"/>
+            <a:r>
+              <a:rPr/>
+              <a:t>The false alarm, a benign tumour, got </a:t>
+            </a:r>
+            <a:r>
+              <a:rPr b="1"/>
+              <a:t>0.62</a:t>
+            </a:r>
+            <a:r>
+              <a:rPr/>
+              <a:t>: called malignant</a:t>
+            </a:r>
+          </a:p>
+          <a:p>
+            <a:pPr lvl="0"/>
+            <a:r>
+              <a:rPr/>
+              <a:t>0.5 is a default. Nobody chose it</a:t>
+            </a:r>
+          </a:p>
+        </p:txBody>
+      </p:sp>
+    </p:spTree>
+  </p:cSld>
+</p:sld>
+</file>
+
+<file path=ppt/slides/slide53.xml><?xml version="1.0" encoding="utf-8"?>
+<p:sld xmlns:a="http://schemas.openxmlformats.org/drawingml/2006/main" xmlns:r="http://schemas.openxmlformats.org/officeDocument/2006/relationships" xmlns:p="http://schemas.openxmlformats.org/presentationml/2006/main">
+  <p:cSld>
+    <p:spTree>
+      <p:nvGrpSpPr>
+        <p:cNvPr id="1" name=""/>
+        <p:cNvGrpSpPr/>
+        <p:nvPr/>
+      </p:nvGrpSpPr>
+      <p:grpSpPr>
+        <a:xfrm>
+          <a:off x="0" y="0"/>
+          <a:ext cx="0" cy="0"/>
+          <a:chOff x="0" y="0"/>
+          <a:chExt cx="0" cy="0"/>
+        </a:xfrm>
+      </p:grpSpPr>
+      <p:sp>
+        <p:nvSpPr>
+          <p:cNvPr id="2" name="Title 1"/>
+          <p:cNvSpPr>
+            <a:spLocks noGrp="1"/>
+          </p:cNvSpPr>
+          <p:nvPr>
+            <p:ph type="title"/>
+          </p:nvPr>
+        </p:nvSpPr>
+        <p:spPr>
+          <a:xfrm>
+            <a:off x="457200" y="205979"/>
+            <a:ext cx="8229600" cy="857250"/>
+          </a:xfrm>
+        </p:spPr>
+        <p:txBody>
+          <a:bodyPr/>
+          <a:lstStyle/>
+          <a:p>
+            <a:pPr lvl="0" indent="0" marL="0">
+              <a:buNone/>
+            </a:pPr>
+            <a:r>
+              <a:rPr/>
               <a:t>The trade-off, drawn</a:t>
             </a:r>
           </a:p>
@@ -17497,109 +17770,6 @@
 </p:sld>
 </file>
 
-<file path=ppt/slides/slide53.xml><?xml version="1.0" encoding="utf-8"?>
-<p:sld xmlns:a="http://schemas.openxmlformats.org/drawingml/2006/main" xmlns:r="http://schemas.openxmlformats.org/officeDocument/2006/relationships" xmlns:p="http://schemas.openxmlformats.org/presentationml/2006/main">
-  <p:cSld>
-    <p:spTree>
-      <p:nvGrpSpPr>
-        <p:cNvPr id="1" name=""/>
-        <p:cNvGrpSpPr/>
-        <p:nvPr/>
-      </p:nvGrpSpPr>
-      <p:grpSpPr>
-        <a:xfrm>
-          <a:off x="0" y="0"/>
-          <a:ext cx="0" cy="0"/>
-          <a:chOff x="0" y="0"/>
-          <a:chExt cx="0" cy="0"/>
-        </a:xfrm>
-      </p:grpSpPr>
-      <p:sp>
-        <p:nvSpPr>
-          <p:cNvPr id="2" name="Title 1"/>
-          <p:cNvSpPr>
-            <a:spLocks noGrp="1"/>
-          </p:cNvSpPr>
-          <p:nvPr>
-            <p:ph type="title"/>
-          </p:nvPr>
-        </p:nvSpPr>
-        <p:spPr>
-          <a:xfrm>
-            <a:off x="457200" y="205979"/>
-            <a:ext cx="8229600" cy="857250"/>
-          </a:xfrm>
-        </p:spPr>
-        <p:txBody>
-          <a:bodyPr/>
-          <a:lstStyle/>
-          <a:p>
-            <a:pPr lvl="0" indent="0" marL="0">
-              <a:buNone/>
-            </a:pPr>
-            <a:r>
-              <a:rPr/>
-              <a:t>What we did not do</a:t>
-            </a:r>
-          </a:p>
-        </p:txBody>
-      </p:sp>
-      <p:sp>
-        <p:nvSpPr>
-          <p:cNvPr id="3" name="Content Placeholder 2"/>
-          <p:cNvSpPr>
-            <a:spLocks noGrp="1"/>
-          </p:cNvSpPr>
-          <p:nvPr>
-            <p:ph idx="1"/>
-          </p:nvPr>
-        </p:nvSpPr>
-        <p:spPr>
-          <a:xfrm>
-            <a:off x="457200" y="1200151"/>
-            <a:ext cx="8229600" cy="3394472"/>
-          </a:xfrm>
-        </p:spPr>
-        <p:txBody>
-          <a:bodyPr/>
-          <a:lstStyle/>
-          <a:p>
-            <a:pPr lvl="0"/>
-            <a:r>
-              <a:rPr/>
-              <a:t>No tuning</a:t>
-            </a:r>
-          </a:p>
-          <a:p>
-            <a:pPr lvl="0"/>
-            <a:r>
-              <a:rPr/>
-              <a:t>No comparison of model families</a:t>
-            </a:r>
-          </a:p>
-          <a:p>
-            <a:pPr lvl="0"/>
-            <a:r>
-              <a:rPr/>
-              <a:t>No check of stability across splits</a:t>
-            </a:r>
-          </a:p>
-          <a:p>
-            <a:pPr lvl="0" indent="0" marL="0">
-              <a:buNone/>
-            </a:pPr>
-            <a:r>
-              <a:rPr/>
-              <a:t>And: we never looked at the test set to make a decision.</a:t>
-            </a:r>
-          </a:p>
-        </p:txBody>
-      </p:sp>
-    </p:spTree>
-  </p:cSld>
-</p:sld>
-</file>
-
 <file path=ppt/slides/slide54.xml><?xml version="1.0" encoding="utf-8"?>
 <p:sld xmlns:a="http://schemas.openxmlformats.org/drawingml/2006/main" xmlns:r="http://schemas.openxmlformats.org/officeDocument/2006/relationships" xmlns:p="http://schemas.openxmlformats.org/presentationml/2006/main">
   <p:cSld>
@@ -17642,7 +17812,7 @@
             </a:pPr>
             <a:r>
               <a:rPr/>
-              <a:t>Four ways a model misleads you</a:t>
+              <a:t>What we did not do</a:t>
             </a:r>
           </a:p>
         </p:txBody>
@@ -17670,37 +17840,30 @@
             <a:pPr lvl="0"/>
             <a:r>
               <a:rPr/>
-              <a:t>Leakage</a:t>
+              <a:t>No tuning</a:t>
             </a:r>
           </a:p>
           <a:p>
             <a:pPr lvl="0"/>
             <a:r>
               <a:rPr/>
-              <a:t>Imbalance</a:t>
+              <a:t>No comparison of model families</a:t>
             </a:r>
           </a:p>
           <a:p>
             <a:pPr lvl="0"/>
             <a:r>
               <a:rPr/>
-              <a:t>Shortcut features</a:t>
-            </a:r>
-          </a:p>
-          <a:p>
-            <a:pPr lvl="0"/>
-            <a:r>
-              <a:rPr/>
-              <a:t>Single-split noise</a:t>
-            </a:r>
-          </a:p>
-          <a:p>
-            <a:pPr lvl="0" indent="0" marL="0">
-              <a:buNone/>
-            </a:pPr>
-            <a:r>
-              <a:rPr/>
-              <a:t>All produce numbers that pass a casual review.</a:t>
+              <a:t>No check of stability across splits</a:t>
+            </a:r>
+          </a:p>
+          <a:p>
+            <a:pPr lvl="0" indent="0" marL="0">
+              <a:buNone/>
+            </a:pPr>
+            <a:r>
+              <a:rPr/>
+              <a:t>And: we never looked at the test set to make a decision.</a:t>
             </a:r>
           </a:p>
         </p:txBody>
@@ -17752,7 +17915,7 @@
             </a:pPr>
             <a:r>
               <a:rPr/>
-              <a:t>Notebook 3, live</a:t>
+              <a:t>Four ways a model misleads you</a:t>
             </a:r>
           </a:p>
         </p:txBody>
@@ -17777,12 +17940,40 @@
           <a:bodyPr/>
           <a:lstStyle/>
           <a:p>
-            <a:pPr lvl="0" indent="0" marL="0">
-              <a:buNone/>
-            </a:pPr>
-            <a:r>
-              <a:rPr/>
-              <a:t>Four failures, four plausible numbers, and not one bug among them.</a:t>
+            <a:pPr lvl="0"/>
+            <a:r>
+              <a:rPr/>
+              <a:t>Leakage</a:t>
+            </a:r>
+          </a:p>
+          <a:p>
+            <a:pPr lvl="0"/>
+            <a:r>
+              <a:rPr/>
+              <a:t>Imbalance</a:t>
+            </a:r>
+          </a:p>
+          <a:p>
+            <a:pPr lvl="0"/>
+            <a:r>
+              <a:rPr/>
+              <a:t>Shortcut features</a:t>
+            </a:r>
+          </a:p>
+          <a:p>
+            <a:pPr lvl="0"/>
+            <a:r>
+              <a:rPr/>
+              <a:t>Single-split noise</a:t>
+            </a:r>
+          </a:p>
+          <a:p>
+            <a:pPr lvl="0" indent="0" marL="0">
+              <a:buNone/>
+            </a:pPr>
+            <a:r>
+              <a:rPr/>
+              <a:t>All produce numbers that pass a casual review.</a:t>
             </a:r>
           </a:p>
         </p:txBody>
@@ -17834,7 +18025,7 @@
             </a:pPr>
             <a:r>
               <a:rPr/>
-              <a:t>200 samples. 5000 random features. Coin-flip labels.</a:t>
+              <a:t>Notebook 3, live</a:t>
             </a:r>
           </a:p>
         </p:txBody>
@@ -17864,16 +18055,7 @@
             </a:pPr>
             <a:r>
               <a:rPr/>
-              <a:t>There is nothing to learn.</a:t>
-            </a:r>
-          </a:p>
-          <a:p>
-            <a:pPr lvl="0" indent="0" marL="0">
-              <a:buNone/>
-            </a:pPr>
-            <a:r>
-              <a:rPr/>
-              <a:t>Anything above 50% is an artefact.</a:t>
+              <a:t>Four failures, four plausible numbers, and not one bug among them.</a:t>
             </a:r>
           </a:p>
         </p:txBody>
@@ -17884,6 +18066,97 @@
 </file>
 
 <file path=ppt/slides/slide57.xml><?xml version="1.0" encoding="utf-8"?>
+<p:sld xmlns:a="http://schemas.openxmlformats.org/drawingml/2006/main" xmlns:r="http://schemas.openxmlformats.org/officeDocument/2006/relationships" xmlns:p="http://schemas.openxmlformats.org/presentationml/2006/main">
+  <p:cSld>
+    <p:spTree>
+      <p:nvGrpSpPr>
+        <p:cNvPr id="1" name=""/>
+        <p:cNvGrpSpPr/>
+        <p:nvPr/>
+      </p:nvGrpSpPr>
+      <p:grpSpPr>
+        <a:xfrm>
+          <a:off x="0" y="0"/>
+          <a:ext cx="0" cy="0"/>
+          <a:chOff x="0" y="0"/>
+          <a:chExt cx="0" cy="0"/>
+        </a:xfrm>
+      </p:grpSpPr>
+      <p:sp>
+        <p:nvSpPr>
+          <p:cNvPr id="2" name="Title 1"/>
+          <p:cNvSpPr>
+            <a:spLocks noGrp="1"/>
+          </p:cNvSpPr>
+          <p:nvPr>
+            <p:ph type="title"/>
+          </p:nvPr>
+        </p:nvSpPr>
+        <p:spPr>
+          <a:xfrm>
+            <a:off x="457200" y="205979"/>
+            <a:ext cx="8229600" cy="857250"/>
+          </a:xfrm>
+        </p:spPr>
+        <p:txBody>
+          <a:bodyPr/>
+          <a:lstStyle/>
+          <a:p>
+            <a:pPr lvl="0" indent="0" marL="0">
+              <a:buNone/>
+            </a:pPr>
+            <a:r>
+              <a:rPr/>
+              <a:t>200 samples. 5000 random features. Coin-flip labels.</a:t>
+            </a:r>
+          </a:p>
+        </p:txBody>
+      </p:sp>
+      <p:sp>
+        <p:nvSpPr>
+          <p:cNvPr id="3" name="Content Placeholder 2"/>
+          <p:cNvSpPr>
+            <a:spLocks noGrp="1"/>
+          </p:cNvSpPr>
+          <p:nvPr>
+            <p:ph idx="1"/>
+          </p:nvPr>
+        </p:nvSpPr>
+        <p:spPr>
+          <a:xfrm>
+            <a:off x="457200" y="1200151"/>
+            <a:ext cx="8229600" cy="3394472"/>
+          </a:xfrm>
+        </p:spPr>
+        <p:txBody>
+          <a:bodyPr/>
+          <a:lstStyle/>
+          <a:p>
+            <a:pPr lvl="0" indent="0" marL="0">
+              <a:buNone/>
+            </a:pPr>
+            <a:r>
+              <a:rPr/>
+              <a:t>There is nothing to learn.</a:t>
+            </a:r>
+          </a:p>
+          <a:p>
+            <a:pPr lvl="0" indent="0" marL="0">
+              <a:buNone/>
+            </a:pPr>
+            <a:r>
+              <a:rPr/>
+              <a:t>Anything above 50% is an artefact.</a:t>
+            </a:r>
+          </a:p>
+        </p:txBody>
+      </p:sp>
+    </p:spTree>
+  </p:cSld>
+</p:sld>
+</file>
+
+<file path=ppt/slides/slide58.xml><?xml version="1.0" encoding="utf-8"?>
 <p:sld xmlns:a="http://schemas.openxmlformats.org/drawingml/2006/main" xmlns:r="http://schemas.openxmlformats.org/officeDocument/2006/relationships" xmlns:p="http://schemas.openxmlformats.org/presentationml/2006/main">
   <p:cSld>
     <p:spTree>
@@ -17965,105 +18238,6 @@
 </p:sld>
 </file>
 
-<file path=ppt/slides/slide58.xml><?xml version="1.0" encoding="utf-8"?>
-<p:sld xmlns:a="http://schemas.openxmlformats.org/drawingml/2006/main" xmlns:r="http://schemas.openxmlformats.org/officeDocument/2006/relationships" xmlns:p="http://schemas.openxmlformats.org/presentationml/2006/main">
-  <p:cSld>
-    <p:spTree>
-      <p:nvGrpSpPr>
-        <p:cNvPr id="1" name=""/>
-        <p:cNvGrpSpPr/>
-        <p:nvPr/>
-      </p:nvGrpSpPr>
-      <p:grpSpPr>
-        <a:xfrm>
-          <a:off x="0" y="0"/>
-          <a:ext cx="0" cy="0"/>
-          <a:chOff x="0" y="0"/>
-          <a:chExt cx="0" cy="0"/>
-        </a:xfrm>
-      </p:grpSpPr>
-      <p:sp>
-        <p:nvSpPr>
-          <p:cNvPr id="2" name="Title 1"/>
-          <p:cNvSpPr>
-            <a:spLocks noGrp="1"/>
-          </p:cNvSpPr>
-          <p:nvPr>
-            <p:ph type="title"/>
-          </p:nvPr>
-        </p:nvSpPr>
-        <p:spPr>
-          <a:xfrm>
-            <a:off x="457200" y="205979"/>
-            <a:ext cx="8229600" cy="857250"/>
-          </a:xfrm>
-        </p:spPr>
-        <p:txBody>
-          <a:bodyPr/>
-          <a:lstStyle/>
-          <a:p>
-            <a:pPr lvl="0" indent="0" marL="0">
-              <a:buNone/>
-            </a:pPr>
-            <a:r>
-              <a:rPr/>
-              <a:t>The rule</a:t>
-            </a:r>
-          </a:p>
-        </p:txBody>
-      </p:sp>
-      <p:sp>
-        <p:nvSpPr>
-          <p:cNvPr id="3" name="Content Placeholder 2"/>
-          <p:cNvSpPr>
-            <a:spLocks noGrp="1"/>
-          </p:cNvSpPr>
-          <p:nvPr>
-            <p:ph idx="1"/>
-          </p:nvPr>
-        </p:nvSpPr>
-        <p:spPr>
-          <a:xfrm>
-            <a:off x="457200" y="1200151"/>
-            <a:ext cx="8229600" cy="3394472"/>
-          </a:xfrm>
-        </p:spPr>
-        <p:txBody>
-          <a:bodyPr/>
-          <a:lstStyle/>
-          <a:p>
-            <a:pPr lvl="0" indent="0" marL="0">
-              <a:buNone/>
-            </a:pPr>
-            <a:r>
-              <a:rPr/>
-              <a:t>Every step that </a:t>
-            </a:r>
-            <a:r>
-              <a:rPr b="1"/>
-              <a:t>learns anything</a:t>
-            </a:r>
-            <a:r>
-              <a:rPr/>
-              <a:t> must be fitted inside the training fold.</a:t>
-            </a:r>
-          </a:p>
-          <a:p>
-            <a:pPr lvl="0" indent="0" marL="0">
-              <a:buNone/>
-            </a:pPr>
-            <a:r>
-              <a:rPr/>
-              <a:t>Scaling. Imputation. Encoding. Selection. Tuning.</a:t>
-            </a:r>
-          </a:p>
-        </p:txBody>
-      </p:sp>
-    </p:spTree>
-  </p:cSld>
-</p:sld>
-</file>
-
 <file path=ppt/slides/slide59.xml><?xml version="1.0" encoding="utf-8"?>
 <p:sld xmlns:a="http://schemas.openxmlformats.org/drawingml/2006/main" xmlns:r="http://schemas.openxmlformats.org/officeDocument/2006/relationships" xmlns:p="http://schemas.openxmlformats.org/presentationml/2006/main">
   <p:cSld>
@@ -18106,7 +18280,7 @@
             </a:pPr>
             <a:r>
               <a:rPr/>
-              <a:t>99% accuracy, detecting nothing</a:t>
+              <a:t>The rule</a:t>
             </a:r>
           </a:p>
         </p:txBody>
@@ -18136,29 +18310,24 @@
             </a:pPr>
             <a:r>
               <a:rPr/>
-              <a:t>1% positives. Answer “negative” every time.</a:t>
-            </a:r>
-          </a:p>
-          <a:p>
-            <a:pPr lvl="0"/>
-            <a:r>
-              <a:rPr/>
-              <a:t>Accuracy: </a:t>
+              <a:t>Every step that </a:t>
             </a:r>
             <a:r>
               <a:rPr b="1"/>
-              <a:t>0.986</a:t>
-            </a:r>
-          </a:p>
-          <a:p>
-            <a:pPr lvl="0"/>
-            <a:r>
-              <a:rPr/>
-              <a:t>Recall on positives: </a:t>
-            </a:r>
-            <a:r>
-              <a:rPr b="1"/>
-              <a:t>0.000</a:t>
+              <a:t>learns anything</a:t>
+            </a:r>
+            <a:r>
+              <a:rPr/>
+              <a:t> must be fitted inside the training fold.</a:t>
+            </a:r>
+          </a:p>
+          <a:p>
+            <a:pPr lvl="0" indent="0" marL="0">
+              <a:buNone/>
+            </a:pPr>
+            <a:r>
+              <a:rPr/>
+              <a:t>Scaling. Imputation. Encoding. Selection. Tuning.</a:t>
             </a:r>
           </a:p>
         </p:txBody>
@@ -18279,6 +18448,110 @@
 </file>
 
 <file path=ppt/slides/slide60.xml><?xml version="1.0" encoding="utf-8"?>
+<p:sld xmlns:a="http://schemas.openxmlformats.org/drawingml/2006/main" xmlns:r="http://schemas.openxmlformats.org/officeDocument/2006/relationships" xmlns:p="http://schemas.openxmlformats.org/presentationml/2006/main">
+  <p:cSld>
+    <p:spTree>
+      <p:nvGrpSpPr>
+        <p:cNvPr id="1" name=""/>
+        <p:cNvGrpSpPr/>
+        <p:nvPr/>
+      </p:nvGrpSpPr>
+      <p:grpSpPr>
+        <a:xfrm>
+          <a:off x="0" y="0"/>
+          <a:ext cx="0" cy="0"/>
+          <a:chOff x="0" y="0"/>
+          <a:chExt cx="0" cy="0"/>
+        </a:xfrm>
+      </p:grpSpPr>
+      <p:sp>
+        <p:nvSpPr>
+          <p:cNvPr id="2" name="Title 1"/>
+          <p:cNvSpPr>
+            <a:spLocks noGrp="1"/>
+          </p:cNvSpPr>
+          <p:nvPr>
+            <p:ph type="title"/>
+          </p:nvPr>
+        </p:nvSpPr>
+        <p:spPr>
+          <a:xfrm>
+            <a:off x="457200" y="205979"/>
+            <a:ext cx="8229600" cy="857250"/>
+          </a:xfrm>
+        </p:spPr>
+        <p:txBody>
+          <a:bodyPr/>
+          <a:lstStyle/>
+          <a:p>
+            <a:pPr lvl="0" indent="0" marL="0">
+              <a:buNone/>
+            </a:pPr>
+            <a:r>
+              <a:rPr/>
+              <a:t>99% accuracy, detecting nothing</a:t>
+            </a:r>
+          </a:p>
+        </p:txBody>
+      </p:sp>
+      <p:sp>
+        <p:nvSpPr>
+          <p:cNvPr id="3" name="Content Placeholder 2"/>
+          <p:cNvSpPr>
+            <a:spLocks noGrp="1"/>
+          </p:cNvSpPr>
+          <p:nvPr>
+            <p:ph idx="1"/>
+          </p:nvPr>
+        </p:nvSpPr>
+        <p:spPr>
+          <a:xfrm>
+            <a:off x="457200" y="1200151"/>
+            <a:ext cx="8229600" cy="3394472"/>
+          </a:xfrm>
+        </p:spPr>
+        <p:txBody>
+          <a:bodyPr/>
+          <a:lstStyle/>
+          <a:p>
+            <a:pPr lvl="0" indent="0" marL="0">
+              <a:buNone/>
+            </a:pPr>
+            <a:r>
+              <a:rPr/>
+              <a:t>1% positives. Answer “negative” every time.</a:t>
+            </a:r>
+          </a:p>
+          <a:p>
+            <a:pPr lvl="0"/>
+            <a:r>
+              <a:rPr/>
+              <a:t>Accuracy: </a:t>
+            </a:r>
+            <a:r>
+              <a:rPr b="1"/>
+              <a:t>0.986</a:t>
+            </a:r>
+          </a:p>
+          <a:p>
+            <a:pPr lvl="0"/>
+            <a:r>
+              <a:rPr/>
+              <a:t>Recall on positives: </a:t>
+            </a:r>
+            <a:r>
+              <a:rPr b="1"/>
+              <a:t>0.000</a:t>
+            </a:r>
+          </a:p>
+        </p:txBody>
+      </p:sp>
+    </p:spTree>
+  </p:cSld>
+</p:sld>
+</file>
+
+<file path=ppt/slides/slide61.xml><?xml version="1.0" encoding="utf-8"?>
 <p:sld xmlns:a="http://schemas.openxmlformats.org/drawingml/2006/main" xmlns:r="http://schemas.openxmlformats.org/officeDocument/2006/relationships" xmlns:p="http://schemas.openxmlformats.org/presentationml/2006/main">
   <p:cSld>
     <p:spTree>
@@ -18360,7 +18633,7 @@
 </p:sld>
 </file>
 
-<file path=ppt/slides/slide61.xml><?xml version="1.0" encoding="utf-8"?>
+<file path=ppt/slides/slide62.xml><?xml version="1.0" encoding="utf-8"?>
 <p:sld xmlns:a="http://schemas.openxmlformats.org/drawingml/2006/main" xmlns:r="http://schemas.openxmlformats.org/officeDocument/2006/relationships" xmlns:p="http://schemas.openxmlformats.org/presentationml/2006/main">
   <p:cSld>
     <p:spTree>
@@ -18465,7 +18738,7 @@
 </p:sld>
 </file>
 
-<file path=ppt/slides/slide62.xml><?xml version="1.0" encoding="utf-8"?>
+<file path=ppt/slides/slide63.xml><?xml version="1.0" encoding="utf-8"?>
 <p:sld xmlns:a="http://schemas.openxmlformats.org/drawingml/2006/main" xmlns:r="http://schemas.openxmlformats.org/officeDocument/2006/relationships" xmlns:p="http://schemas.openxmlformats.org/presentationml/2006/main">
   <p:cSld>
     <p:spTree>
@@ -18547,7 +18820,7 @@
 </p:sld>
 </file>
 
-<file path=ppt/slides/slide63.xml><?xml version="1.0" encoding="utf-8"?>
+<file path=ppt/slides/slide64.xml><?xml version="1.0" encoding="utf-8"?>
 <p:sld xmlns:a="http://schemas.openxmlformats.org/drawingml/2006/main" xmlns:r="http://schemas.openxmlformats.org/officeDocument/2006/relationships" xmlns:p="http://schemas.openxmlformats.org/presentationml/2006/main">
   <p:cSld>
     <p:spTree>
@@ -18629,97 +18902,6 @@
 </p:sld>
 </file>
 
-<file path=ppt/slides/slide64.xml><?xml version="1.0" encoding="utf-8"?>
-<p:sld xmlns:a="http://schemas.openxmlformats.org/drawingml/2006/main" xmlns:r="http://schemas.openxmlformats.org/officeDocument/2006/relationships" xmlns:p="http://schemas.openxmlformats.org/presentationml/2006/main">
-  <p:cSld>
-    <p:spTree>
-      <p:nvGrpSpPr>
-        <p:cNvPr id="1" name=""/>
-        <p:cNvGrpSpPr/>
-        <p:nvPr/>
-      </p:nvGrpSpPr>
-      <p:grpSpPr>
-        <a:xfrm>
-          <a:off x="0" y="0"/>
-          <a:ext cx="0" cy="0"/>
-          <a:chOff x="0" y="0"/>
-          <a:chExt cx="0" cy="0"/>
-        </a:xfrm>
-      </p:grpSpPr>
-      <p:sp>
-        <p:nvSpPr>
-          <p:cNvPr id="2" name="Title 1"/>
-          <p:cNvSpPr>
-            <a:spLocks noGrp="1"/>
-          </p:cNvSpPr>
-          <p:nvPr>
-            <p:ph type="title"/>
-          </p:nvPr>
-        </p:nvSpPr>
-        <p:spPr>
-          <a:xfrm>
-            <a:off x="457200" y="205979"/>
-            <a:ext cx="8229600" cy="857250"/>
-          </a:xfrm>
-        </p:spPr>
-        <p:txBody>
-          <a:bodyPr/>
-          <a:lstStyle/>
-          <a:p>
-            <a:pPr lvl="0" indent="0" marL="0">
-              <a:buNone/>
-            </a:pPr>
-            <a:r>
-              <a:rPr/>
-              <a:t>What the four have in common</a:t>
-            </a:r>
-          </a:p>
-        </p:txBody>
-      </p:sp>
-      <p:sp>
-        <p:nvSpPr>
-          <p:cNvPr id="3" name="Content Placeholder 2"/>
-          <p:cNvSpPr>
-            <a:spLocks noGrp="1"/>
-          </p:cNvSpPr>
-          <p:nvPr>
-            <p:ph idx="1"/>
-          </p:nvPr>
-        </p:nvSpPr>
-        <p:spPr>
-          <a:xfrm>
-            <a:off x="457200" y="1200151"/>
-            <a:ext cx="8229600" cy="3394472"/>
-          </a:xfrm>
-        </p:spPr>
-        <p:txBody>
-          <a:bodyPr/>
-          <a:lstStyle/>
-          <a:p>
-            <a:pPr lvl="0" indent="0" marL="0">
-              <a:buNone/>
-            </a:pPr>
-            <a:r>
-              <a:rPr/>
-              <a:t>None is a coding error.</a:t>
-            </a:r>
-          </a:p>
-          <a:p>
-            <a:pPr lvl="0" indent="0" marL="0">
-              <a:buNone/>
-            </a:pPr>
-            <a:r>
-              <a:rPr/>
-              <a:t>All four run exactly as written and return a plausible number.</a:t>
-            </a:r>
-          </a:p>
-        </p:txBody>
-      </p:sp>
-    </p:spTree>
-  </p:cSld>
-</p:sld>
-</file>
-
 <file path=ppt/slides/slide65.xml><?xml version="1.0" encoding="utf-8"?>
 <p:sld xmlns:a="http://schemas.openxmlformats.org/drawingml/2006/main" xmlns:r="http://schemas.openxmlformats.org/officeDocument/2006/relationships" xmlns:p="http://schemas.openxmlformats.org/presentationml/2006/main">
   <p:cSld>
@@ -18762,7 +18944,7 @@
             </a:pPr>
             <a:r>
               <a:rPr/>
-              <a:t>A model is not objective</a:t>
+              <a:t>What the four have in common</a:t>
             </a:r>
           </a:p>
         </p:txBody>
@@ -18787,36 +18969,21 @@
           <a:bodyPr/>
           <a:lstStyle/>
           <a:p>
-            <a:pPr lvl="0"/>
-            <a:r>
-              <a:rPr/>
-              <a:t>It is a compressed summary of its training data, </a:t>
-            </a:r>
-            <a:r>
-              <a:rPr b="1"/>
-              <a:t>including its injustices</a:t>
-            </a:r>
-          </a:p>
-          <a:p>
-            <a:pPr lvl="0"/>
-            <a:r>
-              <a:rPr/>
-              <a:t>These methods find </a:t>
-            </a:r>
-            <a:r>
-              <a:rPr b="1"/>
-              <a:t>correlation</a:t>
-            </a:r>
-            <a:r>
-              <a:rPr/>
-              <a:t>, not cause</a:t>
-            </a:r>
-          </a:p>
-          <a:p>
-            <a:pPr lvl="0"/>
-            <a:r>
-              <a:rPr/>
-              <a:t>Accuracy is not the only property that matters</a:t>
+            <a:pPr lvl="0" indent="0" marL="0">
+              <a:buNone/>
+            </a:pPr>
+            <a:r>
+              <a:rPr/>
+              <a:t>None is a coding error.</a:t>
+            </a:r>
+          </a:p>
+          <a:p>
+            <a:pPr lvl="0" indent="0" marL="0">
+              <a:buNone/>
+            </a:pPr>
+            <a:r>
+              <a:rPr/>
+              <a:t>All four run exactly as written and return a plausible number.</a:t>
             </a:r>
           </a:p>
         </p:txBody>
@@ -18868,7 +19035,7 @@
             </a:pPr>
             <a:r>
               <a:rPr/>
-              <a:t>Homework: we discuss it on Friday 9 October</a:t>
+              <a:t>A model is not objective</a:t>
             </a:r>
           </a:p>
         </p:txBody>
@@ -18893,45 +19060,36 @@
           <a:bodyPr/>
           <a:lstStyle/>
           <a:p>
-            <a:pPr lvl="0" indent="0" marL="0">
-              <a:buNone/>
-            </a:pPr>
-            <a:r>
-              <a:rPr>
-                <a:latin typeface="Courier"/>
-              </a:rPr>
-              <a:t>Exercises/01_first_workflow.md</a:t>
-            </a:r>
-          </a:p>
-          <a:p>
-            <a:pPr lvl="0" indent="0" marL="0">
-              <a:buNone/>
-            </a:pPr>
-            <a:r>
-              <a:rPr/>
-              <a:t>Wine quality: run the workflow yourself, and </a:t>
+            <a:pPr lvl="0"/>
+            <a:r>
+              <a:rPr/>
+              <a:t>It is a compressed summary of its training data, </a:t>
             </a:r>
             <a:r>
               <a:rPr b="1"/>
-              <a:t>justify every decision</a:t>
-            </a:r>
-            <a:r>
-              <a:rPr/>
-              <a:t>.</a:t>
+              <a:t>including its injustices</a:t>
             </a:r>
           </a:p>
           <a:p>
             <a:pPr lvl="0"/>
             <a:r>
               <a:rPr/>
-              <a:t>No marks for accuracy</a:t>
+              <a:t>These methods find </a:t>
+            </a:r>
+            <a:r>
+              <a:rPr b="1"/>
+              <a:t>correlation</a:t>
+            </a:r>
+            <a:r>
+              <a:rPr/>
+              <a:t>, not cause</a:t>
             </a:r>
           </a:p>
           <a:p>
             <a:pPr lvl="0"/>
             <a:r>
               <a:rPr/>
-              <a:t>Marks for methodology, and for saying what your number does not mean</a:t>
+              <a:t>Accuracy is not the only property that matters</a:t>
             </a:r>
           </a:p>
         </p:txBody>
@@ -18942,6 +19100,121 @@
 </file>
 
 <file path=ppt/slides/slide67.xml><?xml version="1.0" encoding="utf-8"?>
+<p:sld xmlns:a="http://schemas.openxmlformats.org/drawingml/2006/main" xmlns:r="http://schemas.openxmlformats.org/officeDocument/2006/relationships" xmlns:p="http://schemas.openxmlformats.org/presentationml/2006/main">
+  <p:cSld>
+    <p:spTree>
+      <p:nvGrpSpPr>
+        <p:cNvPr id="1" name=""/>
+        <p:cNvGrpSpPr/>
+        <p:nvPr/>
+      </p:nvGrpSpPr>
+      <p:grpSpPr>
+        <a:xfrm>
+          <a:off x="0" y="0"/>
+          <a:ext cx="0" cy="0"/>
+          <a:chOff x="0" y="0"/>
+          <a:chExt cx="0" cy="0"/>
+        </a:xfrm>
+      </p:grpSpPr>
+      <p:sp>
+        <p:nvSpPr>
+          <p:cNvPr id="2" name="Title 1"/>
+          <p:cNvSpPr>
+            <a:spLocks noGrp="1"/>
+          </p:cNvSpPr>
+          <p:nvPr>
+            <p:ph type="title"/>
+          </p:nvPr>
+        </p:nvSpPr>
+        <p:spPr>
+          <a:xfrm>
+            <a:off x="457200" y="205979"/>
+            <a:ext cx="8229600" cy="857250"/>
+          </a:xfrm>
+        </p:spPr>
+        <p:txBody>
+          <a:bodyPr/>
+          <a:lstStyle/>
+          <a:p>
+            <a:pPr lvl="0" indent="0" marL="0">
+              <a:buNone/>
+            </a:pPr>
+            <a:r>
+              <a:rPr/>
+              <a:t>Homework: we discuss it on Friday 9 October</a:t>
+            </a:r>
+          </a:p>
+        </p:txBody>
+      </p:sp>
+      <p:sp>
+        <p:nvSpPr>
+          <p:cNvPr id="3" name="Content Placeholder 2"/>
+          <p:cNvSpPr>
+            <a:spLocks noGrp="1"/>
+          </p:cNvSpPr>
+          <p:nvPr>
+            <p:ph idx="1"/>
+          </p:nvPr>
+        </p:nvSpPr>
+        <p:spPr>
+          <a:xfrm>
+            <a:off x="457200" y="1200151"/>
+            <a:ext cx="8229600" cy="3394472"/>
+          </a:xfrm>
+        </p:spPr>
+        <p:txBody>
+          <a:bodyPr/>
+          <a:lstStyle/>
+          <a:p>
+            <a:pPr lvl="0" indent="0" marL="0">
+              <a:buNone/>
+            </a:pPr>
+            <a:r>
+              <a:rPr>
+                <a:latin typeface="Courier"/>
+              </a:rPr>
+              <a:t>Exercises/01_first_workflow.md</a:t>
+            </a:r>
+          </a:p>
+          <a:p>
+            <a:pPr lvl="0" indent="0" marL="0">
+              <a:buNone/>
+            </a:pPr>
+            <a:r>
+              <a:rPr/>
+              <a:t>Wine quality: run the workflow yourself, and </a:t>
+            </a:r>
+            <a:r>
+              <a:rPr b="1"/>
+              <a:t>justify every decision</a:t>
+            </a:r>
+            <a:r>
+              <a:rPr/>
+              <a:t>.</a:t>
+            </a:r>
+          </a:p>
+          <a:p>
+            <a:pPr lvl="0"/>
+            <a:r>
+              <a:rPr/>
+              <a:t>No marks for accuracy</a:t>
+            </a:r>
+          </a:p>
+          <a:p>
+            <a:pPr lvl="0"/>
+            <a:r>
+              <a:rPr/>
+              <a:t>Marks for methodology, and for saying what your number does not mean</a:t>
+            </a:r>
+          </a:p>
+        </p:txBody>
+      </p:sp>
+    </p:spTree>
+  </p:cSld>
+</p:sld>
+</file>
+
+<file path=ppt/slides/slide68.xml><?xml version="1.0" encoding="utf-8"?>
 <p:sld xmlns:a="http://schemas.openxmlformats.org/drawingml/2006/main" xmlns:r="http://schemas.openxmlformats.org/officeDocument/2006/relationships" xmlns:p="http://schemas.openxmlformats.org/presentationml/2006/main">
   <p:cSld>
     <p:spTree>

</xml_diff>

<commit_message>
Anchor lesson 1's slides to the code its notebooks run
Each notebook slide now carries a table of the calls it makes, and the slide
that introduces a concept names the function that performs it. verify_lesson
checks that every scikit-learn name a notebook uses appears on a slide: a
failure in the lessons already anchored, a note elsewhere.

Co-Authored-By: Claude Opus 5.5 <noreply@anthropic.com>
</commit_message>
<xml_diff>
--- a/Lessons/01_introduction_and_workflow/Slides/introduction_and_workflow_slides.pptx
+++ b/Lessons/01_introduction_and_workflow/Slides/introduction_and_workflow_slides.pptx
@@ -4712,6 +4712,20 @@
             </a:pPr>
             <a:r>
               <a:rPr/>
+              <a:t>The table is the map for the notebook: each row is one of the three questions, the call that answers it, and the number it reaches. Point at the middle column before they start - every name in it is a cell they are about to run.</a:t>
+            </a:r>
+          </a:p>
+          <a:p>
+            <a:pPr lvl="0" indent="0" marL="0">
+              <a:buNone/>
+            </a:pPr>
+          </a:p>
+          <a:p>
+            <a:pPr lvl="0" indent="0" marL="0">
+              <a:buNone/>
+            </a:pPr>
+            <a:r>
+              <a:rPr/>
               <a:t>Open notebook 01 and run it. Twenty minutes, and it is the only place today where all three kinds appear on identical data, which is the whole argument of this segment made operational.</a:t>
             </a:r>
           </a:p>
@@ -4974,6 +4988,20 @@
             </a:pPr>
             <a:r>
               <a:rPr/>
+              <a:t>A question, a dataset, a split, a baseline, a model, and a number you can defend. The table is that sentence with the code attached: each step, the call that performs it, and the slide where the idea was introduced. Students who get lost in a cell can find their way back to the slide from here.</a:t>
+            </a:r>
+          </a:p>
+          <a:p>
+            <a:pPr lvl="0" indent="0" marL="0">
+              <a:buNone/>
+            </a:pPr>
+          </a:p>
+          <a:p>
+            <a:pPr lvl="0" indent="0" marL="0">
+              <a:buNone/>
+            </a:pPr>
+            <a:r>
+              <a:rPr/>
               <a:t>45 minutes, and it runs alongside the next twelve slides rather than instead of them: each step of the workflow is a slide and then the cell that performs it.</a:t>
             </a:r>
           </a:p>
@@ -7012,6 +7040,30 @@
         <p:txBody>
           <a:bodyPr/>
           <a:lstStyle/>
+          <a:p>
+            <a:pPr lvl="0" indent="0" marL="0">
+              <a:buNone/>
+            </a:pPr>
+            <a:r>
+              <a:rPr/>
+              <a:t>Four failures, four plausible numbers, and not one bug among them. The table pairs each failure with the calls that produce it and the slide that explains it; note that the leakage row uses the same </a:t>
+            </a:r>
+            <a:r>
+              <a:rPr>
+                <a:latin typeface="Courier"/>
+              </a:rPr>
+              <a:t>SelectKBest</a:t>
+            </a:r>
+            <a:r>
+              <a:rPr/>
+              <a:t> twice, once in the wrong place and once in the right one.</a:t>
+            </a:r>
+          </a:p>
+          <a:p>
+            <a:pPr lvl="0" indent="0" marL="0">
+              <a:buNone/>
+            </a:pPr>
+          </a:p>
           <a:p>
             <a:pPr lvl="0" indent="0" marL="0">
               <a:buNone/>
@@ -15675,6 +15727,29 @@
               <a:t>The cultivar is not a measurement: it is an answer written down</a:t>
             </a:r>
           </a:p>
+          <a:p>
+            <a:pPr lvl="0"/>
+            <a:r>
+              <a:rPr/>
+              <a:t>In code: a classifier such as </a:t>
+            </a:r>
+            <a:r>
+              <a:rPr>
+                <a:latin typeface="Courier"/>
+              </a:rPr>
+              <a:t>LogisticRegression</a:t>
+            </a:r>
+            <a:r>
+              <a:rPr/>
+              <a:t>, a regressor such as </a:t>
+            </a:r>
+            <a:r>
+              <a:rPr>
+                <a:latin typeface="Courier"/>
+              </a:rPr>
+              <a:t>LinearRegression</a:t>
+            </a:r>
+          </a:p>
         </p:txBody>
       </p:sp>
     </p:spTree>
@@ -15776,6 +15851,33 @@
             <a:r>
               <a:rPr/>
               <a:t>Odd points → anomaly detection</a:t>
+            </a:r>
+          </a:p>
+          <a:p>
+            <a:pPr lvl="0"/>
+            <a:r>
+              <a:rPr/>
+              <a:t>In code: </a:t>
+            </a:r>
+            <a:r>
+              <a:rPr>
+                <a:latin typeface="Courier"/>
+              </a:rPr>
+              <a:t>KMeans</a:t>
+            </a:r>
+            <a:r>
+              <a:rPr/>
+              <a:t> for groups, </a:t>
+            </a:r>
+            <a:r>
+              <a:rPr>
+                <a:latin typeface="Courier"/>
+              </a:rPr>
+              <a:t>PCA</a:t>
+            </a:r>
+            <a:r>
+              <a:rPr/>
+              <a:t> for fewer dimensions</a:t>
             </a:r>
           </a:p>
         </p:txBody>
@@ -16467,86 +16569,328 @@
           </a:p>
         </p:txBody>
       </p:sp>
-      <p:sp>
-        <p:nvSpPr>
-          <p:cNvPr id="3" name="Content Placeholder 2"/>
-          <p:cNvSpPr>
-            <a:spLocks noGrp="1"/>
-          </p:cNvSpPr>
+      <p:graphicFrame>
+        <p:nvGraphicFramePr>
+          <p:cNvPr id="6" name="Content Placeholder 5"/>
+          <p:cNvGraphicFramePr>
+            <a:graphicFrameLocks noGrp="1"/>
+          </p:cNvGraphicFramePr>
           <p:nvPr>
             <p:ph idx="1"/>
           </p:nvPr>
-        </p:nvSpPr>
-        <p:spPr>
-          <a:xfrm>
-            <a:off x="457200" y="1200151"/>
-            <a:ext cx="8229600" cy="3394472"/>
-          </a:xfrm>
-        </p:spPr>
-        <p:txBody>
-          <a:bodyPr/>
-          <a:lstStyle/>
-          <a:p>
-            <a:pPr lvl="0"/>
-            <a:r>
-              <a:rPr b="1"/>
-              <a:t>Supervised</a:t>
-            </a:r>
-            <a:r>
-              <a:rPr/>
-              <a:t>: predict the cultivar. Accuracy </a:t>
-            </a:r>
-            <a:r>
-              <a:rPr b="1"/>
-              <a:t>0.981</a:t>
-            </a:r>
-          </a:p>
-          <a:p>
-            <a:pPr lvl="0"/>
-            <a:r>
-              <a:rPr b="1"/>
-              <a:t>Unsupervised</a:t>
-            </a:r>
-            <a:r>
-              <a:rPr/>
-              <a:t>: throw the labels away. Recovers the cultivars at </a:t>
-            </a:r>
-            <a:r>
-              <a:rPr b="1"/>
-              <a:t>0.897</a:t>
-            </a:r>
-          </a:p>
-          <a:p>
-            <a:pPr lvl="0"/>
-            <a:r>
-              <a:rPr b="1"/>
-              <a:t>Self-supervised</a:t>
-            </a:r>
-            <a:r>
-              <a:rPr/>
-              <a:t>: hide </a:t>
-            </a:r>
-            <a:r>
-              <a:rPr>
-                <a:latin typeface="Courier"/>
-              </a:rPr>
-              <a:t>flavanoids</a:t>
-            </a:r>
-            <a:r>
-              <a:rPr/>
-              <a:t>, predict it. R² </a:t>
-            </a:r>
-            <a:r>
-              <a:rPr b="1"/>
-              <a:t>0.816</a:t>
-            </a:r>
-            <a:r>
-              <a:rPr/>
-              <a:t> (1 = perfect, 0 = no better than always guessing the mean)</a:t>
-            </a:r>
-          </a:p>
-        </p:txBody>
-      </p:sp>
+        </p:nvGraphicFramePr>
+        <p:xfrm>
+          <a:off x="457200" y="1166099"/>
+          <a:ext cx="8229600" cy="3390900"/>
+        </p:xfrm>
+        <a:graphic>
+          <a:graphicData uri="http://schemas.openxmlformats.org/drawingml/2006/table">
+            <a:tbl>
+              <a:tblPr firstRow="1" bandRow="1">
+                <a:tableStyleId>{5C22544A-7EE6-4342-B048-85BDC9FD1C3A}</a:tableStyleId>
+              </a:tblPr>
+              <a:tblGrid>
+                <a:gridCol w="4114800"/>
+                <a:gridCol w="4114800"/>
+              </a:tblGrid>
+              <a:tr h="0">
+                <a:tc>
+                  <a:txBody>
+                    <a:bodyPr/>
+                    <a:lstStyle/>
+                    <a:p>
+                      <a:pPr lvl="0" indent="0" marL="0">
+                        <a:buNone/>
+                      </a:pPr>
+                      <a:r>
+                        <a:rPr/>
+                        <a:t>question</a:t>
+                      </a:r>
+                    </a:p>
+                  </a:txBody>
+                  <a:tcPr/>
+                </a:tc>
+                <a:tc>
+                  <a:txBody>
+                    <a:bodyPr/>
+                    <a:lstStyle/>
+                    <a:p>
+                      <a:pPr lvl="0" indent="0" marL="0">
+                        <a:buNone/>
+                      </a:pPr>
+                      <a:r>
+                        <a:rPr/>
+                        <a:t>you call, and what it scores</a:t>
+                      </a:r>
+                    </a:p>
+                  </a:txBody>
+                  <a:tcPr/>
+                </a:tc>
+              </a:tr>
+              <a:tr h="0">
+                <a:tc>
+                  <a:txBody>
+                    <a:bodyPr/>
+                    <a:lstStyle/>
+                    <a:p>
+                      <a:pPr lvl="0" indent="0" marL="0">
+                        <a:buNone/>
+                      </a:pPr>
+                      <a:r>
+                        <a:rPr/>
+                        <a:t>the data: 178 wines, 13 measurements</a:t>
+                      </a:r>
+                    </a:p>
+                  </a:txBody>
+                </a:tc>
+                <a:tc>
+                  <a:txBody>
+                    <a:bodyPr/>
+                    <a:lstStyle/>
+                    <a:p>
+                      <a:pPr lvl="0" indent="0" marL="0">
+                        <a:buNone/>
+                      </a:pPr>
+                      <a:r>
+                        <a:rPr>
+                          <a:latin typeface="Courier"/>
+                        </a:rPr>
+                        <a:t>load_wine</a:t>
+                      </a:r>
+                    </a:p>
+                  </a:txBody>
+                </a:tc>
+              </a:tr>
+              <a:tr h="0">
+                <a:tc>
+                  <a:txBody>
+                    <a:bodyPr/>
+                    <a:lstStyle/>
+                    <a:p>
+                      <a:pPr lvl="0" indent="0" marL="0">
+                        <a:buNone/>
+                      </a:pPr>
+                      <a:r>
+                        <a:rPr b="1"/>
+                        <a:t>supervised</a:t>
+                      </a:r>
+                      <a:r>
+                        <a:rPr/>
+                        <a:t>: predict the cultivar</a:t>
+                      </a:r>
+                    </a:p>
+                  </a:txBody>
+                </a:tc>
+                <a:tc>
+                  <a:txBody>
+                    <a:bodyPr/>
+                    <a:lstStyle/>
+                    <a:p>
+                      <a:pPr lvl="0" indent="0" marL="0">
+                        <a:buNone/>
+                      </a:pPr>
+                      <a:r>
+                        <a:rPr>
+                          <a:latin typeface="Courier"/>
+                        </a:rPr>
+                        <a:t>make_pipeline(StandardScaler(), LogisticRegression())</a:t>
+                      </a:r>
+                      <a:r>
+                        <a:rPr/>
+                        <a:t> → </a:t>
+                      </a:r>
+                      <a:r>
+                        <a:rPr>
+                          <a:latin typeface="Courier"/>
+                        </a:rPr>
+                        <a:t>accuracy_score</a:t>
+                      </a:r>
+                      <a:r>
+                        <a:rPr/>
+                        <a:t> </a:t>
+                      </a:r>
+                      <a:r>
+                        <a:rPr b="1"/>
+                        <a:t>0.981</a:t>
+                      </a:r>
+                    </a:p>
+                  </a:txBody>
+                </a:tc>
+              </a:tr>
+              <a:tr h="0">
+                <a:tc>
+                  <a:txBody>
+                    <a:bodyPr/>
+                    <a:lstStyle/>
+                    <a:p>
+                      <a:pPr lvl="0" indent="0" marL="0">
+                        <a:buNone/>
+                      </a:pPr>
+                      <a:r>
+                        <a:rPr b="1"/>
+                        <a:t>unsupervised</a:t>
+                      </a:r>
+                      <a:r>
+                        <a:rPr/>
+                        <a:t>: labels thrown away</a:t>
+                      </a:r>
+                    </a:p>
+                  </a:txBody>
+                </a:tc>
+                <a:tc>
+                  <a:txBody>
+                    <a:bodyPr/>
+                    <a:lstStyle/>
+                    <a:p>
+                      <a:pPr lvl="0" indent="0" marL="0">
+                        <a:buNone/>
+                      </a:pPr>
+                      <a:r>
+                        <a:rPr>
+                          <a:latin typeface="Courier"/>
+                        </a:rPr>
+                        <a:t>KMeans(n_clusters=3)</a:t>
+                      </a:r>
+                      <a:r>
+                        <a:rPr/>
+                        <a:t>, drawn with </a:t>
+                      </a:r>
+                      <a:r>
+                        <a:rPr>
+                          <a:latin typeface="Courier"/>
+                        </a:rPr>
+                        <a:t>PCA</a:t>
+                      </a:r>
+                      <a:r>
+                        <a:rPr/>
+                        <a:t> → </a:t>
+                      </a:r>
+                      <a:r>
+                        <a:rPr>
+                          <a:latin typeface="Courier"/>
+                        </a:rPr>
+                        <a:t>adjusted_rand_score</a:t>
+                      </a:r>
+                      <a:r>
+                        <a:rPr/>
+                        <a:t> </a:t>
+                      </a:r>
+                      <a:r>
+                        <a:rPr b="1"/>
+                        <a:t>0.897</a:t>
+                      </a:r>
+                    </a:p>
+                  </a:txBody>
+                </a:tc>
+              </a:tr>
+              <a:tr h="0">
+                <a:tc>
+                  <a:txBody>
+                    <a:bodyPr/>
+                    <a:lstStyle/>
+                    <a:p>
+                      <a:pPr lvl="0" indent="0" marL="0">
+                        <a:buNone/>
+                      </a:pPr>
+                      <a:r>
+                        <a:rPr b="1"/>
+                        <a:t>self-supervised</a:t>
+                      </a:r>
+                      <a:r>
+                        <a:rPr/>
+                        <a:t>: hide </a:t>
+                      </a:r>
+                      <a:r>
+                        <a:rPr>
+                          <a:latin typeface="Courier"/>
+                        </a:rPr>
+                        <a:t>flavanoids</a:t>
+                      </a:r>
+                      <a:r>
+                        <a:rPr/>
+                        <a:t>, predict it</a:t>
+                      </a:r>
+                    </a:p>
+                  </a:txBody>
+                </a:tc>
+                <a:tc>
+                  <a:txBody>
+                    <a:bodyPr/>
+                    <a:lstStyle/>
+                    <a:p>
+                      <a:pPr lvl="0" indent="0" marL="0">
+                        <a:buNone/>
+                      </a:pPr>
+                      <a:r>
+                        <a:rPr>
+                          <a:latin typeface="Courier"/>
+                        </a:rPr>
+                        <a:t>LinearRegression</a:t>
+                      </a:r>
+                      <a:r>
+                        <a:rPr/>
+                        <a:t> → </a:t>
+                      </a:r>
+                      <a:r>
+                        <a:rPr>
+                          <a:latin typeface="Courier"/>
+                        </a:rPr>
+                        <a:t>r2_score</a:t>
+                      </a:r>
+                      <a:r>
+                        <a:rPr/>
+                        <a:t> </a:t>
+                      </a:r>
+                      <a:r>
+                        <a:rPr b="1"/>
+                        <a:t>0.816</a:t>
+                      </a:r>
+                      <a:r>
+                        <a:rPr/>
+                        <a:t> (1 perfect, 0 = guessing the mean)</a:t>
+                      </a:r>
+                    </a:p>
+                  </a:txBody>
+                </a:tc>
+              </a:tr>
+              <a:tr h="0">
+                <a:tc>
+                  <a:txBody>
+                    <a:bodyPr/>
+                    <a:lstStyle/>
+                    <a:p>
+                      <a:pPr lvl="0" indent="0" marL="0">
+                        <a:buNone/>
+                      </a:pPr>
+                      <a:r>
+                        <a:rPr/>
+                        <a:t>before either model with a target</a:t>
+                      </a:r>
+                    </a:p>
+                  </a:txBody>
+                </a:tc>
+                <a:tc>
+                  <a:txBody>
+                    <a:bodyPr/>
+                    <a:lstStyle/>
+                    <a:p>
+                      <a:pPr lvl="0" indent="0" marL="0">
+                        <a:buNone/>
+                      </a:pPr>
+                      <a:r>
+                        <a:rPr>
+                          <a:latin typeface="Courier"/>
+                        </a:rPr>
+                        <a:t>train_test_split</a:t>
+                      </a:r>
+                    </a:p>
+                  </a:txBody>
+                </a:tc>
+              </a:tr>
+            </a:tbl>
+          </a:graphicData>
+        </a:graphic>
+      </p:graphicFrame>
     </p:spTree>
   </p:cSld>
 </p:sld>
@@ -16681,36 +17025,306 @@
           </a:p>
         </p:txBody>
       </p:sp>
-      <p:sp>
-        <p:nvSpPr>
-          <p:cNvPr id="3" name="Content Placeholder 2"/>
-          <p:cNvSpPr>
-            <a:spLocks noGrp="1"/>
-          </p:cNvSpPr>
+      <p:graphicFrame>
+        <p:nvGraphicFramePr>
+          <p:cNvPr id="6" name="Content Placeholder 5"/>
+          <p:cNvGraphicFramePr>
+            <a:graphicFrameLocks noGrp="1"/>
+          </p:cNvGraphicFramePr>
           <p:nvPr>
             <p:ph idx="1"/>
           </p:nvPr>
-        </p:nvSpPr>
-        <p:spPr>
-          <a:xfrm>
-            <a:off x="457200" y="1200151"/>
-            <a:ext cx="8229600" cy="3394472"/>
-          </a:xfrm>
-        </p:spPr>
-        <p:txBody>
-          <a:bodyPr/>
-          <a:lstStyle/>
-          <a:p>
-            <a:pPr lvl="0" indent="0" marL="0">
-              <a:buNone/>
-            </a:pPr>
-            <a:r>
-              <a:rPr/>
-              <a:t>A question, a dataset, a split, a baseline, a model, and a number you can defend.</a:t>
-            </a:r>
-          </a:p>
-        </p:txBody>
-      </p:sp>
+        </p:nvGraphicFramePr>
+        <p:xfrm>
+          <a:off x="457200" y="1166099"/>
+          <a:ext cx="8229600" cy="3390900"/>
+        </p:xfrm>
+        <a:graphic>
+          <a:graphicData uri="http://schemas.openxmlformats.org/drawingml/2006/table">
+            <a:tbl>
+              <a:tblPr firstRow="1" bandRow="1">
+                <a:tableStyleId>{5C22544A-7EE6-4342-B048-85BDC9FD1C3A}</a:tableStyleId>
+              </a:tblPr>
+              <a:tblGrid>
+                <a:gridCol w="4114800"/>
+                <a:gridCol w="4114800"/>
+              </a:tblGrid>
+              <a:tr h="0">
+                <a:tc>
+                  <a:txBody>
+                    <a:bodyPr/>
+                    <a:lstStyle/>
+                    <a:p>
+                      <a:pPr lvl="0" indent="0" marL="0">
+                        <a:buNone/>
+                      </a:pPr>
+                      <a:r>
+                        <a:rPr/>
+                        <a:t>step, and its slide</a:t>
+                      </a:r>
+                    </a:p>
+                  </a:txBody>
+                  <a:tcPr/>
+                </a:tc>
+                <a:tc>
+                  <a:txBody>
+                    <a:bodyPr/>
+                    <a:lstStyle/>
+                    <a:p>
+                      <a:pPr lvl="0" indent="0" marL="0">
+                        <a:buNone/>
+                      </a:pPr>
+                      <a:r>
+                        <a:rPr/>
+                        <a:t>you call</a:t>
+                      </a:r>
+                    </a:p>
+                  </a:txBody>
+                  <a:tcPr/>
+                </a:tc>
+              </a:tr>
+              <a:tr h="0">
+                <a:tc>
+                  <a:txBody>
+                    <a:bodyPr/>
+                    <a:lstStyle/>
+                    <a:p>
+                      <a:pPr lvl="0" indent="0" marL="0">
+                        <a:buNone/>
+                      </a:pPr>
+                      <a:r>
+                        <a:rPr/>
+                        <a:t>look, 46</a:t>
+                      </a:r>
+                    </a:p>
+                  </a:txBody>
+                </a:tc>
+                <a:tc>
+                  <a:txBody>
+                    <a:bodyPr/>
+                    <a:lstStyle/>
+                    <a:p>
+                      <a:pPr lvl="0" indent="0" marL="0">
+                        <a:buNone/>
+                      </a:pPr>
+                      <a:r>
+                        <a:rPr>
+                          <a:latin typeface="Courier"/>
+                        </a:rPr>
+                        <a:t>load_breast_cancer</a:t>
+                      </a:r>
+                    </a:p>
+                  </a:txBody>
+                </a:tc>
+              </a:tr>
+              <a:tr h="0">
+                <a:tc>
+                  <a:txBody>
+                    <a:bodyPr/>
+                    <a:lstStyle/>
+                    <a:p>
+                      <a:pPr lvl="0" indent="0" marL="0">
+                        <a:buNone/>
+                      </a:pPr>
+                      <a:r>
+                        <a:rPr/>
+                        <a:t>split, 47</a:t>
+                      </a:r>
+                    </a:p>
+                  </a:txBody>
+                </a:tc>
+                <a:tc>
+                  <a:txBody>
+                    <a:bodyPr/>
+                    <a:lstStyle/>
+                    <a:p>
+                      <a:pPr lvl="0" indent="0" marL="0">
+                        <a:buNone/>
+                      </a:pPr>
+                      <a:r>
+                        <a:rPr>
+                          <a:latin typeface="Courier"/>
+                        </a:rPr>
+                        <a:t>train_test_split(X, y, test_size=0.25, stratify=y)</a:t>
+                      </a:r>
+                    </a:p>
+                  </a:txBody>
+                </a:tc>
+              </a:tr>
+              <a:tr h="0">
+                <a:tc>
+                  <a:txBody>
+                    <a:bodyPr/>
+                    <a:lstStyle/>
+                    <a:p>
+                      <a:pPr lvl="0" indent="0" marL="0">
+                        <a:buNone/>
+                      </a:pPr>
+                      <a:r>
+                        <a:rPr/>
+                        <a:t>baseline, 48</a:t>
+                      </a:r>
+                    </a:p>
+                  </a:txBody>
+                </a:tc>
+                <a:tc>
+                  <a:txBody>
+                    <a:bodyPr/>
+                    <a:lstStyle/>
+                    <a:p>
+                      <a:pPr lvl="0" indent="0" marL="0">
+                        <a:buNone/>
+                      </a:pPr>
+                      <a:r>
+                        <a:rPr>
+                          <a:latin typeface="Courier"/>
+                        </a:rPr>
+                        <a:t>DummyClassifier</a:t>
+                      </a:r>
+                      <a:r>
+                        <a:rPr/>
+                        <a:t>, always the majority class</a:t>
+                      </a:r>
+                    </a:p>
+                  </a:txBody>
+                </a:tc>
+              </a:tr>
+              <a:tr h="0">
+                <a:tc>
+                  <a:txBody>
+                    <a:bodyPr/>
+                    <a:lstStyle/>
+                    <a:p>
+                      <a:pPr lvl="0" indent="0" marL="0">
+                        <a:buNone/>
+                      </a:pPr>
+                      <a:r>
+                        <a:rPr/>
+                        <a:t>model, 49</a:t>
+                      </a:r>
+                    </a:p>
+                  </a:txBody>
+                </a:tc>
+                <a:tc>
+                  <a:txBody>
+                    <a:bodyPr/>
+                    <a:lstStyle/>
+                    <a:p>
+                      <a:pPr lvl="0" indent="0" marL="0">
+                        <a:buNone/>
+                      </a:pPr>
+                      <a:r>
+                        <a:rPr>
+                          <a:latin typeface="Courier"/>
+                        </a:rPr>
+                        <a:t>make_pipeline(StandardScaler(), LogisticRegression())</a:t>
+                      </a:r>
+                      <a:r>
+                        <a:rPr/>
+                        <a:t>, then </a:t>
+                      </a:r>
+                      <a:r>
+                        <a:rPr>
+                          <a:latin typeface="Courier"/>
+                        </a:rPr>
+                        <a:t>.fit()</a:t>
+                      </a:r>
+                    </a:p>
+                  </a:txBody>
+                </a:tc>
+              </a:tr>
+              <a:tr h="0">
+                <a:tc>
+                  <a:txBody>
+                    <a:bodyPr/>
+                    <a:lstStyle/>
+                    <a:p>
+                      <a:pPr lvl="0" indent="0" marL="0">
+                        <a:buNone/>
+                      </a:pPr>
+                      <a:r>
+                        <a:rPr/>
+                        <a:t>result, 51</a:t>
+                      </a:r>
+                    </a:p>
+                  </a:txBody>
+                </a:tc>
+                <a:tc>
+                  <a:txBody>
+                    <a:bodyPr/>
+                    <a:lstStyle/>
+                    <a:p>
+                      <a:pPr lvl="0" indent="0" marL="0">
+                        <a:buNone/>
+                      </a:pPr>
+                      <a:r>
+                        <a:rPr>
+                          <a:latin typeface="Courier"/>
+                        </a:rPr>
+                        <a:t>.score(X_test, y_test)</a:t>
+                      </a:r>
+                    </a:p>
+                  </a:txBody>
+                </a:tc>
+              </a:tr>
+              <a:tr h="0">
+                <a:tc>
+                  <a:txBody>
+                    <a:bodyPr/>
+                    <a:lstStyle/>
+                    <a:p>
+                      <a:pPr lvl="0" indent="0" marL="0">
+                        <a:buNone/>
+                      </a:pPr>
+                      <a:r>
+                        <a:rPr/>
+                        <a:t>errors, 52-55</a:t>
+                      </a:r>
+                    </a:p>
+                  </a:txBody>
+                </a:tc>
+                <a:tc>
+                  <a:txBody>
+                    <a:bodyPr/>
+                    <a:lstStyle/>
+                    <a:p>
+                      <a:pPr lvl="0" indent="0" marL="0">
+                        <a:buNone/>
+                      </a:pPr>
+                      <a:r>
+                        <a:rPr>
+                          <a:latin typeface="Courier"/>
+                        </a:rPr>
+                        <a:t>ConfusionMatrixDisplay</a:t>
+                      </a:r>
+                      <a:r>
+                        <a:rPr/>
+                        <a:t>, </a:t>
+                      </a:r>
+                      <a:r>
+                        <a:rPr>
+                          <a:latin typeface="Courier"/>
+                        </a:rPr>
+                        <a:t>classification_report</a:t>
+                      </a:r>
+                      <a:r>
+                        <a:rPr/>
+                        <a:t>, </a:t>
+                      </a:r>
+                      <a:r>
+                        <a:rPr>
+                          <a:latin typeface="Courier"/>
+                        </a:rPr>
+                        <a:t>predict_proba</a:t>
+                      </a:r>
+                    </a:p>
+                  </a:txBody>
+                </a:tc>
+              </a:tr>
+            </a:tbl>
+          </a:graphicData>
+        </a:graphic>
+      </p:graphicFrame>
     </p:spTree>
   </p:cSld>
 </p:sld>
@@ -17067,8 +17681,8 @@
         </p:blipFill>
         <p:spPr bwMode="auto">
           <a:xfrm>
-            <a:off x="767456" y="2160270"/>
-            <a:ext cx="7609088" cy="2366010"/>
+            <a:off x="969212" y="2160270"/>
+            <a:ext cx="7205575" cy="2366010"/>
           </a:xfrm>
           <a:prstGeom prst="rect">
             <a:avLst/>
@@ -17181,6 +17795,21 @@
             <a:r>
               <a:rPr/>
               <a:t>Everything from here is measured against that.</a:t>
+            </a:r>
+          </a:p>
+          <a:p>
+            <a:pPr lvl="0" indent="0" marL="0">
+              <a:buNone/>
+            </a:pPr>
+            <a:r>
+              <a:rPr/>
+              <a:t>In code: </a:t>
+            </a:r>
+            <a:r>
+              <a:rPr>
+                <a:latin typeface="Courier"/>
+              </a:rPr>
+              <a:t>DummyClassifier(strategy="most_frequent")</a:t>
             </a:r>
           </a:p>
         </p:txBody>
@@ -17607,6 +18236,29 @@
             </a:r>
           </a:p>
           <a:p>
+            <a:pPr lvl="0"/>
+            <a:r>
+              <a:rPr/>
+              <a:t>In code: </a:t>
+            </a:r>
+            <a:r>
+              <a:rPr>
+                <a:latin typeface="Courier"/>
+              </a:rPr>
+              <a:t>baseline.score(X_test, y_test)</a:t>
+            </a:r>
+            <a:r>
+              <a:rPr/>
+              <a:t>, then </a:t>
+            </a:r>
+            <a:r>
+              <a:rPr>
+                <a:latin typeface="Courier"/>
+              </a:rPr>
+              <a:t>model.score(X_test, y_test)</a:t>
+            </a:r>
+          </a:p>
+          <a:p>
             <a:pPr lvl="0" indent="0" marL="0">
               <a:buNone/>
             </a:pPr>
@@ -17797,6 +18449,23 @@
             <a:r>
               <a:rPr/>
               <a:t>They trade off against each other</a:t>
+            </a:r>
+          </a:p>
+          <a:p>
+            <a:pPr lvl="0"/>
+            <a:r>
+              <a:rPr/>
+              <a:t>In code: </a:t>
+            </a:r>
+            <a:r>
+              <a:rPr>
+                <a:latin typeface="Courier"/>
+              </a:rPr>
+              <a:t>classification_report(y_test, y_pred)</a:t>
+            </a:r>
+            <a:r>
+              <a:rPr/>
+              <a:t> prints both</a:t>
             </a:r>
           </a:p>
         </p:txBody>
@@ -18260,7 +18929,13 @@
             </a:r>
             <a:r>
               <a:rPr/>
-              <a:t> that the tumour is malignant</a:t>
+              <a:t> that the tumour is malignant, </a:t>
+            </a:r>
+            <a:r>
+              <a:rPr>
+                <a:latin typeface="Courier"/>
+              </a:rPr>
+              <a:t>predict_proba()</a:t>
             </a:r>
           </a:p>
           <a:p>
@@ -18666,36 +19341,296 @@
           </a:p>
         </p:txBody>
       </p:sp>
-      <p:sp>
-        <p:nvSpPr>
-          <p:cNvPr id="3" name="Content Placeholder 2"/>
-          <p:cNvSpPr>
-            <a:spLocks noGrp="1"/>
-          </p:cNvSpPr>
+      <p:graphicFrame>
+        <p:nvGraphicFramePr>
+          <p:cNvPr id="6" name="Content Placeholder 5"/>
+          <p:cNvGraphicFramePr>
+            <a:graphicFrameLocks noGrp="1"/>
+          </p:cNvGraphicFramePr>
           <p:nvPr>
             <p:ph idx="1"/>
           </p:nvPr>
-        </p:nvSpPr>
-        <p:spPr>
-          <a:xfrm>
-            <a:off x="457200" y="1200151"/>
-            <a:ext cx="8229600" cy="3394472"/>
-          </a:xfrm>
-        </p:spPr>
-        <p:txBody>
-          <a:bodyPr/>
-          <a:lstStyle/>
-          <a:p>
-            <a:pPr lvl="0" indent="0" marL="0">
-              <a:buNone/>
-            </a:pPr>
-            <a:r>
-              <a:rPr/>
-              <a:t>Four failures, four plausible numbers, and not one bug among them.</a:t>
-            </a:r>
-          </a:p>
-        </p:txBody>
-      </p:sp>
+        </p:nvGraphicFramePr>
+        <p:xfrm>
+          <a:off x="457200" y="1166099"/>
+          <a:ext cx="8229600" cy="3390900"/>
+        </p:xfrm>
+        <a:graphic>
+          <a:graphicData uri="http://schemas.openxmlformats.org/drawingml/2006/table">
+            <a:tbl>
+              <a:tblPr firstRow="1" bandRow="1">
+                <a:tableStyleId>{5C22544A-7EE6-4342-B048-85BDC9FD1C3A}</a:tableStyleId>
+              </a:tblPr>
+              <a:tblGrid>
+                <a:gridCol w="4114800"/>
+                <a:gridCol w="4114800"/>
+              </a:tblGrid>
+              <a:tr h="0">
+                <a:tc>
+                  <a:txBody>
+                    <a:bodyPr/>
+                    <a:lstStyle/>
+                    <a:p>
+                      <a:pPr lvl="0" indent="0" marL="0">
+                        <a:buNone/>
+                      </a:pPr>
+                      <a:r>
+                        <a:rPr/>
+                        <a:t>failure, and its slides</a:t>
+                      </a:r>
+                    </a:p>
+                  </a:txBody>
+                  <a:tcPr/>
+                </a:tc>
+                <a:tc>
+                  <a:txBody>
+                    <a:bodyPr/>
+                    <a:lstStyle/>
+                    <a:p>
+                      <a:pPr lvl="0" indent="0" marL="0">
+                        <a:buNone/>
+                      </a:pPr>
+                      <a:r>
+                        <a:rPr/>
+                        <a:t>you call</a:t>
+                      </a:r>
+                    </a:p>
+                  </a:txBody>
+                  <a:tcPr/>
+                </a:tc>
+              </a:tr>
+              <a:tr h="0">
+                <a:tc>
+                  <a:txBody>
+                    <a:bodyPr/>
+                    <a:lstStyle/>
+                    <a:p>
+                      <a:pPr lvl="0" indent="0" marL="0">
+                        <a:buNone/>
+                      </a:pPr>
+                      <a:r>
+                        <a:rPr/>
+                        <a:t>the model, every time, 49</a:t>
+                      </a:r>
+                    </a:p>
+                  </a:txBody>
+                </a:tc>
+                <a:tc>
+                  <a:txBody>
+                    <a:bodyPr/>
+                    <a:lstStyle/>
+                    <a:p>
+                      <a:pPr lvl="0" indent="0" marL="0">
+                        <a:buNone/>
+                      </a:pPr>
+                      <a:r>
+                        <a:rPr>
+                          <a:latin typeface="Courier"/>
+                        </a:rPr>
+                        <a:t>make_pipeline(StandardScaler(), LogisticRegression())</a:t>
+                      </a:r>
+                    </a:p>
+                  </a:txBody>
+                </a:tc>
+              </a:tr>
+              <a:tr h="0">
+                <a:tc>
+                  <a:txBody>
+                    <a:bodyPr/>
+                    <a:lstStyle/>
+                    <a:p>
+                      <a:pPr lvl="0" indent="0" marL="0">
+                        <a:buNone/>
+                      </a:pPr>
+                      <a:r>
+                        <a:rPr/>
+                        <a:t>leakage, 60-62</a:t>
+                      </a:r>
+                    </a:p>
+                  </a:txBody>
+                </a:tc>
+                <a:tc>
+                  <a:txBody>
+                    <a:bodyPr/>
+                    <a:lstStyle/>
+                    <a:p>
+                      <a:pPr lvl="0" indent="0" marL="0">
+                        <a:buNone/>
+                      </a:pPr>
+                      <a:r>
+                        <a:rPr>
+                          <a:latin typeface="Courier"/>
+                        </a:rPr>
+                        <a:t>SelectKBest(f_classif, k=20)</a:t>
+                      </a:r>
+                      <a:r>
+                        <a:rPr/>
+                        <a:t>, outside the pipeline and then inside it</a:t>
+                      </a:r>
+                    </a:p>
+                  </a:txBody>
+                </a:tc>
+              </a:tr>
+              <a:tr h="0">
+                <a:tc>
+                  <a:txBody>
+                    <a:bodyPr/>
+                    <a:lstStyle/>
+                    <a:p>
+                      <a:pPr lvl="0" indent="0" marL="0">
+                        <a:buNone/>
+                      </a:pPr>
+                      <a:r>
+                        <a:rPr/>
+                        <a:t>imbalance, 63-64</a:t>
+                      </a:r>
+                    </a:p>
+                  </a:txBody>
+                </a:tc>
+                <a:tc>
+                  <a:txBody>
+                    <a:bodyPr/>
+                    <a:lstStyle/>
+                    <a:p>
+                      <a:pPr lvl="0" indent="0" marL="0">
+                        <a:buNone/>
+                      </a:pPr>
+                      <a:r>
+                        <a:rPr>
+                          <a:latin typeface="Courier"/>
+                        </a:rPr>
+                        <a:t>make_classification</a:t>
+                      </a:r>
+                      <a:r>
+                        <a:rPr/>
+                        <a:t>; </a:t>
+                      </a:r>
+                      <a:r>
+                        <a:rPr>
+                          <a:latin typeface="Courier"/>
+                        </a:rPr>
+                        <a:t>accuracy_score</a:t>
+                      </a:r>
+                      <a:r>
+                        <a:rPr/>
+                        <a:t> against </a:t>
+                      </a:r>
+                      <a:r>
+                        <a:rPr>
+                          <a:latin typeface="Courier"/>
+                        </a:rPr>
+                        <a:t>recall_score</a:t>
+                      </a:r>
+                      <a:r>
+                        <a:rPr/>
+                        <a:t>, </a:t>
+                      </a:r>
+                      <a:r>
+                        <a:rPr>
+                          <a:latin typeface="Courier"/>
+                        </a:rPr>
+                        <a:t>confusion_matrix</a:t>
+                      </a:r>
+                    </a:p>
+                  </a:txBody>
+                </a:tc>
+              </a:tr>
+              <a:tr h="0">
+                <a:tc>
+                  <a:txBody>
+                    <a:bodyPr/>
+                    <a:lstStyle/>
+                    <a:p>
+                      <a:pPr lvl="0" indent="0" marL="0">
+                        <a:buNone/>
+                      </a:pPr>
+                      <a:r>
+                        <a:rPr/>
+                        <a:t>shortcut, 65-66</a:t>
+                      </a:r>
+                    </a:p>
+                  </a:txBody>
+                </a:tc>
+                <a:tc>
+                  <a:txBody>
+                    <a:bodyPr/>
+                    <a:lstStyle/>
+                    <a:p>
+                      <a:pPr lvl="0" indent="0" marL="0">
+                        <a:buNone/>
+                      </a:pPr>
+                      <a:r>
+                        <a:rPr>
+                          <a:latin typeface="Courier"/>
+                        </a:rPr>
+                        <a:t>load_breast_cancer</a:t>
+                      </a:r>
+                      <a:r>
+                        <a:rPr/>
+                        <a:t>; </a:t>
+                      </a:r>
+                      <a:r>
+                        <a:rPr>
+                          <a:latin typeface="Courier"/>
+                        </a:rPr>
+                        <a:t>SimpleImputer</a:t>
+                      </a:r>
+                      <a:r>
+                        <a:rPr/>
+                        <a:t> when the column is missing</a:t>
+                      </a:r>
+                    </a:p>
+                  </a:txBody>
+                </a:tc>
+              </a:tr>
+              <a:tr h="0">
+                <a:tc>
+                  <a:txBody>
+                    <a:bodyPr/>
+                    <a:lstStyle/>
+                    <a:p>
+                      <a:pPr lvl="0" indent="0" marL="0">
+                        <a:buNone/>
+                      </a:pPr>
+                      <a:r>
+                        <a:rPr/>
+                        <a:t>single-split noise, 67</a:t>
+                      </a:r>
+                    </a:p>
+                  </a:txBody>
+                </a:tc>
+                <a:tc>
+                  <a:txBody>
+                    <a:bodyPr/>
+                    <a:lstStyle/>
+                    <a:p>
+                      <a:pPr lvl="0" indent="0" marL="0">
+                        <a:buNone/>
+                      </a:pPr>
+                      <a:r>
+                        <a:rPr>
+                          <a:latin typeface="Courier"/>
+                        </a:rPr>
+                        <a:t>train_test_split(random_state=seed)</a:t>
+                      </a:r>
+                      <a:r>
+                        <a:rPr/>
+                        <a:t> against </a:t>
+                      </a:r>
+                      <a:r>
+                        <a:rPr>
+                          <a:latin typeface="Courier"/>
+                        </a:rPr>
+                        <a:t>cross_val_score</a:t>
+                      </a:r>
+                    </a:p>
+                  </a:txBody>
+                </a:tc>
+              </a:tr>
+            </a:tbl>
+          </a:graphicData>
+        </a:graphic>
+      </p:graphicFrame>
     </p:spTree>
   </p:cSld>
 </p:sld>
@@ -19076,6 +20011,51 @@
               <a:t>Scaling. Imputation. Encoding. Selection. Tuning.</a:t>
             </a:r>
           </a:p>
+          <a:p>
+            <a:pPr lvl="0" indent="0" marL="0">
+              <a:buNone/>
+            </a:pPr>
+            <a:r>
+              <a:rPr/>
+              <a:t>In code: </a:t>
+            </a:r>
+            <a:r>
+              <a:rPr>
+                <a:latin typeface="Courier"/>
+              </a:rPr>
+              <a:t>StandardScaler</a:t>
+            </a:r>
+            <a:r>
+              <a:rPr/>
+              <a:t>, </a:t>
+            </a:r>
+            <a:r>
+              <a:rPr>
+                <a:latin typeface="Courier"/>
+              </a:rPr>
+              <a:t>SimpleImputer</a:t>
+            </a:r>
+            <a:r>
+              <a:rPr/>
+              <a:t>, </a:t>
+            </a:r>
+            <a:r>
+              <a:rPr>
+                <a:latin typeface="Courier"/>
+              </a:rPr>
+              <a:t>SelectKBest</a:t>
+            </a:r>
+            <a:r>
+              <a:rPr/>
+              <a:t>… all inside </a:t>
+            </a:r>
+            <a:r>
+              <a:rPr>
+                <a:latin typeface="Courier"/>
+              </a:rPr>
+              <a:t>make_pipeline</a:t>
+            </a:r>
+          </a:p>
         </p:txBody>
       </p:sp>
     </p:spTree>
@@ -19178,6 +20158,33 @@
             <a:r>
               <a:rPr b="1"/>
               <a:t>0.000</a:t>
+            </a:r>
+          </a:p>
+          <a:p>
+            <a:pPr lvl="0"/>
+            <a:r>
+              <a:rPr/>
+              <a:t>In code: </a:t>
+            </a:r>
+            <a:r>
+              <a:rPr>
+                <a:latin typeface="Courier"/>
+              </a:rPr>
+              <a:t>recall_score</a:t>
+            </a:r>
+            <a:r>
+              <a:rPr/>
+              <a:t> beside </a:t>
+            </a:r>
+            <a:r>
+              <a:rPr>
+                <a:latin typeface="Courier"/>
+              </a:rPr>
+              <a:t>accuracy_score</a:t>
+            </a:r>
+            <a:r>
+              <a:rPr/>
+              <a:t>, every time</a:t>
             </a:r>
           </a:p>
         </p:txBody>

</xml_diff>

<commit_message>
Name the parameter the search moves, and the rule that moves it
Lesson 1's threshold figure labelled the data and the parameter with one
caption; its panels now say which is which, and the handout writes the rule
as w1 * radius + b > 0 with w1 fixed, so the search is for b = -15.04. Lesson 2
states the gradient-descent update, w <- w - alpha * grad R(w), on the slide,
under the contour figure and in the handout, in the course's notation and
pointing to lesson 3's theta <- theta - alpha * grad J(theta).

Co-Authored-By: Claude Opus 5.5 <noreply@anthropic.com>
</commit_message>
<xml_diff>
--- a/Lessons/01_introduction_and_workflow/Slides/introduction_and_workflow_slides.pptx
+++ b/Lessons/01_introduction_and_workflow/Slides/introduction_and_workflow_slides.pptx
@@ -1730,6 +1730,20 @@
         <p:txBody>
           <a:bodyPr/>
           <a:lstStyle/>
+          <a:p>
+            <a:pPr lvl="0" indent="0" marL="0">
+              <a:buNone/>
+            </a:pPr>
+            <a:r>
+              <a:rPr/>
+              <a:t>Before reading the curve, say what the two axes are, because they share one scale and are not the same thing. Top: each training tumour’s radius - the data. Bottom: the candidate threshold t - the parameter being chosen. They can share an axis only because this parameter is itself a radius value. Written as a linear model the rule is “malignant if w1 * radius + b &gt; 0” with w1 fixed at 1, so the number being searched for is the intercept, b = -t = -15.04. Any positive w1 gives the same rule (w1 = 2, b = -30.08 is still “radius above 15.04”), so with one feature only the threshold matters. In lesson 2 the parameters are two coefficients, and this curve becomes a surface.</a:t>
+            </a:r>
+          </a:p>
+          <a:p>
+            <a:pPr lvl="0" indent="0" marL="0">
+              <a:buNone/>
+            </a:pPr>
+          </a:p>
           <a:p>
             <a:pPr lvl="0" indent="0" marL="0">
               <a:buNone/>
@@ -13527,8 +13541,8 @@
         </p:blipFill>
         <p:spPr bwMode="auto">
           <a:xfrm>
-            <a:off x="1646000" y="1166099"/>
-            <a:ext cx="5852000" cy="3360181"/>
+            <a:off x="1847359" y="1166099"/>
+            <a:ext cx="5449282" cy="3360181"/>
           </a:xfrm>
           <a:prstGeom prst="rect">
             <a:avLst/>

</xml_diff>

<commit_message>
Say lesson 1 and 2's speaker notes in plain words
Metaphors become what happens to which number, notes about how a slide was
built are gone, and references to marks and due dates follow the course as
it is: nothing is marked or handed in, and the exam discusses one exercise.
Two notes were also wrong: lesson 2's imputation leak barely moves the score,
it does not improve it, and lesson 1's exam does not ask for a derivation.

Co-Authored-By: Claude Opus 5.5 <noreply@anthropic.com>
</commit_message>
<xml_diff>
--- a/Lessons/01_introduction_and_workflow/Slides/introduction_and_workflow_slides.pptx
+++ b/Lessons/01_introduction_and_workflow/Slides/introduction_and_workflow_slides.pptx
@@ -1324,7 +1324,7 @@
             </a:pPr>
             <a:r>
               <a:rPr/>
-              <a:t>Then deliver the punchline and pause on it - we cannot compute this. D is unknown, the expectation is over data that has not been collected, and no amount of cleverness gets around it.</a:t>
+              <a:t>Then say the key point and pause on it - we cannot compute this. D is unknown, the expectation is over data that has not been collected, and no amount of cleverness gets around it.</a:t>
             </a:r>
           </a:p>
           <a:p>
@@ -1998,7 +1998,7 @@
             </a:pPr>
             <a:r>
               <a:rPr/>
-              <a:t>Empirical risk falls monotonically as the model gets more flexible - more parameters always fit the sample better, and with enough of them you reach zero by storing every example and reciting its answer.</a:t>
+              <a:t>Empirical risk falls as the model gets more flexible - more parameters fit the sample better, and with enough of them you reach zero by storing every example and reciting its answer. Say the condition if anyone presses: it falls for families that contain one another, when the solver finds the best member; handout section 2.2 shows np.polyfit at degree 21 returning a worse training error than at degree 20.</a:t>
             </a:r>
           </a:p>
           <a:p>
@@ -5126,7 +5126,7 @@
             </a:pPr>
             <a:r>
               <a:rPr/>
-              <a:t>The step everyone skips, and the one the exercise marks hardest.</a:t>
+              <a:t>The step everyone skips, and the one the exercise discussion probes hardest.</a:t>
             </a:r>
           </a:p>
           <a:p>
@@ -5774,7 +5774,7 @@
             </a:pPr>
             <a:r>
               <a:rPr/>
-              <a:t>StandardScaler LEARNS something - a mean and a standard deviation per feature. That makes it part of the model, not preparation of the data. Inside a pipeline it learns them from the training fold every time the pipeline is fitted, including inside each cross-validation fold in lesson 5.</a:t>
+              <a:t>StandardScaler LEARNS something - a mean and a standard deviation per feature. That makes it part of the model, not preparation of the data. Inside a pipeline it learns them from the training data every time the pipeline is fitted, including on each training part of the cross-validation in lesson 5.</a:t>
             </a:r>
           </a:p>
           <a:p>
@@ -6366,7 +6366,7 @@
             </a:pPr>
             <a:r>
               <a:rPr/>
-              <a:t>Define both against the confusion matrix still in their heads from the last slide, and keep them the right way round: recall divides by the row of things that really were malignant, precision by the column of things we flagged. The next slide makes the trade physical.</a:t>
+              <a:t>Define both against the confusion matrix still in their heads from the last slide, and keep them the right way round: recall divides by the row of things that really were malignant, precision by the column of things we flagged. The next slides make the trade-off concrete.</a:t>
             </a:r>
           </a:p>
           <a:p>
@@ -6882,7 +6882,7 @@
             </a:pPr>
             <a:r>
               <a:rPr/>
-              <a:t>Then land the last line, which is the point of the slide: that discipline is the reason the 0.986 is worth anything at all. Every one of the four failures we are about to see comes from breaking it in some form.</a:t>
+              <a:t>Then end on the last line, which is the point of the slide: that discipline is the reason the 0.986 is worth anything at all. Every one of the four failures we are about to see comes from breaking it in some form.</a:t>
             </a:r>
           </a:p>
         </p:txBody>
@@ -7304,7 +7304,7 @@
             </a:pPr>
             <a:r>
               <a:rPr/>
-              <a:t>Derivations are NOT on the slides. They are in the handout, to be read afterwards. In the room we do results, intuition and code. This is what lets the lecture move at a sensible pace while the course stays rigorous - and it is why the exam can ask them to reproduce a derivation.</a:t>
+              <a:t>Derivations are NOT on the slides. They are in the handout, to be read afterwards. In the room we do results, intuition and code. This is what lets the lecture move at a sensible pace while the course stays rigorous - and it is why the handout matters at the exam: “why did you choose this metric?” about their own notebook is answered with the derivations, not with the code.</a:t>
             </a:r>
           </a:p>
           <a:p>
@@ -7442,7 +7442,7 @@
             </a:pPr>
             <a:r>
               <a:rPr/>
-              <a:t>Nobody wrote a bug. Selection feels harmless because it fits no model - but it LEARNS from data, so it belongs inside the training fold.</a:t>
+              <a:t>Nobody wrote a bug. Selection feels harmless because it fits no model - but it LEARNS from data, so it must be fitted on the training data only.</a:t>
             </a:r>
           </a:p>
           <a:p>
@@ -7580,7 +7580,7 @@
             </a:pPr>
             <a:r>
               <a:rPr/>
-              <a:t>Tell them the exercise checks this: scaling the full dataset before splitting caps the methodology marks regardless of the result obtained.</a:t>
+              <a:t>Tell them the exercise discussion looks for exactly this: scaling the full dataset before splitting is a methodological error, whatever result it gives.</a:t>
             </a:r>
           </a:p>
         </p:txBody>
@@ -8516,7 +8516,7 @@
             </a:pPr>
             <a:r>
               <a:rPr/>
-              <a:t>Set it explicitly - do not let anyone leave without knowing it exists and when it is due.</a:t>
+              <a:t>Set it explicitly - do not let anyone leave without knowing it exists and when it is discussed.</a:t>
             </a:r>
           </a:p>
           <a:p>
@@ -8544,7 +8544,7 @@
             </a:pPr>
             <a:r>
               <a:rPr/>
-              <a:t>Remind them: scaling the full dataset before splitting loses the methodology marks regardless of the score. And there are no marks for accuracy anywhere in this course.</a:t>
+              <a:t>Remind them: scaling the full dataset before splitting is a methodological error whatever the score, and it is what the discussion will look for. Accuracy is never what counts in this course.</a:t>
             </a:r>
           </a:p>
           <a:p>
@@ -9020,7 +9020,7 @@
             </a:pPr>
             <a:r>
               <a:rPr/>
-              <a:t>Timing: roughly 50 minutes to the break, then the three kinds of learning, then the workflow worked live, then the failure modes. Homework is set in the last five minutes - do not let it slip, it is due next Friday.</a:t>
+              <a:t>Timing: roughly 50 minutes to the break, then the three kinds of learning, then the workflow worked live, then the failure modes. Homework is set in the last five minutes - do not let it slip; nothing is handed in, and it is discussed next Friday.</a:t>
             </a:r>
           </a:p>
         </p:txBody>
@@ -9116,7 +9116,7 @@
             </a:pPr>
             <a:r>
               <a:rPr/>
-              <a:t>Get them to feel the frustration before offering the alternative. The point to land, and it is handout section 2: the program is not hard to write, the RULE is impossible to state. You recognise spam instantly and cannot articulate how.</a:t>
+              <a:t>Get them to feel the frustration before offering the alternative. The point to make, and it is handout section 2: the program is not hard to write, the RULE is impossible to state. You recognise spam instantly and cannot articulate how.</a:t>
             </a:r>
           </a:p>
           <a:p>
@@ -20969,14 +20969,14 @@
             <a:pPr lvl="0"/>
             <a:r>
               <a:rPr/>
-              <a:t>No marks for accuracy</a:t>
+              <a:t>Accuracy is not what counts</a:t>
             </a:r>
           </a:p>
           <a:p>
             <a:pPr lvl="0"/>
             <a:r>
               <a:rPr/>
-              <a:t>Marks for methodology, and for saying what your number does not mean</a:t>
+              <a:t>Methodology is, and saying what your number does not mean</a:t>
             </a:r>
           </a:p>
         </p:txBody>

</xml_diff>

<commit_message>
Align notebook timings, carry-home numbers and two standing rules
Speaker notes in lessons 1, 3 and 5 now give the minutes the lesson plans
give; verify_lesson reads plans with a Minutes column and minutes spelled as
words, which is how the mismatches had slipped past it. CLAUDE.md's table of
numbers to remember now quotes what the decks for lessons 7, 8 and 9 single
out. Lesson 2's notebook 3 no longer imports NearestNeighbors, which it never
used, nor claims to search with it. The Italian translation of the handouts
is no longer produced, and every lesson is to get a commentary in Docs.

Co-Authored-By: Claude Opus 5.5 <noreply@anthropic.com>
</commit_message>
<xml_diff>
--- a/Lessons/01_introduction_and_workflow/Slides/introduction_and_workflow_slides.pptx
+++ b/Lessons/01_introduction_and_workflow/Slides/introduction_and_workflow_slides.pptx
@@ -4740,7 +4740,7 @@
             </a:pPr>
             <a:r>
               <a:rPr/>
-              <a:t>Open notebook 01 and run it. Twenty minutes, and it is the only place today where all three kinds appear on identical data, which is the whole argument of this segment made operational.</a:t>
+              <a:t>Open notebook 01 and run it. Fifteen minutes, and it is the only place today where all three kinds appear on identical data, which is the whole argument of this segment made operational.</a:t>
             </a:r>
           </a:p>
           <a:p>
@@ -5016,7 +5016,7 @@
             </a:pPr>
             <a:r>
               <a:rPr/>
-              <a:t>45 minutes, and it runs alongside the next twelve slides rather than instead of them: each step of the workflow is a slide and then the cell that performs it.</a:t>
+              <a:t>40 minutes, and it runs alongside the next twelve slides rather than instead of them: each step of the workflow is a slide and then the cell that performs it.</a:t>
             </a:r>
           </a:p>
           <a:p>
@@ -7084,7 +7084,7 @@
             </a:pPr>
             <a:r>
               <a:rPr/>
-              <a:t>25 minutes, again alongside the slides that follow rather than instead of them.</a:t>
+              <a:t>20 minutes, again alongside the slides that follow rather than instead of them.</a:t>
             </a:r>
           </a:p>
           <a:p>

</xml_diff>

<commit_message>
Rewrite lesson 1's speaker notes in full
Every note reread against its slide and every number checked against the
notebook outputs. Fixes the cost surface placed in lesson 2 (it is lesson 3),
XOR 'in four lines of Keras' (lesson 9 solves it with a hand-built network),
Samuel credited with the arrows picture, a supervised regression notebook 01
does not run, the break timing and slide counts, and 'an exercise due'.
Expands LLM, SVM and ReLU, names McCulloch and Pitts and the convergence
theorem's condition, glosses dropout, augmentation and 5-fold
cross-validation, and removes three duplicated paragraphs.

Co-Authored-By: Claude Opus 5.5 <noreply@anthropic.com>
</commit_message>
<xml_diff>
--- a/Lessons/01_introduction_and_workflow/Slides/introduction_and_workflow_slides.pptx
+++ b/Lessons/01_introduction_and_workflow/Slides/introduction_and_workflow_slides.pptx
@@ -870,7 +870,7 @@
             </a:pPr>
             <a:r>
               <a:rPr/>
-              <a:t>Worth adding: this framing is due to Arthur Samuel in the 1950s, and it is still the cleanest one-sentence description of what changed.</a:t>
+              <a:t>Worth adding: the idea is old. Arthur Samuel’s checkers program, in the 1950s, improved by playing games rather than by rules somebody wrote for it, and he called that machine learning. The arrows picture is a modern way of drawing what he did, and it is still the cleanest one-sentence description of what changed.</a:t>
             </a:r>
           </a:p>
         </p:txBody>
@@ -1104,7 +1104,7 @@
             </a:pPr>
             <a:r>
               <a:rPr/>
-              <a:t>The loss function is where the domain enters the mathematics. Choosing it is a decision about which mistakes matter, and we make that choice explicitly in twenty minutes.</a:t>
+              <a:t>The loss function is where the domain enters the mathematics. Choosing it is a decision about which mistakes matter, and we make that choice explicitly for the tumour data on slide 45, “Which error is worse?”.</a:t>
             </a:r>
           </a:p>
         </p:txBody>
@@ -1448,7 +1448,7 @@
             </a:pPr>
             <a:r>
               <a:rPr/>
-              <a:t>And say that choosing L is a modelling decision, not a technicality: it is where you state what counts as a bad mistake, before any model exists. Zero-one says every error costs the same, which is almost never true. Lesson 3 uses squared error, lesson 4 uses cross-entropy and then prices the two kinds of mistake separately. Handout 2.1.</a:t>
+              <a:t>And say that choosing L is a modelling decision, not a technicality: it is where you state what counts as a bad mistake, before any model exists. The zero-one loss of the next slide says every error costs the same, which is almost never true. Lesson 3 uses squared error, lesson 4 uses cross-entropy and then prices the two kinds of mistake separately. Handout 2.1.</a:t>
             </a:r>
           </a:p>
         </p:txBody>
@@ -1736,21 +1736,21 @@
             </a:pPr>
             <a:r>
               <a:rPr/>
-              <a:t>Before reading the curve, say what the two axes are, because they share one scale and are not the same thing. Top: each training tumour’s radius - the data. Bottom: the candidate threshold t - the parameter being chosen. They can share an axis only because this parameter is itself a radius value. Written as a linear model the rule is “malignant if w1 * radius + b &gt; 0” with w1 fixed at 1, so the number being searched for is the intercept, b = -t = -15.04. Any positive w1 gives the same rule (w1 = 2, b = -30.08 is still “radius above 15.04”), so with one feature only the threshold matters. In lesson 2 the parameters are two coefficients, and this curve becomes a surface.</a:t>
-            </a:r>
-          </a:p>
-          <a:p>
-            <a:pPr lvl="0" indent="0" marL="0">
-              <a:buNone/>
-            </a:pPr>
-          </a:p>
-          <a:p>
-            <a:pPr lvl="0" indent="0" marL="0">
-              <a:buNone/>
-            </a:pPr>
-            <a:r>
-              <a:rPr/>
-              <a:t>What “fit” actually does, on the smallest model there is. One feature - the mean radius of the tumour - and one family of rules: call a tumour malignant if its radius is above a threshold t. Every value of t is a different candidate model.</a:t>
+              <a:t>This is what “fit” actually does, on the smallest model there is. One feature - the mean radius of the tumour - and one family of rules: call a tumour malignant if its radius is above a threshold t. Every value of t is a different candidate model.</a:t>
+            </a:r>
+          </a:p>
+          <a:p>
+            <a:pPr lvl="0" indent="0" marL="0">
+              <a:buNone/>
+            </a:pPr>
+          </a:p>
+          <a:p>
+            <a:pPr lvl="0" indent="0" marL="0">
+              <a:buNone/>
+            </a:pPr>
+            <a:r>
+              <a:rPr/>
+              <a:t>Before reading the curve, say what the two axes are, because they share one scale and are not the same thing. Top: each training tumour’s radius - the data. Bottom: the candidate threshold t - the parameter being chosen. They can share an axis only because this parameter is itself a radius value. Written as a linear model the rule is “malignant if w1 * radius + b &gt; 0” with w1 fixed at 1, so the number being searched for is the intercept, b = -t = -15.04. Any positive w1 gives the same rule (w1 = 2, b = -30.08 is still “radius above 15.04”), so with one feature only the threshold matters. In lesson 3 the parameters are two coefficients, a slope and an intercept, and this curve becomes a surface.</a:t>
             </a:r>
           </a:p>
           <a:p>
@@ -1888,7 +1888,7 @@
             </a:pPr>
             <a:r>
               <a:rPr/>
-              <a:t>Say explicitly that there are no LLMs in this course - they belong to another module in the programme. Some will be disappointed. Tell them the material here is what those systems are built on: the transformer is a neural network, trained by gradient descent on a loss function, and evaluated - badly, often - with the same statistical tools we will spend ten weeks on.</a:t>
+              <a:t>Say explicitly that there are no large language models (LLMs), the systems behind chatbots, in this course - they belong to another module in the programme. Some will be disappointed. Tell them the material here is what those systems are built on: the transformer, the architecture inside them, is a neural network, trained by gradient descent on a loss function, and evaluated - badly, often - with the same statistical tools we will spend ten weeks on.</a:t>
             </a:r>
           </a:p>
           <a:p>
@@ -2136,7 +2136,7 @@
             </a:pPr>
             <a:r>
               <a:rPr/>
-              <a:t>Three fits to identical points. Left: a straight line cannot follow the curve, so it is wrong everywhere in the same way - high bias, poor on training AND test data. Right: degree-18 passes through nearly every point and oscillates wildly between them - it will be badly wrong on anything new.</a:t>
+              <a:t>Three fits to identical points. Left: a straight line cannot follow the curve, so it is wrong everywhere in the same way - what lesson 5 will call high bias, a model too simple for the pattern - and poor on training AND test data alike. Right: degree-18 passes through nearly every point and oscillates wildly between them - it will be badly wrong on anything new.</a:t>
             </a:r>
           </a:p>
           <a:p>
@@ -2468,21 +2468,21 @@
             </a:pPr>
             <a:r>
               <a:rPr/>
-              <a:t>Third, and expect this one to be challenged, because it sounds like something you could only know after deploying. Make the point that all three judgements are available before any code is written.</a:t>
-            </a:r>
-          </a:p>
-          <a:p>
-            <a:pPr lvl="0" indent="0" marL="0">
-              <a:buNone/>
-            </a:pPr>
-          </a:p>
-          <a:p>
-            <a:pPr lvl="0" indent="0" marL="0">
-              <a:buNone/>
-            </a:pPr>
-            <a:r>
-              <a:rPr/>
-              <a:t>The model WILL be wrong - not might be. Section 2.2 settled that, and today’s best model gets 2 of 143 wrong. You cannot know which 2 in advance; if you could, you would fix them. Whether a wrong answer can be undone is a fact about the application - a misfiled ticket is reopened, a wrong dose is not. Whether a person sees the output before it acts is a fact about the deployment, not about the weights.</a:t>
+              <a:t>Third, and expect this one to be challenged, because it sounds like something you could only know after deploying. Make the point that all three judgements - that errors will happen, that they cannot be undone, that nobody reviews the output - are available before any code is written.</a:t>
+            </a:r>
+          </a:p>
+          <a:p>
+            <a:pPr lvl="0" indent="0" marL="0">
+              <a:buNone/>
+            </a:pPr>
+          </a:p>
+          <a:p>
+            <a:pPr lvl="0" indent="0" marL="0">
+              <a:buNone/>
+            </a:pPr>
+            <a:r>
+              <a:rPr/>
+              <a:t>The model WILL be wrong - not might be. Handout section 2.2 settled that, and today’s best model gets 2 of 143 wrong. You cannot know which 2 in advance; if you could, you would fix them. Whether a wrong answer can be undone is a fact about the application - a misfiled ticket is reopened, a wrong dose is not. Whether a person sees the output before it acts is a fact about the deployment, not about the weights.</a:t>
             </a:r>
           </a:p>
           <a:p>
@@ -2538,7 +2538,7 @@
             </a:pPr>
             <a:r>
               <a:rPr/>
-              <a:t>Fifth: often a threshold on one variable solves 90% of the problem, is understandable by everyone, and needs no maintenance. Establishing baselines - step 4 of the workflow - is partly how you discover this before building something complicated.</a:t>
+              <a:t>Fifth: often a simple rule, such as a threshold on one variable, solves most of the problem, is understandable by everyone, and needs no maintenance. Establishing baselines - step 4 of the workflow - is partly how you discover this before building something complicated.</a:t>
             </a:r>
           </a:p>
         </p:txBody>
@@ -2716,7 +2716,7 @@
             </a:pPr>
             <a:r>
               <a:rPr/>
-              <a:t>A neurophysiologist and a logician. Their claim was philosophical as much as technical: thought might be computation. They showed networks of such units can compute any logical proposition.</a:t>
+              <a:t>Warren McCulloch, a neurophysiologist, and Walter Pitts, a logician. Their claim was philosophical as much as technical: thought might be computation. They showed networks of such units can compute any logical proposition.</a:t>
             </a:r>
           </a:p>
           <a:p>
@@ -2744,21 +2744,7 @@
             </a:pPr>
             <a:r>
               <a:rPr/>
-              <a:t>Tell them the unit in lesson 9 is this unit with a smoother threshold. The history is not decoration; it is the same objects under different names.</a:t>
-            </a:r>
-          </a:p>
-          <a:p>
-            <a:pPr lvl="0" indent="0" marL="0">
-              <a:buNone/>
-            </a:pPr>
-          </a:p>
-          <a:p>
-            <a:pPr lvl="0" indent="0" marL="0">
-              <a:buNone/>
-            </a:pPr>
-            <a:r>
-              <a:rPr/>
-              <a:t>Walk the diagram: inputs, a weight on each, a sum, and a hard threshold. Then point at the right-hand panel - the step function is what makes it all-or-nothing, and it is exactly what gets replaced by a smooth sigmoid in lesson 4 and by ReLU in lesson 9. Same object, softened, so that it becomes differentiable and therefore trainable.</a:t>
+              <a:t>Walk the diagram: inputs, a weight on each, a sum, and a hard threshold. Then point at the right-hand panel - the step function is what makes it all-or-nothing, and it is exactly what gets replaced by a smooth sigmoid in lesson 4 and by the rectified linear unit (ReLU) in lesson 9. Same object, softened, so that it has a slope everywhere and can therefore be trained by following that slope. The history is not decoration; it is the same objects under different names.</a:t>
             </a:r>
           </a:p>
         </p:txBody>
@@ -3088,7 +3074,7 @@
             </a:pPr>
             <a:r>
               <a:rPr/>
-              <a:t>Stress the CONDITION on the theorem: “if linearly separable”. The theorem is true and that clause is carrying enormous weight, as 1969 will show.</a:t>
+              <a:t>Stress the CONDITION on Rosenblatt’s convergence theorem: if a straight line can separate the two classes (they are “linearly separable”), the learning rule finds such a line in a finite number of steps. The theorem is true, and that “if” is carrying enormous weight, as 1969 will show.</a:t>
             </a:r>
           </a:p>
           <a:p>
@@ -3198,7 +3184,7 @@
             </a:pPr>
             <a:r>
               <a:rPr/>
-              <a:t>Draw XOR on the board - four points, alternating labels - and let them see that no single straight line separates them. Takes thirty seconds and lands permanently.</a:t>
+              <a:t>XOR is exclusive-or: true when exactly one of two inputs is true. As points, it is the four corners of a square with alternating labels, and no single straight line separates them. Use the figure: AND on the left, one line, done; XOR on the right, where the dashed lines are attempts and each leaves a point on the wrong side. Ask them to try to find one that works before you move on - the impossibility is more convincing when they have looked for it themselves.</a:t>
             </a:r>
           </a:p>
           <a:p>
@@ -3226,7 +3212,7 @@
             </a:pPr>
             <a:r>
               <a:rPr/>
-              <a:t>In lesson 9 a hidden layer disposes of XOR in four lines of Keras. Fifteen years of lost time for a limitation that a correct reading would have scoped much more narrowly.</a:t>
+              <a:t>In lesson 9 a hidden layer of two units disposes of an XOR problem, with weights small enough to write by hand. Seventeen years passed between Minsky and Papert’s 1969 book, Perceptrons, and backpropagation in 1986, for a limitation that a correct reading would have scoped much more narrowly.</a:t>
             </a:r>
           </a:p>
           <a:p>
@@ -3241,20 +3227,6 @@
             <a:r>
               <a:rPr/>
               <a:t>The transferable lesson: a correct result about a restricted case was received as a verdict on the whole approach. That failure mode is alive and well in how ML results get reported today.</a:t>
-            </a:r>
-          </a:p>
-          <a:p>
-            <a:pPr lvl="0" indent="0" marL="0">
-              <a:buNone/>
-            </a:pPr>
-          </a:p>
-          <a:p>
-            <a:pPr lvl="0" indent="0" marL="0">
-              <a:buNone/>
-            </a:pPr>
-            <a:r>
-              <a:rPr/>
-              <a:t>Use the figure instead of the board. AND on the left: one line, done. XOR on the right: the dashed lines are attempts, and each leaves a point on the wrong side. Ask them to try to find one that works before you move on - the impossibility is more convincing when they have looked for it themselves.</a:t>
             </a:r>
           </a:p>
         </p:txBody>
@@ -3460,20 +3432,6 @@
             </a:pPr>
             <a:r>
               <a:rPr/>
-              <a:t>Lesson 9 derives this algorithm.</a:t>
-            </a:r>
-          </a:p>
-          <a:p>
-            <a:pPr lvl="0" indent="0" marL="0">
-              <a:buNone/>
-            </a:pPr>
-          </a:p>
-          <a:p>
-            <a:pPr lvl="0" indent="0" marL="0">
-              <a:buNone/>
-            </a:pPr>
-            <a:r>
-              <a:rPr/>
               <a:t>Two passes: forward to compute a prediction, backward to distribute the error across every weight, including the hidden ones. That second arrow is what was missing in 1969 - not expressiveness, but a way to assign blame to a unit that never sees the target directly. Lesson 9 derives it.</a:t>
             </a:r>
           </a:p>
@@ -3556,7 +3514,7 @@
             </a:pPr>
             <a:r>
               <a:rPr/>
-              <a:t>Say that most of this course lives here, and it is where the reliable tools come from. SVMs arrived with theory explaining WHY they generalise. Random forests and boosting won competitions for a decade. The bias-variance decomposition and cross-validation became standard practice.</a:t>
+              <a:t>Say that most of this course lives here, and it is where the reliable tools come from. Support vector machines (SVMs) arrived with theory explaining WHY they generalise. Random forests and boosting won competitions for a decade. The bias-variance decomposition and cross-validation became standard practice.</a:t>
             </a:r>
           </a:p>
           <a:p>
@@ -3680,7 +3638,7 @@
             </a:pPr>
             <a:r>
               <a:rPr/>
-              <a:t>What changed was DATA - ImageNet, 1.2 million labelled images, assembled over years - and COMPUTE, two consumer GPUs. Plus details that mattered: ReLU activations, dropout, augmentation.</a:t>
+              <a:t>What changed was DATA - ImageNet, 1.2 million labelled images, assembled over years - and COMPUTE, two consumer graphics cards. Plus details that mattered, all met in lessons 9 and 10: ReLU activations, dropout (switching off random units during training) and augmentation (training on shifted and flipped copies of the images).</a:t>
             </a:r>
           </a:p>
           <a:p>
@@ -3914,7 +3872,17 @@
             </a:pPr>
             <a:r>
               <a:rPr/>
-              <a:t>Correct the common misconception immediately, before it takes hold. It is not about which algorithm you use: the same estimator can serve more than one setting, and they will see exactly that in notebook 01 where the supervised regression and the self-supervised task run identical code.</a:t>
+              <a:t>Correct the common misconception immediately, before it takes hold. It is not about which algorithm you use: the same estimator can serve more than one setting. In notebook 01 the self-supervised task is solved with </a:t>
+            </a:r>
+            <a:r>
+              <a:rPr>
+                <a:latin typeface="Courier"/>
+              </a:rPr>
+              <a:t>LinearRegression</a:t>
+            </a:r>
+            <a:r>
+              <a:rPr/>
+              <a:t>, the same estimator a supervised regression would use; what makes it self-supervised is only where its target comes from.</a:t>
             </a:r>
           </a:p>
           <a:p>
@@ -4134,7 +4102,7 @@
             </a:pPr>
             <a:r>
               <a:rPr/>
-              <a:t>Plant the difficulty now, but plant the right one. It is NOT that there is nothing to minimise - k-means minimises the within-cluster sum of squares, which is an empirical risk in the sense of the slide before the break, with the loss measured against the model’s own summary instead of a label. Lesson 8 derives it and proves the algorithm decreases it every step.</a:t>
+              <a:t>Plant the difficulty now, but plant the right one. It is NOT that there is nothing to minimise - k-means minimises the within-cluster sum of squares, which is an empirical risk in the sense of slide 17, with the loss measured against the model’s own summary instead of a label. Lesson 8 derives it and proves the algorithm decreases it every step.</a:t>
             </a:r>
           </a:p>
           <a:p>
@@ -4810,7 +4778,7 @@
             </a:pPr>
             <a:r>
               <a:rPr/>
-              <a:t>If time is short, drop the R² aside and the n_init experiment; keep all three results, because the comparison is the content. Handout section 5.</a:t>
+              <a:t>If time is short, drop the R² aside and the n_init experiment (k-means run from one random start against ten); keep all three results, because the comparison is the content. Handout section 5.</a:t>
             </a:r>
           </a:p>
         </p:txBody>
@@ -5016,7 +4984,7 @@
             </a:pPr>
             <a:r>
               <a:rPr/>
-              <a:t>40 minutes, and it runs alongside the next twelve slides rather than instead of them: each step of the workflow is a slide and then the cell that performs it.</a:t>
+              <a:t>40 minutes, and it runs alongside the next fourteen slides, 44 to 57, rather than instead of them: each step of the workflow is a slide and then the cell that performs it.</a:t>
             </a:r>
           </a:p>
           <a:p>
@@ -5926,7 +5894,7 @@
             </a:pPr>
             <a:r>
               <a:rPr/>
-              <a:t>Emphasise that last part. This is not a mistake that announces itself: it produces a working notebook and a plausible number. Lesson 2 measures what it costs on a real dataset, and lesson 5 gives it its name.</a:t>
+              <a:t>Emphasise that last part. This is not a mistake that announces itself: it produces a working notebook and a plausible number. Lesson 2 measures what it costs on a real dataset, and lesson 5 meets it again inside cross-validation.</a:t>
             </a:r>
           </a:p>
         </p:txBody>
@@ -8172,7 +8140,7 @@
             </a:pPr>
             <a:r>
               <a:rPr/>
-              <a:t>Cross-validation replaces the single draw with an average and - more usefully - reports the spread. On this data, 5-fold gives 0.960 ± 0.030.</a:t>
+              <a:t>Cross-validation replaces the single draw with an average and - more usefully - reports the spread. In 5-fold cross-validation the data is cut into five parts and each part serves once as the test set, so every row is tested exactly once. On this data it gives 0.960 ± 0.030: the mean of the five scores, plus or minus their standard deviation.</a:t>
             </a:r>
           </a:p>
           <a:p>
@@ -8678,7 +8646,7 @@
             </a:pPr>
             <a:r>
               <a:rPr/>
-              <a:t>Do this live and take ten minutes over it. Making sure everyone has JupyterLab running today is far cheaper than fixing it during lesson 3, when they also have an exercise due.</a:t>
+              <a:t>Do this live and take ten minutes over it. Making sure everyone has JupyterLab running today is far cheaper than fixing it during lesson 3, when they are also working on an exercise.</a:t>
             </a:r>
           </a:p>
           <a:p>
@@ -9020,7 +8988,7 @@
             </a:pPr>
             <a:r>
               <a:rPr/>
-              <a:t>Timing: roughly 50 minutes to the break, then the three kinds of learning, then the workflow worked live, then the failure modes. Homework is set in the last five minutes - do not let it slip; nothing is handed in, and it is discussed next Friday.</a:t>
+              <a:t>Timing: about an hour to the break, which comes after the history (slide 34); then the three kinds of learning, then the workflow worked live, then the failure modes. Homework is set in the last five minutes - do not let it slip; nothing is handed in, and it is discussed next Friday.</a:t>
             </a:r>
           </a:p>
         </p:txBody>
@@ -9131,20 +9099,6 @@
             <a:r>
               <a:rPr/>
               <a:t>If someone proposes machine learning immediately, slow them down - the interesting part is understanding precisely which difficulty it addresses.</a:t>
-            </a:r>
-          </a:p>
-          <a:p>
-            <a:pPr lvl="0" indent="0" marL="0">
-              <a:buNone/>
-            </a:pPr>
-          </a:p>
-          <a:p>
-            <a:pPr lvl="0" indent="0" marL="0">
-              <a:buNone/>
-            </a:pPr>
-            <a:r>
-              <a:rPr/>
-              <a:t>Take each row in turn and let someone in the room supply the exception before you reveal it. The pattern to draw out: every rule is defensible and every rule breaks, and the list has no end.</a:t>
             </a:r>
           </a:p>
         </p:txBody>

</xml_diff>